<commit_message>
docs(presentation): show routing conditions and concrete design tradeoffs
변경 내용
- 3장에 최신 생성 결과 관계도와 원문 검토 화면을 함께 배치했다.
- 4장에 실제 route 조건식과 조건부 연결 코드를 표시해 수정 판단의 세 조건을 설명하도록 바꿨다.
- 6·7장에 전체 기준의 비용·지연과 수정 상한으로 남을 수 있는 문제를 명시했다.
- 발표 대본과 7개 발표자 노트를 동기화하고 7장·285초 목표 배분을 유지했다.

변경 이유
- 평가자가 구현 결과와 코드의 실제 판단 로직, 설계 선택의 대가를 발표 안에서 확인할 수 있도록 보완했다.

검증
- PPTX 구조·레이아웃·폰트·재가져오기 검사 통과, 7장 전체 렌더링 확인.
- 슬라이드 route 조건식을 AST로 파싱해 실제 workflow.py의 조건식과 동일함을 확인했다.
- 대본과 노트 일치, 화면 시간 표시 없음, 변경 대상 밖 1·2·5장 픽셀 동일성을 확인했다.
- 대본 공백 제외 1,371자, 목표 285초. 실제 낭독 시간과 PowerPoint 네이티브 발표 환경은 측정하지 않았다.

주의사항
- 화면은 과거 공개 실제 API 저장 결과의 최신 UI 재열람이며 신규 생성 품질 검증이 아니다.
</commit_message>
<xml_diff>
--- a/docs/presentation/LoreForge-G074-KimJimin.pptx
+++ b/docs/presentation/LoreForge-G074-KimJimin.pptx
@@ -2,19 +2,19 @@
 <file path=ppt/presentation.xml><?xml version="1.0" encoding="utf-8"?>
 <p:presentation xmlns:p="http://schemas.openxmlformats.org/presentationml/2006/main">
   <p:sldMasterIdLst>
-    <p:sldMasterId xmlns:r="http://schemas.openxmlformats.org/officeDocument/2006/relationships" id="2147483648" r:id="R78c7ffb84b0e4d06"/>
+    <p:sldMasterId xmlns:r="http://schemas.openxmlformats.org/officeDocument/2006/relationships" id="2147483648" r:id="Rf6181d2a72a6451a"/>
   </p:sldMasterIdLst>
   <p:notesMasterIdLst>
-    <p:notesMasterId xmlns:r="http://schemas.openxmlformats.org/officeDocument/2006/relationships" r:id="Rb0dcfafd3a334e74"/>
+    <p:notesMasterId xmlns:r="http://schemas.openxmlformats.org/officeDocument/2006/relationships" r:id="R0c199413a138451e"/>
   </p:notesMasterIdLst>
   <p:sldIdLst>
-    <p:sldId xmlns:r="http://schemas.openxmlformats.org/officeDocument/2006/relationships" id="256" r:id="Rf1e991c5b8454185"/>
-    <p:sldId xmlns:r="http://schemas.openxmlformats.org/officeDocument/2006/relationships" id="257" r:id="R9388c2e67baf47bc"/>
-    <p:sldId xmlns:r="http://schemas.openxmlformats.org/officeDocument/2006/relationships" id="258" r:id="R15726084f4364893"/>
-    <p:sldId xmlns:r="http://schemas.openxmlformats.org/officeDocument/2006/relationships" id="259" r:id="R8c5ae7496b024484"/>
-    <p:sldId xmlns:r="http://schemas.openxmlformats.org/officeDocument/2006/relationships" id="260" r:id="R947d463cf9774717"/>
-    <p:sldId xmlns:r="http://schemas.openxmlformats.org/officeDocument/2006/relationships" id="261" r:id="R53f9594a26ac44a3"/>
-    <p:sldId xmlns:r="http://schemas.openxmlformats.org/officeDocument/2006/relationships" id="262" r:id="R49ce687d1c494a22"/>
+    <p:sldId xmlns:r="http://schemas.openxmlformats.org/officeDocument/2006/relationships" id="256" r:id="Re594f3e240664de8"/>
+    <p:sldId xmlns:r="http://schemas.openxmlformats.org/officeDocument/2006/relationships" id="257" r:id="R1c44c2bfbfaa479e"/>
+    <p:sldId xmlns:r="http://schemas.openxmlformats.org/officeDocument/2006/relationships" id="258" r:id="Rd9e0a08e437f4c91"/>
+    <p:sldId xmlns:r="http://schemas.openxmlformats.org/officeDocument/2006/relationships" id="259" r:id="Racc7bd9520654395"/>
+    <p:sldId xmlns:r="http://schemas.openxmlformats.org/officeDocument/2006/relationships" id="260" r:id="Rc9db19f10b4a443b"/>
+    <p:sldId xmlns:r="http://schemas.openxmlformats.org/officeDocument/2006/relationships" id="261" r:id="Rc13d0a1531dc445c"/>
+    <p:sldId xmlns:r="http://schemas.openxmlformats.org/officeDocument/2006/relationships" id="262" r:id="R5c28a47230ff4792"/>
   </p:sldIdLst>
   <p:sldSz cx="12192000" cy="6858000"/>
   <p:notesSz cx="6858000" cy="9144000"/>
@@ -448,7 +448,7 @@
           <a:lstStyle xmlns:a="http://schemas.openxmlformats.org/drawingml/2006/main"/>
           <a:p xmlns:a="http://schemas.openxmlformats.org/drawingml/2006/main">
             <a:r>
-              <a:t>[00:00–00:20 / 20초]</a:t>
+              <a:t>[설정공방 LoreForge — 00:00–00:20 / 20초]</a:t>
             </a:r>
           </a:p>
           <a:p xmlns:a="http://schemas.openxmlformats.org/drawingml/2006/main">
@@ -463,12 +463,7 @@
           </a:p>
           <a:p xmlns:a="http://schemas.openxmlformats.org/drawingml/2006/main">
             <a:r>
-              <a:t>코드·자료 근거: README.md의 주제·목표.</a:t>
-            </a:r>
-          </a:p>
-          <a:p xmlns:a="http://schemas.openxmlformats.org/drawingml/2006/main">
-            <a:r>
-              <a:t>검증 기준 코드: a3086ff (2026-10-21).</a:t>
+              <a:t>자료: docs/PRESENTATION.md, docs/RESULTS.md. 코드 기준 a3086ff. 공개 v4 생성·v5 검토 저장 결과를 2026-10-22 최신 화면에서 조회만 허용한 서버로 재캡처. v8 회귀 10건과는 별도 실행. 화면 시간 표시는 없음.</a:t>
             </a:r>
           </a:p>
         </p:txBody>
@@ -538,7 +533,7 @@
           <a:lstStyle xmlns:a="http://schemas.openxmlformats.org/drawingml/2006/main"/>
           <a:p xmlns:a="http://schemas.openxmlformats.org/drawingml/2006/main">
             <a:r>
-              <a:t>[00:20–01:05 / 45초]</a:t>
+              <a:t>[주제와 세부 태스크 — 00:20–01:05 / 45초]</a:t>
             </a:r>
           </a:p>
           <a:p xmlns:a="http://schemas.openxmlformats.org/drawingml/2006/main">
@@ -553,12 +548,7 @@
           </a:p>
           <a:p xmlns:a="http://schemas.openxmlformats.org/drawingml/2006/main">
             <a:r>
-              <a:t>코드·자료 근거: README.md 주요 task 및 사용 흐름, backend/workflow.py.</a:t>
-            </a:r>
-          </a:p>
-          <a:p xmlns:a="http://schemas.openxmlformats.org/drawingml/2006/main">
-            <a:r>
-              <a:t>검증 기준 코드: a3086ff (2026-10-21).</a:t>
+              <a:t>자료: docs/PRESENTATION.md, docs/RESULTS.md. 코드 기준 a3086ff. 공개 v4 생성·v5 검토 저장 결과를 2026-10-22 최신 화면에서 조회만 허용한 서버로 재캡처. v8 회귀 10건과는 별도 실행. 화면 시간 표시는 없음.</a:t>
             </a:r>
           </a:p>
         </p:txBody>
@@ -628,12 +618,12 @@
           <a:lstStyle xmlns:a="http://schemas.openxmlformats.org/drawingml/2006/main"/>
           <a:p xmlns:a="http://schemas.openxmlformats.org/drawingml/2006/main">
             <a:r>
-              <a:t>[01:05–02:00 / 55초]</a:t>
+              <a:t>[구현 결과와 검증 — 01:05–02:00 / 55초]</a:t>
             </a:r>
           </a:p>
           <a:p xmlns:a="http://schemas.openxmlformats.org/drawingml/2006/main">
             <a:r>
-              <a:t>오른쪽은 공개 가상 원고를 실제 API로 검토한 저장 결과입니다. 하나뿐인 열쇠를 두 사람이 같은 시각, 서로 다른 장소에서 가지고 있다는 내용을 내부 모순으로 지적하고, 원문 두 문단을 연결했습니다. 키워드 생성과 한 번의 수정, 채택 후 이어쓰기까지도 실제 흐름을 확인했습니다. 최근에는 정상 예외 여섯 건과 실제 문제 네 건을 묶은 회귀 검사를 모두 통과했습니다. 자동 검사는 Python 105개와 프런트엔드 17개, 타입 검사와 빌드까지 통과했습니다. 다만 이 수치가 모든 원고의 정확성을 보장하는 것은 아닙니다. 이제 이를 제어하는 코드를 설명하겠습니다.</a:t>
+              <a:t>두 화면은 공개 입력으로 얻은 실제 API 결과를 최신 화면에서 다시 연 것입니다. 왼쪽은 키워드로 만든 이야기의 수정본을 관계도로 본 화면입니다. 본문과 같은 데이터로 인물·장소·사건을 연결합니다. 오른쪽은 원문 검토입니다. 하나뿐인 열쇠가 같은 시각 서로 다른 장소에 있다는 내부 모순을 지적하고 원문 두 문단을 연결했습니다. 채택 후 이어쓰기까지 실제 흐름을 확인했고, 정상 예외 여섯 건과 실제 문제 네 건의 회귀 검사도 통과했습니다. 자동 검사와 타입·빌드도 확인했습니다. 다만 작은 회귀 표본이 모든 원고의 정확성을 보장하지는 않습니다. 이제 실행 코드를 설명하겠습니다.</a:t>
             </a:r>
           </a:p>
           <a:p xmlns:a="http://schemas.openxmlformats.org/drawingml/2006/main">
@@ -643,12 +633,7 @@
           </a:p>
           <a:p xmlns:a="http://schemas.openxmlformats.org/drawingml/2006/main">
             <a:r>
-              <a:t>코드·자료 근거: docs/images/review-findings.jpg 및 README.md. 화면은 2026-10-20 v5의 저장 결과, 회귀 10건은 2026-10-21 v8 검증으로 별개다. docs/RESULTS.md.</a:t>
-            </a:r>
-          </a:p>
-          <a:p xmlns:a="http://schemas.openxmlformats.org/drawingml/2006/main">
-            <a:r>
-              <a:t>검증 기준 코드: a3086ff (2026-10-21).</a:t>
+              <a:t>자료: docs/PRESENTATION.md, docs/RESULTS.md. 코드 기준 a3086ff. 공개 v4 생성·v5 검토 저장 결과를 2026-10-22 최신 화면에서 조회만 허용한 서버로 재캡처. v8 회귀 10건과는 별도 실행. 화면 시간 표시는 없음.</a:t>
             </a:r>
           </a:p>
         </p:txBody>
@@ -718,12 +703,12 @@
           <a:lstStyle xmlns:a="http://schemas.openxmlformats.org/drawingml/2006/main"/>
           <a:p xmlns:a="http://schemas.openxmlformats.org/drawingml/2006/main">
             <a:r>
-              <a:t>[02:00–03:00 / 60초]</a:t>
+              <a:t>[Agent Graph의 실행 경로와 종료 조건 — 02:00–03:00 / 60초]</a:t>
             </a:r>
           </a:p>
           <a:p xmlns:a="http://schemas.openxmlformats.org/drawingml/2006/main">
             <a:r>
-              <a:t>설정 분석은 그래프 전에 수행하고, 분석 결과와 사용자 조건을 실행 상태에 넣습니다. LangGraph에는 생성, 검토, 수정, 종료 노드를 등록했습니다. 생성 모드는 초안 생성부터, 원문 검토 모드는 검토 노드부터 시작합니다. 오른쪽 조건부 연결의 route 함수가 핵심입니다. 생성 모드이고, 아직 수정본이 없으며, 의도 확인 질문이 아닌 미해결 문제가 있을 때만 수정으로 갑니다. 수정본은 다시 검토하지만 두 번째 수정은 하지 않습니다. 문제가 남으면 확인 필요 상태로 종료합니다. 역할별 프롬프트를 나눈 순차 구조이고, 자율 토론 구조는 아닙니다. 분석을 포함해 정상 최대 다섯 번, 재시도까지 최대 여섯 번으로 제한했습니다.</a:t>
+              <a:t>설정 분석 후 기준과 사용자 조건을 실행 상태에 넣고 LangGraph를 실행합니다. 생성 모드는 생성부터, 원문 검토는 검토 노드부터 시작합니다. 오른쪽 route 코드의 세 조건이 핵심입니다. 첫째, 검토 전용 모드가 아니어야 합니다. 둘째, revision이 없어야 합니다. 이 조건으로 두 번째 수정을 막습니다. 셋째, open 상태이면서 intent_question이 아닌 문제가 있어야 합니다. 작성자 의도 질문만 있으면 자동으로 답을 정하지 않습니다. 세 조건을 모두 만족하면 revise, 아니면 finish를 반환하고 조건부 연결이 다음 노드를 고릅니다. 수정 후에도 문제가 남으면 확인 필요로 종료합니다. 역할별 순차 실행이며 분석을 포함해 정상 최대 다섯 번, 재시도 포함 여섯 번으로 제한했습니다.</a:t>
             </a:r>
           </a:p>
           <a:p xmlns:a="http://schemas.openxmlformats.org/drawingml/2006/main">
@@ -733,12 +718,7 @@
           </a:p>
           <a:p xmlns:a="http://schemas.openxmlformats.org/drawingml/2006/main">
             <a:r>
-              <a:t>코드·자료 근거: backend/workflow.py:37–96, route 71–76; backend/provider.py:158–186. 코드 일부 발췌·줄바꿈. 분석은 backend/main.py의 analyze API.</a:t>
-            </a:r>
-          </a:p>
-          <a:p xmlns:a="http://schemas.openxmlformats.org/drawingml/2006/main">
-            <a:r>
-              <a:t>검증 기준 코드: a3086ff (2026-10-21).</a:t>
+              <a:t>자료: docs/PRESENTATION.md, docs/RESULTS.md. 코드 기준 a3086ff. 공개 v4 생성·v5 검토 저장 결과를 2026-10-22 최신 화면에서 조회만 허용한 서버로 재캡처. v8 회귀 10건과는 별도 실행. 화면 시간 표시는 없음.</a:t>
             </a:r>
           </a:p>
         </p:txBody>
@@ -808,7 +788,7 @@
           <a:lstStyle xmlns:a="http://schemas.openxmlformats.org/drawingml/2006/main"/>
           <a:p xmlns:a="http://schemas.openxmlformats.org/drawingml/2006/main">
             <a:r>
-              <a:t>[03:00–03:45 / 45초]</a:t>
+              <a:t>[MCP로 실행 당시 원문 근거 재조회 — 03:00–03:45 / 45초]</a:t>
             </a:r>
           </a:p>
           <a:p xmlns:a="http://schemas.openxmlformats.org/drawingml/2006/main">
@@ -823,12 +803,7 @@
           </a:p>
           <a:p xmlns:a="http://schemas.openxmlformats.org/drawingml/2006/main">
             <a:r>
-              <a:t>코드·자료 근거: backend/mcp_client.py:7–19, backend/mcp_server.py:10–26, backend/workflow.py:23–35. 코드 발췌·줄바꿈.</a:t>
-            </a:r>
-          </a:p>
-          <a:p xmlns:a="http://schemas.openxmlformats.org/drawingml/2006/main">
-            <a:r>
-              <a:t>검증 기준 코드: a3086ff (2026-10-21).</a:t>
+              <a:t>자료: docs/PRESENTATION.md, docs/RESULTS.md. 코드 기준 a3086ff. 공개 v4 생성·v5 검토 저장 결과를 2026-10-22 최신 화면에서 조회만 허용한 서버로 재캡처. v8 회귀 10건과는 별도 실행. 화면 시간 표시는 없음.</a:t>
             </a:r>
           </a:p>
         </p:txBody>
@@ -898,12 +873,12 @@
           <a:lstStyle xmlns:a="http://schemas.openxmlformats.org/drawingml/2006/main"/>
           <a:p xmlns:a="http://schemas.openxmlformats.org/drawingml/2006/main">
             <a:r>
-              <a:t>[03:45–04:20 / 35초]</a:t>
+              <a:t>[RAG 적용 범위와 현재 기준 전달 방식 — 03:45–04:20 / 35초]</a:t>
             </a:r>
           </a:p>
           <a:p xmlns:a="http://schemas.openxmlformats.org/drawingml/2006/main">
             <a:r>
-              <a:t>RAG는 이번 MVP에 구현하지 않았습니다. 현재는 입력, 조건, 채택한 설정 등을 합친 기준을 이만 자 이내로 제한하고 전체를 전달합니다. MCP도 벡터 검색이 아니라 지정한 문단을 재조회합니다. 짧은 설정에서는 다른 곳의 예외까지 함께 확인하는 것이 중요하다고 봤습니다. 긴 원고를 지원할 때는 검색을 추가하되, 관련 문장만 가져오면서 예외를 놓치지 않는지 함께 평가할 계획입니다.</a:t>
+              <a:t>RAG는 이번 MVP에 구현하지 않았습니다. 입력과 조건, 채택 설정 등의 기준을 이만 자 이내로 제한해 전체를 제공합니다. 일부만 검색하다 예외를 빠뜨리는 위험을 줄이기 위한 선택입니다. 대신 기준이 길어지면 입력 비용과 지연이 늘고, 긴 원고는 범위를 줄여야 합니다. 이후 검색을 추가할 때는 관련 문장뿐 아니라 예외까지 찾는지 함께 평가하겠습니다.</a:t>
             </a:r>
           </a:p>
           <a:p xmlns:a="http://schemas.openxmlformats.org/drawingml/2006/main">
@@ -913,12 +888,7 @@
           </a:p>
           <a:p xmlns:a="http://schemas.openxmlformats.org/drawingml/2006/main">
             <a:r>
-              <a:t>코드·자료 근거: backend/main.py:234–245, backend/workflow.py:23–32, README.md RAG 적용 범위. context 객체는 실제 코드의 줄바꿈 발췌이며 검색 코드는 아직 없다.</a:t>
-            </a:r>
-          </a:p>
-          <a:p xmlns:a="http://schemas.openxmlformats.org/drawingml/2006/main">
-            <a:r>
-              <a:t>검증 기준 코드: a3086ff (2026-10-21).</a:t>
+              <a:t>자료: docs/PRESENTATION.md, docs/RESULTS.md. 코드 기준 a3086ff. 공개 v4 생성·v5 검토 저장 결과를 2026-10-22 최신 화면에서 조회만 허용한 서버로 재캡처. v8 회귀 10건과는 별도 실행. 화면 시간 표시는 없음.</a:t>
             </a:r>
           </a:p>
         </p:txBody>
@@ -988,12 +958,12 @@
           <a:lstStyle xmlns:a="http://schemas.openxmlformats.org/drawingml/2006/main"/>
           <a:p xmlns:a="http://schemas.openxmlformats.org/drawingml/2006/main">
             <a:r>
-              <a:t>[04:20–04:45 / 25초]</a:t>
+              <a:t>[검토 오탐 보완과 남은 한계 — 04:20–04:45 / 25초]</a:t>
             </a:r>
           </a:p>
           <a:p xmlns:a="http://schemas.openxmlformats.org/drawingml/2006/main">
             <a:r>
-              <a:t>마지막으로 일반 후보 목록과 특정 회차의 예외를 모순으로 잡는 오탐을 보완했습니다. 비교 전에 회차와 시점, 조건, 확정 여부를 구분하도록 했고, 실제 위반 사례도 함께 검사했습니다. 최종 판단은 창작자에게 남깁니다. 저는 요구사항과 결과를 판단하고, AI 코딩 에이전트의 구현·검증 지원을 받았습니다. 감사합니다.</a:t>
+              <a:t>회차와 조건을 먼저 비교해 정상 예외와 실제 위반을 구분하도록 보완했습니다. 수정 한 번으로 반복과 비용은 제한했지만, 더 수정하면 해결될 문제도 남을 수 있어 작성자에게 넘깁니다. 지적이 없다는 결과도 정확성 보장은 아닙니다. 구현에는 AI 도구를 활용했고, 요구사항과 결과를 직접 판단했습니다. 감사합니다.</a:t>
             </a:r>
           </a:p>
           <a:p xmlns:a="http://schemas.openxmlformats.org/drawingml/2006/main">
@@ -1003,12 +973,7 @@
           </a:p>
           <a:p xmlns:a="http://schemas.openxmlformats.org/drawingml/2006/main">
             <a:r>
-              <a:t>코드·자료 근거: backend/provider.py:9–26, fixtures/review_counterevidence.json, docs/RESULTS.md. 화면 문장은 지침의 일부 발췌·줄바꿈.</a:t>
-            </a:r>
-          </a:p>
-          <a:p xmlns:a="http://schemas.openxmlformats.org/drawingml/2006/main">
-            <a:r>
-              <a:t>검증 기준 코드: a3086ff (2026-10-21).</a:t>
+              <a:t>자료: docs/PRESENTATION.md, docs/RESULTS.md. 코드 기준 a3086ff. 공개 v4 생성·v5 검토 저장 결과를 2026-10-22 최신 화면에서 조회만 허용한 서버로 재캡처. v8 회귀 10건과는 별도 실행. 화면 시간 표시는 없음.</a:t>
             </a:r>
           </a:p>
         </p:txBody>
@@ -3451,12 +3416,12 @@
   </p:cSld>
   <p:clrMap bg1="lt1" tx1="dk1" bg2="lt2" tx2="dk2" accent1="accent1" accent2="accent2" accent3="accent3" accent4="accent4" accent5="accent5" accent6="accent6" hlink="hlink" folHlink="folHlink"/>
   <p:sldLayoutIdLst>
-    <p:sldLayoutId xmlns:r="http://schemas.openxmlformats.org/officeDocument/2006/relationships" id="2147483649" r:id="Rd558ae48c168499c"/>
-    <p:sldLayoutId xmlns:r="http://schemas.openxmlformats.org/officeDocument/2006/relationships" id="2147483650" r:id="Rf98b8dd72b5b4f32"/>
-    <p:sldLayoutId xmlns:r="http://schemas.openxmlformats.org/officeDocument/2006/relationships" id="2147483651" r:id="R011dd2ef68404079"/>
-    <p:sldLayoutId xmlns:r="http://schemas.openxmlformats.org/officeDocument/2006/relationships" id="2147483652" r:id="R5c458ced23144de7"/>
-    <p:sldLayoutId xmlns:r="http://schemas.openxmlformats.org/officeDocument/2006/relationships" id="2147483653" r:id="R7164485c769a49e0"/>
-    <p:sldLayoutId xmlns:r="http://schemas.openxmlformats.org/officeDocument/2006/relationships" id="2147483654" r:id="R9fd1a591633e462c"/>
+    <p:sldLayoutId xmlns:r="http://schemas.openxmlformats.org/officeDocument/2006/relationships" id="2147483649" r:id="Re9a225e002c94bdd"/>
+    <p:sldLayoutId xmlns:r="http://schemas.openxmlformats.org/officeDocument/2006/relationships" id="2147483650" r:id="R96081535776b4a66"/>
+    <p:sldLayoutId xmlns:r="http://schemas.openxmlformats.org/officeDocument/2006/relationships" id="2147483651" r:id="R43a867a9c0be481f"/>
+    <p:sldLayoutId xmlns:r="http://schemas.openxmlformats.org/officeDocument/2006/relationships" id="2147483652" r:id="Rfeb75db849ba4b65"/>
+    <p:sldLayoutId xmlns:r="http://schemas.openxmlformats.org/officeDocument/2006/relationships" id="2147483653" r:id="R851073e4b62d40d8"/>
+    <p:sldLayoutId xmlns:r="http://schemas.openxmlformats.org/officeDocument/2006/relationships" id="2147483654" r:id="Rb037b7e45f27430d"/>
   </p:sldLayoutIdLst>
   <p:txStyles>
     <p:titleStyle>
@@ -7541,7 +7506,7 @@
                 <a:ea typeface="Apple SD Gothic Neo"/>
                 <a:cs typeface="Apple SD Gothic Neo"/>
               </a:rPr>
-              <a:t>구현 결과와 검증</a:t>
+              <a:t>생성·관계 탐색과 원문 검토</a:t>
             </a:r>
           </a:p>
         </p:txBody>
@@ -7894,8 +7859,8 @@
         </p:nvSpPr>
         <p:spPr>
           <a:xfrm xmlns:a="http://schemas.openxmlformats.org/drawingml/2006/main">
-            <a:off x="609600" y="1333500"/>
-            <a:ext cx="5238750" cy="409575"/>
+            <a:off x="609600" y="1362075"/>
+            <a:ext cx="5238750" cy="428625"/>
           </a:xfrm>
           <a:prstGeom xmlns:a="http://schemas.openxmlformats.org/drawingml/2006/main" prst="rect">
             <a:avLst/>
@@ -7909,7 +7874,7 @@
           <a:bodyPr xmlns:a="http://schemas.openxmlformats.org/drawingml/2006/main" lIns="0" tIns="0" rIns="0" bIns="0"/>
           <a:lstStyle xmlns:a="http://schemas.openxmlformats.org/drawingml/2006/main">
             <a:defPPr>
-              <a:defRPr sz="2175" b="1">
+              <a:defRPr sz="2100" b="1">
                 <a:solidFill>
                   <a:srgbClr val="0F52BA"/>
                 </a:solidFill>
@@ -8021,7 +7986,7 @@
           <a:p xmlns:a="http://schemas.openxmlformats.org/drawingml/2006/main">
             <a:pPr>
               <a:buNone/>
-              <a:defRPr sz="2175" b="1">
+              <a:defRPr sz="2100" b="1">
                 <a:solidFill>
                   <a:srgbClr val="0F52BA"/>
                 </a:solidFill>
@@ -8031,7 +7996,7 @@
               </a:defRPr>
             </a:pPr>
             <a:r>
-              <a:rPr sz="2175" b="1">
+              <a:rPr sz="2100" b="1">
                 <a:solidFill>
                   <a:srgbClr val="0F52BA"/>
                 </a:solidFill>
@@ -8039,7 +8004,7 @@
                 <a:ea typeface="Apple SD Gothic Neo"/>
                 <a:cs typeface="Apple SD Gothic Neo"/>
               </a:rPr>
-              <a:t>공개 원고의 실제 검토 결과</a:t>
+              <a:t>키워드로 만든 이야기의 관계도</a:t>
             </a:r>
           </a:p>
         </p:txBody>
@@ -8060,8 +8025,8 @@
         </p:nvSpPr>
         <p:spPr>
           <a:xfrm xmlns:a="http://schemas.openxmlformats.org/drawingml/2006/main">
-            <a:off x="609600" y="2000250"/>
-            <a:ext cx="5048250" cy="1028700"/>
+            <a:off x="609600" y="1943100"/>
+            <a:ext cx="5238750" cy="428625"/>
           </a:xfrm>
           <a:prstGeom xmlns:a="http://schemas.openxmlformats.org/drawingml/2006/main" prst="rect">
             <a:avLst/>
@@ -8075,7 +8040,7 @@
           <a:bodyPr xmlns:a="http://schemas.openxmlformats.org/drawingml/2006/main" lIns="0" tIns="0" rIns="0" bIns="0"/>
           <a:lstStyle xmlns:a="http://schemas.openxmlformats.org/drawingml/2006/main">
             <a:defPPr>
-              <a:defRPr sz="2625" b="1">
+              <a:defRPr sz="2175" b="1">
                 <a:solidFill>
                   <a:srgbClr val="000926"/>
                 </a:solidFill>
@@ -8187,7 +8152,7 @@
           <a:p xmlns:a="http://schemas.openxmlformats.org/drawingml/2006/main">
             <a:pPr>
               <a:buNone/>
-              <a:defRPr sz="2625" b="1">
+              <a:defRPr sz="2175" b="1">
                 <a:solidFill>
                   <a:srgbClr val="000926"/>
                 </a:solidFill>
@@ -8197,7 +8162,7 @@
               </a:defRPr>
             </a:pPr>
             <a:r>
-              <a:rPr sz="2625" b="1">
+              <a:rPr sz="2175" b="1">
                 <a:solidFill>
                   <a:srgbClr val="000926"/>
                 </a:solidFill>
@@ -8205,31 +8170,7 @@
                 <a:ea typeface="Apple SD Gothic Neo"/>
                 <a:cs typeface="Apple SD Gothic Neo"/>
               </a:rPr>
-              <a:t>하나뿐인 열쇠</a:t>
-            </a:r>
-          </a:p>
-          <a:p xmlns:a="http://schemas.openxmlformats.org/drawingml/2006/main">
-            <a:pPr>
-              <a:buNone/>
-              <a:defRPr sz="2625" b="1">
-                <a:solidFill>
-                  <a:srgbClr val="000926"/>
-                </a:solidFill>
-                <a:latin typeface="Apple SD Gothic Neo"/>
-                <a:ea typeface="Apple SD Gothic Neo"/>
-                <a:cs typeface="Apple SD Gothic Neo"/>
-              </a:defRPr>
-            </a:pPr>
-            <a:r>
-              <a:rPr sz="2625" b="1">
-                <a:solidFill>
-                  <a:srgbClr val="000926"/>
-                </a:solidFill>
-                <a:latin typeface="Apple SD Gothic Neo"/>
-                <a:ea typeface="Apple SD Gothic Neo"/>
-                <a:cs typeface="Apple SD Gothic Neo"/>
-              </a:rPr>
-              <a:t>같은 정오, 서로 다른 두 장소</a:t>
+              <a:t>폭풍 도시의 마지막 배달</a:t>
             </a:r>
           </a:p>
         </p:txBody>
@@ -8250,8 +8191,8 @@
         </p:nvSpPr>
         <p:spPr>
           <a:xfrm xmlns:a="http://schemas.openxmlformats.org/drawingml/2006/main">
-            <a:off x="609600" y="3286125"/>
-            <a:ext cx="5048250" cy="952500"/>
+            <a:off x="609600" y="4381500"/>
+            <a:ext cx="5238750" cy="790575"/>
           </a:xfrm>
           <a:prstGeom xmlns:a="http://schemas.openxmlformats.org/drawingml/2006/main" prst="rect">
             <a:avLst/>
@@ -8265,7 +8206,7 @@
           <a:bodyPr xmlns:a="http://schemas.openxmlformats.org/drawingml/2006/main" lIns="0" tIns="0" rIns="0" bIns="0"/>
           <a:lstStyle xmlns:a="http://schemas.openxmlformats.org/drawingml/2006/main">
             <a:defPPr>
-              <a:defRPr sz="2175" b="0">
+              <a:defRPr sz="1950" b="0">
                 <a:solidFill>
                   <a:srgbClr val="172B45"/>
                 </a:solidFill>
@@ -8377,7 +8318,7 @@
           <a:p xmlns:a="http://schemas.openxmlformats.org/drawingml/2006/main">
             <a:pPr>
               <a:buNone/>
-              <a:defRPr sz="2175" b="0">
+              <a:defRPr sz="1950" b="0">
                 <a:solidFill>
                   <a:srgbClr val="172B45"/>
                 </a:solidFill>
@@ -8387,7 +8328,7 @@
               </a:defRPr>
             </a:pPr>
             <a:r>
-              <a:rPr sz="2175" b="0">
+              <a:rPr sz="1950" b="0">
                 <a:solidFill>
                   <a:srgbClr val="172B45"/>
                 </a:solidFill>
@@ -8395,13 +8336,13 @@
                 <a:ea typeface="Apple SD Gothic Neo"/>
                 <a:cs typeface="Apple SD Gothic Neo"/>
               </a:rPr>
-              <a:t>내부 모순 1건을 제시하고</a:t>
+              <a:t>수정본의 인물·장소·사건을 연결</a:t>
             </a:r>
           </a:p>
           <a:p xmlns:a="http://schemas.openxmlformats.org/drawingml/2006/main">
             <a:pPr>
               <a:buNone/>
-              <a:defRPr sz="2175" b="0">
+              <a:defRPr sz="1950" b="0">
                 <a:solidFill>
                   <a:srgbClr val="172B45"/>
                 </a:solidFill>
@@ -8411,7 +8352,7 @@
               </a:defRPr>
             </a:pPr>
             <a:r>
-              <a:rPr sz="2175" b="0">
+              <a:rPr sz="1950" b="0">
                 <a:solidFill>
                   <a:srgbClr val="172B45"/>
                 </a:solidFill>
@@ -8419,7 +8360,7 @@
                 <a:ea typeface="Apple SD Gothic Neo"/>
                 <a:cs typeface="Apple SD Gothic Neo"/>
               </a:rPr>
-              <a:t>관련 문단 2곳으로 연결</a:t>
+              <a:t>본문과 같은 구조화 데이터 사용</a:t>
             </a:r>
           </a:p>
         </p:txBody>
@@ -8440,8 +8381,8 @@
         </p:nvSpPr>
         <p:spPr>
           <a:xfrm xmlns:a="http://schemas.openxmlformats.org/drawingml/2006/main">
-            <a:off x="609600" y="4619625"/>
-            <a:ext cx="5048250" cy="419100"/>
+            <a:off x="609600" y="5410200"/>
+            <a:ext cx="5143500" cy="381000"/>
           </a:xfrm>
           <a:prstGeom xmlns:a="http://schemas.openxmlformats.org/drawingml/2006/main" prst="rect">
             <a:avLst/>
@@ -8455,7 +8396,7 @@
           <a:bodyPr xmlns:a="http://schemas.openxmlformats.org/drawingml/2006/main" lIns="0" tIns="0" rIns="0" bIns="0"/>
           <a:lstStyle xmlns:a="http://schemas.openxmlformats.org/drawingml/2006/main">
             <a:defPPr>
-              <a:defRPr sz="2325" b="1">
+              <a:defRPr sz="2175" b="1">
                 <a:solidFill>
                   <a:srgbClr val="0F52BA"/>
                 </a:solidFill>
@@ -8567,7 +8508,7 @@
           <a:p xmlns:a="http://schemas.openxmlformats.org/drawingml/2006/main">
             <a:pPr>
               <a:buNone/>
-              <a:defRPr sz="2325" b="1">
+              <a:defRPr sz="2175" b="1">
                 <a:solidFill>
                   <a:srgbClr val="0F52BA"/>
                 </a:solidFill>
@@ -8577,7 +8518,7 @@
               </a:defRPr>
             </a:pPr>
             <a:r>
-              <a:rPr sz="2325" b="1">
+              <a:rPr sz="2175" b="1">
                 <a:solidFill>
                   <a:srgbClr val="0F52BA"/>
                 </a:solidFill>
@@ -8606,8 +8547,8 @@
         </p:nvSpPr>
         <p:spPr>
           <a:xfrm xmlns:a="http://schemas.openxmlformats.org/drawingml/2006/main">
-            <a:off x="609600" y="5153025"/>
-            <a:ext cx="5048250" cy="800100"/>
+            <a:off x="609600" y="5829300"/>
+            <a:ext cx="10953750" cy="333375"/>
           </a:xfrm>
           <a:prstGeom xmlns:a="http://schemas.openxmlformats.org/drawingml/2006/main" prst="rect">
             <a:avLst/>
@@ -8621,7 +8562,7 @@
           <a:bodyPr xmlns:a="http://schemas.openxmlformats.org/drawingml/2006/main" lIns="0" tIns="0" rIns="0" bIns="0"/>
           <a:lstStyle xmlns:a="http://schemas.openxmlformats.org/drawingml/2006/main">
             <a:defPPr>
-              <a:defRPr sz="1800" b="0">
+              <a:defRPr sz="1725" b="0">
                 <a:solidFill>
                   <a:srgbClr val="526A84"/>
                 </a:solidFill>
@@ -8733,7 +8674,7 @@
           <a:p xmlns:a="http://schemas.openxmlformats.org/drawingml/2006/main">
             <a:pPr>
               <a:buNone/>
-              <a:defRPr sz="1800" b="0">
+              <a:defRPr sz="1725" b="0">
                 <a:solidFill>
                   <a:srgbClr val="526A84"/>
                 </a:solidFill>
@@ -8743,7 +8684,7 @@
               </a:defRPr>
             </a:pPr>
             <a:r>
-              <a:rPr sz="1800" b="0">
+              <a:rPr sz="1725" b="0">
                 <a:solidFill>
                   <a:srgbClr val="526A84"/>
                 </a:solidFill>
@@ -8751,31 +8692,7 @@
                 <a:ea typeface="Apple SD Gothic Neo"/>
                 <a:cs typeface="Apple SD Gothic Neo"/>
               </a:rPr>
-              <a:t>정상 예외 6건과 실제 문제 4건</a:t>
-            </a:r>
-          </a:p>
-          <a:p xmlns:a="http://schemas.openxmlformats.org/drawingml/2006/main">
-            <a:pPr>
-              <a:buNone/>
-              <a:defRPr sz="1800" b="0">
-                <a:solidFill>
-                  <a:srgbClr val="526A84"/>
-                </a:solidFill>
-                <a:latin typeface="Apple SD Gothic Neo"/>
-                <a:ea typeface="Apple SD Gothic Neo"/>
-                <a:cs typeface="Apple SD Gothic Neo"/>
-              </a:defRPr>
-            </a:pPr>
-            <a:r>
-              <a:rPr sz="1800" b="0">
-                <a:solidFill>
-                  <a:srgbClr val="526A84"/>
-                </a:solidFill>
-                <a:latin typeface="Apple SD Gothic Neo"/>
-                <a:ea typeface="Apple SD Gothic Neo"/>
-                <a:cs typeface="Apple SD Gothic Neo"/>
-              </a:rPr>
-              <a:t>소규모 회귀 검사이며 일반 정확도는 아님</a:t>
+              <a:t>정상 6건·실제 문제 4건 / 일반 정확도 아님</a:t>
             </a:r>
           </a:p>
         </p:txBody>
@@ -8785,7 +8702,7 @@
           <p:cNvPr id="9" name="">
             <a:extLst xmlns:a="http://schemas.openxmlformats.org/drawingml/2006/main">
               <a:ext uri="{FF2B5EF4-FFF2-40B4-BE49-F238E27FC236}">
-                <a16:creationId xmlns:a16="http://schemas.microsoft.com/office/drawing/2014/main" id="{55B94A34-757F-49E7-83F1-7A00A571D6F4}"/>
+                <a16:creationId xmlns:a16="http://schemas.microsoft.com/office/drawing/2014/main" id="{FD697D05-19E1-4124-BD64-810CBED541DC}"/>
               </a:ext>
             </a:extLst>
           </p:cNvPr>
@@ -8795,14 +8712,199 @@
           <p:nvPr/>
         </p:nvPicPr>
         <p:blipFill>
-          <a:blip xmlns:r="http://schemas.openxmlformats.org/officeDocument/2006/relationships" xmlns:a="http://schemas.openxmlformats.org/drawingml/2006/main" r:embed="R88ec5710520948ec"/>
-          <a:srcRect xmlns:a="http://schemas.openxmlformats.org/drawingml/2006/main" l="24000" t="26000" r="25000" b="24000"/>
+          <a:blip xmlns:r="http://schemas.openxmlformats.org/officeDocument/2006/relationships" xmlns:a="http://schemas.openxmlformats.org/drawingml/2006/main" r:embed="R8014c74caf4f44c4"/>
+          <a:srcRect xmlns:a="http://schemas.openxmlformats.org/drawingml/2006/main" l="24500" t="32000" r="25000" b="22000"/>
           <a:stretch xmlns:a="http://schemas.openxmlformats.org/drawingml/2006/main"/>
         </p:blipFill>
         <p:spPr>
           <a:xfrm xmlns:a="http://schemas.openxmlformats.org/drawingml/2006/main">
-            <a:off x="6000750" y="1381125"/>
-            <a:ext cx="5572125" cy="4667250"/>
+            <a:off x="6048375" y="1905000"/>
+            <a:ext cx="5524500" cy="3714750"/>
+          </a:xfrm>
+          <a:prstGeom xmlns:a="http://schemas.openxmlformats.org/drawingml/2006/main" prst="rect">
+            <a:avLst/>
+          </a:prstGeom>
+        </p:spPr>
+      </p:pic>
+      <p:sp>
+        <p:nvSpPr>
+          <p:cNvPr id="11" name="">
+            <a:extLst xmlns:a="http://schemas.openxmlformats.org/drawingml/2006/main">
+              <a:ext uri="{FF2B5EF4-FFF2-40B4-BE49-F238E27FC236}">
+                <a16:creationId xmlns:a16="http://schemas.microsoft.com/office/drawing/2014/main" id="{204F852C-6B6F-4060-890D-D73FC665E74E}"/>
+              </a:ext>
+            </a:extLst>
+          </p:cNvPr>
+          <p:cNvSpPr>
+            <a:spLocks xmlns:a="http://schemas.openxmlformats.org/drawingml/2006/main" noGrp="1"/>
+          </p:cNvSpPr>
+          <p:nvPr/>
+        </p:nvSpPr>
+        <p:spPr>
+          <a:xfrm xmlns:a="http://schemas.openxmlformats.org/drawingml/2006/main">
+            <a:off x="6048375" y="1362075"/>
+            <a:ext cx="5619750" cy="428625"/>
+          </a:xfrm>
+          <a:prstGeom xmlns:a="http://schemas.openxmlformats.org/drawingml/2006/main" prst="rect">
+            <a:avLst/>
+          </a:prstGeom>
+          <a:noFill xmlns:a="http://schemas.openxmlformats.org/drawingml/2006/main"/>
+          <a:ln xmlns:a="http://schemas.openxmlformats.org/drawingml/2006/main" w="0">
+            <a:noFill/>
+          </a:ln>
+        </p:spPr>
+        <p:txBody>
+          <a:bodyPr xmlns:a="http://schemas.openxmlformats.org/drawingml/2006/main" lIns="0" tIns="0" rIns="0" bIns="0"/>
+          <a:lstStyle xmlns:a="http://schemas.openxmlformats.org/drawingml/2006/main">
+            <a:defPPr>
+              <a:defRPr sz="2100" b="1">
+                <a:solidFill>
+                  <a:srgbClr val="0F52BA"/>
+                </a:solidFill>
+                <a:latin typeface="Apple SD Gothic Neo"/>
+                <a:ea typeface="Apple SD Gothic Neo"/>
+                <a:cs typeface="Apple SD Gothic Neo"/>
+              </a:defRPr>
+            </a:defPPr>
+            <a:lvl1pPr>
+              <a:defRPr sz="2100" b="1">
+                <a:solidFill>
+                  <a:srgbClr val="0F52BA"/>
+                </a:solidFill>
+                <a:latin typeface="Apple SD Gothic Neo"/>
+                <a:ea typeface="Apple SD Gothic Neo"/>
+                <a:cs typeface="Apple SD Gothic Neo"/>
+              </a:defRPr>
+            </a:lvl1pPr>
+            <a:lvl2pPr>
+              <a:defRPr sz="2100" b="1">
+                <a:solidFill>
+                  <a:srgbClr val="0F52BA"/>
+                </a:solidFill>
+                <a:latin typeface="Apple SD Gothic Neo"/>
+                <a:ea typeface="Apple SD Gothic Neo"/>
+                <a:cs typeface="Apple SD Gothic Neo"/>
+              </a:defRPr>
+            </a:lvl2pPr>
+            <a:lvl3pPr>
+              <a:defRPr sz="2100" b="1">
+                <a:solidFill>
+                  <a:srgbClr val="0F52BA"/>
+                </a:solidFill>
+                <a:latin typeface="Apple SD Gothic Neo"/>
+                <a:ea typeface="Apple SD Gothic Neo"/>
+                <a:cs typeface="Apple SD Gothic Neo"/>
+              </a:defRPr>
+            </a:lvl3pPr>
+            <a:lvl4pPr>
+              <a:defRPr sz="2100" b="1">
+                <a:solidFill>
+                  <a:srgbClr val="0F52BA"/>
+                </a:solidFill>
+                <a:latin typeface="Apple SD Gothic Neo"/>
+                <a:ea typeface="Apple SD Gothic Neo"/>
+                <a:cs typeface="Apple SD Gothic Neo"/>
+              </a:defRPr>
+            </a:lvl4pPr>
+            <a:lvl5pPr>
+              <a:defRPr sz="2100" b="1">
+                <a:solidFill>
+                  <a:srgbClr val="0F52BA"/>
+                </a:solidFill>
+                <a:latin typeface="Apple SD Gothic Neo"/>
+                <a:ea typeface="Apple SD Gothic Neo"/>
+                <a:cs typeface="Apple SD Gothic Neo"/>
+              </a:defRPr>
+            </a:lvl5pPr>
+            <a:lvl6pPr>
+              <a:defRPr sz="2100" b="1">
+                <a:solidFill>
+                  <a:srgbClr val="0F52BA"/>
+                </a:solidFill>
+                <a:latin typeface="Apple SD Gothic Neo"/>
+                <a:ea typeface="Apple SD Gothic Neo"/>
+                <a:cs typeface="Apple SD Gothic Neo"/>
+              </a:defRPr>
+            </a:lvl6pPr>
+            <a:lvl7pPr>
+              <a:defRPr sz="2100" b="1">
+                <a:solidFill>
+                  <a:srgbClr val="0F52BA"/>
+                </a:solidFill>
+                <a:latin typeface="Apple SD Gothic Neo"/>
+                <a:ea typeface="Apple SD Gothic Neo"/>
+                <a:cs typeface="Apple SD Gothic Neo"/>
+              </a:defRPr>
+            </a:lvl7pPr>
+            <a:lvl8pPr>
+              <a:defRPr sz="2100" b="1">
+                <a:solidFill>
+                  <a:srgbClr val="0F52BA"/>
+                </a:solidFill>
+                <a:latin typeface="Apple SD Gothic Neo"/>
+                <a:ea typeface="Apple SD Gothic Neo"/>
+                <a:cs typeface="Apple SD Gothic Neo"/>
+              </a:defRPr>
+            </a:lvl8pPr>
+            <a:lvl9pPr>
+              <a:defRPr sz="2100" b="1">
+                <a:solidFill>
+                  <a:srgbClr val="0F52BA"/>
+                </a:solidFill>
+                <a:latin typeface="Apple SD Gothic Neo"/>
+                <a:ea typeface="Apple SD Gothic Neo"/>
+                <a:cs typeface="Apple SD Gothic Neo"/>
+              </a:defRPr>
+            </a:lvl9pPr>
+          </a:lstStyle>
+          <a:p xmlns:a="http://schemas.openxmlformats.org/drawingml/2006/main">
+            <a:pPr>
+              <a:defRPr sz="2100" b="1">
+                <a:solidFill>
+                  <a:srgbClr val="0F52BA"/>
+                </a:solidFill>
+                <a:latin typeface="Apple SD Gothic Neo"/>
+                <a:ea typeface="Apple SD Gothic Neo"/>
+                <a:cs typeface="Apple SD Gothic Neo"/>
+              </a:defRPr>
+            </a:pPr>
+            <a:r>
+              <a:rPr sz="2100" b="1">
+                <a:solidFill>
+                  <a:srgbClr val="0F52BA"/>
+                </a:solidFill>
+                <a:latin typeface="Apple SD Gothic Neo"/>
+                <a:ea typeface="Apple SD Gothic Neo"/>
+                <a:cs typeface="Apple SD Gothic Neo"/>
+              </a:rPr>
+              <a:t>원문 검토: 모순 1건과 근거 2문단</a:t>
+            </a:r>
+          </a:p>
+        </p:txBody>
+      </p:sp>
+      <p:pic>
+        <p:nvPicPr>
+          <p:cNvPr id="12" name="">
+            <a:extLst xmlns:a="http://schemas.openxmlformats.org/drawingml/2006/main">
+              <a:ext uri="{FF2B5EF4-FFF2-40B4-BE49-F238E27FC236}">
+                <a16:creationId xmlns:a16="http://schemas.microsoft.com/office/drawing/2014/main" id="{4BF91EB4-C6AE-4F47-9A21-B0628A948923}"/>
+              </a:ext>
+            </a:extLst>
+          </p:cNvPr>
+          <p:cNvPicPr>
+            <a:picLocks xmlns:a="http://schemas.openxmlformats.org/drawingml/2006/main" noChangeAspect="1"/>
+          </p:cNvPicPr>
+          <p:nvPr/>
+        </p:nvPicPr>
+        <p:blipFill>
+          <a:blip xmlns:r="http://schemas.openxmlformats.org/officeDocument/2006/relationships" xmlns:a="http://schemas.openxmlformats.org/drawingml/2006/main" r:embed="R73f51b7280384f2f"/>
+          <a:srcRect xmlns:a="http://schemas.openxmlformats.org/drawingml/2006/main" l="2700" t="39500" r="3200" b="20500"/>
+          <a:stretch xmlns:a="http://schemas.openxmlformats.org/drawingml/2006/main"/>
+        </p:blipFill>
+        <p:spPr>
+          <a:xfrm xmlns:a="http://schemas.openxmlformats.org/drawingml/2006/main">
+            <a:off x="609600" y="2524125"/>
+            <a:ext cx="5238750" cy="1666875"/>
           </a:xfrm>
           <a:prstGeom xmlns:a="http://schemas.openxmlformats.org/drawingml/2006/main" prst="rect">
             <a:avLst/>
@@ -8843,7 +8945,7 @@
           <p:cNvPr id="12" name="">
             <a:extLst xmlns:a="http://schemas.openxmlformats.org/drawingml/2006/main">
               <a:ext uri="{FF2B5EF4-FFF2-40B4-BE49-F238E27FC236}">
-                <a16:creationId xmlns:a16="http://schemas.microsoft.com/office/drawing/2014/main" id="{6903A1D6-47D0-4803-84EC-CE206F345A42}"/>
+                <a16:creationId xmlns:a16="http://schemas.microsoft.com/office/drawing/2014/main" id="{67F69969-E50C-4CD6-ACC8-0AE12129F3D9}"/>
               </a:ext>
             </a:extLst>
           </p:cNvPr>
@@ -8874,7 +8976,7 @@
           <p:cNvPr id="11" name="">
             <a:extLst xmlns:a="http://schemas.openxmlformats.org/drawingml/2006/main">
               <a:ext uri="{FF2B5EF4-FFF2-40B4-BE49-F238E27FC236}">
-                <a16:creationId xmlns:a16="http://schemas.microsoft.com/office/drawing/2014/main" id="{8441AB48-23EF-401C-B669-F29B809AA844}"/>
+                <a16:creationId xmlns:a16="http://schemas.microsoft.com/office/drawing/2014/main" id="{E7001E22-D221-467E-B917-BAF9AA5AF7F5}"/>
               </a:ext>
             </a:extLst>
           </p:cNvPr>
@@ -8905,7 +9007,7 @@
           <p:cNvPr id="10" name="">
             <a:extLst xmlns:a="http://schemas.openxmlformats.org/drawingml/2006/main">
               <a:ext uri="{FF2B5EF4-FFF2-40B4-BE49-F238E27FC236}">
-                <a16:creationId xmlns:a16="http://schemas.microsoft.com/office/drawing/2014/main" id="{6DEEB057-4E0B-43F9-80BD-5D58E4C4DBC7}"/>
+                <a16:creationId xmlns:a16="http://schemas.microsoft.com/office/drawing/2014/main" id="{F1A33267-BC34-44CD-9D16-487283C195B2}"/>
               </a:ext>
             </a:extLst>
           </p:cNvPr>
@@ -8936,7 +9038,7 @@
           <p:cNvPr id="9" name="">
             <a:extLst xmlns:a="http://schemas.openxmlformats.org/drawingml/2006/main">
               <a:ext uri="{FF2B5EF4-FFF2-40B4-BE49-F238E27FC236}">
-                <a16:creationId xmlns:a16="http://schemas.microsoft.com/office/drawing/2014/main" id="{155861BC-F85F-4096-8998-4F1042AF56F9}"/>
+                <a16:creationId xmlns:a16="http://schemas.microsoft.com/office/drawing/2014/main" id="{2305999E-62EB-493D-AF6E-7C304FB4BF69}"/>
               </a:ext>
             </a:extLst>
           </p:cNvPr>
@@ -10820,8 +10922,8 @@
         </p:nvSpPr>
         <p:spPr>
           <a:xfrm xmlns:a="http://schemas.openxmlformats.org/drawingml/2006/main">
-            <a:off x="6038850" y="1857375"/>
-            <a:ext cx="5524500" cy="314325"/>
+            <a:off x="5762625" y="1790700"/>
+            <a:ext cx="5905500" cy="314325"/>
           </a:xfrm>
           <a:prstGeom xmlns:a="http://schemas.openxmlformats.org/drawingml/2006/main" prst="rect">
             <a:avLst/>
@@ -10835,7 +10937,7 @@
           <a:bodyPr xmlns:a="http://schemas.openxmlformats.org/drawingml/2006/main" lIns="0" tIns="0" rIns="0" bIns="0"/>
           <a:lstStyle xmlns:a="http://schemas.openxmlformats.org/drawingml/2006/main">
             <a:defPPr>
-              <a:defRPr sz="1575" b="0">
+              <a:defRPr sz="1500" b="0">
                 <a:solidFill>
                   <a:srgbClr val="526A84"/>
                 </a:solidFill>
@@ -10947,7 +11049,7 @@
           <a:p xmlns:a="http://schemas.openxmlformats.org/drawingml/2006/main">
             <a:pPr>
               <a:buNone/>
-              <a:defRPr sz="1575" b="0">
+              <a:defRPr sz="1500" b="0">
                 <a:solidFill>
                   <a:srgbClr val="526A84"/>
                 </a:solidFill>
@@ -10957,7 +11059,7 @@
               </a:defRPr>
             </a:pPr>
             <a:r>
-              <a:rPr sz="1575" b="0">
+              <a:rPr sz="1500" b="0">
                 <a:solidFill>
                   <a:srgbClr val="526A84"/>
                 </a:solidFill>
@@ -10965,7 +11067,7 @@
                 <a:ea typeface="Apple SD Gothic Neo"/>
                 <a:cs typeface="Apple SD Gothic Neo"/>
               </a:rPr>
-              <a:t>backend/workflow.py:86–95  발췌</a:t>
+              <a:t>backend/workflow.py:73  조건식 발췌·줄바꿈</a:t>
             </a:r>
           </a:p>
         </p:txBody>
@@ -10986,8 +11088,8 @@
         </p:nvSpPr>
         <p:spPr>
           <a:xfrm xmlns:a="http://schemas.openxmlformats.org/drawingml/2006/main">
-            <a:off x="6038850" y="2333625"/>
-            <a:ext cx="5619750" cy="2952750"/>
+            <a:off x="5762625" y="2219325"/>
+            <a:ext cx="5905500" cy="2667000"/>
           </a:xfrm>
           <a:prstGeom xmlns:a="http://schemas.openxmlformats.org/drawingml/2006/main" prst="rect">
             <a:avLst/>
@@ -11001,7 +11103,7 @@
           <a:bodyPr xmlns:a="http://schemas.openxmlformats.org/drawingml/2006/main" lIns="0" tIns="0" rIns="0" bIns="0"/>
           <a:lstStyle xmlns:a="http://schemas.openxmlformats.org/drawingml/2006/main">
             <a:defPPr>
-              <a:defRPr sz="1650" b="0">
+              <a:defRPr sz="1500" b="0">
                 <a:solidFill>
                   <a:srgbClr val="172B45"/>
                 </a:solidFill>
@@ -11113,7 +11215,7 @@
           <a:p xmlns:a="http://schemas.openxmlformats.org/drawingml/2006/main">
             <a:pPr>
               <a:buNone/>
-              <a:defRPr sz="1650" b="0">
+              <a:defRPr sz="1500" b="0">
                 <a:solidFill>
                   <a:srgbClr val="172B45"/>
                 </a:solidFill>
@@ -11123,7 +11225,7 @@
               </a:defRPr>
             </a:pPr>
             <a:r>
-              <a:rPr sz="1650" b="0">
+              <a:rPr sz="1500" b="0">
                 <a:solidFill>
                   <a:srgbClr val="172B45"/>
                 </a:solidFill>
@@ -11131,13 +11233,13 @@
                 <a:ea typeface="Menlo"/>
                 <a:cs typeface="Menlo"/>
               </a:rPr>
-              <a:t>graph = StateGraph(State)</a:t>
+              <a:t>choice = "revise" if (</a:t>
             </a:r>
           </a:p>
           <a:p xmlns:a="http://schemas.openxmlformats.org/drawingml/2006/main">
             <a:pPr>
               <a:buNone/>
-              <a:defRPr sz="1650" b="0">
+              <a:defRPr sz="1500" b="0">
                 <a:solidFill>
                   <a:srgbClr val="172B45"/>
                 </a:solidFill>
@@ -11147,7 +11249,7 @@
               </a:defRPr>
             </a:pPr>
             <a:r>
-              <a:rPr sz="1650" b="0">
+              <a:rPr sz="1500" b="0">
                 <a:solidFill>
                   <a:srgbClr val="172B45"/>
                 </a:solidFill>
@@ -11155,13 +11257,13 @@
                 <a:ea typeface="Menlo"/>
                 <a:cs typeface="Menlo"/>
               </a:rPr>
-              <a:t>graph.add_node("generate", generate)</a:t>
+              <a:t>    run.get("mode", "create") != "review"</a:t>
             </a:r>
           </a:p>
           <a:p xmlns:a="http://schemas.openxmlformats.org/drawingml/2006/main">
             <a:pPr>
               <a:buNone/>
-              <a:defRPr sz="1650" b="0">
+              <a:defRPr sz="1500" b="0">
                 <a:solidFill>
                   <a:srgbClr val="172B45"/>
                 </a:solidFill>
@@ -11171,7 +11273,7 @@
               </a:defRPr>
             </a:pPr>
             <a:r>
-              <a:rPr sz="1650" b="0">
+              <a:rPr sz="1500" b="0">
                 <a:solidFill>
                   <a:srgbClr val="172B45"/>
                 </a:solidFill>
@@ -11179,13 +11281,13 @@
                 <a:ea typeface="Menlo"/>
                 <a:cs typeface="Menlo"/>
               </a:rPr>
-              <a:t>graph.add_node("review", inspect)</a:t>
+              <a:t>    and not run["revision"]</a:t>
             </a:r>
           </a:p>
           <a:p xmlns:a="http://schemas.openxmlformats.org/drawingml/2006/main">
             <a:pPr>
               <a:buNone/>
-              <a:defRPr sz="1650" b="0">
+              <a:defRPr sz="1500" b="0">
                 <a:solidFill>
                   <a:srgbClr val="172B45"/>
                 </a:solidFill>
@@ -11195,7 +11297,7 @@
               </a:defRPr>
             </a:pPr>
             <a:r>
-              <a:rPr sz="1650" b="0">
+              <a:rPr sz="1500" b="0">
                 <a:solidFill>
                   <a:srgbClr val="172B45"/>
                 </a:solidFill>
@@ -11203,13 +11305,13 @@
                 <a:ea typeface="Menlo"/>
                 <a:cs typeface="Menlo"/>
               </a:rPr>
-              <a:t>graph.add_node("revise", revise)</a:t>
+              <a:t>    and any(</a:t>
             </a:r>
           </a:p>
           <a:p xmlns:a="http://schemas.openxmlformats.org/drawingml/2006/main">
             <a:pPr>
               <a:buNone/>
-              <a:defRPr sz="1650" b="0">
+              <a:defRPr sz="1500" b="0">
                 <a:solidFill>
                   <a:srgbClr val="172B45"/>
                 </a:solidFill>
@@ -11219,7 +11321,7 @@
               </a:defRPr>
             </a:pPr>
             <a:r>
-              <a:rPr sz="1650" b="0">
+              <a:rPr sz="1500" b="0">
                 <a:solidFill>
                   <a:srgbClr val="172B45"/>
                 </a:solidFill>
@@ -11227,13 +11329,13 @@
                 <a:ea typeface="Menlo"/>
                 <a:cs typeface="Menlo"/>
               </a:rPr>
-              <a:t>graph.add_conditional_edges(</a:t>
+              <a:t>        i["status"] == "open"</a:t>
             </a:r>
           </a:p>
           <a:p xmlns:a="http://schemas.openxmlformats.org/drawingml/2006/main">
             <a:pPr>
               <a:buNone/>
-              <a:defRPr sz="1650" b="0">
+              <a:defRPr sz="1500" b="0">
                 <a:solidFill>
                   <a:srgbClr val="172B45"/>
                 </a:solidFill>
@@ -11243,7 +11345,7 @@
               </a:defRPr>
             </a:pPr>
             <a:r>
-              <a:rPr sz="1650" b="0">
+              <a:rPr sz="1500" b="0">
                 <a:solidFill>
                   <a:srgbClr val="172B45"/>
                 </a:solidFill>
@@ -11251,13 +11353,13 @@
                 <a:ea typeface="Menlo"/>
                 <a:cs typeface="Menlo"/>
               </a:rPr>
-              <a:t>    "review", route,</a:t>
+              <a:t>        and i["kind"] != "intent_question"</a:t>
             </a:r>
           </a:p>
           <a:p xmlns:a="http://schemas.openxmlformats.org/drawingml/2006/main">
             <a:pPr>
               <a:buNone/>
-              <a:defRPr sz="1650" b="0">
+              <a:defRPr sz="1500" b="0">
                 <a:solidFill>
                   <a:srgbClr val="172B45"/>
                 </a:solidFill>
@@ -11267,7 +11369,7 @@
               </a:defRPr>
             </a:pPr>
             <a:r>
-              <a:rPr sz="1650" b="0">
+              <a:rPr sz="1500" b="0">
                 <a:solidFill>
                   <a:srgbClr val="172B45"/>
                 </a:solidFill>
@@ -11275,13 +11377,13 @@
                 <a:ea typeface="Menlo"/>
                 <a:cs typeface="Menlo"/>
               </a:rPr>
-              <a:t>    {"revise": "revise",</a:t>
+              <a:t>        for i in run["reviews"][-1]["issues"]</a:t>
             </a:r>
           </a:p>
           <a:p xmlns:a="http://schemas.openxmlformats.org/drawingml/2006/main">
             <a:pPr>
               <a:buNone/>
-              <a:defRPr sz="1650" b="0">
+              <a:defRPr sz="1500" b="0">
                 <a:solidFill>
                   <a:srgbClr val="172B45"/>
                 </a:solidFill>
@@ -11291,7 +11393,7 @@
               </a:defRPr>
             </a:pPr>
             <a:r>
-              <a:rPr sz="1650" b="0">
+              <a:rPr sz="1500" b="0">
                 <a:solidFill>
                   <a:srgbClr val="172B45"/>
                 </a:solidFill>
@@ -11299,13 +11401,13 @@
                 <a:ea typeface="Menlo"/>
                 <a:cs typeface="Menlo"/>
               </a:rPr>
-              <a:t>     "finish": "finish"})</a:t>
+              <a:t>    )</a:t>
             </a:r>
           </a:p>
           <a:p xmlns:a="http://schemas.openxmlformats.org/drawingml/2006/main">
             <a:pPr>
               <a:buNone/>
-              <a:defRPr sz="1650" b="0">
+              <a:defRPr sz="1500" b="0">
                 <a:solidFill>
                   <a:srgbClr val="172B45"/>
                 </a:solidFill>
@@ -11315,7 +11417,7 @@
               </a:defRPr>
             </a:pPr>
             <a:r>
-              <a:rPr sz="1650" b="0">
+              <a:rPr sz="1500" b="0">
                 <a:solidFill>
                   <a:srgbClr val="172B45"/>
                 </a:solidFill>
@@ -11323,7 +11425,7 @@
                 <a:ea typeface="Menlo"/>
                 <a:cs typeface="Menlo"/>
               </a:rPr>
-              <a:t>graph.add_edge("revise", "review")</a:t>
+              <a:t>) else "finish"</a:t>
             </a:r>
           </a:p>
         </p:txBody>
@@ -11344,8 +11446,8 @@
         </p:nvSpPr>
         <p:spPr>
           <a:xfrm xmlns:a="http://schemas.openxmlformats.org/drawingml/2006/main">
-            <a:off x="6038850" y="5448300"/>
-            <a:ext cx="5619750" cy="666750"/>
+            <a:off x="5762625" y="5619750"/>
+            <a:ext cx="5905500" cy="619125"/>
           </a:xfrm>
           <a:prstGeom xmlns:a="http://schemas.openxmlformats.org/drawingml/2006/main" prst="rect">
             <a:avLst/>
@@ -11489,7 +11591,7 @@
                 <a:ea typeface="Apple SD Gothic Neo"/>
                 <a:cs typeface="Apple SD Gothic Neo"/>
               </a:rPr>
-              <a:t>route()는 코드로 다음 단계를 결정</a:t>
+              <a:t>세 조건을 모두 만족할 때만 수정</a:t>
             </a:r>
           </a:p>
           <a:p xmlns:a="http://schemas.openxmlformats.org/drawingml/2006/main">
@@ -11514,6 +11616,208 @@
                 <a:cs typeface="Apple SD Gothic Neo"/>
               </a:rPr>
               <a:t>생성 정상 최대 5회 / 재시도 포함 최대 6회</a:t>
+            </a:r>
+          </a:p>
+        </p:txBody>
+      </p:sp>
+      <p:sp>
+        <p:nvSpPr>
+          <p:cNvPr id="20" name="">
+            <a:extLst xmlns:a="http://schemas.openxmlformats.org/drawingml/2006/main">
+              <a:ext uri="{FF2B5EF4-FFF2-40B4-BE49-F238E27FC236}">
+                <a16:creationId xmlns:a16="http://schemas.microsoft.com/office/drawing/2014/main" id="{7426EC16-2917-4780-9BD1-97D8A26D20C6}"/>
+              </a:ext>
+            </a:extLst>
+          </p:cNvPr>
+          <p:cNvSpPr>
+            <a:spLocks xmlns:a="http://schemas.openxmlformats.org/drawingml/2006/main" noGrp="1"/>
+          </p:cNvSpPr>
+          <p:nvPr/>
+        </p:nvSpPr>
+        <p:spPr>
+          <a:xfrm xmlns:a="http://schemas.openxmlformats.org/drawingml/2006/main">
+            <a:off x="5762625" y="4733925"/>
+            <a:ext cx="5905500" cy="762000"/>
+          </a:xfrm>
+          <a:prstGeom xmlns:a="http://schemas.openxmlformats.org/drawingml/2006/main" prst="rect">
+            <a:avLst/>
+          </a:prstGeom>
+          <a:noFill xmlns:a="http://schemas.openxmlformats.org/drawingml/2006/main"/>
+          <a:ln xmlns:a="http://schemas.openxmlformats.org/drawingml/2006/main" w="0">
+            <a:noFill/>
+          </a:ln>
+        </p:spPr>
+        <p:txBody>
+          <a:bodyPr xmlns:a="http://schemas.openxmlformats.org/drawingml/2006/main" lIns="0" tIns="0" rIns="0" bIns="0"/>
+          <a:lstStyle xmlns:a="http://schemas.openxmlformats.org/drawingml/2006/main">
+            <a:defPPr>
+              <a:defRPr sz="1425" b="0">
+                <a:solidFill>
+                  <a:srgbClr val="172B45"/>
+                </a:solidFill>
+                <a:latin typeface="Menlo"/>
+                <a:ea typeface="Menlo"/>
+                <a:cs typeface="Menlo"/>
+              </a:defRPr>
+            </a:defPPr>
+            <a:lvl1pPr>
+              <a:defRPr sz="1425" b="0">
+                <a:solidFill>
+                  <a:srgbClr val="172B45"/>
+                </a:solidFill>
+                <a:latin typeface="Menlo"/>
+                <a:ea typeface="Menlo"/>
+                <a:cs typeface="Menlo"/>
+              </a:defRPr>
+            </a:lvl1pPr>
+            <a:lvl2pPr>
+              <a:defRPr sz="1425" b="0">
+                <a:solidFill>
+                  <a:srgbClr val="172B45"/>
+                </a:solidFill>
+                <a:latin typeface="Menlo"/>
+                <a:ea typeface="Menlo"/>
+                <a:cs typeface="Menlo"/>
+              </a:defRPr>
+            </a:lvl2pPr>
+            <a:lvl3pPr>
+              <a:defRPr sz="1425" b="0">
+                <a:solidFill>
+                  <a:srgbClr val="172B45"/>
+                </a:solidFill>
+                <a:latin typeface="Menlo"/>
+                <a:ea typeface="Menlo"/>
+                <a:cs typeface="Menlo"/>
+              </a:defRPr>
+            </a:lvl3pPr>
+            <a:lvl4pPr>
+              <a:defRPr sz="1425" b="0">
+                <a:solidFill>
+                  <a:srgbClr val="172B45"/>
+                </a:solidFill>
+                <a:latin typeface="Menlo"/>
+                <a:ea typeface="Menlo"/>
+                <a:cs typeface="Menlo"/>
+              </a:defRPr>
+            </a:lvl4pPr>
+            <a:lvl5pPr>
+              <a:defRPr sz="1425" b="0">
+                <a:solidFill>
+                  <a:srgbClr val="172B45"/>
+                </a:solidFill>
+                <a:latin typeface="Menlo"/>
+                <a:ea typeface="Menlo"/>
+                <a:cs typeface="Menlo"/>
+              </a:defRPr>
+            </a:lvl5pPr>
+            <a:lvl6pPr>
+              <a:defRPr sz="1425" b="0">
+                <a:solidFill>
+                  <a:srgbClr val="172B45"/>
+                </a:solidFill>
+                <a:latin typeface="Menlo"/>
+                <a:ea typeface="Menlo"/>
+                <a:cs typeface="Menlo"/>
+              </a:defRPr>
+            </a:lvl6pPr>
+            <a:lvl7pPr>
+              <a:defRPr sz="1425" b="0">
+                <a:solidFill>
+                  <a:srgbClr val="172B45"/>
+                </a:solidFill>
+                <a:latin typeface="Menlo"/>
+                <a:ea typeface="Menlo"/>
+                <a:cs typeface="Menlo"/>
+              </a:defRPr>
+            </a:lvl7pPr>
+            <a:lvl8pPr>
+              <a:defRPr sz="1425" b="0">
+                <a:solidFill>
+                  <a:srgbClr val="172B45"/>
+                </a:solidFill>
+                <a:latin typeface="Menlo"/>
+                <a:ea typeface="Menlo"/>
+                <a:cs typeface="Menlo"/>
+              </a:defRPr>
+            </a:lvl8pPr>
+            <a:lvl9pPr>
+              <a:defRPr sz="1425" b="0">
+                <a:solidFill>
+                  <a:srgbClr val="172B45"/>
+                </a:solidFill>
+                <a:latin typeface="Menlo"/>
+                <a:ea typeface="Menlo"/>
+                <a:cs typeface="Menlo"/>
+              </a:defRPr>
+            </a:lvl9pPr>
+          </a:lstStyle>
+          <a:p xmlns:a="http://schemas.openxmlformats.org/drawingml/2006/main">
+            <a:pPr>
+              <a:defRPr sz="1425" b="0">
+                <a:solidFill>
+                  <a:srgbClr val="172B45"/>
+                </a:solidFill>
+                <a:latin typeface="Menlo"/>
+                <a:ea typeface="Menlo"/>
+                <a:cs typeface="Menlo"/>
+              </a:defRPr>
+            </a:pPr>
+            <a:r>
+              <a:rPr sz="1425" b="0">
+                <a:solidFill>
+                  <a:srgbClr val="172B45"/>
+                </a:solidFill>
+                <a:latin typeface="Menlo"/>
+                <a:ea typeface="Menlo"/>
+                <a:cs typeface="Menlo"/>
+              </a:rPr>
+              <a:t>graph.add_conditional_edges(</a:t>
+            </a:r>
+          </a:p>
+          <a:p xmlns:a="http://schemas.openxmlformats.org/drawingml/2006/main">
+            <a:pPr>
+              <a:defRPr sz="1425" b="0">
+                <a:solidFill>
+                  <a:srgbClr val="172B45"/>
+                </a:solidFill>
+                <a:latin typeface="Menlo"/>
+                <a:ea typeface="Menlo"/>
+                <a:cs typeface="Menlo"/>
+              </a:defRPr>
+            </a:pPr>
+            <a:r>
+              <a:rPr sz="1425" b="0">
+                <a:solidFill>
+                  <a:srgbClr val="172B45"/>
+                </a:solidFill>
+                <a:latin typeface="Menlo"/>
+                <a:ea typeface="Menlo"/>
+                <a:cs typeface="Menlo"/>
+              </a:rPr>
+              <a:t>    "review", route,</a:t>
+            </a:r>
+          </a:p>
+          <a:p xmlns:a="http://schemas.openxmlformats.org/drawingml/2006/main">
+            <a:pPr>
+              <a:defRPr sz="1425" b="0">
+                <a:solidFill>
+                  <a:srgbClr val="172B45"/>
+                </a:solidFill>
+                <a:latin typeface="Menlo"/>
+                <a:ea typeface="Menlo"/>
+                <a:cs typeface="Menlo"/>
+              </a:defRPr>
+            </a:pPr>
+            <a:r>
+              <a:rPr sz="1425" b="0">
+                <a:solidFill>
+                  <a:srgbClr val="172B45"/>
+                </a:solidFill>
+                <a:latin typeface="Menlo"/>
+                <a:ea typeface="Menlo"/>
+                <a:cs typeface="Menlo"/>
+              </a:rPr>
+              <a:t>    {"revise": "revise", "finish": "finish"})</a:t>
             </a:r>
           </a:p>
         </p:txBody>
@@ -14370,8 +14674,8 @@
         </p:nvSpPr>
         <p:spPr>
           <a:xfrm xmlns:a="http://schemas.openxmlformats.org/drawingml/2006/main">
-            <a:off x="609600" y="3905250"/>
-            <a:ext cx="5334000" cy="952500"/>
+            <a:off x="609600" y="3667125"/>
+            <a:ext cx="5334000" cy="1285875"/>
           </a:xfrm>
           <a:prstGeom xmlns:a="http://schemas.openxmlformats.org/drawingml/2006/main" prst="rect">
             <a:avLst/>
@@ -14385,7 +14689,7 @@
           <a:bodyPr xmlns:a="http://schemas.openxmlformats.org/drawingml/2006/main" lIns="0" tIns="0" rIns="0" bIns="0"/>
           <a:lstStyle xmlns:a="http://schemas.openxmlformats.org/drawingml/2006/main">
             <a:defPPr>
-              <a:defRPr sz="2175" b="0">
+              <a:defRPr sz="2100" b="0">
                 <a:solidFill>
                   <a:srgbClr val="172B45"/>
                 </a:solidFill>
@@ -14497,7 +14801,7 @@
           <a:p xmlns:a="http://schemas.openxmlformats.org/drawingml/2006/main">
             <a:pPr>
               <a:buNone/>
-              <a:defRPr sz="2175" b="0">
+              <a:defRPr sz="2100" b="0">
                 <a:solidFill>
                   <a:srgbClr val="172B45"/>
                 </a:solidFill>
@@ -14507,7 +14811,7 @@
               </a:defRPr>
             </a:pPr>
             <a:r>
-              <a:rPr sz="2175" b="0">
+              <a:rPr sz="2100" b="0">
                 <a:solidFill>
                   <a:srgbClr val="172B45"/>
                 </a:solidFill>
@@ -14515,13 +14819,13 @@
                 <a:ea typeface="Apple SD Gothic Neo"/>
                 <a:cs typeface="Apple SD Gothic Neo"/>
               </a:rPr>
-              <a:t>다른 문단에 있는 예외도</a:t>
+              <a:t>예외까지 함께 제공</a:t>
             </a:r>
           </a:p>
           <a:p xmlns:a="http://schemas.openxmlformats.org/drawingml/2006/main">
             <a:pPr>
               <a:buNone/>
-              <a:defRPr sz="2175" b="0">
+              <a:defRPr sz="2100" b="0">
                 <a:solidFill>
                   <a:srgbClr val="172B45"/>
                 </a:solidFill>
@@ -14531,7 +14835,7 @@
               </a:defRPr>
             </a:pPr>
             <a:r>
-              <a:rPr sz="2175" b="0">
+              <a:rPr sz="2100" b="0">
                 <a:solidFill>
                   <a:srgbClr val="172B45"/>
                 </a:solidFill>
@@ -14539,7 +14843,31 @@
                 <a:ea typeface="Apple SD Gothic Neo"/>
                 <a:cs typeface="Apple SD Gothic Neo"/>
               </a:rPr>
-              <a:t>검토 맥락에 포함하기 위한 선택</a:t>
+              <a:t>대신 입력 비용·지연이 늘고</a:t>
+            </a:r>
+          </a:p>
+          <a:p xmlns:a="http://schemas.openxmlformats.org/drawingml/2006/main">
+            <a:pPr>
+              <a:buNone/>
+              <a:defRPr sz="2100" b="0">
+                <a:solidFill>
+                  <a:srgbClr val="172B45"/>
+                </a:solidFill>
+                <a:latin typeface="Apple SD Gothic Neo"/>
+                <a:ea typeface="Apple SD Gothic Neo"/>
+                <a:cs typeface="Apple SD Gothic Neo"/>
+              </a:defRPr>
+            </a:pPr>
+            <a:r>
+              <a:rPr sz="2100" b="0">
+                <a:solidFill>
+                  <a:srgbClr val="172B45"/>
+                </a:solidFill>
+                <a:latin typeface="Apple SD Gothic Neo"/>
+                <a:ea typeface="Apple SD Gothic Neo"/>
+                <a:cs typeface="Apple SD Gothic Neo"/>
+              </a:rPr>
+              <a:t>긴 원고는 범위를 줄여야 함</a:t>
             </a:r>
           </a:p>
         </p:txBody>
@@ -15376,7 +15704,7 @@
                 <a:ea typeface="Apple SD Gothic Neo"/>
                 <a:cs typeface="Apple SD Gothic Neo"/>
               </a:rPr>
-              <a:t>검토 오탐 보완과 남은 한계</a:t>
+              <a:t>오탐 보완과 수정 상한의 한계</a:t>
             </a:r>
           </a:p>
         </p:txBody>
@@ -15895,8 +16223,8 @@
         </p:nvSpPr>
         <p:spPr>
           <a:xfrm xmlns:a="http://schemas.openxmlformats.org/drawingml/2006/main">
-            <a:off x="609600" y="2447925"/>
-            <a:ext cx="10763250" cy="381000"/>
+            <a:off x="609600" y="2047875"/>
+            <a:ext cx="10953750" cy="333375"/>
           </a:xfrm>
           <a:prstGeom xmlns:a="http://schemas.openxmlformats.org/drawingml/2006/main" prst="rect">
             <a:avLst/>
@@ -16061,8 +16389,8 @@
         </p:nvSpPr>
         <p:spPr>
           <a:xfrm xmlns:a="http://schemas.openxmlformats.org/drawingml/2006/main">
-            <a:off x="609600" y="3067050"/>
-            <a:ext cx="10858500" cy="1104900"/>
+            <a:off x="609600" y="2619375"/>
+            <a:ext cx="10953750" cy="857250"/>
           </a:xfrm>
           <a:prstGeom xmlns:a="http://schemas.openxmlformats.org/drawingml/2006/main" prst="rect">
             <a:avLst/>
@@ -16076,7 +16404,7 @@
           <a:bodyPr xmlns:a="http://schemas.openxmlformats.org/drawingml/2006/main" lIns="0" tIns="0" rIns="0" bIns="0"/>
           <a:lstStyle xmlns:a="http://schemas.openxmlformats.org/drawingml/2006/main">
             <a:defPPr>
-              <a:defRPr sz="2550" b="1">
+              <a:defRPr sz="2250" b="1">
                 <a:solidFill>
                   <a:srgbClr val="000926"/>
                 </a:solidFill>
@@ -16188,7 +16516,7 @@
           <a:p xmlns:a="http://schemas.openxmlformats.org/drawingml/2006/main">
             <a:pPr>
               <a:buNone/>
-              <a:defRPr sz="2550" b="1">
+              <a:defRPr sz="2250" b="1">
                 <a:solidFill>
                   <a:srgbClr val="000926"/>
                 </a:solidFill>
@@ -16198,7 +16526,7 @@
               </a:defRPr>
             </a:pPr>
             <a:r>
-              <a:rPr sz="2550" b="1">
+              <a:rPr sz="2250" b="1">
                 <a:solidFill>
                   <a:srgbClr val="000926"/>
                 </a:solidFill>
@@ -16212,7 +16540,7 @@
           <a:p xmlns:a="http://schemas.openxmlformats.org/drawingml/2006/main">
             <a:pPr>
               <a:buNone/>
-              <a:defRPr sz="2550" b="1">
+              <a:defRPr sz="2250" b="1">
                 <a:solidFill>
                   <a:srgbClr val="000926"/>
                 </a:solidFill>
@@ -16222,7 +16550,7 @@
               </a:defRPr>
             </a:pPr>
             <a:r>
-              <a:rPr sz="2550" b="1">
+              <a:rPr sz="2250" b="1">
                 <a:solidFill>
                   <a:srgbClr val="000926"/>
                 </a:solidFill>
@@ -16251,8 +16579,8 @@
         </p:nvSpPr>
         <p:spPr>
           <a:xfrm xmlns:a="http://schemas.openxmlformats.org/drawingml/2006/main">
-            <a:off x="609600" y="4552950"/>
-            <a:ext cx="10953750" cy="581025"/>
+            <a:off x="609600" y="3667125"/>
+            <a:ext cx="10953750" cy="400050"/>
           </a:xfrm>
           <a:prstGeom xmlns:a="http://schemas.openxmlformats.org/drawingml/2006/main" prst="rect">
             <a:avLst/>
@@ -16266,7 +16594,7 @@
           <a:bodyPr xmlns:a="http://schemas.openxmlformats.org/drawingml/2006/main" lIns="0" tIns="0" rIns="0" bIns="0"/>
           <a:lstStyle xmlns:a="http://schemas.openxmlformats.org/drawingml/2006/main">
             <a:defPPr>
-              <a:defRPr sz="2175" b="0">
+              <a:defRPr sz="2025" b="0">
                 <a:solidFill>
                   <a:srgbClr val="172B45"/>
                 </a:solidFill>
@@ -16378,7 +16706,7 @@
           <a:p xmlns:a="http://schemas.openxmlformats.org/drawingml/2006/main">
             <a:pPr>
               <a:buNone/>
-              <a:defRPr sz="2175" b="0">
+              <a:defRPr sz="2025" b="0">
                 <a:solidFill>
                   <a:srgbClr val="172B45"/>
                 </a:solidFill>
@@ -16388,7 +16716,7 @@
               </a:defRPr>
             </a:pPr>
             <a:r>
-              <a:rPr sz="2175" b="0">
+              <a:rPr sz="2025" b="0">
                 <a:solidFill>
                   <a:srgbClr val="172B45"/>
                 </a:solidFill>
@@ -16417,8 +16745,8 @@
         </p:nvSpPr>
         <p:spPr>
           <a:xfrm xmlns:a="http://schemas.openxmlformats.org/drawingml/2006/main">
-            <a:off x="609600" y="5524500"/>
-            <a:ext cx="10953750" cy="514350"/>
+            <a:off x="609600" y="5667375"/>
+            <a:ext cx="10953750" cy="381000"/>
           </a:xfrm>
           <a:prstGeom xmlns:a="http://schemas.openxmlformats.org/drawingml/2006/main" prst="rect">
             <a:avLst/>
@@ -16432,7 +16760,7 @@
           <a:bodyPr xmlns:a="http://schemas.openxmlformats.org/drawingml/2006/main" lIns="0" tIns="0" rIns="0" bIns="0"/>
           <a:lstStyle xmlns:a="http://schemas.openxmlformats.org/drawingml/2006/main">
             <a:defPPr>
-              <a:defRPr sz="2025" b="0">
+              <a:defRPr sz="1800" b="0">
                 <a:solidFill>
                   <a:srgbClr val="526A84"/>
                 </a:solidFill>
@@ -16544,7 +16872,7 @@
           <a:p xmlns:a="http://schemas.openxmlformats.org/drawingml/2006/main">
             <a:pPr>
               <a:buNone/>
-              <a:defRPr sz="2025" b="0">
+              <a:defRPr sz="1800" b="0">
                 <a:solidFill>
                   <a:srgbClr val="526A84"/>
                 </a:solidFill>
@@ -16554,7 +16882,7 @@
               </a:defRPr>
             </a:pPr>
             <a:r>
-              <a:rPr sz="2025" b="0">
+              <a:rPr sz="1800" b="0">
                 <a:solidFill>
                   <a:srgbClr val="526A84"/>
                 </a:solidFill>
@@ -16562,7 +16890,186 @@
                 <a:ea typeface="Apple SD Gothic Neo"/>
                 <a:cs typeface="Apple SD Gothic Neo"/>
               </a:rPr>
-              <a:t>지적 0건도 정확성 보증은 아님. 원문 근거와 함께 최종 판단.</a:t>
+              <a:t>남은 쟁점은 작성자에게 전달. 지적 0건도 정확성 보증은 아님.</a:t>
+            </a:r>
+          </a:p>
+        </p:txBody>
+      </p:sp>
+      <p:sp>
+        <p:nvSpPr>
+          <p:cNvPr id="10" name="">
+            <a:extLst xmlns:a="http://schemas.openxmlformats.org/drawingml/2006/main">
+              <a:ext uri="{FF2B5EF4-FFF2-40B4-BE49-F238E27FC236}">
+                <a16:creationId xmlns:a16="http://schemas.microsoft.com/office/drawing/2014/main" id="{31FCE2E0-7F03-4D5C-A12B-6B8770E678AB}"/>
+              </a:ext>
+            </a:extLst>
+          </p:cNvPr>
+          <p:cNvSpPr>
+            <a:spLocks xmlns:a="http://schemas.openxmlformats.org/drawingml/2006/main" noGrp="1"/>
+          </p:cNvSpPr>
+          <p:nvPr/>
+        </p:nvSpPr>
+        <p:spPr>
+          <a:xfrm xmlns:a="http://schemas.openxmlformats.org/drawingml/2006/main">
+            <a:off x="609600" y="4381500"/>
+            <a:ext cx="10953750" cy="857250"/>
+          </a:xfrm>
+          <a:prstGeom xmlns:a="http://schemas.openxmlformats.org/drawingml/2006/main" prst="rect">
+            <a:avLst/>
+          </a:prstGeom>
+          <a:noFill xmlns:a="http://schemas.openxmlformats.org/drawingml/2006/main"/>
+          <a:ln xmlns:a="http://schemas.openxmlformats.org/drawingml/2006/main" w="0">
+            <a:noFill/>
+          </a:ln>
+        </p:spPr>
+        <p:txBody>
+          <a:bodyPr xmlns:a="http://schemas.openxmlformats.org/drawingml/2006/main" lIns="0" tIns="0" rIns="0" bIns="0"/>
+          <a:lstStyle xmlns:a="http://schemas.openxmlformats.org/drawingml/2006/main">
+            <a:defPPr>
+              <a:defRPr sz="2325" b="1">
+                <a:solidFill>
+                  <a:srgbClr val="0F52BA"/>
+                </a:solidFill>
+                <a:latin typeface="Apple SD Gothic Neo"/>
+                <a:ea typeface="Apple SD Gothic Neo"/>
+                <a:cs typeface="Apple SD Gothic Neo"/>
+              </a:defRPr>
+            </a:defPPr>
+            <a:lvl1pPr>
+              <a:defRPr sz="2325" b="1">
+                <a:solidFill>
+                  <a:srgbClr val="0F52BA"/>
+                </a:solidFill>
+                <a:latin typeface="Apple SD Gothic Neo"/>
+                <a:ea typeface="Apple SD Gothic Neo"/>
+                <a:cs typeface="Apple SD Gothic Neo"/>
+              </a:defRPr>
+            </a:lvl1pPr>
+            <a:lvl2pPr>
+              <a:defRPr sz="2325" b="1">
+                <a:solidFill>
+                  <a:srgbClr val="0F52BA"/>
+                </a:solidFill>
+                <a:latin typeface="Apple SD Gothic Neo"/>
+                <a:ea typeface="Apple SD Gothic Neo"/>
+                <a:cs typeface="Apple SD Gothic Neo"/>
+              </a:defRPr>
+            </a:lvl2pPr>
+            <a:lvl3pPr>
+              <a:defRPr sz="2325" b="1">
+                <a:solidFill>
+                  <a:srgbClr val="0F52BA"/>
+                </a:solidFill>
+                <a:latin typeface="Apple SD Gothic Neo"/>
+                <a:ea typeface="Apple SD Gothic Neo"/>
+                <a:cs typeface="Apple SD Gothic Neo"/>
+              </a:defRPr>
+            </a:lvl3pPr>
+            <a:lvl4pPr>
+              <a:defRPr sz="2325" b="1">
+                <a:solidFill>
+                  <a:srgbClr val="0F52BA"/>
+                </a:solidFill>
+                <a:latin typeface="Apple SD Gothic Neo"/>
+                <a:ea typeface="Apple SD Gothic Neo"/>
+                <a:cs typeface="Apple SD Gothic Neo"/>
+              </a:defRPr>
+            </a:lvl4pPr>
+            <a:lvl5pPr>
+              <a:defRPr sz="2325" b="1">
+                <a:solidFill>
+                  <a:srgbClr val="0F52BA"/>
+                </a:solidFill>
+                <a:latin typeface="Apple SD Gothic Neo"/>
+                <a:ea typeface="Apple SD Gothic Neo"/>
+                <a:cs typeface="Apple SD Gothic Neo"/>
+              </a:defRPr>
+            </a:lvl5pPr>
+            <a:lvl6pPr>
+              <a:defRPr sz="2325" b="1">
+                <a:solidFill>
+                  <a:srgbClr val="0F52BA"/>
+                </a:solidFill>
+                <a:latin typeface="Apple SD Gothic Neo"/>
+                <a:ea typeface="Apple SD Gothic Neo"/>
+                <a:cs typeface="Apple SD Gothic Neo"/>
+              </a:defRPr>
+            </a:lvl6pPr>
+            <a:lvl7pPr>
+              <a:defRPr sz="2325" b="1">
+                <a:solidFill>
+                  <a:srgbClr val="0F52BA"/>
+                </a:solidFill>
+                <a:latin typeface="Apple SD Gothic Neo"/>
+                <a:ea typeface="Apple SD Gothic Neo"/>
+                <a:cs typeface="Apple SD Gothic Neo"/>
+              </a:defRPr>
+            </a:lvl7pPr>
+            <a:lvl8pPr>
+              <a:defRPr sz="2325" b="1">
+                <a:solidFill>
+                  <a:srgbClr val="0F52BA"/>
+                </a:solidFill>
+                <a:latin typeface="Apple SD Gothic Neo"/>
+                <a:ea typeface="Apple SD Gothic Neo"/>
+                <a:cs typeface="Apple SD Gothic Neo"/>
+              </a:defRPr>
+            </a:lvl8pPr>
+            <a:lvl9pPr>
+              <a:defRPr sz="2325" b="1">
+                <a:solidFill>
+                  <a:srgbClr val="0F52BA"/>
+                </a:solidFill>
+                <a:latin typeface="Apple SD Gothic Neo"/>
+                <a:ea typeface="Apple SD Gothic Neo"/>
+                <a:cs typeface="Apple SD Gothic Neo"/>
+              </a:defRPr>
+            </a:lvl9pPr>
+          </a:lstStyle>
+          <a:p xmlns:a="http://schemas.openxmlformats.org/drawingml/2006/main">
+            <a:pPr>
+              <a:defRPr sz="2325" b="1">
+                <a:solidFill>
+                  <a:srgbClr val="0F52BA"/>
+                </a:solidFill>
+                <a:latin typeface="Apple SD Gothic Neo"/>
+                <a:ea typeface="Apple SD Gothic Neo"/>
+                <a:cs typeface="Apple SD Gothic Neo"/>
+              </a:defRPr>
+            </a:pPr>
+            <a:r>
+              <a:rPr sz="2325" b="1">
+                <a:solidFill>
+                  <a:srgbClr val="0F52BA"/>
+                </a:solidFill>
+                <a:latin typeface="Apple SD Gothic Neo"/>
+                <a:ea typeface="Apple SD Gothic Neo"/>
+                <a:cs typeface="Apple SD Gothic Neo"/>
+              </a:rPr>
+              <a:t>수정 1회로 반복·비용 제한</a:t>
+            </a:r>
+          </a:p>
+          <a:p xmlns:a="http://schemas.openxmlformats.org/drawingml/2006/main">
+            <a:pPr>
+              <a:defRPr sz="2325" b="1">
+                <a:solidFill>
+                  <a:srgbClr val="0F52BA"/>
+                </a:solidFill>
+                <a:latin typeface="Apple SD Gothic Neo"/>
+                <a:ea typeface="Apple SD Gothic Neo"/>
+                <a:cs typeface="Apple SD Gothic Neo"/>
+              </a:defRPr>
+            </a:pPr>
+            <a:r>
+              <a:rPr sz="2325" b="1">
+                <a:solidFill>
+                  <a:srgbClr val="0F52BA"/>
+                </a:solidFill>
+                <a:latin typeface="Apple SD Gothic Neo"/>
+                <a:ea typeface="Apple SD Gothic Neo"/>
+                <a:cs typeface="Apple SD Gothic Neo"/>
+              </a:rPr>
+              <a:t>추가 수정으로 해결될 문제도 남을 수 있음</a:t>
             </a:r>
           </a:p>
         </p:txBody>

</xml_diff>

<commit_message>
docs(presentation): introduce worldbuilding review through familiar stories
변경 내용
- PPT 첫 장을 원피스·노블레스·외모지상주의·갓 오브 하이스쿨 이미지와 설정 일관성 질문으로 구성했다.
- 신의 탑 대신 샹크스와 갓 오브 하이스쿨의 제아봉침 25만 배 장면을 설명하며, 의도된 예외와 오류를 구분하는 문제 정의로 연결했다.
- PRESENTATION.md와 첫 세 장의 발표자 노트를 맞추고 앞 2분을 도입 55초·기능 25초·결과 40초로 재배분했다.
- 이미지 제공 경위, 확인 가능한 작품 안내, 사례 해석의 범위를 기록했다.

변경 이유
- 익숙한 작품으로 서비스의 필요성을 설명하되 작품별 설정 오류나 제작 의도를 근거 없이 단정하지 않기 위해 수정했다.
- 기존 Agent Graph·MCP·RAG 코드 설명 시간을 확보하며 5분 발표 구성을 유지했다.

검증
- finalize-opening.mjs: PPTX 무결성·레이아웃·폰트·재가져오기 검사 통과, 발견 사항 0건.
- check-opening.py: 총 7장과 대본·노트 일치, 제공 이미지 4장 원본 바이트 보존, 기존 3~7장 렌더 동일성 확인.
- 전체 7장 렌더를 확인했고 git diff --check를 통과했다.
- 발표 목표는 4분 45초이며 실제 낭독 시간은 측정하지 않았다. 애플리케이션 코드와 AI 실행 결과는 변경하지 않았다.
</commit_message>
<xml_diff>
--- a/docs/presentation/LoreForge-G074-KimJimin.pptx
+++ b/docs/presentation/LoreForge-G074-KimJimin.pptx
@@ -2,19 +2,19 @@
 <file path=ppt/presentation.xml><?xml version="1.0" encoding="utf-8"?>
 <p:presentation xmlns:p="http://schemas.openxmlformats.org/presentationml/2006/main">
   <p:sldMasterIdLst>
-    <p:sldMasterId xmlns:r="http://schemas.openxmlformats.org/officeDocument/2006/relationships" id="2147483648" r:id="Rf6181d2a72a6451a"/>
+    <p:sldMasterId xmlns:r="http://schemas.openxmlformats.org/officeDocument/2006/relationships" id="2147483648" r:id="R4fcc621c20bb4e4e"/>
   </p:sldMasterIdLst>
   <p:notesMasterIdLst>
-    <p:notesMasterId xmlns:r="http://schemas.openxmlformats.org/officeDocument/2006/relationships" r:id="R0c199413a138451e"/>
+    <p:notesMasterId xmlns:r="http://schemas.openxmlformats.org/officeDocument/2006/relationships" r:id="Rf2ef293576f64e9b"/>
   </p:notesMasterIdLst>
   <p:sldIdLst>
-    <p:sldId xmlns:r="http://schemas.openxmlformats.org/officeDocument/2006/relationships" id="256" r:id="Re594f3e240664de8"/>
-    <p:sldId xmlns:r="http://schemas.openxmlformats.org/officeDocument/2006/relationships" id="257" r:id="R1c44c2bfbfaa479e"/>
-    <p:sldId xmlns:r="http://schemas.openxmlformats.org/officeDocument/2006/relationships" id="258" r:id="Rd9e0a08e437f4c91"/>
-    <p:sldId xmlns:r="http://schemas.openxmlformats.org/officeDocument/2006/relationships" id="259" r:id="Racc7bd9520654395"/>
-    <p:sldId xmlns:r="http://schemas.openxmlformats.org/officeDocument/2006/relationships" id="260" r:id="Rc9db19f10b4a443b"/>
-    <p:sldId xmlns:r="http://schemas.openxmlformats.org/officeDocument/2006/relationships" id="261" r:id="Rc13d0a1531dc445c"/>
-    <p:sldId xmlns:r="http://schemas.openxmlformats.org/officeDocument/2006/relationships" id="262" r:id="R5c28a47230ff4792"/>
+    <p:sldId xmlns:r="http://schemas.openxmlformats.org/officeDocument/2006/relationships" id="256" r:id="R65a123d4da2c4716"/>
+    <p:sldId xmlns:r="http://schemas.openxmlformats.org/officeDocument/2006/relationships" id="257" r:id="Rb3cdac174cd44939"/>
+    <p:sldId xmlns:r="http://schemas.openxmlformats.org/officeDocument/2006/relationships" id="258" r:id="R4e92794ddfe842b2"/>
+    <p:sldId xmlns:r="http://schemas.openxmlformats.org/officeDocument/2006/relationships" id="259" r:id="R558de94d30fb4df5"/>
+    <p:sldId xmlns:r="http://schemas.openxmlformats.org/officeDocument/2006/relationships" id="260" r:id="R8e5326e25e42465a"/>
+    <p:sldId xmlns:r="http://schemas.openxmlformats.org/officeDocument/2006/relationships" id="261" r:id="R68cf8f41b33e4559"/>
+    <p:sldId xmlns:r="http://schemas.openxmlformats.org/officeDocument/2006/relationships" id="262" r:id="Rfc3ddf69b8aa46a0"/>
   </p:sldIdLst>
   <p:sldSz cx="12192000" cy="6858000"/>
   <p:notesSz cx="6858000" cy="9144000"/>
@@ -448,12 +448,12 @@
           <a:lstStyle xmlns:a="http://schemas.openxmlformats.org/drawingml/2006/main"/>
           <a:p xmlns:a="http://schemas.openxmlformats.org/drawingml/2006/main">
             <a:r>
-              <a:t>[설정공방 LoreForge — 00:00–00:20 / 20초]</a:t>
+              <a:t>[작품 사례와 문제 정의 — 00:00–00:55 / 55초]</a:t>
             </a:r>
           </a:p>
           <a:p xmlns:a="http://schemas.openxmlformats.org/drawingml/2006/main">
             <a:r>
-              <a:t>안녕하세요. SKALA 4기 광주캠퍼스 G074 김지민입니다. 과제 2로 세계관 창작과 설정 검토를 돕는 웹 서비스, 설정공방 LoreForge를 만들었습니다. 아이디어를 이야기로 확장하고, 충돌이 의심되는 부분은 원문 근거로 확인하는 서비스입니다.</a:t>
+              <a:t>안녕하세요. SKALA 4기 광주캠퍼스 G074 김지민입니다. 과제 2로 세계관 창작과 검토를 돕는 설정공방 LoreForge를 만들었습니다. 여러분, 샹크스가 루피를 구하다 팔을 잃는 장면을 기억하시나요? 이후의 강력한 모습과 비교하면, 왜 그때 팔을 잃었는지 의문이 생깁니다. 갓 오브 하이스쿨의 ‘제아봉침 25만 배’ 같은 장면에서는, 커진 능력이 기존의 한계와 대가에 어떻게 연결되는지 궁금해집니다. 물론 이런 장면을 곧바로 설정 오류라고 단정할 수는 없습니다. 복선이나 의도된 예외일 수도 있습니다. 제가 주목한 건 이야기가 길어질수록 설정과 예외를 모두 기억하고 대조하기 어렵다는 점입니다. 그래서 의심되는 부분과 원문 근거를 찾아, 작성자가 판단하도록 돕는 서비스를 구상했습니다.</a:t>
             </a:r>
           </a:p>
           <a:p xmlns:a="http://schemas.openxmlformats.org/drawingml/2006/main">
@@ -463,7 +463,27 @@
           </a:p>
           <a:p xmlns:a="http://schemas.openxmlformats.org/drawingml/2006/main">
             <a:r>
-              <a:t>자료: docs/PRESENTATION.md, docs/RESULTS.md. 코드 기준 a3086ff. 공개 v4 생성·v5 검토 저장 결과를 2026-10-22 최신 화면에서 조회만 허용한 서버로 재캡처. v8 회귀 10건과는 별도 실행. 화면 시간 표시는 없음.</a:t>
+              <a:t>이미지: 발표자가 제공한 원피스·노블레스·외모지상주의·갓 오브 하이스쿨 이미지 4장. 원본 회차 및 최초 게시 URL 미확인.</a:t>
+            </a:r>
+          </a:p>
+          <a:p xmlns:a="http://schemas.openxmlformats.org/drawingml/2006/main">
+            <a:r>
+              <a:t>사건 확인: https://one-piece.com/character/Shanks/index.html</a:t>
+            </a:r>
+          </a:p>
+          <a:p xmlns:a="http://schemas.openxmlformats.org/drawingml/2006/main">
+            <a:r>
+              <a:t>작품 안내(이미지 원본 출처와 구분): https://m.comic.naver.com/webtoon/list?titleId=25455 / https://comic.naver.com/webtoon/list?titleId=641253 / https://comic.naver.com/webtoon/list?titleId=318995</a:t>
+            </a:r>
+          </a:p>
+          <a:p xmlns:a="http://schemas.openxmlformats.org/drawingml/2006/main">
+            <a:r>
+              <a:t>갓 오브 하이스쿨의 25만 배는 제공 이미지의 문구. 의도된 예외·복선 가능성을 열어두고, 작품별 설정 오류로 단정하지 않는다. 외모지상주의·노블레스는 작품 맥락 소개.</a:t>
+            </a:r>
+          </a:p>
+          <a:p xmlns:a="http://schemas.openxmlformats.org/drawingml/2006/main">
+            <a:r>
+              <a:t>발표 동작: 샹크스와 갓 오브 하이스쿨 장면을 차례로 가리킨 뒤 기능 소개로 전환.</a:t>
             </a:r>
           </a:p>
         </p:txBody>
@@ -533,12 +553,12 @@
           <a:lstStyle xmlns:a="http://schemas.openxmlformats.org/drawingml/2006/main"/>
           <a:p xmlns:a="http://schemas.openxmlformats.org/drawingml/2006/main">
             <a:r>
-              <a:t>[주제와 세부 태스크 — 00:20–01:05 / 45초]</a:t>
+              <a:t>[LoreForge의 주요 기능 — 00:55–01:20 / 25초]</a:t>
             </a:r>
           </a:p>
           <a:p xmlns:a="http://schemas.openxmlformats.org/drawingml/2006/main">
             <a:r>
-              <a:t>이야기를 만들다 보면 인물과 사건이 늘어나면서, 앞의 설정과 뒤의 장면이 충돌하는지 확인하기 어려워집니다. 이를 세 가지 태스크로 나눴습니다. 첫째, 키워드와 유지 조건으로 초안을 만들고 검토합니다. 둘째, 이미 있는 원고는 다시 쓰지 않고 문제 위치와 이유부터 보여줍니다. 셋째, 관계도에서 연결과 근거를 확인하고, 채택한 최종본을 기준으로 이어씁니다. 생성과 검토를 별도 탭으로 나눈 이유도, 긴 글 전체를 매번 다시 읽는 부담을 줄이기 위해서입니다.</a:t>
+              <a:t>기능은 세 가지입니다. 키워드로 초안을 생성하고 검토하는 기능, 기존 원고를 유지하면서 문제 위치와 이유를 보여주는 검토 전용 기능, 그리고 관계도에서 근거를 확인하고 채택한 설정으로 이어쓰는 기능입니다. 특히 기존 원고를 검토할 때는 긴 글을 통째로 다시 읽지 않아도, 의심되는 부분부터 확인할 수 있게 했습니다.</a:t>
             </a:r>
           </a:p>
           <a:p xmlns:a="http://schemas.openxmlformats.org/drawingml/2006/main">
@@ -548,7 +568,7 @@
           </a:p>
           <a:p xmlns:a="http://schemas.openxmlformats.org/drawingml/2006/main">
             <a:r>
-              <a:t>자료: docs/PRESENTATION.md, docs/RESULTS.md. 코드 기준 a3086ff. 공개 v4 생성·v5 검토 저장 결과를 2026-10-22 최신 화면에서 조회만 허용한 서버로 재캡처. v8 회귀 10건과는 별도 실행. 화면 시간 표시는 없음.</a:t>
+              <a:t>자료: docs/PRESENTATION.md, docs/RESULTS.md. 공개 v4 생성·v5 검토 저장 결과를 최신 화면에서 재열람. v8 회귀 10건과는 별도 실행.</a:t>
             </a:r>
           </a:p>
         </p:txBody>
@@ -618,12 +638,12 @@
           <a:lstStyle xmlns:a="http://schemas.openxmlformats.org/drawingml/2006/main"/>
           <a:p xmlns:a="http://schemas.openxmlformats.org/drawingml/2006/main">
             <a:r>
-              <a:t>[구현 결과와 검증 — 01:05–02:00 / 55초]</a:t>
+              <a:t>[구현 결과와 검증 — 01:20–02:00 / 40초]</a:t>
             </a:r>
           </a:p>
           <a:p xmlns:a="http://schemas.openxmlformats.org/drawingml/2006/main">
             <a:r>
-              <a:t>두 화면은 공개 입력으로 얻은 실제 API 결과를 최신 화면에서 다시 연 것입니다. 왼쪽은 키워드로 만든 이야기의 수정본을 관계도로 본 화면입니다. 본문과 같은 데이터로 인물·장소·사건을 연결합니다. 오른쪽은 원문 검토입니다. 하나뿐인 열쇠가 같은 시각 서로 다른 장소에 있다는 내부 모순을 지적하고 원문 두 문단을 연결했습니다. 채택 후 이어쓰기까지 실제 흐름을 확인했고, 정상 예외 여섯 건과 실제 문제 네 건의 회귀 검사도 통과했습니다. 자동 검사와 타입·빌드도 확인했습니다. 다만 작은 회귀 표본이 모든 원고의 정확성을 보장하지는 않습니다. 이제 실행 코드를 설명하겠습니다.</a:t>
+              <a:t>두 화면은 공개 입력의 실제 API 저장 결과입니다. 왼쪽은 생성된 이야기를 관계도로 탐색하는 화면이고, 오른쪽은 기존 원고의 검토 결과입니다. 하나뿐인 열쇠가 같은 시각 서로 다른 장소에 있다는 문제와 관련 문단 두 곳을 보여줍니다. 채택 후 이어쓰기까지 확인했고, 별도로 정상 예외 여섯 건과 실제 문제 네 건의 회귀 검사도 통과했습니다. 다만 작은 검사 표본이 모든 원고의 정확성을 보장하지는 않습니다. 이제 실행 코드를 설명하겠습니다.</a:t>
             </a:r>
           </a:p>
           <a:p xmlns:a="http://schemas.openxmlformats.org/drawingml/2006/main">
@@ -633,7 +653,7 @@
           </a:p>
           <a:p xmlns:a="http://schemas.openxmlformats.org/drawingml/2006/main">
             <a:r>
-              <a:t>자료: docs/PRESENTATION.md, docs/RESULTS.md. 코드 기준 a3086ff. 공개 v4 생성·v5 검토 저장 결과를 2026-10-22 최신 화면에서 조회만 허용한 서버로 재캡처. v8 회귀 10건과는 별도 실행. 화면 시간 표시는 없음.</a:t>
+              <a:t>자료: docs/PRESENTATION.md, docs/RESULTS.md. 공개 v4 생성·v5 검토 저장 결과를 최신 화면에서 재열람. v8 회귀 10건과는 별도 실행.</a:t>
             </a:r>
           </a:p>
         </p:txBody>
@@ -3416,12 +3436,12 @@
   </p:cSld>
   <p:clrMap bg1="lt1" tx1="dk1" bg2="lt2" tx2="dk2" accent1="accent1" accent2="accent2" accent3="accent3" accent4="accent4" accent5="accent5" accent6="accent6" hlink="hlink" folHlink="folHlink"/>
   <p:sldLayoutIdLst>
-    <p:sldLayoutId xmlns:r="http://schemas.openxmlformats.org/officeDocument/2006/relationships" id="2147483649" r:id="Re9a225e002c94bdd"/>
-    <p:sldLayoutId xmlns:r="http://schemas.openxmlformats.org/officeDocument/2006/relationships" id="2147483650" r:id="R96081535776b4a66"/>
-    <p:sldLayoutId xmlns:r="http://schemas.openxmlformats.org/officeDocument/2006/relationships" id="2147483651" r:id="R43a867a9c0be481f"/>
-    <p:sldLayoutId xmlns:r="http://schemas.openxmlformats.org/officeDocument/2006/relationships" id="2147483652" r:id="Rfeb75db849ba4b65"/>
-    <p:sldLayoutId xmlns:r="http://schemas.openxmlformats.org/officeDocument/2006/relationships" id="2147483653" r:id="R851073e4b62d40d8"/>
-    <p:sldLayoutId xmlns:r="http://schemas.openxmlformats.org/officeDocument/2006/relationships" id="2147483654" r:id="Rb037b7e45f27430d"/>
+    <p:sldLayoutId xmlns:r="http://schemas.openxmlformats.org/officeDocument/2006/relationships" id="2147483649" r:id="R9737df6856c1452f"/>
+    <p:sldLayoutId xmlns:r="http://schemas.openxmlformats.org/officeDocument/2006/relationships" id="2147483650" r:id="R7921ec6271d648c7"/>
+    <p:sldLayoutId xmlns:r="http://schemas.openxmlformats.org/officeDocument/2006/relationships" id="2147483651" r:id="R68e88bdf303247bd"/>
+    <p:sldLayoutId xmlns:r="http://schemas.openxmlformats.org/officeDocument/2006/relationships" id="2147483652" r:id="R04d6ff71f5304b3d"/>
+    <p:sldLayoutId xmlns:r="http://schemas.openxmlformats.org/officeDocument/2006/relationships" id="2147483653" r:id="R9d8f50e44e054fab"/>
+    <p:sldLayoutId xmlns:r="http://schemas.openxmlformats.org/officeDocument/2006/relationships" id="2147483654" r:id="Rd59ae1ac0e1a427b"/>
   </p:sldLayoutIdLst>
   <p:txStyles>
     <p:titleStyle>
@@ -3983,8 +4003,8 @@
         </p:nvSpPr>
         <p:spPr>
           <a:xfrm xmlns:a="http://schemas.openxmlformats.org/drawingml/2006/main">
-            <a:off x="723900" y="1114425"/>
-            <a:ext cx="10477500" cy="666750"/>
+            <a:off x="609600" y="361950"/>
+            <a:ext cx="5715000" cy="419100"/>
           </a:xfrm>
           <a:prstGeom xmlns:a="http://schemas.openxmlformats.org/drawingml/2006/main" prst="rect">
             <a:avLst/>
@@ -3998,7 +4018,7 @@
           <a:bodyPr xmlns:a="http://schemas.openxmlformats.org/drawingml/2006/main" lIns="0" tIns="0" rIns="0" bIns="0"/>
           <a:lstStyle xmlns:a="http://schemas.openxmlformats.org/drawingml/2006/main">
             <a:defPPr>
-              <a:defRPr sz="3750" b="0">
+              <a:defRPr sz="2400" b="1">
                 <a:solidFill>
                   <a:srgbClr val="D6E6F3"/>
                 </a:solidFill>
@@ -4110,7 +4130,7 @@
           <a:p xmlns:a="http://schemas.openxmlformats.org/drawingml/2006/main">
             <a:pPr>
               <a:buNone/>
-              <a:defRPr sz="3750" b="0">
+              <a:defRPr sz="2400" b="1">
                 <a:solidFill>
                   <a:srgbClr val="D6E6F3"/>
                 </a:solidFill>
@@ -4120,7 +4140,7 @@
               </a:defRPr>
             </a:pPr>
             <a:r>
-              <a:rPr sz="3750" b="0">
+              <a:rPr sz="2400" b="1">
                 <a:solidFill>
                   <a:srgbClr val="D6E6F3"/>
                 </a:solidFill>
@@ -4128,7 +4148,7 @@
                 <a:ea typeface="Apple SD Gothic Neo"/>
                 <a:cs typeface="Apple SD Gothic Neo"/>
               </a:rPr>
-              <a:t>설정공방</a:t>
+              <a:t>설정공방 LoreForge</a:t>
             </a:r>
           </a:p>
         </p:txBody>
@@ -4149,8 +4169,8 @@
         </p:nvSpPr>
         <p:spPr>
           <a:xfrm xmlns:a="http://schemas.openxmlformats.org/drawingml/2006/main">
-            <a:off x="685800" y="1924050"/>
-            <a:ext cx="10668000" cy="1104900"/>
+            <a:off x="609600" y="962025"/>
+            <a:ext cx="10972800" cy="1190625"/>
           </a:xfrm>
           <a:prstGeom xmlns:a="http://schemas.openxmlformats.org/drawingml/2006/main" prst="rect">
             <a:avLst/>
@@ -4164,7 +4184,7 @@
           <a:bodyPr xmlns:a="http://schemas.openxmlformats.org/drawingml/2006/main" lIns="0" tIns="0" rIns="0" bIns="0"/>
           <a:lstStyle xmlns:a="http://schemas.openxmlformats.org/drawingml/2006/main">
             <a:defPPr>
-              <a:defRPr sz="6750" b="1">
+              <a:defRPr sz="3600" b="1">
                 <a:solidFill>
                   <a:srgbClr val="FFFFFF"/>
                 </a:solidFill>
@@ -4276,7 +4296,7 @@
           <a:p xmlns:a="http://schemas.openxmlformats.org/drawingml/2006/main">
             <a:pPr>
               <a:buNone/>
-              <a:defRPr sz="6750" b="1">
+              <a:defRPr sz="3600" b="1">
                 <a:solidFill>
                   <a:srgbClr val="FFFFFF"/>
                 </a:solidFill>
@@ -4286,7 +4306,7 @@
               </a:defRPr>
             </a:pPr>
             <a:r>
-              <a:rPr sz="6750" b="1">
+              <a:rPr sz="3600" b="1">
                 <a:solidFill>
                   <a:srgbClr val="FFFFFF"/>
                 </a:solidFill>
@@ -4294,7 +4314,31 @@
                 <a:ea typeface="Apple SD Gothic Neo"/>
                 <a:cs typeface="Apple SD Gothic Neo"/>
               </a:rPr>
-              <a:t>LoreForge</a:t>
+              <a:t>앞에서 정한 설정과,</a:t>
+            </a:r>
+          </a:p>
+          <a:p xmlns:a="http://schemas.openxmlformats.org/drawingml/2006/main">
+            <a:pPr>
+              <a:buNone/>
+              <a:defRPr sz="3600" b="1">
+                <a:solidFill>
+                  <a:srgbClr val="FFFFFF"/>
+                </a:solidFill>
+                <a:latin typeface="Apple SD Gothic Neo"/>
+                <a:ea typeface="Apple SD Gothic Neo"/>
+                <a:cs typeface="Apple SD Gothic Neo"/>
+              </a:defRPr>
+            </a:pPr>
+            <a:r>
+              <a:rPr sz="3600" b="1">
+                <a:solidFill>
+                  <a:srgbClr val="FFFFFF"/>
+                </a:solidFill>
+                <a:latin typeface="Apple SD Gothic Neo"/>
+                <a:ea typeface="Apple SD Gothic Neo"/>
+                <a:cs typeface="Apple SD Gothic Neo"/>
+              </a:rPr>
+              <a:t>지금의 이야기는 이어지고 있을까?</a:t>
             </a:r>
           </a:p>
         </p:txBody>
@@ -4315,8 +4359,8 @@
         </p:nvSpPr>
         <p:spPr>
           <a:xfrm xmlns:a="http://schemas.openxmlformats.org/drawingml/2006/main">
-            <a:off x="742950" y="3371850"/>
-            <a:ext cx="10477500" cy="914400"/>
+            <a:off x="609600" y="5953125"/>
+            <a:ext cx="10953750" cy="409575"/>
           </a:xfrm>
           <a:prstGeom xmlns:a="http://schemas.openxmlformats.org/drawingml/2006/main" prst="rect">
             <a:avLst/>
@@ -4330,9 +4374,9 @@
           <a:bodyPr xmlns:a="http://schemas.openxmlformats.org/drawingml/2006/main" lIns="0" tIns="0" rIns="0" bIns="0"/>
           <a:lstStyle xmlns:a="http://schemas.openxmlformats.org/drawingml/2006/main">
             <a:defPPr>
-              <a:defRPr sz="2250" b="0">
-                <a:solidFill>
-                  <a:srgbClr val="A6C5D7"/>
+              <a:defRPr sz="2250" b="1">
+                <a:solidFill>
+                  <a:srgbClr val="D6E6F3"/>
                 </a:solidFill>
                 <a:latin typeface="Apple SD Gothic Neo"/>
                 <a:ea typeface="Apple SD Gothic Neo"/>
@@ -4442,9 +4486,9 @@
           <a:p xmlns:a="http://schemas.openxmlformats.org/drawingml/2006/main">
             <a:pPr>
               <a:buNone/>
-              <a:defRPr sz="2250" b="0">
-                <a:solidFill>
-                  <a:srgbClr val="A6C5D7"/>
+              <a:defRPr sz="2250" b="1">
+                <a:solidFill>
+                  <a:srgbClr val="D6E6F3"/>
                 </a:solidFill>
                 <a:latin typeface="Apple SD Gothic Neo"/>
                 <a:ea typeface="Apple SD Gothic Neo"/>
@@ -4452,15 +4496,15 @@
               </a:defRPr>
             </a:pPr>
             <a:r>
-              <a:rPr sz="2250" b="0">
-                <a:solidFill>
-                  <a:srgbClr val="A6C5D7"/>
+              <a:rPr sz="2250" b="1">
+                <a:solidFill>
+                  <a:srgbClr val="D6E6F3"/>
                 </a:solidFill>
                 <a:latin typeface="Apple SD Gothic Neo"/>
                 <a:ea typeface="Apple SD Gothic Neo"/>
                 <a:cs typeface="Apple SD Gothic Neo"/>
               </a:rPr>
-              <a:t>키워드로 만들고, 원문 근거로 검토하는 세계관 웹 서비스</a:t>
+              <a:t>모순인지 의도된 예외인지, 원문 근거로 확인합니다</a:t>
             </a:r>
           </a:p>
         </p:txBody>
@@ -4481,8 +4525,8 @@
         </p:nvSpPr>
         <p:spPr>
           <a:xfrm xmlns:a="http://schemas.openxmlformats.org/drawingml/2006/main">
-            <a:off x="742950" y="5057775"/>
-            <a:ext cx="10477500" cy="476250"/>
+            <a:off x="7620000" y="466725"/>
+            <a:ext cx="3962400" cy="304800"/>
           </a:xfrm>
           <a:prstGeom xmlns:a="http://schemas.openxmlformats.org/drawingml/2006/main" prst="rect">
             <a:avLst/>
@@ -4496,9 +4540,9 @@
           <a:bodyPr xmlns:a="http://schemas.openxmlformats.org/drawingml/2006/main" lIns="0" tIns="0" rIns="0" bIns="0"/>
           <a:lstStyle xmlns:a="http://schemas.openxmlformats.org/drawingml/2006/main">
             <a:defPPr>
-              <a:defRPr sz="2550" b="1">
-                <a:solidFill>
-                  <a:srgbClr val="FFFFFF"/>
+              <a:defRPr sz="1650" b="0">
+                <a:solidFill>
+                  <a:srgbClr val="A6C5D7"/>
                 </a:solidFill>
                 <a:latin typeface="Apple SD Gothic Neo"/>
                 <a:ea typeface="Apple SD Gothic Neo"/>
@@ -4608,9 +4652,9 @@
           <a:p xmlns:a="http://schemas.openxmlformats.org/drawingml/2006/main">
             <a:pPr>
               <a:buNone/>
-              <a:defRPr sz="2550" b="1">
-                <a:solidFill>
-                  <a:srgbClr val="FFFFFF"/>
+              <a:defRPr sz="1650" b="0">
+                <a:solidFill>
+                  <a:srgbClr val="A6C5D7"/>
                 </a:solidFill>
                 <a:latin typeface="Apple SD Gothic Neo"/>
                 <a:ea typeface="Apple SD Gothic Neo"/>
@@ -4618,15 +4662,15 @@
               </a:defRPr>
             </a:pPr>
             <a:r>
-              <a:rPr sz="2550" b="1">
-                <a:solidFill>
-                  <a:srgbClr val="FFFFFF"/>
+              <a:rPr sz="1650" b="0">
+                <a:solidFill>
+                  <a:srgbClr val="A6C5D7"/>
                 </a:solidFill>
                 <a:latin typeface="Apple SD Gothic Neo"/>
                 <a:ea typeface="Apple SD Gothic Neo"/>
                 <a:cs typeface="Apple SD Gothic Neo"/>
               </a:rPr>
-              <a:t>G074  김지민</a:t>
+              <a:t>G074 김지민 · SKALA 4기 광주캠퍼스</a:t>
             </a:r>
           </a:p>
         </p:txBody>
@@ -4647,8 +4691,8 @@
         </p:nvSpPr>
         <p:spPr>
           <a:xfrm xmlns:a="http://schemas.openxmlformats.org/drawingml/2006/main">
-            <a:off x="742950" y="5619750"/>
-            <a:ext cx="9525000" cy="428625"/>
+            <a:off x="609600" y="6486525"/>
+            <a:ext cx="10972800" cy="238125"/>
           </a:xfrm>
           <a:prstGeom xmlns:a="http://schemas.openxmlformats.org/drawingml/2006/main" prst="rect">
             <a:avLst/>
@@ -4662,9 +4706,9 @@
           <a:bodyPr xmlns:a="http://schemas.openxmlformats.org/drawingml/2006/main" lIns="0" tIns="0" rIns="0" bIns="0"/>
           <a:lstStyle xmlns:a="http://schemas.openxmlformats.org/drawingml/2006/main">
             <a:defPPr>
-              <a:defRPr sz="1950" b="0">
-                <a:solidFill>
-                  <a:srgbClr val="D6E6F3"/>
+              <a:defRPr sz="1275" b="0">
+                <a:solidFill>
+                  <a:srgbClr val="A6C5D7"/>
                 </a:solidFill>
                 <a:latin typeface="Apple SD Gothic Neo"/>
                 <a:ea typeface="Apple SD Gothic Neo"/>
@@ -4774,9 +4818,9 @@
           <a:p xmlns:a="http://schemas.openxmlformats.org/drawingml/2006/main">
             <a:pPr>
               <a:buNone/>
-              <a:defRPr sz="1950" b="0">
-                <a:solidFill>
-                  <a:srgbClr val="D6E6F3"/>
+              <a:defRPr sz="1275" b="0">
+                <a:solidFill>
+                  <a:srgbClr val="A6C5D7"/>
                 </a:solidFill>
                 <a:latin typeface="Apple SD Gothic Neo"/>
                 <a:ea typeface="Apple SD Gothic Neo"/>
@@ -4784,15 +4828,15 @@
               </a:defRPr>
             </a:pPr>
             <a:r>
-              <a:rPr sz="1950" b="0">
-                <a:solidFill>
-                  <a:srgbClr val="D6E6F3"/>
+              <a:rPr sz="1275" b="0">
+                <a:solidFill>
+                  <a:srgbClr val="A6C5D7"/>
                 </a:solidFill>
                 <a:latin typeface="Apple SD Gothic Neo"/>
                 <a:ea typeface="Apple SD Gothic Neo"/>
                 <a:cs typeface="Apple SD Gothic Neo"/>
               </a:rPr>
-              <a:t>SKALA 4기 광주캠퍼스</a:t>
+              <a:t>이미지: 발표자 제공 · 작품별 설정 오류 판정이나 서비스 검증 결과가 아님</a:t>
             </a:r>
           </a:p>
         </p:txBody>
@@ -4813,8 +4857,8 @@
         </p:nvSpPr>
         <p:spPr>
           <a:xfrm xmlns:a="http://schemas.openxmlformats.org/drawingml/2006/main">
-            <a:off x="742950" y="6305550"/>
-            <a:ext cx="9525000" cy="285750"/>
+            <a:off x="609600" y="2133600"/>
+            <a:ext cx="8572500" cy="266700"/>
           </a:xfrm>
           <a:prstGeom xmlns:a="http://schemas.openxmlformats.org/drawingml/2006/main" prst="rect">
             <a:avLst/>
@@ -4828,7 +4872,7 @@
           <a:bodyPr xmlns:a="http://schemas.openxmlformats.org/drawingml/2006/main" lIns="0" tIns="0" rIns="0" bIns="0"/>
           <a:lstStyle xmlns:a="http://schemas.openxmlformats.org/drawingml/2006/main">
             <a:defPPr>
-              <a:defRPr sz="1425" b="0">
+              <a:defRPr sz="1500" b="0">
                 <a:solidFill>
                   <a:srgbClr val="A6C5D7"/>
                 </a:solidFill>
@@ -4940,7 +4984,7 @@
           <a:p xmlns:a="http://schemas.openxmlformats.org/drawingml/2006/main">
             <a:pPr>
               <a:buNone/>
-              <a:defRPr sz="1425" b="0">
+              <a:defRPr sz="1500" b="0">
                 <a:solidFill>
                   <a:srgbClr val="A6C5D7"/>
                 </a:solidFill>
@@ -4950,7 +4994,7 @@
               </a:defRPr>
             </a:pPr>
             <a:r>
-              <a:rPr sz="1425" b="0">
+              <a:rPr sz="1500" b="0">
                 <a:solidFill>
                   <a:srgbClr val="A6C5D7"/>
                 </a:solidFill>
@@ -4958,7 +5002,899 @@
                 <a:ea typeface="Apple SD Gothic Neo"/>
                 <a:cs typeface="Apple SD Gothic Neo"/>
               </a:rPr>
-              <a:t>과제 2  자유 주제 AI 서비스 개발</a:t>
+              <a:t>과제 2 · 세계관 창작과 설정 검토</a:t>
+            </a:r>
+          </a:p>
+        </p:txBody>
+      </p:sp>
+      <p:pic>
+        <p:nvPicPr>
+          <p:cNvPr id="8" name="">
+            <a:extLst xmlns:a="http://schemas.openxmlformats.org/drawingml/2006/main">
+              <a:ext uri="{FF2B5EF4-FFF2-40B4-BE49-F238E27FC236}">
+                <a16:creationId xmlns:a16="http://schemas.microsoft.com/office/drawing/2014/main" id="{FC56AD85-8D52-4D00-AA7D-4ADC53BA4842}"/>
+              </a:ext>
+            </a:extLst>
+          </p:cNvPr>
+          <p:cNvPicPr>
+            <a:picLocks xmlns:a="http://schemas.openxmlformats.org/drawingml/2006/main" noChangeAspect="1"/>
+          </p:cNvPicPr>
+          <p:nvPr/>
+        </p:nvPicPr>
+        <p:blipFill>
+          <a:blip xmlns:r="http://schemas.openxmlformats.org/officeDocument/2006/relationships" xmlns:a="http://schemas.openxmlformats.org/drawingml/2006/main" r:embed="R5c26e606e8ff463e"/>
+          <a:stretch xmlns:a="http://schemas.openxmlformats.org/drawingml/2006/main"/>
+        </p:blipFill>
+        <p:spPr>
+          <a:xfrm xmlns:a="http://schemas.openxmlformats.org/drawingml/2006/main">
+            <a:off x="685720" y="2505075"/>
+            <a:ext cx="3467259" cy="2762250"/>
+          </a:xfrm>
+          <a:prstGeom xmlns:a="http://schemas.openxmlformats.org/drawingml/2006/main" prst="rect">
+            <a:avLst/>
+          </a:prstGeom>
+        </p:spPr>
+      </p:pic>
+      <p:sp>
+        <p:nvSpPr>
+          <p:cNvPr id="9" name="">
+            <a:extLst xmlns:a="http://schemas.openxmlformats.org/drawingml/2006/main">
+              <a:ext uri="{FF2B5EF4-FFF2-40B4-BE49-F238E27FC236}">
+                <a16:creationId xmlns:a16="http://schemas.microsoft.com/office/drawing/2014/main" id="{729FD431-422F-452A-ABB7-035033715D25}"/>
+              </a:ext>
+            </a:extLst>
+          </p:cNvPr>
+          <p:cNvSpPr>
+            <a:spLocks xmlns:a="http://schemas.openxmlformats.org/drawingml/2006/main" noGrp="1"/>
+          </p:cNvSpPr>
+          <p:nvPr/>
+        </p:nvSpPr>
+        <p:spPr>
+          <a:xfrm xmlns:a="http://schemas.openxmlformats.org/drawingml/2006/main">
+            <a:off x="609600" y="5381625"/>
+            <a:ext cx="3619500" cy="352425"/>
+          </a:xfrm>
+          <a:prstGeom xmlns:a="http://schemas.openxmlformats.org/drawingml/2006/main" prst="rect">
+            <a:avLst/>
+          </a:prstGeom>
+          <a:noFill xmlns:a="http://schemas.openxmlformats.org/drawingml/2006/main"/>
+          <a:ln xmlns:a="http://schemas.openxmlformats.org/drawingml/2006/main" w="0">
+            <a:noFill/>
+          </a:ln>
+        </p:spPr>
+        <p:txBody>
+          <a:bodyPr xmlns:a="http://schemas.openxmlformats.org/drawingml/2006/main" lIns="0" tIns="0" rIns="0" bIns="0"/>
+          <a:lstStyle xmlns:a="http://schemas.openxmlformats.org/drawingml/2006/main">
+            <a:defPPr>
+              <a:defRPr sz="1950" b="1">
+                <a:solidFill>
+                  <a:srgbClr val="FFFFFF"/>
+                </a:solidFill>
+                <a:latin typeface="Apple SD Gothic Neo"/>
+                <a:ea typeface="Apple SD Gothic Neo"/>
+                <a:cs typeface="Apple SD Gothic Neo"/>
+              </a:defRPr>
+            </a:defPPr>
+            <a:lvl1pPr>
+              <a:defRPr sz="1950" b="1">
+                <a:solidFill>
+                  <a:srgbClr val="FFFFFF"/>
+                </a:solidFill>
+                <a:latin typeface="Apple SD Gothic Neo"/>
+                <a:ea typeface="Apple SD Gothic Neo"/>
+                <a:cs typeface="Apple SD Gothic Neo"/>
+              </a:defRPr>
+            </a:lvl1pPr>
+            <a:lvl2pPr>
+              <a:defRPr sz="1950" b="1">
+                <a:solidFill>
+                  <a:srgbClr val="FFFFFF"/>
+                </a:solidFill>
+                <a:latin typeface="Apple SD Gothic Neo"/>
+                <a:ea typeface="Apple SD Gothic Neo"/>
+                <a:cs typeface="Apple SD Gothic Neo"/>
+              </a:defRPr>
+            </a:lvl2pPr>
+            <a:lvl3pPr>
+              <a:defRPr sz="1950" b="1">
+                <a:solidFill>
+                  <a:srgbClr val="FFFFFF"/>
+                </a:solidFill>
+                <a:latin typeface="Apple SD Gothic Neo"/>
+                <a:ea typeface="Apple SD Gothic Neo"/>
+                <a:cs typeface="Apple SD Gothic Neo"/>
+              </a:defRPr>
+            </a:lvl3pPr>
+            <a:lvl4pPr>
+              <a:defRPr sz="1950" b="1">
+                <a:solidFill>
+                  <a:srgbClr val="FFFFFF"/>
+                </a:solidFill>
+                <a:latin typeface="Apple SD Gothic Neo"/>
+                <a:ea typeface="Apple SD Gothic Neo"/>
+                <a:cs typeface="Apple SD Gothic Neo"/>
+              </a:defRPr>
+            </a:lvl4pPr>
+            <a:lvl5pPr>
+              <a:defRPr sz="1950" b="1">
+                <a:solidFill>
+                  <a:srgbClr val="FFFFFF"/>
+                </a:solidFill>
+                <a:latin typeface="Apple SD Gothic Neo"/>
+                <a:ea typeface="Apple SD Gothic Neo"/>
+                <a:cs typeface="Apple SD Gothic Neo"/>
+              </a:defRPr>
+            </a:lvl5pPr>
+            <a:lvl6pPr>
+              <a:defRPr sz="1950" b="1">
+                <a:solidFill>
+                  <a:srgbClr val="FFFFFF"/>
+                </a:solidFill>
+                <a:latin typeface="Apple SD Gothic Neo"/>
+                <a:ea typeface="Apple SD Gothic Neo"/>
+                <a:cs typeface="Apple SD Gothic Neo"/>
+              </a:defRPr>
+            </a:lvl6pPr>
+            <a:lvl7pPr>
+              <a:defRPr sz="1950" b="1">
+                <a:solidFill>
+                  <a:srgbClr val="FFFFFF"/>
+                </a:solidFill>
+                <a:latin typeface="Apple SD Gothic Neo"/>
+                <a:ea typeface="Apple SD Gothic Neo"/>
+                <a:cs typeface="Apple SD Gothic Neo"/>
+              </a:defRPr>
+            </a:lvl7pPr>
+            <a:lvl8pPr>
+              <a:defRPr sz="1950" b="1">
+                <a:solidFill>
+                  <a:srgbClr val="FFFFFF"/>
+                </a:solidFill>
+                <a:latin typeface="Apple SD Gothic Neo"/>
+                <a:ea typeface="Apple SD Gothic Neo"/>
+                <a:cs typeface="Apple SD Gothic Neo"/>
+              </a:defRPr>
+            </a:lvl8pPr>
+            <a:lvl9pPr>
+              <a:defRPr sz="1950" b="1">
+                <a:solidFill>
+                  <a:srgbClr val="FFFFFF"/>
+                </a:solidFill>
+                <a:latin typeface="Apple SD Gothic Neo"/>
+                <a:ea typeface="Apple SD Gothic Neo"/>
+                <a:cs typeface="Apple SD Gothic Neo"/>
+              </a:defRPr>
+            </a:lvl9pPr>
+          </a:lstStyle>
+          <a:p xmlns:a="http://schemas.openxmlformats.org/drawingml/2006/main">
+            <a:pPr>
+              <a:defRPr sz="1950" b="1">
+                <a:solidFill>
+                  <a:srgbClr val="FFFFFF"/>
+                </a:solidFill>
+                <a:latin typeface="Apple SD Gothic Neo"/>
+                <a:ea typeface="Apple SD Gothic Neo"/>
+                <a:cs typeface="Apple SD Gothic Neo"/>
+              </a:defRPr>
+            </a:pPr>
+            <a:r>
+              <a:rPr sz="1950" b="1">
+                <a:solidFill>
+                  <a:srgbClr val="FFFFFF"/>
+                </a:solidFill>
+                <a:latin typeface="Apple SD Gothic Neo"/>
+                <a:ea typeface="Apple SD Gothic Neo"/>
+                <a:cs typeface="Apple SD Gothic Neo"/>
+              </a:rPr>
+              <a:t>원피스</a:t>
+            </a:r>
+          </a:p>
+        </p:txBody>
+      </p:sp>
+      <p:pic>
+        <p:nvPicPr>
+          <p:cNvPr id="10" name="">
+            <a:extLst xmlns:a="http://schemas.openxmlformats.org/drawingml/2006/main">
+              <a:ext uri="{FF2B5EF4-FFF2-40B4-BE49-F238E27FC236}">
+                <a16:creationId xmlns:a16="http://schemas.microsoft.com/office/drawing/2014/main" id="{AE430326-4553-4D4D-A1CE-24D813C294E1}"/>
+              </a:ext>
+            </a:extLst>
+          </p:cNvPr>
+          <p:cNvPicPr>
+            <a:picLocks xmlns:a="http://schemas.openxmlformats.org/drawingml/2006/main" noChangeAspect="1"/>
+          </p:cNvPicPr>
+          <p:nvPr/>
+        </p:nvPicPr>
+        <p:blipFill>
+          <a:blip xmlns:r="http://schemas.openxmlformats.org/officeDocument/2006/relationships" xmlns:a="http://schemas.openxmlformats.org/drawingml/2006/main" r:embed="R6669dc521aa74a49"/>
+          <a:stretch xmlns:a="http://schemas.openxmlformats.org/drawingml/2006/main"/>
+        </p:blipFill>
+        <p:spPr>
+          <a:xfrm xmlns:a="http://schemas.openxmlformats.org/drawingml/2006/main">
+            <a:off x="4457700" y="2684499"/>
+            <a:ext cx="2381250" cy="2403401"/>
+          </a:xfrm>
+          <a:prstGeom xmlns:a="http://schemas.openxmlformats.org/drawingml/2006/main" prst="rect">
+            <a:avLst/>
+          </a:prstGeom>
+        </p:spPr>
+      </p:pic>
+      <p:sp>
+        <p:nvSpPr>
+          <p:cNvPr id="11" name="">
+            <a:extLst xmlns:a="http://schemas.openxmlformats.org/drawingml/2006/main">
+              <a:ext uri="{FF2B5EF4-FFF2-40B4-BE49-F238E27FC236}">
+                <a16:creationId xmlns:a16="http://schemas.microsoft.com/office/drawing/2014/main" id="{F7DF040A-E355-4D9E-BB62-33E726ED59A2}"/>
+              </a:ext>
+            </a:extLst>
+          </p:cNvPr>
+          <p:cNvSpPr>
+            <a:spLocks xmlns:a="http://schemas.openxmlformats.org/drawingml/2006/main" noGrp="1"/>
+          </p:cNvSpPr>
+          <p:nvPr/>
+        </p:nvSpPr>
+        <p:spPr>
+          <a:xfrm xmlns:a="http://schemas.openxmlformats.org/drawingml/2006/main">
+            <a:off x="4457700" y="5381625"/>
+            <a:ext cx="2381250" cy="352425"/>
+          </a:xfrm>
+          <a:prstGeom xmlns:a="http://schemas.openxmlformats.org/drawingml/2006/main" prst="rect">
+            <a:avLst/>
+          </a:prstGeom>
+          <a:noFill xmlns:a="http://schemas.openxmlformats.org/drawingml/2006/main"/>
+          <a:ln xmlns:a="http://schemas.openxmlformats.org/drawingml/2006/main" w="0">
+            <a:noFill/>
+          </a:ln>
+        </p:spPr>
+        <p:txBody>
+          <a:bodyPr xmlns:a="http://schemas.openxmlformats.org/drawingml/2006/main" lIns="0" tIns="0" rIns="0" bIns="0"/>
+          <a:lstStyle xmlns:a="http://schemas.openxmlformats.org/drawingml/2006/main">
+            <a:defPPr>
+              <a:defRPr sz="1950" b="1">
+                <a:solidFill>
+                  <a:srgbClr val="FFFFFF"/>
+                </a:solidFill>
+                <a:latin typeface="Apple SD Gothic Neo"/>
+                <a:ea typeface="Apple SD Gothic Neo"/>
+                <a:cs typeface="Apple SD Gothic Neo"/>
+              </a:defRPr>
+            </a:defPPr>
+            <a:lvl1pPr>
+              <a:defRPr sz="1950" b="1">
+                <a:solidFill>
+                  <a:srgbClr val="FFFFFF"/>
+                </a:solidFill>
+                <a:latin typeface="Apple SD Gothic Neo"/>
+                <a:ea typeface="Apple SD Gothic Neo"/>
+                <a:cs typeface="Apple SD Gothic Neo"/>
+              </a:defRPr>
+            </a:lvl1pPr>
+            <a:lvl2pPr>
+              <a:defRPr sz="1950" b="1">
+                <a:solidFill>
+                  <a:srgbClr val="FFFFFF"/>
+                </a:solidFill>
+                <a:latin typeface="Apple SD Gothic Neo"/>
+                <a:ea typeface="Apple SD Gothic Neo"/>
+                <a:cs typeface="Apple SD Gothic Neo"/>
+              </a:defRPr>
+            </a:lvl2pPr>
+            <a:lvl3pPr>
+              <a:defRPr sz="1950" b="1">
+                <a:solidFill>
+                  <a:srgbClr val="FFFFFF"/>
+                </a:solidFill>
+                <a:latin typeface="Apple SD Gothic Neo"/>
+                <a:ea typeface="Apple SD Gothic Neo"/>
+                <a:cs typeface="Apple SD Gothic Neo"/>
+              </a:defRPr>
+            </a:lvl3pPr>
+            <a:lvl4pPr>
+              <a:defRPr sz="1950" b="1">
+                <a:solidFill>
+                  <a:srgbClr val="FFFFFF"/>
+                </a:solidFill>
+                <a:latin typeface="Apple SD Gothic Neo"/>
+                <a:ea typeface="Apple SD Gothic Neo"/>
+                <a:cs typeface="Apple SD Gothic Neo"/>
+              </a:defRPr>
+            </a:lvl4pPr>
+            <a:lvl5pPr>
+              <a:defRPr sz="1950" b="1">
+                <a:solidFill>
+                  <a:srgbClr val="FFFFFF"/>
+                </a:solidFill>
+                <a:latin typeface="Apple SD Gothic Neo"/>
+                <a:ea typeface="Apple SD Gothic Neo"/>
+                <a:cs typeface="Apple SD Gothic Neo"/>
+              </a:defRPr>
+            </a:lvl5pPr>
+            <a:lvl6pPr>
+              <a:defRPr sz="1950" b="1">
+                <a:solidFill>
+                  <a:srgbClr val="FFFFFF"/>
+                </a:solidFill>
+                <a:latin typeface="Apple SD Gothic Neo"/>
+                <a:ea typeface="Apple SD Gothic Neo"/>
+                <a:cs typeface="Apple SD Gothic Neo"/>
+              </a:defRPr>
+            </a:lvl6pPr>
+            <a:lvl7pPr>
+              <a:defRPr sz="1950" b="1">
+                <a:solidFill>
+                  <a:srgbClr val="FFFFFF"/>
+                </a:solidFill>
+                <a:latin typeface="Apple SD Gothic Neo"/>
+                <a:ea typeface="Apple SD Gothic Neo"/>
+                <a:cs typeface="Apple SD Gothic Neo"/>
+              </a:defRPr>
+            </a:lvl7pPr>
+            <a:lvl8pPr>
+              <a:defRPr sz="1950" b="1">
+                <a:solidFill>
+                  <a:srgbClr val="FFFFFF"/>
+                </a:solidFill>
+                <a:latin typeface="Apple SD Gothic Neo"/>
+                <a:ea typeface="Apple SD Gothic Neo"/>
+                <a:cs typeface="Apple SD Gothic Neo"/>
+              </a:defRPr>
+            </a:lvl8pPr>
+            <a:lvl9pPr>
+              <a:defRPr sz="1950" b="1">
+                <a:solidFill>
+                  <a:srgbClr val="FFFFFF"/>
+                </a:solidFill>
+                <a:latin typeface="Apple SD Gothic Neo"/>
+                <a:ea typeface="Apple SD Gothic Neo"/>
+                <a:cs typeface="Apple SD Gothic Neo"/>
+              </a:defRPr>
+            </a:lvl9pPr>
+          </a:lstStyle>
+          <a:p xmlns:a="http://schemas.openxmlformats.org/drawingml/2006/main">
+            <a:pPr>
+              <a:defRPr sz="1950" b="1">
+                <a:solidFill>
+                  <a:srgbClr val="FFFFFF"/>
+                </a:solidFill>
+                <a:latin typeface="Apple SD Gothic Neo"/>
+                <a:ea typeface="Apple SD Gothic Neo"/>
+                <a:cs typeface="Apple SD Gothic Neo"/>
+              </a:defRPr>
+            </a:pPr>
+            <a:r>
+              <a:rPr sz="1950" b="1">
+                <a:solidFill>
+                  <a:srgbClr val="FFFFFF"/>
+                </a:solidFill>
+                <a:latin typeface="Apple SD Gothic Neo"/>
+                <a:ea typeface="Apple SD Gothic Neo"/>
+                <a:cs typeface="Apple SD Gothic Neo"/>
+              </a:rPr>
+              <a:t>노블레스</a:t>
+            </a:r>
+          </a:p>
+        </p:txBody>
+      </p:sp>
+      <p:pic>
+        <p:nvPicPr>
+          <p:cNvPr id="12" name="">
+            <a:extLst xmlns:a="http://schemas.openxmlformats.org/drawingml/2006/main">
+              <a:ext uri="{FF2B5EF4-FFF2-40B4-BE49-F238E27FC236}">
+                <a16:creationId xmlns:a16="http://schemas.microsoft.com/office/drawing/2014/main" id="{9C0846F1-F142-4E91-ADDF-4FF3EA6BD482}"/>
+              </a:ext>
+            </a:extLst>
+          </p:cNvPr>
+          <p:cNvPicPr>
+            <a:picLocks xmlns:a="http://schemas.openxmlformats.org/drawingml/2006/main" noChangeAspect="1"/>
+          </p:cNvPicPr>
+          <p:nvPr/>
+        </p:nvPicPr>
+        <p:blipFill>
+          <a:blip xmlns:r="http://schemas.openxmlformats.org/officeDocument/2006/relationships" xmlns:a="http://schemas.openxmlformats.org/drawingml/2006/main" r:embed="R80cdf11481a44241"/>
+          <a:stretch xmlns:a="http://schemas.openxmlformats.org/drawingml/2006/main"/>
+        </p:blipFill>
+        <p:spPr>
+          <a:xfrm xmlns:a="http://schemas.openxmlformats.org/drawingml/2006/main">
+            <a:off x="7071481" y="2505075"/>
+            <a:ext cx="2135263" cy="2762250"/>
+          </a:xfrm>
+          <a:prstGeom xmlns:a="http://schemas.openxmlformats.org/drawingml/2006/main" prst="rect">
+            <a:avLst/>
+          </a:prstGeom>
+        </p:spPr>
+      </p:pic>
+      <p:sp>
+        <p:nvSpPr>
+          <p:cNvPr id="13" name="">
+            <a:extLst xmlns:a="http://schemas.openxmlformats.org/drawingml/2006/main">
+              <a:ext uri="{FF2B5EF4-FFF2-40B4-BE49-F238E27FC236}">
+                <a16:creationId xmlns:a16="http://schemas.microsoft.com/office/drawing/2014/main" id="{399F4D99-3864-48B0-8CAC-EB3621664CA2}"/>
+              </a:ext>
+            </a:extLst>
+          </p:cNvPr>
+          <p:cNvSpPr>
+            <a:spLocks xmlns:a="http://schemas.openxmlformats.org/drawingml/2006/main" noGrp="1"/>
+          </p:cNvSpPr>
+          <p:nvPr/>
+        </p:nvSpPr>
+        <p:spPr>
+          <a:xfrm xmlns:a="http://schemas.openxmlformats.org/drawingml/2006/main">
+            <a:off x="7067550" y="5381625"/>
+            <a:ext cx="2143125" cy="352425"/>
+          </a:xfrm>
+          <a:prstGeom xmlns:a="http://schemas.openxmlformats.org/drawingml/2006/main" prst="rect">
+            <a:avLst/>
+          </a:prstGeom>
+          <a:noFill xmlns:a="http://schemas.openxmlformats.org/drawingml/2006/main"/>
+          <a:ln xmlns:a="http://schemas.openxmlformats.org/drawingml/2006/main" w="0">
+            <a:noFill/>
+          </a:ln>
+        </p:spPr>
+        <p:txBody>
+          <a:bodyPr xmlns:a="http://schemas.openxmlformats.org/drawingml/2006/main" lIns="0" tIns="0" rIns="0" bIns="0"/>
+          <a:lstStyle xmlns:a="http://schemas.openxmlformats.org/drawingml/2006/main">
+            <a:defPPr>
+              <a:defRPr sz="1950" b="1">
+                <a:solidFill>
+                  <a:srgbClr val="FFFFFF"/>
+                </a:solidFill>
+                <a:latin typeface="Apple SD Gothic Neo"/>
+                <a:ea typeface="Apple SD Gothic Neo"/>
+                <a:cs typeface="Apple SD Gothic Neo"/>
+              </a:defRPr>
+            </a:defPPr>
+            <a:lvl1pPr>
+              <a:defRPr sz="1950" b="1">
+                <a:solidFill>
+                  <a:srgbClr val="FFFFFF"/>
+                </a:solidFill>
+                <a:latin typeface="Apple SD Gothic Neo"/>
+                <a:ea typeface="Apple SD Gothic Neo"/>
+                <a:cs typeface="Apple SD Gothic Neo"/>
+              </a:defRPr>
+            </a:lvl1pPr>
+            <a:lvl2pPr>
+              <a:defRPr sz="1950" b="1">
+                <a:solidFill>
+                  <a:srgbClr val="FFFFFF"/>
+                </a:solidFill>
+                <a:latin typeface="Apple SD Gothic Neo"/>
+                <a:ea typeface="Apple SD Gothic Neo"/>
+                <a:cs typeface="Apple SD Gothic Neo"/>
+              </a:defRPr>
+            </a:lvl2pPr>
+            <a:lvl3pPr>
+              <a:defRPr sz="1950" b="1">
+                <a:solidFill>
+                  <a:srgbClr val="FFFFFF"/>
+                </a:solidFill>
+                <a:latin typeface="Apple SD Gothic Neo"/>
+                <a:ea typeface="Apple SD Gothic Neo"/>
+                <a:cs typeface="Apple SD Gothic Neo"/>
+              </a:defRPr>
+            </a:lvl3pPr>
+            <a:lvl4pPr>
+              <a:defRPr sz="1950" b="1">
+                <a:solidFill>
+                  <a:srgbClr val="FFFFFF"/>
+                </a:solidFill>
+                <a:latin typeface="Apple SD Gothic Neo"/>
+                <a:ea typeface="Apple SD Gothic Neo"/>
+                <a:cs typeface="Apple SD Gothic Neo"/>
+              </a:defRPr>
+            </a:lvl4pPr>
+            <a:lvl5pPr>
+              <a:defRPr sz="1950" b="1">
+                <a:solidFill>
+                  <a:srgbClr val="FFFFFF"/>
+                </a:solidFill>
+                <a:latin typeface="Apple SD Gothic Neo"/>
+                <a:ea typeface="Apple SD Gothic Neo"/>
+                <a:cs typeface="Apple SD Gothic Neo"/>
+              </a:defRPr>
+            </a:lvl5pPr>
+            <a:lvl6pPr>
+              <a:defRPr sz="1950" b="1">
+                <a:solidFill>
+                  <a:srgbClr val="FFFFFF"/>
+                </a:solidFill>
+                <a:latin typeface="Apple SD Gothic Neo"/>
+                <a:ea typeface="Apple SD Gothic Neo"/>
+                <a:cs typeface="Apple SD Gothic Neo"/>
+              </a:defRPr>
+            </a:lvl6pPr>
+            <a:lvl7pPr>
+              <a:defRPr sz="1950" b="1">
+                <a:solidFill>
+                  <a:srgbClr val="FFFFFF"/>
+                </a:solidFill>
+                <a:latin typeface="Apple SD Gothic Neo"/>
+                <a:ea typeface="Apple SD Gothic Neo"/>
+                <a:cs typeface="Apple SD Gothic Neo"/>
+              </a:defRPr>
+            </a:lvl7pPr>
+            <a:lvl8pPr>
+              <a:defRPr sz="1950" b="1">
+                <a:solidFill>
+                  <a:srgbClr val="FFFFFF"/>
+                </a:solidFill>
+                <a:latin typeface="Apple SD Gothic Neo"/>
+                <a:ea typeface="Apple SD Gothic Neo"/>
+                <a:cs typeface="Apple SD Gothic Neo"/>
+              </a:defRPr>
+            </a:lvl8pPr>
+            <a:lvl9pPr>
+              <a:defRPr sz="1950" b="1">
+                <a:solidFill>
+                  <a:srgbClr val="FFFFFF"/>
+                </a:solidFill>
+                <a:latin typeface="Apple SD Gothic Neo"/>
+                <a:ea typeface="Apple SD Gothic Neo"/>
+                <a:cs typeface="Apple SD Gothic Neo"/>
+              </a:defRPr>
+            </a:lvl9pPr>
+          </a:lstStyle>
+          <a:p xmlns:a="http://schemas.openxmlformats.org/drawingml/2006/main">
+            <a:pPr>
+              <a:defRPr sz="1950" b="1">
+                <a:solidFill>
+                  <a:srgbClr val="FFFFFF"/>
+                </a:solidFill>
+                <a:latin typeface="Apple SD Gothic Neo"/>
+                <a:ea typeface="Apple SD Gothic Neo"/>
+                <a:cs typeface="Apple SD Gothic Neo"/>
+              </a:defRPr>
+            </a:pPr>
+            <a:r>
+              <a:rPr sz="1950" b="1">
+                <a:solidFill>
+                  <a:srgbClr val="FFFFFF"/>
+                </a:solidFill>
+                <a:latin typeface="Apple SD Gothic Neo"/>
+                <a:ea typeface="Apple SD Gothic Neo"/>
+                <a:cs typeface="Apple SD Gothic Neo"/>
+              </a:rPr>
+              <a:t>외모지상주의</a:t>
+            </a:r>
+          </a:p>
+        </p:txBody>
+      </p:sp>
+      <p:pic>
+        <p:nvPicPr>
+          <p:cNvPr id="14" name="">
+            <a:extLst xmlns:a="http://schemas.openxmlformats.org/drawingml/2006/main">
+              <a:ext uri="{FF2B5EF4-FFF2-40B4-BE49-F238E27FC236}">
+                <a16:creationId xmlns:a16="http://schemas.microsoft.com/office/drawing/2014/main" id="{96F60B14-CFF5-45AD-9964-1643FE74AFC0}"/>
+              </a:ext>
+            </a:extLst>
+          </p:cNvPr>
+          <p:cNvPicPr>
+            <a:picLocks xmlns:a="http://schemas.openxmlformats.org/drawingml/2006/main" noChangeAspect="1"/>
+          </p:cNvPicPr>
+          <p:nvPr/>
+        </p:nvPicPr>
+        <p:blipFill>
+          <a:blip xmlns:r="http://schemas.openxmlformats.org/officeDocument/2006/relationships" xmlns:a="http://schemas.openxmlformats.org/drawingml/2006/main" r:embed="R1ae4126f3de54a06"/>
+          <a:stretch xmlns:a="http://schemas.openxmlformats.org/drawingml/2006/main"/>
+        </p:blipFill>
+        <p:spPr>
+          <a:xfrm xmlns:a="http://schemas.openxmlformats.org/drawingml/2006/main">
+            <a:off x="9664397" y="2505075"/>
+            <a:ext cx="1550006" cy="2762250"/>
+          </a:xfrm>
+          <a:prstGeom xmlns:a="http://schemas.openxmlformats.org/drawingml/2006/main" prst="rect">
+            <a:avLst/>
+          </a:prstGeom>
+        </p:spPr>
+      </p:pic>
+      <p:sp>
+        <p:nvSpPr>
+          <p:cNvPr id="15" name="">
+            <a:extLst xmlns:a="http://schemas.openxmlformats.org/drawingml/2006/main">
+              <a:ext uri="{FF2B5EF4-FFF2-40B4-BE49-F238E27FC236}">
+                <a16:creationId xmlns:a16="http://schemas.microsoft.com/office/drawing/2014/main" id="{E4C91EFA-668D-4E71-9F3F-73715DEF9E7D}"/>
+              </a:ext>
+            </a:extLst>
+          </p:cNvPr>
+          <p:cNvSpPr>
+            <a:spLocks xmlns:a="http://schemas.openxmlformats.org/drawingml/2006/main" noGrp="1"/>
+          </p:cNvSpPr>
+          <p:nvPr/>
+        </p:nvSpPr>
+        <p:spPr>
+          <a:xfrm xmlns:a="http://schemas.openxmlformats.org/drawingml/2006/main">
+            <a:off x="9439275" y="5381625"/>
+            <a:ext cx="2000250" cy="352425"/>
+          </a:xfrm>
+          <a:prstGeom xmlns:a="http://schemas.openxmlformats.org/drawingml/2006/main" prst="rect">
+            <a:avLst/>
+          </a:prstGeom>
+          <a:noFill xmlns:a="http://schemas.openxmlformats.org/drawingml/2006/main"/>
+          <a:ln xmlns:a="http://schemas.openxmlformats.org/drawingml/2006/main" w="0">
+            <a:noFill/>
+          </a:ln>
+        </p:spPr>
+        <p:txBody>
+          <a:bodyPr xmlns:a="http://schemas.openxmlformats.org/drawingml/2006/main" lIns="0" tIns="0" rIns="0" bIns="0"/>
+          <a:lstStyle xmlns:a="http://schemas.openxmlformats.org/drawingml/2006/main">
+            <a:defPPr>
+              <a:defRPr sz="1950" b="1">
+                <a:solidFill>
+                  <a:srgbClr val="FFFFFF"/>
+                </a:solidFill>
+                <a:latin typeface="Apple SD Gothic Neo"/>
+                <a:ea typeface="Apple SD Gothic Neo"/>
+                <a:cs typeface="Apple SD Gothic Neo"/>
+              </a:defRPr>
+            </a:defPPr>
+            <a:lvl1pPr>
+              <a:defRPr sz="1950" b="1">
+                <a:solidFill>
+                  <a:srgbClr val="FFFFFF"/>
+                </a:solidFill>
+                <a:latin typeface="Apple SD Gothic Neo"/>
+                <a:ea typeface="Apple SD Gothic Neo"/>
+                <a:cs typeface="Apple SD Gothic Neo"/>
+              </a:defRPr>
+            </a:lvl1pPr>
+            <a:lvl2pPr>
+              <a:defRPr sz="1950" b="1">
+                <a:solidFill>
+                  <a:srgbClr val="FFFFFF"/>
+                </a:solidFill>
+                <a:latin typeface="Apple SD Gothic Neo"/>
+                <a:ea typeface="Apple SD Gothic Neo"/>
+                <a:cs typeface="Apple SD Gothic Neo"/>
+              </a:defRPr>
+            </a:lvl2pPr>
+            <a:lvl3pPr>
+              <a:defRPr sz="1950" b="1">
+                <a:solidFill>
+                  <a:srgbClr val="FFFFFF"/>
+                </a:solidFill>
+                <a:latin typeface="Apple SD Gothic Neo"/>
+                <a:ea typeface="Apple SD Gothic Neo"/>
+                <a:cs typeface="Apple SD Gothic Neo"/>
+              </a:defRPr>
+            </a:lvl3pPr>
+            <a:lvl4pPr>
+              <a:defRPr sz="1950" b="1">
+                <a:solidFill>
+                  <a:srgbClr val="FFFFFF"/>
+                </a:solidFill>
+                <a:latin typeface="Apple SD Gothic Neo"/>
+                <a:ea typeface="Apple SD Gothic Neo"/>
+                <a:cs typeface="Apple SD Gothic Neo"/>
+              </a:defRPr>
+            </a:lvl4pPr>
+            <a:lvl5pPr>
+              <a:defRPr sz="1950" b="1">
+                <a:solidFill>
+                  <a:srgbClr val="FFFFFF"/>
+                </a:solidFill>
+                <a:latin typeface="Apple SD Gothic Neo"/>
+                <a:ea typeface="Apple SD Gothic Neo"/>
+                <a:cs typeface="Apple SD Gothic Neo"/>
+              </a:defRPr>
+            </a:lvl5pPr>
+            <a:lvl6pPr>
+              <a:defRPr sz="1950" b="1">
+                <a:solidFill>
+                  <a:srgbClr val="FFFFFF"/>
+                </a:solidFill>
+                <a:latin typeface="Apple SD Gothic Neo"/>
+                <a:ea typeface="Apple SD Gothic Neo"/>
+                <a:cs typeface="Apple SD Gothic Neo"/>
+              </a:defRPr>
+            </a:lvl6pPr>
+            <a:lvl7pPr>
+              <a:defRPr sz="1950" b="1">
+                <a:solidFill>
+                  <a:srgbClr val="FFFFFF"/>
+                </a:solidFill>
+                <a:latin typeface="Apple SD Gothic Neo"/>
+                <a:ea typeface="Apple SD Gothic Neo"/>
+                <a:cs typeface="Apple SD Gothic Neo"/>
+              </a:defRPr>
+            </a:lvl7pPr>
+            <a:lvl8pPr>
+              <a:defRPr sz="1950" b="1">
+                <a:solidFill>
+                  <a:srgbClr val="FFFFFF"/>
+                </a:solidFill>
+                <a:latin typeface="Apple SD Gothic Neo"/>
+                <a:ea typeface="Apple SD Gothic Neo"/>
+                <a:cs typeface="Apple SD Gothic Neo"/>
+              </a:defRPr>
+            </a:lvl8pPr>
+            <a:lvl9pPr>
+              <a:defRPr sz="1950" b="1">
+                <a:solidFill>
+                  <a:srgbClr val="FFFFFF"/>
+                </a:solidFill>
+                <a:latin typeface="Apple SD Gothic Neo"/>
+                <a:ea typeface="Apple SD Gothic Neo"/>
+                <a:cs typeface="Apple SD Gothic Neo"/>
+              </a:defRPr>
+            </a:lvl9pPr>
+          </a:lstStyle>
+          <a:p xmlns:a="http://schemas.openxmlformats.org/drawingml/2006/main">
+            <a:pPr>
+              <a:defRPr sz="1950" b="1">
+                <a:solidFill>
+                  <a:srgbClr val="FFFFFF"/>
+                </a:solidFill>
+                <a:latin typeface="Apple SD Gothic Neo"/>
+                <a:ea typeface="Apple SD Gothic Neo"/>
+                <a:cs typeface="Apple SD Gothic Neo"/>
+              </a:defRPr>
+            </a:pPr>
+            <a:r>
+              <a:rPr sz="1950" b="1">
+                <a:solidFill>
+                  <a:srgbClr val="FFFFFF"/>
+                </a:solidFill>
+                <a:latin typeface="Apple SD Gothic Neo"/>
+                <a:ea typeface="Apple SD Gothic Neo"/>
+                <a:cs typeface="Apple SD Gothic Neo"/>
+              </a:rPr>
+              <a:t>갓 오브 하이스쿨</a:t>
+            </a:r>
+          </a:p>
+        </p:txBody>
+      </p:sp>
+      <p:sp>
+        <p:nvSpPr>
+          <p:cNvPr id="16" name="">
+            <a:extLst xmlns:a="http://schemas.openxmlformats.org/drawingml/2006/main">
+              <a:ext uri="{FF2B5EF4-FFF2-40B4-BE49-F238E27FC236}">
+                <a16:creationId xmlns:a16="http://schemas.microsoft.com/office/drawing/2014/main" id="{22AE983F-7B29-4860-B09C-1EDBB0FAA8DF}"/>
+              </a:ext>
+            </a:extLst>
+          </p:cNvPr>
+          <p:cNvSpPr>
+            <a:spLocks xmlns:a="http://schemas.openxmlformats.org/drawingml/2006/main" noGrp="1"/>
+          </p:cNvSpPr>
+          <p:nvPr/>
+        </p:nvSpPr>
+        <p:spPr>
+          <a:xfrm xmlns:a="http://schemas.openxmlformats.org/drawingml/2006/main">
+            <a:off x="9439275" y="5724525"/>
+            <a:ext cx="2000250" cy="238125"/>
+          </a:xfrm>
+          <a:prstGeom xmlns:a="http://schemas.openxmlformats.org/drawingml/2006/main" prst="rect">
+            <a:avLst/>
+          </a:prstGeom>
+          <a:noFill xmlns:a="http://schemas.openxmlformats.org/drawingml/2006/main"/>
+          <a:ln xmlns:a="http://schemas.openxmlformats.org/drawingml/2006/main" w="0">
+            <a:noFill/>
+          </a:ln>
+        </p:spPr>
+        <p:txBody>
+          <a:bodyPr xmlns:a="http://schemas.openxmlformats.org/drawingml/2006/main" lIns="0" tIns="0" rIns="0" bIns="0"/>
+          <a:lstStyle xmlns:a="http://schemas.openxmlformats.org/drawingml/2006/main">
+            <a:defPPr>
+              <a:defRPr sz="1350" b="0">
+                <a:solidFill>
+                  <a:srgbClr val="A6C5D7"/>
+                </a:solidFill>
+                <a:latin typeface="Apple SD Gothic Neo"/>
+                <a:ea typeface="Apple SD Gothic Neo"/>
+                <a:cs typeface="Apple SD Gothic Neo"/>
+              </a:defRPr>
+            </a:defPPr>
+            <a:lvl1pPr>
+              <a:defRPr sz="1350" b="0">
+                <a:solidFill>
+                  <a:srgbClr val="A6C5D7"/>
+                </a:solidFill>
+                <a:latin typeface="Apple SD Gothic Neo"/>
+                <a:ea typeface="Apple SD Gothic Neo"/>
+                <a:cs typeface="Apple SD Gothic Neo"/>
+              </a:defRPr>
+            </a:lvl1pPr>
+            <a:lvl2pPr>
+              <a:defRPr sz="1350" b="0">
+                <a:solidFill>
+                  <a:srgbClr val="A6C5D7"/>
+                </a:solidFill>
+                <a:latin typeface="Apple SD Gothic Neo"/>
+                <a:ea typeface="Apple SD Gothic Neo"/>
+                <a:cs typeface="Apple SD Gothic Neo"/>
+              </a:defRPr>
+            </a:lvl2pPr>
+            <a:lvl3pPr>
+              <a:defRPr sz="1350" b="0">
+                <a:solidFill>
+                  <a:srgbClr val="A6C5D7"/>
+                </a:solidFill>
+                <a:latin typeface="Apple SD Gothic Neo"/>
+                <a:ea typeface="Apple SD Gothic Neo"/>
+                <a:cs typeface="Apple SD Gothic Neo"/>
+              </a:defRPr>
+            </a:lvl3pPr>
+            <a:lvl4pPr>
+              <a:defRPr sz="1350" b="0">
+                <a:solidFill>
+                  <a:srgbClr val="A6C5D7"/>
+                </a:solidFill>
+                <a:latin typeface="Apple SD Gothic Neo"/>
+                <a:ea typeface="Apple SD Gothic Neo"/>
+                <a:cs typeface="Apple SD Gothic Neo"/>
+              </a:defRPr>
+            </a:lvl4pPr>
+            <a:lvl5pPr>
+              <a:defRPr sz="1350" b="0">
+                <a:solidFill>
+                  <a:srgbClr val="A6C5D7"/>
+                </a:solidFill>
+                <a:latin typeface="Apple SD Gothic Neo"/>
+                <a:ea typeface="Apple SD Gothic Neo"/>
+                <a:cs typeface="Apple SD Gothic Neo"/>
+              </a:defRPr>
+            </a:lvl5pPr>
+            <a:lvl6pPr>
+              <a:defRPr sz="1350" b="0">
+                <a:solidFill>
+                  <a:srgbClr val="A6C5D7"/>
+                </a:solidFill>
+                <a:latin typeface="Apple SD Gothic Neo"/>
+                <a:ea typeface="Apple SD Gothic Neo"/>
+                <a:cs typeface="Apple SD Gothic Neo"/>
+              </a:defRPr>
+            </a:lvl6pPr>
+            <a:lvl7pPr>
+              <a:defRPr sz="1350" b="0">
+                <a:solidFill>
+                  <a:srgbClr val="A6C5D7"/>
+                </a:solidFill>
+                <a:latin typeface="Apple SD Gothic Neo"/>
+                <a:ea typeface="Apple SD Gothic Neo"/>
+                <a:cs typeface="Apple SD Gothic Neo"/>
+              </a:defRPr>
+            </a:lvl7pPr>
+            <a:lvl8pPr>
+              <a:defRPr sz="1350" b="0">
+                <a:solidFill>
+                  <a:srgbClr val="A6C5D7"/>
+                </a:solidFill>
+                <a:latin typeface="Apple SD Gothic Neo"/>
+                <a:ea typeface="Apple SD Gothic Neo"/>
+                <a:cs typeface="Apple SD Gothic Neo"/>
+              </a:defRPr>
+            </a:lvl8pPr>
+            <a:lvl9pPr>
+              <a:defRPr sz="1350" b="0">
+                <a:solidFill>
+                  <a:srgbClr val="A6C5D7"/>
+                </a:solidFill>
+                <a:latin typeface="Apple SD Gothic Neo"/>
+                <a:ea typeface="Apple SD Gothic Neo"/>
+                <a:cs typeface="Apple SD Gothic Neo"/>
+              </a:defRPr>
+            </a:lvl9pPr>
+          </a:lstStyle>
+          <a:p xmlns:a="http://schemas.openxmlformats.org/drawingml/2006/main">
+            <a:pPr>
+              <a:defRPr sz="1350" b="0">
+                <a:solidFill>
+                  <a:srgbClr val="A6C5D7"/>
+                </a:solidFill>
+                <a:latin typeface="Apple SD Gothic Neo"/>
+                <a:ea typeface="Apple SD Gothic Neo"/>
+                <a:cs typeface="Apple SD Gothic Neo"/>
+              </a:defRPr>
+            </a:pPr>
+            <a:r>
+              <a:rPr sz="1350" b="0">
+                <a:solidFill>
+                  <a:srgbClr val="A6C5D7"/>
+                </a:solidFill>
+                <a:latin typeface="Apple SD Gothic Neo"/>
+                <a:ea typeface="Apple SD Gothic Neo"/>
+                <a:cs typeface="Apple SD Gothic Neo"/>
+              </a:rPr>
+              <a:t>제아봉침 25만 배</a:t>
             </a:r>
           </a:p>
         </p:txBody>
@@ -5153,7 +6089,7 @@
                 <a:ea typeface="Apple SD Gothic Neo"/>
                 <a:cs typeface="Apple SD Gothic Neo"/>
               </a:rPr>
-              <a:t>주제와 세부 태스크</a:t>
+              <a:t>LoreForge의 주요 기능</a:t>
             </a:r>
           </a:p>
         </p:txBody>
@@ -5521,7 +6457,7 @@
           <a:bodyPr xmlns:a="http://schemas.openxmlformats.org/drawingml/2006/main" lIns="0" tIns="0" rIns="0" bIns="0"/>
           <a:lstStyle xmlns:a="http://schemas.openxmlformats.org/drawingml/2006/main">
             <a:defPPr>
-              <a:defRPr sz="2325" b="1">
+              <a:defRPr sz="2250" b="1">
                 <a:solidFill>
                   <a:srgbClr val="0F52BA"/>
                 </a:solidFill>
@@ -5633,7 +6569,7 @@
           <a:p xmlns:a="http://schemas.openxmlformats.org/drawingml/2006/main">
             <a:pPr>
               <a:buNone/>
-              <a:defRPr sz="2325" b="1">
+              <a:defRPr sz="2250" b="1">
                 <a:solidFill>
                   <a:srgbClr val="0F52BA"/>
                 </a:solidFill>
@@ -5643,7 +6579,7 @@
               </a:defRPr>
             </a:pPr>
             <a:r>
-              <a:rPr sz="2325" b="1">
+              <a:rPr sz="2250" b="1">
                 <a:solidFill>
                   <a:srgbClr val="0F52BA"/>
                 </a:solidFill>
@@ -5651,7 +6587,7 @@
                 <a:ea typeface="Apple SD Gothic Neo"/>
                 <a:cs typeface="Apple SD Gothic Neo"/>
               </a:rPr>
-              <a:t>설정이 늘어날수록, 무엇이 어디와 충돌하는지 찾기 어렵다</a:t>
+              <a:t>의심되는 설정을 찾고, 작성자가 근거를 확인한다</a:t>
             </a:r>
           </a:p>
         </p:txBody>
@@ -8702,7 +9638,7 @@
           <p:cNvPr id="9" name="">
             <a:extLst xmlns:a="http://schemas.openxmlformats.org/drawingml/2006/main">
               <a:ext uri="{FF2B5EF4-FFF2-40B4-BE49-F238E27FC236}">
-                <a16:creationId xmlns:a16="http://schemas.microsoft.com/office/drawing/2014/main" id="{FD697D05-19E1-4124-BD64-810CBED541DC}"/>
+                <a16:creationId xmlns:a16="http://schemas.microsoft.com/office/drawing/2014/main" id="{1C6CF6E0-7E2C-4D31-80D5-721C37BEF46F}"/>
               </a:ext>
             </a:extLst>
           </p:cNvPr>
@@ -8712,7 +9648,7 @@
           <p:nvPr/>
         </p:nvPicPr>
         <p:blipFill>
-          <a:blip xmlns:r="http://schemas.openxmlformats.org/officeDocument/2006/relationships" xmlns:a="http://schemas.openxmlformats.org/drawingml/2006/main" r:embed="R8014c74caf4f44c4"/>
+          <a:blip xmlns:r="http://schemas.openxmlformats.org/officeDocument/2006/relationships" xmlns:a="http://schemas.openxmlformats.org/drawingml/2006/main" r:embed="Rd02ed7daaa3b4187"/>
           <a:srcRect xmlns:a="http://schemas.openxmlformats.org/drawingml/2006/main" l="24500" t="32000" r="25000" b="22000"/>
           <a:stretch xmlns:a="http://schemas.openxmlformats.org/drawingml/2006/main"/>
         </p:blipFill>
@@ -8767,6 +9703,7 @@
               </a:defRPr>
             </a:defPPr>
             <a:lvl1pPr>
+              <a:buNone/>
               <a:defRPr sz="2100" b="1">
                 <a:solidFill>
                   <a:srgbClr val="0F52BA"/>
@@ -8777,6 +9714,7 @@
               </a:defRPr>
             </a:lvl1pPr>
             <a:lvl2pPr>
+              <a:buNone/>
               <a:defRPr sz="2100" b="1">
                 <a:solidFill>
                   <a:srgbClr val="0F52BA"/>
@@ -8787,6 +9725,7 @@
               </a:defRPr>
             </a:lvl2pPr>
             <a:lvl3pPr>
+              <a:buNone/>
               <a:defRPr sz="2100" b="1">
                 <a:solidFill>
                   <a:srgbClr val="0F52BA"/>
@@ -8797,6 +9736,7 @@
               </a:defRPr>
             </a:lvl3pPr>
             <a:lvl4pPr>
+              <a:buNone/>
               <a:defRPr sz="2100" b="1">
                 <a:solidFill>
                   <a:srgbClr val="0F52BA"/>
@@ -8807,6 +9747,7 @@
               </a:defRPr>
             </a:lvl4pPr>
             <a:lvl5pPr>
+              <a:buNone/>
               <a:defRPr sz="2100" b="1">
                 <a:solidFill>
                   <a:srgbClr val="0F52BA"/>
@@ -8817,6 +9758,7 @@
               </a:defRPr>
             </a:lvl5pPr>
             <a:lvl6pPr>
+              <a:buNone/>
               <a:defRPr sz="2100" b="1">
                 <a:solidFill>
                   <a:srgbClr val="0F52BA"/>
@@ -8827,6 +9769,7 @@
               </a:defRPr>
             </a:lvl6pPr>
             <a:lvl7pPr>
+              <a:buNone/>
               <a:defRPr sz="2100" b="1">
                 <a:solidFill>
                   <a:srgbClr val="0F52BA"/>
@@ -8837,6 +9780,7 @@
               </a:defRPr>
             </a:lvl7pPr>
             <a:lvl8pPr>
+              <a:buNone/>
               <a:defRPr sz="2100" b="1">
                 <a:solidFill>
                   <a:srgbClr val="0F52BA"/>
@@ -8847,6 +9791,7 @@
               </a:defRPr>
             </a:lvl8pPr>
             <a:lvl9pPr>
+              <a:buNone/>
               <a:defRPr sz="2100" b="1">
                 <a:solidFill>
                   <a:srgbClr val="0F52BA"/>
@@ -8859,6 +9804,7 @@
           </a:lstStyle>
           <a:p xmlns:a="http://schemas.openxmlformats.org/drawingml/2006/main">
             <a:pPr>
+              <a:buNone/>
               <a:defRPr sz="2100" b="1">
                 <a:solidFill>
                   <a:srgbClr val="0F52BA"/>
@@ -8887,7 +9833,7 @@
           <p:cNvPr id="12" name="">
             <a:extLst xmlns:a="http://schemas.openxmlformats.org/drawingml/2006/main">
               <a:ext uri="{FF2B5EF4-FFF2-40B4-BE49-F238E27FC236}">
-                <a16:creationId xmlns:a16="http://schemas.microsoft.com/office/drawing/2014/main" id="{4BF91EB4-C6AE-4F47-9A21-B0628A948923}"/>
+                <a16:creationId xmlns:a16="http://schemas.microsoft.com/office/drawing/2014/main" id="{7327C31E-7690-4351-A486-F5D30B7E03C0}"/>
               </a:ext>
             </a:extLst>
           </p:cNvPr>
@@ -8897,7 +9843,7 @@
           <p:nvPr/>
         </p:nvPicPr>
         <p:blipFill>
-          <a:blip xmlns:r="http://schemas.openxmlformats.org/officeDocument/2006/relationships" xmlns:a="http://schemas.openxmlformats.org/drawingml/2006/main" r:embed="R73f51b7280384f2f"/>
+          <a:blip xmlns:r="http://schemas.openxmlformats.org/officeDocument/2006/relationships" xmlns:a="http://schemas.openxmlformats.org/drawingml/2006/main" r:embed="R2c831c56f7d14837"/>
           <a:srcRect xmlns:a="http://schemas.openxmlformats.org/drawingml/2006/main" l="2700" t="39500" r="3200" b="20500"/>
           <a:stretch xmlns:a="http://schemas.openxmlformats.org/drawingml/2006/main"/>
         </p:blipFill>
@@ -8945,7 +9891,7 @@
           <p:cNvPr id="12" name="">
             <a:extLst xmlns:a="http://schemas.openxmlformats.org/drawingml/2006/main">
               <a:ext uri="{FF2B5EF4-FFF2-40B4-BE49-F238E27FC236}">
-                <a16:creationId xmlns:a16="http://schemas.microsoft.com/office/drawing/2014/main" id="{67F69969-E50C-4CD6-ACC8-0AE12129F3D9}"/>
+                <a16:creationId xmlns:a16="http://schemas.microsoft.com/office/drawing/2014/main" id="{C7EDEDBE-A00F-435B-95DD-48AC8508442C}"/>
               </a:ext>
             </a:extLst>
           </p:cNvPr>
@@ -8976,7 +9922,7 @@
           <p:cNvPr id="11" name="">
             <a:extLst xmlns:a="http://schemas.openxmlformats.org/drawingml/2006/main">
               <a:ext uri="{FF2B5EF4-FFF2-40B4-BE49-F238E27FC236}">
-                <a16:creationId xmlns:a16="http://schemas.microsoft.com/office/drawing/2014/main" id="{E7001E22-D221-467E-B917-BAF9AA5AF7F5}"/>
+                <a16:creationId xmlns:a16="http://schemas.microsoft.com/office/drawing/2014/main" id="{214A8C57-3CAB-400B-872D-3980AB55CC25}"/>
               </a:ext>
             </a:extLst>
           </p:cNvPr>
@@ -9007,7 +9953,7 @@
           <p:cNvPr id="10" name="">
             <a:extLst xmlns:a="http://schemas.openxmlformats.org/drawingml/2006/main">
               <a:ext uri="{FF2B5EF4-FFF2-40B4-BE49-F238E27FC236}">
-                <a16:creationId xmlns:a16="http://schemas.microsoft.com/office/drawing/2014/main" id="{F1A33267-BC34-44CD-9D16-487283C195B2}"/>
+                <a16:creationId xmlns:a16="http://schemas.microsoft.com/office/drawing/2014/main" id="{2A684972-CFF4-436F-A961-A509E8F9BFC0}"/>
               </a:ext>
             </a:extLst>
           </p:cNvPr>
@@ -9038,7 +9984,7 @@
           <p:cNvPr id="9" name="">
             <a:extLst xmlns:a="http://schemas.openxmlformats.org/drawingml/2006/main">
               <a:ext uri="{FF2B5EF4-FFF2-40B4-BE49-F238E27FC236}">
-                <a16:creationId xmlns:a16="http://schemas.microsoft.com/office/drawing/2014/main" id="{2305999E-62EB-493D-AF6E-7C304FB4BF69}"/>
+                <a16:creationId xmlns:a16="http://schemas.microsoft.com/office/drawing/2014/main" id="{616F4DB4-FD43-4C82-88F9-877A61552A96}"/>
               </a:ext>
             </a:extLst>
           </p:cNvPr>
@@ -11661,6 +12607,7 @@
               </a:defRPr>
             </a:defPPr>
             <a:lvl1pPr>
+              <a:buNone/>
               <a:defRPr sz="1425" b="0">
                 <a:solidFill>
                   <a:srgbClr val="172B45"/>
@@ -11671,6 +12618,7 @@
               </a:defRPr>
             </a:lvl1pPr>
             <a:lvl2pPr>
+              <a:buNone/>
               <a:defRPr sz="1425" b="0">
                 <a:solidFill>
                   <a:srgbClr val="172B45"/>
@@ -11681,6 +12629,7 @@
               </a:defRPr>
             </a:lvl2pPr>
             <a:lvl3pPr>
+              <a:buNone/>
               <a:defRPr sz="1425" b="0">
                 <a:solidFill>
                   <a:srgbClr val="172B45"/>
@@ -11691,6 +12640,7 @@
               </a:defRPr>
             </a:lvl3pPr>
             <a:lvl4pPr>
+              <a:buNone/>
               <a:defRPr sz="1425" b="0">
                 <a:solidFill>
                   <a:srgbClr val="172B45"/>
@@ -11701,6 +12651,7 @@
               </a:defRPr>
             </a:lvl4pPr>
             <a:lvl5pPr>
+              <a:buNone/>
               <a:defRPr sz="1425" b="0">
                 <a:solidFill>
                   <a:srgbClr val="172B45"/>
@@ -11711,6 +12662,7 @@
               </a:defRPr>
             </a:lvl5pPr>
             <a:lvl6pPr>
+              <a:buNone/>
               <a:defRPr sz="1425" b="0">
                 <a:solidFill>
                   <a:srgbClr val="172B45"/>
@@ -11721,6 +12673,7 @@
               </a:defRPr>
             </a:lvl6pPr>
             <a:lvl7pPr>
+              <a:buNone/>
               <a:defRPr sz="1425" b="0">
                 <a:solidFill>
                   <a:srgbClr val="172B45"/>
@@ -11731,6 +12684,7 @@
               </a:defRPr>
             </a:lvl7pPr>
             <a:lvl8pPr>
+              <a:buNone/>
               <a:defRPr sz="1425" b="0">
                 <a:solidFill>
                   <a:srgbClr val="172B45"/>
@@ -11741,6 +12695,7 @@
               </a:defRPr>
             </a:lvl8pPr>
             <a:lvl9pPr>
+              <a:buNone/>
               <a:defRPr sz="1425" b="0">
                 <a:solidFill>
                   <a:srgbClr val="172B45"/>
@@ -11753,6 +12708,7 @@
           </a:lstStyle>
           <a:p xmlns:a="http://schemas.openxmlformats.org/drawingml/2006/main">
             <a:pPr>
+              <a:buNone/>
               <a:defRPr sz="1425" b="0">
                 <a:solidFill>
                   <a:srgbClr val="172B45"/>
@@ -11776,6 +12732,7 @@
           </a:p>
           <a:p xmlns:a="http://schemas.openxmlformats.org/drawingml/2006/main">
             <a:pPr>
+              <a:buNone/>
               <a:defRPr sz="1425" b="0">
                 <a:solidFill>
                   <a:srgbClr val="172B45"/>
@@ -11799,6 +12756,7 @@
           </a:p>
           <a:p xmlns:a="http://schemas.openxmlformats.org/drawingml/2006/main">
             <a:pPr>
+              <a:buNone/>
               <a:defRPr sz="1425" b="0">
                 <a:solidFill>
                   <a:srgbClr val="172B45"/>
@@ -16936,6 +17894,7 @@
               </a:defRPr>
             </a:defPPr>
             <a:lvl1pPr>
+              <a:buNone/>
               <a:defRPr sz="2325" b="1">
                 <a:solidFill>
                   <a:srgbClr val="0F52BA"/>
@@ -16946,6 +17905,7 @@
               </a:defRPr>
             </a:lvl1pPr>
             <a:lvl2pPr>
+              <a:buNone/>
               <a:defRPr sz="2325" b="1">
                 <a:solidFill>
                   <a:srgbClr val="0F52BA"/>
@@ -16956,6 +17916,7 @@
               </a:defRPr>
             </a:lvl2pPr>
             <a:lvl3pPr>
+              <a:buNone/>
               <a:defRPr sz="2325" b="1">
                 <a:solidFill>
                   <a:srgbClr val="0F52BA"/>
@@ -16966,6 +17927,7 @@
               </a:defRPr>
             </a:lvl3pPr>
             <a:lvl4pPr>
+              <a:buNone/>
               <a:defRPr sz="2325" b="1">
                 <a:solidFill>
                   <a:srgbClr val="0F52BA"/>
@@ -16976,6 +17938,7 @@
               </a:defRPr>
             </a:lvl4pPr>
             <a:lvl5pPr>
+              <a:buNone/>
               <a:defRPr sz="2325" b="1">
                 <a:solidFill>
                   <a:srgbClr val="0F52BA"/>
@@ -16986,6 +17949,7 @@
               </a:defRPr>
             </a:lvl5pPr>
             <a:lvl6pPr>
+              <a:buNone/>
               <a:defRPr sz="2325" b="1">
                 <a:solidFill>
                   <a:srgbClr val="0F52BA"/>
@@ -16996,6 +17960,7 @@
               </a:defRPr>
             </a:lvl6pPr>
             <a:lvl7pPr>
+              <a:buNone/>
               <a:defRPr sz="2325" b="1">
                 <a:solidFill>
                   <a:srgbClr val="0F52BA"/>
@@ -17006,6 +17971,7 @@
               </a:defRPr>
             </a:lvl7pPr>
             <a:lvl8pPr>
+              <a:buNone/>
               <a:defRPr sz="2325" b="1">
                 <a:solidFill>
                   <a:srgbClr val="0F52BA"/>
@@ -17016,6 +17982,7 @@
               </a:defRPr>
             </a:lvl8pPr>
             <a:lvl9pPr>
+              <a:buNone/>
               <a:defRPr sz="2325" b="1">
                 <a:solidFill>
                   <a:srgbClr val="0F52BA"/>
@@ -17028,6 +17995,7 @@
           </a:lstStyle>
           <a:p xmlns:a="http://schemas.openxmlformats.org/drawingml/2006/main">
             <a:pPr>
+              <a:buNone/>
               <a:defRPr sz="2325" b="1">
                 <a:solidFill>
                   <a:srgbClr val="0F52BA"/>
@@ -17051,6 +18019,7 @@
           </a:p>
           <a:p xmlns:a="http://schemas.openxmlformats.org/drawingml/2006/main">
             <a:pPr>
+              <a:buNone/>
               <a:defRPr sz="2325" b="1">
                 <a:solidFill>
                   <a:srgbClr val="0F52BA"/>

</xml_diff>

<commit_message>
docs(presentation): separate title slide from story examples
변경 내용
- 주제 소개를 별도 첫 장으로 복원하고 작품 사례와 문제 정의를 두 번째 장으로 분리했다.
- 네 이미지의 높이를 300px로 통일하고 원본 비율을 유지해 위아래 선과 간격을 맞췄다.
- 총 8장의 페이지 번호와 대본·발표자 노트를 맞췄다. 도입 55초를 소개 15초와 문제 정의 40초로 나누고 전체 목표 4분 45초를 유지했다.

변경 이유
- 주제 소개와 사례 이미지가 한 페이지에 몰려 있던 정보 밀도를 낮추고 사진 크기 차이로 생긴 정렬 불균형을 해소했다.

검증
- finalize-split.mjs: PPTX 무결성·레이아웃·폰트·재가져오기 검사 통과, 발견 사항 0건.
- check-split.py: 8장 구성, 첫 장 이미지 없음, 두 번째 장 이미지 4개의 동일 높이·상단 좌표, 대본과 노트 일치 확인.
- 8장 렌더를 육안 확인하고 기존 기능·결과·코드 장의 본문 렌더가 페이지 번호 영역을 제외하고 동일함을 확인했다.
- git diff --check 통과. 실제 낭독 시간은 측정하지 않았다.
</commit_message>
<xml_diff>
--- a/docs/presentation/LoreForge-G074-KimJimin.pptx
+++ b/docs/presentation/LoreForge-G074-KimJimin.pptx
@@ -2,19 +2,20 @@
 <file path=ppt/presentation.xml><?xml version="1.0" encoding="utf-8"?>
 <p:presentation xmlns:p="http://schemas.openxmlformats.org/presentationml/2006/main">
   <p:sldMasterIdLst>
-    <p:sldMasterId xmlns:r="http://schemas.openxmlformats.org/officeDocument/2006/relationships" id="2147483648" r:id="R4fcc621c20bb4e4e"/>
+    <p:sldMasterId xmlns:r="http://schemas.openxmlformats.org/officeDocument/2006/relationships" id="2147483648" r:id="Racc8c6d32ac041c3"/>
   </p:sldMasterIdLst>
   <p:notesMasterIdLst>
-    <p:notesMasterId xmlns:r="http://schemas.openxmlformats.org/officeDocument/2006/relationships" r:id="Rf2ef293576f64e9b"/>
+    <p:notesMasterId xmlns:r="http://schemas.openxmlformats.org/officeDocument/2006/relationships" r:id="R9e9927a003fe46a4"/>
   </p:notesMasterIdLst>
   <p:sldIdLst>
-    <p:sldId xmlns:r="http://schemas.openxmlformats.org/officeDocument/2006/relationships" id="256" r:id="R65a123d4da2c4716"/>
-    <p:sldId xmlns:r="http://schemas.openxmlformats.org/officeDocument/2006/relationships" id="257" r:id="Rb3cdac174cd44939"/>
-    <p:sldId xmlns:r="http://schemas.openxmlformats.org/officeDocument/2006/relationships" id="258" r:id="R4e92794ddfe842b2"/>
-    <p:sldId xmlns:r="http://schemas.openxmlformats.org/officeDocument/2006/relationships" id="259" r:id="R558de94d30fb4df5"/>
-    <p:sldId xmlns:r="http://schemas.openxmlformats.org/officeDocument/2006/relationships" id="260" r:id="R8e5326e25e42465a"/>
-    <p:sldId xmlns:r="http://schemas.openxmlformats.org/officeDocument/2006/relationships" id="261" r:id="R68cf8f41b33e4559"/>
-    <p:sldId xmlns:r="http://schemas.openxmlformats.org/officeDocument/2006/relationships" id="262" r:id="Rfc3ddf69b8aa46a0"/>
+    <p:sldId xmlns:r="http://schemas.openxmlformats.org/officeDocument/2006/relationships" id="256" r:id="Rf9e2382e861c4e6b"/>
+    <p:sldId xmlns:r="http://schemas.openxmlformats.org/officeDocument/2006/relationships" id="257" r:id="R907e80bd8ffe4345"/>
+    <p:sldId xmlns:r="http://schemas.openxmlformats.org/officeDocument/2006/relationships" id="258" r:id="R96c21c7530164453"/>
+    <p:sldId xmlns:r="http://schemas.openxmlformats.org/officeDocument/2006/relationships" id="259" r:id="Rc8a5a864f7e84109"/>
+    <p:sldId xmlns:r="http://schemas.openxmlformats.org/officeDocument/2006/relationships" id="260" r:id="R0090ee0dc30345c0"/>
+    <p:sldId xmlns:r="http://schemas.openxmlformats.org/officeDocument/2006/relationships" id="261" r:id="Re8be4268710f4614"/>
+    <p:sldId xmlns:r="http://schemas.openxmlformats.org/officeDocument/2006/relationships" id="262" r:id="Raf8278feab1e4d32"/>
+    <p:sldId xmlns:r="http://schemas.openxmlformats.org/officeDocument/2006/relationships" id="263" r:id="R4f1ac3a8a2db4f38"/>
   </p:sldIdLst>
   <p:sldSz cx="12192000" cy="6858000"/>
   <p:notesSz cx="6858000" cy="9144000"/>
@@ -448,12 +449,87 @@
           <a:lstStyle xmlns:a="http://schemas.openxmlformats.org/drawingml/2006/main"/>
           <a:p xmlns:a="http://schemas.openxmlformats.org/drawingml/2006/main">
             <a:r>
-              <a:t>[작품 사례와 문제 정의 — 00:00–00:55 / 55초]</a:t>
+              <a:t>[주제 소개 — 00:00–00:15 / 15초]</a:t>
             </a:r>
           </a:p>
           <a:p xmlns:a="http://schemas.openxmlformats.org/drawingml/2006/main">
             <a:r>
-              <a:t>안녕하세요. SKALA 4기 광주캠퍼스 G074 김지민입니다. 과제 2로 세계관 창작과 검토를 돕는 설정공방 LoreForge를 만들었습니다. 여러분, 샹크스가 루피를 구하다 팔을 잃는 장면을 기억하시나요? 이후의 강력한 모습과 비교하면, 왜 그때 팔을 잃었는지 의문이 생깁니다. 갓 오브 하이스쿨의 ‘제아봉침 25만 배’ 같은 장면에서는, 커진 능력이 기존의 한계와 대가에 어떻게 연결되는지 궁금해집니다. 물론 이런 장면을 곧바로 설정 오류라고 단정할 수는 없습니다. 복선이나 의도된 예외일 수도 있습니다. 제가 주목한 건 이야기가 길어질수록 설정과 예외를 모두 기억하고 대조하기 어렵다는 점입니다. 그래서 의심되는 부분과 원문 근거를 찾아, 작성자가 판단하도록 돕는 서비스를 구상했습니다.</a:t>
+              <a:t>안녕하세요. SKALA 4기 광주캠퍼스 G074 김지민입니다. 과제 2로 세계관 창작과 검토를 돕는 설정공방 LoreForge를 만들었습니다.</a:t>
+            </a:r>
+          </a:p>
+        </p:txBody>
+      </p:sp>
+      <p:sp>
+        <p:nvSpPr>
+          <p:cNvPr id="4" name="Slide Number Placeholder 3"/>
+          <p:cNvSpPr>
+            <a:spLocks xmlns:a="http://schemas.openxmlformats.org/drawingml/2006/main" noGrp="1"/>
+          </p:cNvSpPr>
+          <p:nvPr>
+            <p:ph type="sldNum" idx="5"/>
+          </p:nvPr>
+        </p:nvSpPr>
+        <p:spPr/>
+        <p:txBody>
+          <a:bodyPr xmlns:a="http://schemas.openxmlformats.org/drawingml/2006/main"/>
+          <a:lstStyle xmlns:a="http://schemas.openxmlformats.org/drawingml/2006/main"/>
+          <a:p xmlns:a="http://schemas.openxmlformats.org/drawingml/2006/main"/>
+        </p:txBody>
+      </p:sp>
+    </p:spTree>
+  </p:cSld>
+  <p:clrMapOvr>
+    <a:masterClrMapping xmlns:a="http://schemas.openxmlformats.org/drawingml/2006/main"/>
+  </p:clrMapOvr>
+</p:notes>
+</file>
+
+<file path=ppt/notesSlides/notesSlide2.xml><?xml version="1.0" encoding="utf-8"?>
+<p:notes xmlns:p="http://schemas.openxmlformats.org/presentationml/2006/main">
+  <p:cSld>
+    <p:spTree>
+      <p:nvGrpSpPr>
+        <p:cNvPr id="1" name=""/>
+        <p:cNvGrpSpPr/>
+        <p:nvPr/>
+      </p:nvGrpSpPr>
+      <p:grpSpPr>
+        <a:xfrm xmlns:a="http://schemas.openxmlformats.org/drawingml/2006/main"/>
+      </p:grpSpPr>
+      <p:sp>
+        <p:nvSpPr>
+          <p:cNvPr id="2" name="Slide Image Placeholder 1"/>
+          <p:cNvSpPr>
+            <a:spLocks xmlns:a="http://schemas.openxmlformats.org/drawingml/2006/main" noGrp="1"/>
+          </p:cNvSpPr>
+          <p:nvPr>
+            <p:ph type="sldImg" idx="0"/>
+          </p:nvPr>
+        </p:nvSpPr>
+        <p:spPr/>
+      </p:sp>
+      <p:sp>
+        <p:nvSpPr>
+          <p:cNvPr id="3" name="Notes Placeholder 2"/>
+          <p:cNvSpPr>
+            <a:spLocks xmlns:a="http://schemas.openxmlformats.org/drawingml/2006/main" noGrp="1"/>
+          </p:cNvSpPr>
+          <p:nvPr>
+            <p:ph type="body" idx="1"/>
+          </p:nvPr>
+        </p:nvSpPr>
+        <p:spPr/>
+        <p:txBody>
+          <a:bodyPr xmlns:a="http://schemas.openxmlformats.org/drawingml/2006/main"/>
+          <a:lstStyle xmlns:a="http://schemas.openxmlformats.org/drawingml/2006/main"/>
+          <a:p xmlns:a="http://schemas.openxmlformats.org/drawingml/2006/main">
+            <a:r>
+              <a:t>[작품 사례와 문제 정의 — 00:15–00:55 / 40초]</a:t>
+            </a:r>
+          </a:p>
+          <a:p xmlns:a="http://schemas.openxmlformats.org/drawingml/2006/main">
+            <a:r>
+              <a:t>여러분, 샹크스가 루피를 구하다 팔을 잃는 장면을 기억하시나요? 이후의 강력한 모습과 비교하면, 왜 그때 팔을 잃었는지 의문이 생깁니다. 갓 오브 하이스쿨의 ‘제아봉침 25만 배’ 같은 장면에서는, 커진 능력이 기존의 한계와 대가에 어떻게 연결되는지 궁금해집니다. 물론 이런 장면을 곧바로 설정 오류라고 단정할 수는 없습니다. 복선이나 의도된 예외일 수도 있습니다. 제가 주목한 건 이야기가 길어질수록 설정과 예외를 모두 기억하고 대조하기 어렵다는 점입니다. 그래서 의심되는 부분과 원문 근거를 찾아, 작성자가 판단하도록 돕는 서비스를 구상했습니다.</a:t>
             </a:r>
           </a:p>
           <a:p xmlns:a="http://schemas.openxmlformats.org/drawingml/2006/main">
@@ -513,7 +589,7 @@
 </p:notes>
 </file>
 
-<file path=ppt/notesSlides/notesSlide2.xml><?xml version="1.0" encoding="utf-8"?>
+<file path=ppt/notesSlides/notesSlide3.xml><?xml version="1.0" encoding="utf-8"?>
 <p:notes xmlns:p="http://schemas.openxmlformats.org/presentationml/2006/main">
   <p:cSld>
     <p:spTree>
@@ -598,7 +674,7 @@
 </p:notes>
 </file>
 
-<file path=ppt/notesSlides/notesSlide3.xml><?xml version="1.0" encoding="utf-8"?>
+<file path=ppt/notesSlides/notesSlide4.xml><?xml version="1.0" encoding="utf-8"?>
 <p:notes xmlns:p="http://schemas.openxmlformats.org/presentationml/2006/main">
   <p:cSld>
     <p:spTree>
@@ -683,7 +759,7 @@
 </p:notes>
 </file>
 
-<file path=ppt/notesSlides/notesSlide4.xml><?xml version="1.0" encoding="utf-8"?>
+<file path=ppt/notesSlides/notesSlide5.xml><?xml version="1.0" encoding="utf-8"?>
 <p:notes xmlns:p="http://schemas.openxmlformats.org/presentationml/2006/main">
   <p:cSld>
     <p:spTree>
@@ -768,7 +844,7 @@
 </p:notes>
 </file>
 
-<file path=ppt/notesSlides/notesSlide5.xml><?xml version="1.0" encoding="utf-8"?>
+<file path=ppt/notesSlides/notesSlide6.xml><?xml version="1.0" encoding="utf-8"?>
 <p:notes xmlns:p="http://schemas.openxmlformats.org/presentationml/2006/main">
   <p:cSld>
     <p:spTree>
@@ -853,7 +929,7 @@
 </p:notes>
 </file>
 
-<file path=ppt/notesSlides/notesSlide6.xml><?xml version="1.0" encoding="utf-8"?>
+<file path=ppt/notesSlides/notesSlide7.xml><?xml version="1.0" encoding="utf-8"?>
 <p:notes xmlns:p="http://schemas.openxmlformats.org/presentationml/2006/main">
   <p:cSld>
     <p:spTree>
@@ -938,7 +1014,7 @@
 </p:notes>
 </file>
 
-<file path=ppt/notesSlides/notesSlide7.xml><?xml version="1.0" encoding="utf-8"?>
+<file path=ppt/notesSlides/notesSlide8.xml><?xml version="1.0" encoding="utf-8"?>
 <p:notes xmlns:p="http://schemas.openxmlformats.org/presentationml/2006/main">
   <p:cSld>
     <p:spTree>
@@ -3436,12 +3512,12 @@
   </p:cSld>
   <p:clrMap bg1="lt1" tx1="dk1" bg2="lt2" tx2="dk2" accent1="accent1" accent2="accent2" accent3="accent3" accent4="accent4" accent5="accent5" accent6="accent6" hlink="hlink" folHlink="folHlink"/>
   <p:sldLayoutIdLst>
-    <p:sldLayoutId xmlns:r="http://schemas.openxmlformats.org/officeDocument/2006/relationships" id="2147483649" r:id="R9737df6856c1452f"/>
-    <p:sldLayoutId xmlns:r="http://schemas.openxmlformats.org/officeDocument/2006/relationships" id="2147483650" r:id="R7921ec6271d648c7"/>
-    <p:sldLayoutId xmlns:r="http://schemas.openxmlformats.org/officeDocument/2006/relationships" id="2147483651" r:id="R68e88bdf303247bd"/>
-    <p:sldLayoutId xmlns:r="http://schemas.openxmlformats.org/officeDocument/2006/relationships" id="2147483652" r:id="R04d6ff71f5304b3d"/>
-    <p:sldLayoutId xmlns:r="http://schemas.openxmlformats.org/officeDocument/2006/relationships" id="2147483653" r:id="R9d8f50e44e054fab"/>
-    <p:sldLayoutId xmlns:r="http://schemas.openxmlformats.org/officeDocument/2006/relationships" id="2147483654" r:id="Rd59ae1ac0e1a427b"/>
+    <p:sldLayoutId xmlns:r="http://schemas.openxmlformats.org/officeDocument/2006/relationships" id="2147483649" r:id="Recd62abd2c2a421b"/>
+    <p:sldLayoutId xmlns:r="http://schemas.openxmlformats.org/officeDocument/2006/relationships" id="2147483650" r:id="R06f897c37c004173"/>
+    <p:sldLayoutId xmlns:r="http://schemas.openxmlformats.org/officeDocument/2006/relationships" id="2147483651" r:id="R3355fe4964894074"/>
+    <p:sldLayoutId xmlns:r="http://schemas.openxmlformats.org/officeDocument/2006/relationships" id="2147483652" r:id="R5851319acdfa431f"/>
+    <p:sldLayoutId xmlns:r="http://schemas.openxmlformats.org/officeDocument/2006/relationships" id="2147483653" r:id="Radeae5b4ab064945"/>
+    <p:sldLayoutId xmlns:r="http://schemas.openxmlformats.org/officeDocument/2006/relationships" id="2147483654" r:id="R8866585884b74860"/>
   </p:sldLayoutIdLst>
   <p:txStyles>
     <p:titleStyle>
@@ -3989,6 +4065,1127 @@
       </p:grpSpPr>
       <p:sp>
         <p:nvSpPr>
+          <p:cNvPr id="8" name="">
+            <a:extLst xmlns:a="http://schemas.openxmlformats.org/drawingml/2006/main">
+              <a:ext uri="{FF2B5EF4-FFF2-40B4-BE49-F238E27FC236}">
+                <a16:creationId xmlns:a16="http://schemas.microsoft.com/office/drawing/2014/main" id="{9B283B52-0196-4DCE-81B8-4DCA63B6003C}"/>
+              </a:ext>
+            </a:extLst>
+          </p:cNvPr>
+          <p:cNvSpPr>
+            <a:spLocks xmlns:a="http://schemas.openxmlformats.org/drawingml/2006/main" noGrp="1"/>
+          </p:cNvSpPr>
+          <p:nvPr/>
+        </p:nvSpPr>
+        <p:spPr>
+          <a:xfrm xmlns:a="http://schemas.openxmlformats.org/drawingml/2006/main">
+            <a:off x="723900" y="1133475"/>
+            <a:ext cx="10477500" cy="647700"/>
+          </a:xfrm>
+          <a:prstGeom xmlns:a="http://schemas.openxmlformats.org/drawingml/2006/main" prst="rect">
+            <a:avLst/>
+          </a:prstGeom>
+          <a:noFill xmlns:a="http://schemas.openxmlformats.org/drawingml/2006/main"/>
+          <a:ln xmlns:a="http://schemas.openxmlformats.org/drawingml/2006/main" w="0">
+            <a:noFill/>
+          </a:ln>
+        </p:spPr>
+        <p:txBody>
+          <a:bodyPr xmlns:a="http://schemas.openxmlformats.org/drawingml/2006/main" lIns="0" tIns="0" rIns="0" bIns="0"/>
+          <a:lstStyle xmlns:a="http://schemas.openxmlformats.org/drawingml/2006/main">
+            <a:defPPr>
+              <a:defRPr sz="3600" b="0">
+                <a:solidFill>
+                  <a:srgbClr val="D6E6F3"/>
+                </a:solidFill>
+                <a:latin typeface="Apple SD Gothic Neo"/>
+                <a:ea typeface="Apple SD Gothic Neo"/>
+                <a:cs typeface="Apple SD Gothic Neo"/>
+              </a:defRPr>
+            </a:defPPr>
+            <a:lvl1pPr>
+              <a:defRPr sz="3600" b="0">
+                <a:solidFill>
+                  <a:srgbClr val="D6E6F3"/>
+                </a:solidFill>
+                <a:latin typeface="Apple SD Gothic Neo"/>
+                <a:ea typeface="Apple SD Gothic Neo"/>
+                <a:cs typeface="Apple SD Gothic Neo"/>
+              </a:defRPr>
+            </a:lvl1pPr>
+            <a:lvl2pPr>
+              <a:defRPr sz="3600" b="0">
+                <a:solidFill>
+                  <a:srgbClr val="D6E6F3"/>
+                </a:solidFill>
+                <a:latin typeface="Apple SD Gothic Neo"/>
+                <a:ea typeface="Apple SD Gothic Neo"/>
+                <a:cs typeface="Apple SD Gothic Neo"/>
+              </a:defRPr>
+            </a:lvl2pPr>
+            <a:lvl3pPr>
+              <a:defRPr sz="3600" b="0">
+                <a:solidFill>
+                  <a:srgbClr val="D6E6F3"/>
+                </a:solidFill>
+                <a:latin typeface="Apple SD Gothic Neo"/>
+                <a:ea typeface="Apple SD Gothic Neo"/>
+                <a:cs typeface="Apple SD Gothic Neo"/>
+              </a:defRPr>
+            </a:lvl3pPr>
+            <a:lvl4pPr>
+              <a:defRPr sz="3600" b="0">
+                <a:solidFill>
+                  <a:srgbClr val="D6E6F3"/>
+                </a:solidFill>
+                <a:latin typeface="Apple SD Gothic Neo"/>
+                <a:ea typeface="Apple SD Gothic Neo"/>
+                <a:cs typeface="Apple SD Gothic Neo"/>
+              </a:defRPr>
+            </a:lvl4pPr>
+            <a:lvl5pPr>
+              <a:defRPr sz="3600" b="0">
+                <a:solidFill>
+                  <a:srgbClr val="D6E6F3"/>
+                </a:solidFill>
+                <a:latin typeface="Apple SD Gothic Neo"/>
+                <a:ea typeface="Apple SD Gothic Neo"/>
+                <a:cs typeface="Apple SD Gothic Neo"/>
+              </a:defRPr>
+            </a:lvl5pPr>
+            <a:lvl6pPr>
+              <a:defRPr sz="3600" b="0">
+                <a:solidFill>
+                  <a:srgbClr val="D6E6F3"/>
+                </a:solidFill>
+                <a:latin typeface="Apple SD Gothic Neo"/>
+                <a:ea typeface="Apple SD Gothic Neo"/>
+                <a:cs typeface="Apple SD Gothic Neo"/>
+              </a:defRPr>
+            </a:lvl6pPr>
+            <a:lvl7pPr>
+              <a:defRPr sz="3600" b="0">
+                <a:solidFill>
+                  <a:srgbClr val="D6E6F3"/>
+                </a:solidFill>
+                <a:latin typeface="Apple SD Gothic Neo"/>
+                <a:ea typeface="Apple SD Gothic Neo"/>
+                <a:cs typeface="Apple SD Gothic Neo"/>
+              </a:defRPr>
+            </a:lvl7pPr>
+            <a:lvl8pPr>
+              <a:defRPr sz="3600" b="0">
+                <a:solidFill>
+                  <a:srgbClr val="D6E6F3"/>
+                </a:solidFill>
+                <a:latin typeface="Apple SD Gothic Neo"/>
+                <a:ea typeface="Apple SD Gothic Neo"/>
+                <a:cs typeface="Apple SD Gothic Neo"/>
+              </a:defRPr>
+            </a:lvl8pPr>
+            <a:lvl9pPr>
+              <a:defRPr sz="3600" b="0">
+                <a:solidFill>
+                  <a:srgbClr val="D6E6F3"/>
+                </a:solidFill>
+                <a:latin typeface="Apple SD Gothic Neo"/>
+                <a:ea typeface="Apple SD Gothic Neo"/>
+                <a:cs typeface="Apple SD Gothic Neo"/>
+              </a:defRPr>
+            </a:lvl9pPr>
+          </a:lstStyle>
+          <a:p xmlns:a="http://schemas.openxmlformats.org/drawingml/2006/main">
+            <a:pPr>
+              <a:defRPr sz="3600" b="0">
+                <a:solidFill>
+                  <a:srgbClr val="D6E6F3"/>
+                </a:solidFill>
+                <a:latin typeface="Apple SD Gothic Neo"/>
+                <a:ea typeface="Apple SD Gothic Neo"/>
+                <a:cs typeface="Apple SD Gothic Neo"/>
+              </a:defRPr>
+            </a:pPr>
+            <a:r>
+              <a:rPr sz="3600" b="0">
+                <a:solidFill>
+                  <a:srgbClr val="D6E6F3"/>
+                </a:solidFill>
+                <a:latin typeface="Apple SD Gothic Neo"/>
+                <a:ea typeface="Apple SD Gothic Neo"/>
+                <a:cs typeface="Apple SD Gothic Neo"/>
+              </a:rPr>
+              <a:t>설정공방</a:t>
+            </a:r>
+          </a:p>
+        </p:txBody>
+      </p:sp>
+      <p:sp>
+        <p:nvSpPr>
+          <p:cNvPr id="2" name="">
+            <a:extLst xmlns:a="http://schemas.openxmlformats.org/drawingml/2006/main">
+              <a:ext uri="{FF2B5EF4-FFF2-40B4-BE49-F238E27FC236}">
+                <a16:creationId xmlns:a16="http://schemas.microsoft.com/office/drawing/2014/main" id="{B4A32C95-E019-4826-910E-5F2D5CDADE31}"/>
+              </a:ext>
+            </a:extLst>
+          </p:cNvPr>
+          <p:cNvSpPr>
+            <a:spLocks xmlns:a="http://schemas.openxmlformats.org/drawingml/2006/main" noGrp="1"/>
+          </p:cNvSpPr>
+          <p:nvPr/>
+        </p:nvSpPr>
+        <p:spPr>
+          <a:xfrm xmlns:a="http://schemas.openxmlformats.org/drawingml/2006/main">
+            <a:off x="723900" y="2000250"/>
+            <a:ext cx="10477500" cy="1095375"/>
+          </a:xfrm>
+          <a:prstGeom xmlns:a="http://schemas.openxmlformats.org/drawingml/2006/main" prst="rect">
+            <a:avLst/>
+          </a:prstGeom>
+          <a:noFill xmlns:a="http://schemas.openxmlformats.org/drawingml/2006/main"/>
+          <a:ln xmlns:a="http://schemas.openxmlformats.org/drawingml/2006/main" w="0">
+            <a:noFill/>
+          </a:ln>
+        </p:spPr>
+        <p:txBody>
+          <a:bodyPr xmlns:a="http://schemas.openxmlformats.org/drawingml/2006/main" lIns="0" tIns="0" rIns="0" bIns="0"/>
+          <a:lstStyle xmlns:a="http://schemas.openxmlformats.org/drawingml/2006/main">
+            <a:defPPr>
+              <a:defRPr sz="6600" b="1">
+                <a:solidFill>
+                  <a:srgbClr val="FFFFFF"/>
+                </a:solidFill>
+                <a:latin typeface="Apple SD Gothic Neo"/>
+                <a:ea typeface="Apple SD Gothic Neo"/>
+                <a:cs typeface="Apple SD Gothic Neo"/>
+              </a:defRPr>
+            </a:defPPr>
+            <a:lvl1pPr>
+              <a:defRPr sz="6600" b="1">
+                <a:solidFill>
+                  <a:srgbClr val="FFFFFF"/>
+                </a:solidFill>
+                <a:latin typeface="Apple SD Gothic Neo"/>
+                <a:ea typeface="Apple SD Gothic Neo"/>
+                <a:cs typeface="Apple SD Gothic Neo"/>
+              </a:defRPr>
+            </a:lvl1pPr>
+            <a:lvl2pPr>
+              <a:defRPr sz="6600" b="1">
+                <a:solidFill>
+                  <a:srgbClr val="FFFFFF"/>
+                </a:solidFill>
+                <a:latin typeface="Apple SD Gothic Neo"/>
+                <a:ea typeface="Apple SD Gothic Neo"/>
+                <a:cs typeface="Apple SD Gothic Neo"/>
+              </a:defRPr>
+            </a:lvl2pPr>
+            <a:lvl3pPr>
+              <a:defRPr sz="6600" b="1">
+                <a:solidFill>
+                  <a:srgbClr val="FFFFFF"/>
+                </a:solidFill>
+                <a:latin typeface="Apple SD Gothic Neo"/>
+                <a:ea typeface="Apple SD Gothic Neo"/>
+                <a:cs typeface="Apple SD Gothic Neo"/>
+              </a:defRPr>
+            </a:lvl3pPr>
+            <a:lvl4pPr>
+              <a:defRPr sz="6600" b="1">
+                <a:solidFill>
+                  <a:srgbClr val="FFFFFF"/>
+                </a:solidFill>
+                <a:latin typeface="Apple SD Gothic Neo"/>
+                <a:ea typeface="Apple SD Gothic Neo"/>
+                <a:cs typeface="Apple SD Gothic Neo"/>
+              </a:defRPr>
+            </a:lvl4pPr>
+            <a:lvl5pPr>
+              <a:defRPr sz="6600" b="1">
+                <a:solidFill>
+                  <a:srgbClr val="FFFFFF"/>
+                </a:solidFill>
+                <a:latin typeface="Apple SD Gothic Neo"/>
+                <a:ea typeface="Apple SD Gothic Neo"/>
+                <a:cs typeface="Apple SD Gothic Neo"/>
+              </a:defRPr>
+            </a:lvl5pPr>
+            <a:lvl6pPr>
+              <a:defRPr sz="6600" b="1">
+                <a:solidFill>
+                  <a:srgbClr val="FFFFFF"/>
+                </a:solidFill>
+                <a:latin typeface="Apple SD Gothic Neo"/>
+                <a:ea typeface="Apple SD Gothic Neo"/>
+                <a:cs typeface="Apple SD Gothic Neo"/>
+              </a:defRPr>
+            </a:lvl6pPr>
+            <a:lvl7pPr>
+              <a:defRPr sz="6600" b="1">
+                <a:solidFill>
+                  <a:srgbClr val="FFFFFF"/>
+                </a:solidFill>
+                <a:latin typeface="Apple SD Gothic Neo"/>
+                <a:ea typeface="Apple SD Gothic Neo"/>
+                <a:cs typeface="Apple SD Gothic Neo"/>
+              </a:defRPr>
+            </a:lvl7pPr>
+            <a:lvl8pPr>
+              <a:defRPr sz="6600" b="1">
+                <a:solidFill>
+                  <a:srgbClr val="FFFFFF"/>
+                </a:solidFill>
+                <a:latin typeface="Apple SD Gothic Neo"/>
+                <a:ea typeface="Apple SD Gothic Neo"/>
+                <a:cs typeface="Apple SD Gothic Neo"/>
+              </a:defRPr>
+            </a:lvl8pPr>
+            <a:lvl9pPr>
+              <a:defRPr sz="6600" b="1">
+                <a:solidFill>
+                  <a:srgbClr val="FFFFFF"/>
+                </a:solidFill>
+                <a:latin typeface="Apple SD Gothic Neo"/>
+                <a:ea typeface="Apple SD Gothic Neo"/>
+                <a:cs typeface="Apple SD Gothic Neo"/>
+              </a:defRPr>
+            </a:lvl9pPr>
+          </a:lstStyle>
+          <a:p xmlns:a="http://schemas.openxmlformats.org/drawingml/2006/main">
+            <a:pPr>
+              <a:defRPr sz="6600" b="1">
+                <a:solidFill>
+                  <a:srgbClr val="FFFFFF"/>
+                </a:solidFill>
+                <a:latin typeface="Apple SD Gothic Neo"/>
+                <a:ea typeface="Apple SD Gothic Neo"/>
+                <a:cs typeface="Apple SD Gothic Neo"/>
+              </a:defRPr>
+            </a:pPr>
+            <a:r>
+              <a:rPr sz="6600" b="1">
+                <a:solidFill>
+                  <a:srgbClr val="FFFFFF"/>
+                </a:solidFill>
+                <a:latin typeface="Apple SD Gothic Neo"/>
+                <a:ea typeface="Apple SD Gothic Neo"/>
+                <a:cs typeface="Apple SD Gothic Neo"/>
+              </a:rPr>
+              <a:t>LoreForge</a:t>
+            </a:r>
+          </a:p>
+        </p:txBody>
+      </p:sp>
+      <p:sp>
+        <p:nvSpPr>
+          <p:cNvPr id="3" name="">
+            <a:extLst xmlns:a="http://schemas.openxmlformats.org/drawingml/2006/main">
+              <a:ext uri="{FF2B5EF4-FFF2-40B4-BE49-F238E27FC236}">
+                <a16:creationId xmlns:a16="http://schemas.microsoft.com/office/drawing/2014/main" id="{FB7A95DF-062F-4C6D-A9AA-7E6D262CA815}"/>
+              </a:ext>
+            </a:extLst>
+          </p:cNvPr>
+          <p:cNvSpPr>
+            <a:spLocks xmlns:a="http://schemas.openxmlformats.org/drawingml/2006/main" noGrp="1"/>
+          </p:cNvSpPr>
+          <p:nvPr/>
+        </p:nvSpPr>
+        <p:spPr>
+          <a:xfrm xmlns:a="http://schemas.openxmlformats.org/drawingml/2006/main">
+            <a:off x="742950" y="3390900"/>
+            <a:ext cx="10668000" cy="571500"/>
+          </a:xfrm>
+          <a:prstGeom xmlns:a="http://schemas.openxmlformats.org/drawingml/2006/main" prst="rect">
+            <a:avLst/>
+          </a:prstGeom>
+          <a:noFill xmlns:a="http://schemas.openxmlformats.org/drawingml/2006/main"/>
+          <a:ln xmlns:a="http://schemas.openxmlformats.org/drawingml/2006/main" w="0">
+            <a:noFill/>
+          </a:ln>
+        </p:spPr>
+        <p:txBody>
+          <a:bodyPr xmlns:a="http://schemas.openxmlformats.org/drawingml/2006/main" lIns="0" tIns="0" rIns="0" bIns="0"/>
+          <a:lstStyle xmlns:a="http://schemas.openxmlformats.org/drawingml/2006/main">
+            <a:defPPr>
+              <a:defRPr sz="2400" b="0">
+                <a:solidFill>
+                  <a:srgbClr val="A6C5D7"/>
+                </a:solidFill>
+                <a:latin typeface="Apple SD Gothic Neo"/>
+                <a:ea typeface="Apple SD Gothic Neo"/>
+                <a:cs typeface="Apple SD Gothic Neo"/>
+              </a:defRPr>
+            </a:defPPr>
+            <a:lvl1pPr>
+              <a:defRPr sz="2400" b="0">
+                <a:solidFill>
+                  <a:srgbClr val="A6C5D7"/>
+                </a:solidFill>
+                <a:latin typeface="Apple SD Gothic Neo"/>
+                <a:ea typeface="Apple SD Gothic Neo"/>
+                <a:cs typeface="Apple SD Gothic Neo"/>
+              </a:defRPr>
+            </a:lvl1pPr>
+            <a:lvl2pPr>
+              <a:defRPr sz="2400" b="0">
+                <a:solidFill>
+                  <a:srgbClr val="A6C5D7"/>
+                </a:solidFill>
+                <a:latin typeface="Apple SD Gothic Neo"/>
+                <a:ea typeface="Apple SD Gothic Neo"/>
+                <a:cs typeface="Apple SD Gothic Neo"/>
+              </a:defRPr>
+            </a:lvl2pPr>
+            <a:lvl3pPr>
+              <a:defRPr sz="2400" b="0">
+                <a:solidFill>
+                  <a:srgbClr val="A6C5D7"/>
+                </a:solidFill>
+                <a:latin typeface="Apple SD Gothic Neo"/>
+                <a:ea typeface="Apple SD Gothic Neo"/>
+                <a:cs typeface="Apple SD Gothic Neo"/>
+              </a:defRPr>
+            </a:lvl3pPr>
+            <a:lvl4pPr>
+              <a:defRPr sz="2400" b="0">
+                <a:solidFill>
+                  <a:srgbClr val="A6C5D7"/>
+                </a:solidFill>
+                <a:latin typeface="Apple SD Gothic Neo"/>
+                <a:ea typeface="Apple SD Gothic Neo"/>
+                <a:cs typeface="Apple SD Gothic Neo"/>
+              </a:defRPr>
+            </a:lvl4pPr>
+            <a:lvl5pPr>
+              <a:defRPr sz="2400" b="0">
+                <a:solidFill>
+                  <a:srgbClr val="A6C5D7"/>
+                </a:solidFill>
+                <a:latin typeface="Apple SD Gothic Neo"/>
+                <a:ea typeface="Apple SD Gothic Neo"/>
+                <a:cs typeface="Apple SD Gothic Neo"/>
+              </a:defRPr>
+            </a:lvl5pPr>
+            <a:lvl6pPr>
+              <a:defRPr sz="2400" b="0">
+                <a:solidFill>
+                  <a:srgbClr val="A6C5D7"/>
+                </a:solidFill>
+                <a:latin typeface="Apple SD Gothic Neo"/>
+                <a:ea typeface="Apple SD Gothic Neo"/>
+                <a:cs typeface="Apple SD Gothic Neo"/>
+              </a:defRPr>
+            </a:lvl6pPr>
+            <a:lvl7pPr>
+              <a:defRPr sz="2400" b="0">
+                <a:solidFill>
+                  <a:srgbClr val="A6C5D7"/>
+                </a:solidFill>
+                <a:latin typeface="Apple SD Gothic Neo"/>
+                <a:ea typeface="Apple SD Gothic Neo"/>
+                <a:cs typeface="Apple SD Gothic Neo"/>
+              </a:defRPr>
+            </a:lvl7pPr>
+            <a:lvl8pPr>
+              <a:defRPr sz="2400" b="0">
+                <a:solidFill>
+                  <a:srgbClr val="A6C5D7"/>
+                </a:solidFill>
+                <a:latin typeface="Apple SD Gothic Neo"/>
+                <a:ea typeface="Apple SD Gothic Neo"/>
+                <a:cs typeface="Apple SD Gothic Neo"/>
+              </a:defRPr>
+            </a:lvl8pPr>
+            <a:lvl9pPr>
+              <a:defRPr sz="2400" b="0">
+                <a:solidFill>
+                  <a:srgbClr val="A6C5D7"/>
+                </a:solidFill>
+                <a:latin typeface="Apple SD Gothic Neo"/>
+                <a:ea typeface="Apple SD Gothic Neo"/>
+                <a:cs typeface="Apple SD Gothic Neo"/>
+              </a:defRPr>
+            </a:lvl9pPr>
+          </a:lstStyle>
+          <a:p xmlns:a="http://schemas.openxmlformats.org/drawingml/2006/main">
+            <a:pPr>
+              <a:defRPr sz="2400" b="0">
+                <a:solidFill>
+                  <a:srgbClr val="A6C5D7"/>
+                </a:solidFill>
+                <a:latin typeface="Apple SD Gothic Neo"/>
+                <a:ea typeface="Apple SD Gothic Neo"/>
+                <a:cs typeface="Apple SD Gothic Neo"/>
+              </a:defRPr>
+            </a:pPr>
+            <a:r>
+              <a:rPr sz="2400" b="0">
+                <a:solidFill>
+                  <a:srgbClr val="A6C5D7"/>
+                </a:solidFill>
+                <a:latin typeface="Apple SD Gothic Neo"/>
+                <a:ea typeface="Apple SD Gothic Neo"/>
+                <a:cs typeface="Apple SD Gothic Neo"/>
+              </a:rPr>
+              <a:t>키워드로 만들고, 원문 근거로 검토하는 세계관 웹 서비스</a:t>
+            </a:r>
+          </a:p>
+        </p:txBody>
+      </p:sp>
+      <p:sp>
+        <p:nvSpPr>
+          <p:cNvPr id="4" name="">
+            <a:extLst xmlns:a="http://schemas.openxmlformats.org/drawingml/2006/main">
+              <a:ext uri="{FF2B5EF4-FFF2-40B4-BE49-F238E27FC236}">
+                <a16:creationId xmlns:a16="http://schemas.microsoft.com/office/drawing/2014/main" id="{628848FA-2E2B-4E43-A4E6-349EB1046FBC}"/>
+              </a:ext>
+            </a:extLst>
+          </p:cNvPr>
+          <p:cNvSpPr>
+            <a:spLocks xmlns:a="http://schemas.openxmlformats.org/drawingml/2006/main" noGrp="1"/>
+          </p:cNvSpPr>
+          <p:nvPr/>
+        </p:nvSpPr>
+        <p:spPr>
+          <a:xfrm xmlns:a="http://schemas.openxmlformats.org/drawingml/2006/main">
+            <a:off x="742950" y="5067300"/>
+            <a:ext cx="10477500" cy="495300"/>
+          </a:xfrm>
+          <a:prstGeom xmlns:a="http://schemas.openxmlformats.org/drawingml/2006/main" prst="rect">
+            <a:avLst/>
+          </a:prstGeom>
+          <a:noFill xmlns:a="http://schemas.openxmlformats.org/drawingml/2006/main"/>
+          <a:ln xmlns:a="http://schemas.openxmlformats.org/drawingml/2006/main" w="0">
+            <a:noFill/>
+          </a:ln>
+        </p:spPr>
+        <p:txBody>
+          <a:bodyPr xmlns:a="http://schemas.openxmlformats.org/drawingml/2006/main" lIns="0" tIns="0" rIns="0" bIns="0"/>
+          <a:lstStyle xmlns:a="http://schemas.openxmlformats.org/drawingml/2006/main">
+            <a:defPPr>
+              <a:defRPr sz="2700" b="1">
+                <a:solidFill>
+                  <a:srgbClr val="FFFFFF"/>
+                </a:solidFill>
+                <a:latin typeface="Apple SD Gothic Neo"/>
+                <a:ea typeface="Apple SD Gothic Neo"/>
+                <a:cs typeface="Apple SD Gothic Neo"/>
+              </a:defRPr>
+            </a:defPPr>
+            <a:lvl1pPr>
+              <a:defRPr sz="2700" b="1">
+                <a:solidFill>
+                  <a:srgbClr val="FFFFFF"/>
+                </a:solidFill>
+                <a:latin typeface="Apple SD Gothic Neo"/>
+                <a:ea typeface="Apple SD Gothic Neo"/>
+                <a:cs typeface="Apple SD Gothic Neo"/>
+              </a:defRPr>
+            </a:lvl1pPr>
+            <a:lvl2pPr>
+              <a:defRPr sz="2700" b="1">
+                <a:solidFill>
+                  <a:srgbClr val="FFFFFF"/>
+                </a:solidFill>
+                <a:latin typeface="Apple SD Gothic Neo"/>
+                <a:ea typeface="Apple SD Gothic Neo"/>
+                <a:cs typeface="Apple SD Gothic Neo"/>
+              </a:defRPr>
+            </a:lvl2pPr>
+            <a:lvl3pPr>
+              <a:defRPr sz="2700" b="1">
+                <a:solidFill>
+                  <a:srgbClr val="FFFFFF"/>
+                </a:solidFill>
+                <a:latin typeface="Apple SD Gothic Neo"/>
+                <a:ea typeface="Apple SD Gothic Neo"/>
+                <a:cs typeface="Apple SD Gothic Neo"/>
+              </a:defRPr>
+            </a:lvl3pPr>
+            <a:lvl4pPr>
+              <a:defRPr sz="2700" b="1">
+                <a:solidFill>
+                  <a:srgbClr val="FFFFFF"/>
+                </a:solidFill>
+                <a:latin typeface="Apple SD Gothic Neo"/>
+                <a:ea typeface="Apple SD Gothic Neo"/>
+                <a:cs typeface="Apple SD Gothic Neo"/>
+              </a:defRPr>
+            </a:lvl4pPr>
+            <a:lvl5pPr>
+              <a:defRPr sz="2700" b="1">
+                <a:solidFill>
+                  <a:srgbClr val="FFFFFF"/>
+                </a:solidFill>
+                <a:latin typeface="Apple SD Gothic Neo"/>
+                <a:ea typeface="Apple SD Gothic Neo"/>
+                <a:cs typeface="Apple SD Gothic Neo"/>
+              </a:defRPr>
+            </a:lvl5pPr>
+            <a:lvl6pPr>
+              <a:defRPr sz="2700" b="1">
+                <a:solidFill>
+                  <a:srgbClr val="FFFFFF"/>
+                </a:solidFill>
+                <a:latin typeface="Apple SD Gothic Neo"/>
+                <a:ea typeface="Apple SD Gothic Neo"/>
+                <a:cs typeface="Apple SD Gothic Neo"/>
+              </a:defRPr>
+            </a:lvl6pPr>
+            <a:lvl7pPr>
+              <a:defRPr sz="2700" b="1">
+                <a:solidFill>
+                  <a:srgbClr val="FFFFFF"/>
+                </a:solidFill>
+                <a:latin typeface="Apple SD Gothic Neo"/>
+                <a:ea typeface="Apple SD Gothic Neo"/>
+                <a:cs typeface="Apple SD Gothic Neo"/>
+              </a:defRPr>
+            </a:lvl7pPr>
+            <a:lvl8pPr>
+              <a:defRPr sz="2700" b="1">
+                <a:solidFill>
+                  <a:srgbClr val="FFFFFF"/>
+                </a:solidFill>
+                <a:latin typeface="Apple SD Gothic Neo"/>
+                <a:ea typeface="Apple SD Gothic Neo"/>
+                <a:cs typeface="Apple SD Gothic Neo"/>
+              </a:defRPr>
+            </a:lvl8pPr>
+            <a:lvl9pPr>
+              <a:defRPr sz="2700" b="1">
+                <a:solidFill>
+                  <a:srgbClr val="FFFFFF"/>
+                </a:solidFill>
+                <a:latin typeface="Apple SD Gothic Neo"/>
+                <a:ea typeface="Apple SD Gothic Neo"/>
+                <a:cs typeface="Apple SD Gothic Neo"/>
+              </a:defRPr>
+            </a:lvl9pPr>
+          </a:lstStyle>
+          <a:p xmlns:a="http://schemas.openxmlformats.org/drawingml/2006/main">
+            <a:pPr>
+              <a:defRPr sz="2700" b="1">
+                <a:solidFill>
+                  <a:srgbClr val="FFFFFF"/>
+                </a:solidFill>
+                <a:latin typeface="Apple SD Gothic Neo"/>
+                <a:ea typeface="Apple SD Gothic Neo"/>
+                <a:cs typeface="Apple SD Gothic Neo"/>
+              </a:defRPr>
+            </a:pPr>
+            <a:r>
+              <a:rPr sz="2700" b="1">
+                <a:solidFill>
+                  <a:srgbClr val="FFFFFF"/>
+                </a:solidFill>
+                <a:latin typeface="Apple SD Gothic Neo"/>
+                <a:ea typeface="Apple SD Gothic Neo"/>
+                <a:cs typeface="Apple SD Gothic Neo"/>
+              </a:rPr>
+              <a:t>G074 김지민</a:t>
+            </a:r>
+          </a:p>
+        </p:txBody>
+      </p:sp>
+      <p:sp>
+        <p:nvSpPr>
+          <p:cNvPr id="5" name="">
+            <a:extLst xmlns:a="http://schemas.openxmlformats.org/drawingml/2006/main">
+              <a:ext uri="{FF2B5EF4-FFF2-40B4-BE49-F238E27FC236}">
+                <a16:creationId xmlns:a16="http://schemas.microsoft.com/office/drawing/2014/main" id="{382603D5-617D-441A-AC71-2CB061509DE9}"/>
+              </a:ext>
+            </a:extLst>
+          </p:cNvPr>
+          <p:cNvSpPr>
+            <a:spLocks xmlns:a="http://schemas.openxmlformats.org/drawingml/2006/main" noGrp="1"/>
+          </p:cNvSpPr>
+          <p:nvPr/>
+        </p:nvSpPr>
+        <p:spPr>
+          <a:xfrm xmlns:a="http://schemas.openxmlformats.org/drawingml/2006/main">
+            <a:off x="742950" y="5676900"/>
+            <a:ext cx="10477500" cy="381000"/>
+          </a:xfrm>
+          <a:prstGeom xmlns:a="http://schemas.openxmlformats.org/drawingml/2006/main" prst="rect">
+            <a:avLst/>
+          </a:prstGeom>
+          <a:noFill xmlns:a="http://schemas.openxmlformats.org/drawingml/2006/main"/>
+          <a:ln xmlns:a="http://schemas.openxmlformats.org/drawingml/2006/main" w="0">
+            <a:noFill/>
+          </a:ln>
+        </p:spPr>
+        <p:txBody>
+          <a:bodyPr xmlns:a="http://schemas.openxmlformats.org/drawingml/2006/main" lIns="0" tIns="0" rIns="0" bIns="0"/>
+          <a:lstStyle xmlns:a="http://schemas.openxmlformats.org/drawingml/2006/main">
+            <a:defPPr>
+              <a:defRPr sz="1950" b="0">
+                <a:solidFill>
+                  <a:srgbClr val="D6E6F3"/>
+                </a:solidFill>
+                <a:latin typeface="Apple SD Gothic Neo"/>
+                <a:ea typeface="Apple SD Gothic Neo"/>
+                <a:cs typeface="Apple SD Gothic Neo"/>
+              </a:defRPr>
+            </a:defPPr>
+            <a:lvl1pPr>
+              <a:defRPr sz="1950" b="0">
+                <a:solidFill>
+                  <a:srgbClr val="D6E6F3"/>
+                </a:solidFill>
+                <a:latin typeface="Apple SD Gothic Neo"/>
+                <a:ea typeface="Apple SD Gothic Neo"/>
+                <a:cs typeface="Apple SD Gothic Neo"/>
+              </a:defRPr>
+            </a:lvl1pPr>
+            <a:lvl2pPr>
+              <a:defRPr sz="1950" b="0">
+                <a:solidFill>
+                  <a:srgbClr val="D6E6F3"/>
+                </a:solidFill>
+                <a:latin typeface="Apple SD Gothic Neo"/>
+                <a:ea typeface="Apple SD Gothic Neo"/>
+                <a:cs typeface="Apple SD Gothic Neo"/>
+              </a:defRPr>
+            </a:lvl2pPr>
+            <a:lvl3pPr>
+              <a:defRPr sz="1950" b="0">
+                <a:solidFill>
+                  <a:srgbClr val="D6E6F3"/>
+                </a:solidFill>
+                <a:latin typeface="Apple SD Gothic Neo"/>
+                <a:ea typeface="Apple SD Gothic Neo"/>
+                <a:cs typeface="Apple SD Gothic Neo"/>
+              </a:defRPr>
+            </a:lvl3pPr>
+            <a:lvl4pPr>
+              <a:defRPr sz="1950" b="0">
+                <a:solidFill>
+                  <a:srgbClr val="D6E6F3"/>
+                </a:solidFill>
+                <a:latin typeface="Apple SD Gothic Neo"/>
+                <a:ea typeface="Apple SD Gothic Neo"/>
+                <a:cs typeface="Apple SD Gothic Neo"/>
+              </a:defRPr>
+            </a:lvl4pPr>
+            <a:lvl5pPr>
+              <a:defRPr sz="1950" b="0">
+                <a:solidFill>
+                  <a:srgbClr val="D6E6F3"/>
+                </a:solidFill>
+                <a:latin typeface="Apple SD Gothic Neo"/>
+                <a:ea typeface="Apple SD Gothic Neo"/>
+                <a:cs typeface="Apple SD Gothic Neo"/>
+              </a:defRPr>
+            </a:lvl5pPr>
+            <a:lvl6pPr>
+              <a:defRPr sz="1950" b="0">
+                <a:solidFill>
+                  <a:srgbClr val="D6E6F3"/>
+                </a:solidFill>
+                <a:latin typeface="Apple SD Gothic Neo"/>
+                <a:ea typeface="Apple SD Gothic Neo"/>
+                <a:cs typeface="Apple SD Gothic Neo"/>
+              </a:defRPr>
+            </a:lvl6pPr>
+            <a:lvl7pPr>
+              <a:defRPr sz="1950" b="0">
+                <a:solidFill>
+                  <a:srgbClr val="D6E6F3"/>
+                </a:solidFill>
+                <a:latin typeface="Apple SD Gothic Neo"/>
+                <a:ea typeface="Apple SD Gothic Neo"/>
+                <a:cs typeface="Apple SD Gothic Neo"/>
+              </a:defRPr>
+            </a:lvl7pPr>
+            <a:lvl8pPr>
+              <a:defRPr sz="1950" b="0">
+                <a:solidFill>
+                  <a:srgbClr val="D6E6F3"/>
+                </a:solidFill>
+                <a:latin typeface="Apple SD Gothic Neo"/>
+                <a:ea typeface="Apple SD Gothic Neo"/>
+                <a:cs typeface="Apple SD Gothic Neo"/>
+              </a:defRPr>
+            </a:lvl8pPr>
+            <a:lvl9pPr>
+              <a:defRPr sz="1950" b="0">
+                <a:solidFill>
+                  <a:srgbClr val="D6E6F3"/>
+                </a:solidFill>
+                <a:latin typeface="Apple SD Gothic Neo"/>
+                <a:ea typeface="Apple SD Gothic Neo"/>
+                <a:cs typeface="Apple SD Gothic Neo"/>
+              </a:defRPr>
+            </a:lvl9pPr>
+          </a:lstStyle>
+          <a:p xmlns:a="http://schemas.openxmlformats.org/drawingml/2006/main">
+            <a:pPr>
+              <a:defRPr sz="1950" b="0">
+                <a:solidFill>
+                  <a:srgbClr val="D6E6F3"/>
+                </a:solidFill>
+                <a:latin typeface="Apple SD Gothic Neo"/>
+                <a:ea typeface="Apple SD Gothic Neo"/>
+                <a:cs typeface="Apple SD Gothic Neo"/>
+              </a:defRPr>
+            </a:pPr>
+            <a:r>
+              <a:rPr sz="1950" b="0">
+                <a:solidFill>
+                  <a:srgbClr val="D6E6F3"/>
+                </a:solidFill>
+                <a:latin typeface="Apple SD Gothic Neo"/>
+                <a:ea typeface="Apple SD Gothic Neo"/>
+                <a:cs typeface="Apple SD Gothic Neo"/>
+              </a:rPr>
+              <a:t>SKALA 4기 광주캠퍼스</a:t>
+            </a:r>
+          </a:p>
+        </p:txBody>
+      </p:sp>
+      <p:sp>
+        <p:nvSpPr>
+          <p:cNvPr id="6" name="">
+            <a:extLst xmlns:a="http://schemas.openxmlformats.org/drawingml/2006/main">
+              <a:ext uri="{FF2B5EF4-FFF2-40B4-BE49-F238E27FC236}">
+                <a16:creationId xmlns:a16="http://schemas.microsoft.com/office/drawing/2014/main" id="{D29AF102-A090-43A0-A46C-DD86A69DDC9C}"/>
+              </a:ext>
+            </a:extLst>
+          </p:cNvPr>
+          <p:cNvSpPr>
+            <a:spLocks xmlns:a="http://schemas.openxmlformats.org/drawingml/2006/main" noGrp="1"/>
+          </p:cNvSpPr>
+          <p:nvPr/>
+        </p:nvSpPr>
+        <p:spPr>
+          <a:xfrm xmlns:a="http://schemas.openxmlformats.org/drawingml/2006/main">
+            <a:off x="742950" y="6334125"/>
+            <a:ext cx="9525000" cy="304800"/>
+          </a:xfrm>
+          <a:prstGeom xmlns:a="http://schemas.openxmlformats.org/drawingml/2006/main" prst="rect">
+            <a:avLst/>
+          </a:prstGeom>
+          <a:noFill xmlns:a="http://schemas.openxmlformats.org/drawingml/2006/main"/>
+          <a:ln xmlns:a="http://schemas.openxmlformats.org/drawingml/2006/main" w="0">
+            <a:noFill/>
+          </a:ln>
+        </p:spPr>
+        <p:txBody>
+          <a:bodyPr xmlns:a="http://schemas.openxmlformats.org/drawingml/2006/main" lIns="0" tIns="0" rIns="0" bIns="0"/>
+          <a:lstStyle xmlns:a="http://schemas.openxmlformats.org/drawingml/2006/main">
+            <a:defPPr>
+              <a:defRPr sz="1500" b="0">
+                <a:solidFill>
+                  <a:srgbClr val="A6C5D7"/>
+                </a:solidFill>
+                <a:latin typeface="Apple SD Gothic Neo"/>
+                <a:ea typeface="Apple SD Gothic Neo"/>
+                <a:cs typeface="Apple SD Gothic Neo"/>
+              </a:defRPr>
+            </a:defPPr>
+            <a:lvl1pPr>
+              <a:defRPr sz="1500" b="0">
+                <a:solidFill>
+                  <a:srgbClr val="A6C5D7"/>
+                </a:solidFill>
+                <a:latin typeface="Apple SD Gothic Neo"/>
+                <a:ea typeface="Apple SD Gothic Neo"/>
+                <a:cs typeface="Apple SD Gothic Neo"/>
+              </a:defRPr>
+            </a:lvl1pPr>
+            <a:lvl2pPr>
+              <a:defRPr sz="1500" b="0">
+                <a:solidFill>
+                  <a:srgbClr val="A6C5D7"/>
+                </a:solidFill>
+                <a:latin typeface="Apple SD Gothic Neo"/>
+                <a:ea typeface="Apple SD Gothic Neo"/>
+                <a:cs typeface="Apple SD Gothic Neo"/>
+              </a:defRPr>
+            </a:lvl2pPr>
+            <a:lvl3pPr>
+              <a:defRPr sz="1500" b="0">
+                <a:solidFill>
+                  <a:srgbClr val="A6C5D7"/>
+                </a:solidFill>
+                <a:latin typeface="Apple SD Gothic Neo"/>
+                <a:ea typeface="Apple SD Gothic Neo"/>
+                <a:cs typeface="Apple SD Gothic Neo"/>
+              </a:defRPr>
+            </a:lvl3pPr>
+            <a:lvl4pPr>
+              <a:defRPr sz="1500" b="0">
+                <a:solidFill>
+                  <a:srgbClr val="A6C5D7"/>
+                </a:solidFill>
+                <a:latin typeface="Apple SD Gothic Neo"/>
+                <a:ea typeface="Apple SD Gothic Neo"/>
+                <a:cs typeface="Apple SD Gothic Neo"/>
+              </a:defRPr>
+            </a:lvl4pPr>
+            <a:lvl5pPr>
+              <a:defRPr sz="1500" b="0">
+                <a:solidFill>
+                  <a:srgbClr val="A6C5D7"/>
+                </a:solidFill>
+                <a:latin typeface="Apple SD Gothic Neo"/>
+                <a:ea typeface="Apple SD Gothic Neo"/>
+                <a:cs typeface="Apple SD Gothic Neo"/>
+              </a:defRPr>
+            </a:lvl5pPr>
+            <a:lvl6pPr>
+              <a:defRPr sz="1500" b="0">
+                <a:solidFill>
+                  <a:srgbClr val="A6C5D7"/>
+                </a:solidFill>
+                <a:latin typeface="Apple SD Gothic Neo"/>
+                <a:ea typeface="Apple SD Gothic Neo"/>
+                <a:cs typeface="Apple SD Gothic Neo"/>
+              </a:defRPr>
+            </a:lvl6pPr>
+            <a:lvl7pPr>
+              <a:defRPr sz="1500" b="0">
+                <a:solidFill>
+                  <a:srgbClr val="A6C5D7"/>
+                </a:solidFill>
+                <a:latin typeface="Apple SD Gothic Neo"/>
+                <a:ea typeface="Apple SD Gothic Neo"/>
+                <a:cs typeface="Apple SD Gothic Neo"/>
+              </a:defRPr>
+            </a:lvl7pPr>
+            <a:lvl8pPr>
+              <a:defRPr sz="1500" b="0">
+                <a:solidFill>
+                  <a:srgbClr val="A6C5D7"/>
+                </a:solidFill>
+                <a:latin typeface="Apple SD Gothic Neo"/>
+                <a:ea typeface="Apple SD Gothic Neo"/>
+                <a:cs typeface="Apple SD Gothic Neo"/>
+              </a:defRPr>
+            </a:lvl8pPr>
+            <a:lvl9pPr>
+              <a:defRPr sz="1500" b="0">
+                <a:solidFill>
+                  <a:srgbClr val="A6C5D7"/>
+                </a:solidFill>
+                <a:latin typeface="Apple SD Gothic Neo"/>
+                <a:ea typeface="Apple SD Gothic Neo"/>
+                <a:cs typeface="Apple SD Gothic Neo"/>
+              </a:defRPr>
+            </a:lvl9pPr>
+          </a:lstStyle>
+          <a:p xmlns:a="http://schemas.openxmlformats.org/drawingml/2006/main">
+            <a:pPr>
+              <a:defRPr sz="1500" b="0">
+                <a:solidFill>
+                  <a:srgbClr val="A6C5D7"/>
+                </a:solidFill>
+                <a:latin typeface="Apple SD Gothic Neo"/>
+                <a:ea typeface="Apple SD Gothic Neo"/>
+                <a:cs typeface="Apple SD Gothic Neo"/>
+              </a:defRPr>
+            </a:pPr>
+            <a:r>
+              <a:rPr sz="1500" b="0">
+                <a:solidFill>
+                  <a:srgbClr val="A6C5D7"/>
+                </a:solidFill>
+                <a:latin typeface="Apple SD Gothic Neo"/>
+                <a:ea typeface="Apple SD Gothic Neo"/>
+                <a:cs typeface="Apple SD Gothic Neo"/>
+              </a:rPr>
+              <a:t>과제 2 · 자유 주제 AI 서비스 개발</a:t>
+            </a:r>
+          </a:p>
+        </p:txBody>
+      </p:sp>
+      <p:sp>
+        <p:nvSpPr>
+          <p:cNvPr id="7" name="">
+            <a:extLst xmlns:a="http://schemas.openxmlformats.org/drawingml/2006/main">
+              <a:ext uri="{FF2B5EF4-FFF2-40B4-BE49-F238E27FC236}">
+                <a16:creationId xmlns:a16="http://schemas.microsoft.com/office/drawing/2014/main" id="{02EF47F3-39F3-4E14-9536-DC0EDCF71D32}"/>
+              </a:ext>
+            </a:extLst>
+          </p:cNvPr>
+          <p:cNvSpPr>
+            <a:spLocks xmlns:a="http://schemas.openxmlformats.org/drawingml/2006/main" noGrp="1"/>
+          </p:cNvSpPr>
+          <p:nvPr/>
+        </p:nvSpPr>
+        <p:spPr>
+          <a:xfrm xmlns:a="http://schemas.openxmlformats.org/drawingml/2006/main">
+            <a:off x="10953750" y="6486525"/>
+            <a:ext cx="619125" cy="257175"/>
+          </a:xfrm>
+          <a:prstGeom xmlns:a="http://schemas.openxmlformats.org/drawingml/2006/main" prst="rect">
+            <a:avLst/>
+          </a:prstGeom>
+          <a:noFill xmlns:a="http://schemas.openxmlformats.org/drawingml/2006/main"/>
+          <a:ln xmlns:a="http://schemas.openxmlformats.org/drawingml/2006/main" w="0">
+            <a:noFill/>
+          </a:ln>
+        </p:spPr>
+        <p:txBody>
+          <a:bodyPr xmlns:a="http://schemas.openxmlformats.org/drawingml/2006/main" lIns="0" tIns="0" rIns="0" bIns="0"/>
+          <a:lstStyle xmlns:a="http://schemas.openxmlformats.org/drawingml/2006/main">
+            <a:defPPr>
+              <a:defRPr sz="1350" b="0">
+                <a:solidFill>
+                  <a:srgbClr val="A6C5D7"/>
+                </a:solidFill>
+                <a:latin typeface="Apple SD Gothic Neo"/>
+                <a:ea typeface="Apple SD Gothic Neo"/>
+                <a:cs typeface="Apple SD Gothic Neo"/>
+              </a:defRPr>
+            </a:defPPr>
+            <a:lvl1pPr>
+              <a:defRPr sz="1350" b="0">
+                <a:solidFill>
+                  <a:srgbClr val="A6C5D7"/>
+                </a:solidFill>
+                <a:latin typeface="Apple SD Gothic Neo"/>
+                <a:ea typeface="Apple SD Gothic Neo"/>
+                <a:cs typeface="Apple SD Gothic Neo"/>
+              </a:defRPr>
+            </a:lvl1pPr>
+            <a:lvl2pPr>
+              <a:defRPr sz="1350" b="0">
+                <a:solidFill>
+                  <a:srgbClr val="A6C5D7"/>
+                </a:solidFill>
+                <a:latin typeface="Apple SD Gothic Neo"/>
+                <a:ea typeface="Apple SD Gothic Neo"/>
+                <a:cs typeface="Apple SD Gothic Neo"/>
+              </a:defRPr>
+            </a:lvl2pPr>
+            <a:lvl3pPr>
+              <a:defRPr sz="1350" b="0">
+                <a:solidFill>
+                  <a:srgbClr val="A6C5D7"/>
+                </a:solidFill>
+                <a:latin typeface="Apple SD Gothic Neo"/>
+                <a:ea typeface="Apple SD Gothic Neo"/>
+                <a:cs typeface="Apple SD Gothic Neo"/>
+              </a:defRPr>
+            </a:lvl3pPr>
+            <a:lvl4pPr>
+              <a:defRPr sz="1350" b="0">
+                <a:solidFill>
+                  <a:srgbClr val="A6C5D7"/>
+                </a:solidFill>
+                <a:latin typeface="Apple SD Gothic Neo"/>
+                <a:ea typeface="Apple SD Gothic Neo"/>
+                <a:cs typeface="Apple SD Gothic Neo"/>
+              </a:defRPr>
+            </a:lvl4pPr>
+            <a:lvl5pPr>
+              <a:defRPr sz="1350" b="0">
+                <a:solidFill>
+                  <a:srgbClr val="A6C5D7"/>
+                </a:solidFill>
+                <a:latin typeface="Apple SD Gothic Neo"/>
+                <a:ea typeface="Apple SD Gothic Neo"/>
+                <a:cs typeface="Apple SD Gothic Neo"/>
+              </a:defRPr>
+            </a:lvl5pPr>
+            <a:lvl6pPr>
+              <a:defRPr sz="1350" b="0">
+                <a:solidFill>
+                  <a:srgbClr val="A6C5D7"/>
+                </a:solidFill>
+                <a:latin typeface="Apple SD Gothic Neo"/>
+                <a:ea typeface="Apple SD Gothic Neo"/>
+                <a:cs typeface="Apple SD Gothic Neo"/>
+              </a:defRPr>
+            </a:lvl6pPr>
+            <a:lvl7pPr>
+              <a:defRPr sz="1350" b="0">
+                <a:solidFill>
+                  <a:srgbClr val="A6C5D7"/>
+                </a:solidFill>
+                <a:latin typeface="Apple SD Gothic Neo"/>
+                <a:ea typeface="Apple SD Gothic Neo"/>
+                <a:cs typeface="Apple SD Gothic Neo"/>
+              </a:defRPr>
+            </a:lvl7pPr>
+            <a:lvl8pPr>
+              <a:defRPr sz="1350" b="0">
+                <a:solidFill>
+                  <a:srgbClr val="A6C5D7"/>
+                </a:solidFill>
+                <a:latin typeface="Apple SD Gothic Neo"/>
+                <a:ea typeface="Apple SD Gothic Neo"/>
+                <a:cs typeface="Apple SD Gothic Neo"/>
+              </a:defRPr>
+            </a:lvl8pPr>
+            <a:lvl9pPr>
+              <a:defRPr sz="1350" b="0">
+                <a:solidFill>
+                  <a:srgbClr val="A6C5D7"/>
+                </a:solidFill>
+                <a:latin typeface="Apple SD Gothic Neo"/>
+                <a:ea typeface="Apple SD Gothic Neo"/>
+                <a:cs typeface="Apple SD Gothic Neo"/>
+              </a:defRPr>
+            </a:lvl9pPr>
+          </a:lstStyle>
+          <a:p xmlns:a="http://schemas.openxmlformats.org/drawingml/2006/main">
+            <a:pPr>
+              <a:defRPr sz="1350" b="0">
+                <a:solidFill>
+                  <a:srgbClr val="A6C5D7"/>
+                </a:solidFill>
+                <a:latin typeface="Apple SD Gothic Neo"/>
+                <a:ea typeface="Apple SD Gothic Neo"/>
+                <a:cs typeface="Apple SD Gothic Neo"/>
+              </a:defRPr>
+            </a:pPr>
+            <a:r>
+              <a:rPr sz="1350" b="0">
+                <a:solidFill>
+                  <a:srgbClr val="A6C5D7"/>
+                </a:solidFill>
+                <a:latin typeface="Apple SD Gothic Neo"/>
+                <a:ea typeface="Apple SD Gothic Neo"/>
+                <a:cs typeface="Apple SD Gothic Neo"/>
+              </a:rPr>
+              <a:t>1/8</a:t>
+            </a:r>
+          </a:p>
+        </p:txBody>
+      </p:sp>
+    </p:spTree>
+    <p:extLst>
+      <p:ext uri="{BB962C8B-B14F-4D97-AF65-F5344CB8AC3E}">
+        <p14:creationId xmlns:p14="http://schemas.microsoft.com/office/powerpoint/2010/main" val="472476322"/>
+      </p:ext>
+    </p:extLst>
+  </p:cSld>
+</p:sld>
+</file>
+
+<file path=ppt/slides/slide2.xml><?xml version="1.0" encoding="utf-8"?>
+<p:sld xmlns:p="http://schemas.openxmlformats.org/presentationml/2006/main">
+  <p:cSld>
+    <p:bg>
+      <p:bgPr>
+        <a:solidFill xmlns:a="http://schemas.openxmlformats.org/drawingml/2006/main">
+          <a:srgbClr val="000926"/>
+        </a:solidFill>
+      </p:bgPr>
+    </p:bg>
+    <p:spTree>
+      <p:nvGrpSpPr>
+        <p:cNvPr id="1" name=""/>
+        <p:cNvGrpSpPr/>
+        <p:nvPr/>
+      </p:nvGrpSpPr>
+      <p:grpSpPr>
+        <a:xfrm xmlns:a="http://schemas.openxmlformats.org/drawingml/2006/main"/>
+      </p:grpSpPr>
+      <p:sp>
+        <p:nvSpPr>
           <p:cNvPr id="7" name="">
             <a:extLst xmlns:a="http://schemas.openxmlformats.org/drawingml/2006/main">
               <a:ext uri="{FF2B5EF4-FFF2-40B4-BE49-F238E27FC236}">
@@ -4018,9 +5215,9 @@
           <a:bodyPr xmlns:a="http://schemas.openxmlformats.org/drawingml/2006/main" lIns="0" tIns="0" rIns="0" bIns="0"/>
           <a:lstStyle xmlns:a="http://schemas.openxmlformats.org/drawingml/2006/main">
             <a:defPPr>
-              <a:defRPr sz="2400" b="1">
-                <a:solidFill>
-                  <a:srgbClr val="D6E6F3"/>
+              <a:defRPr sz="2250" b="1">
+                <a:solidFill>
+                  <a:srgbClr val="A6C5D7"/>
                 </a:solidFill>
                 <a:latin typeface="Apple SD Gothic Neo"/>
                 <a:ea typeface="Apple SD Gothic Neo"/>
@@ -4130,9 +5327,9 @@
           <a:p xmlns:a="http://schemas.openxmlformats.org/drawingml/2006/main">
             <a:pPr>
               <a:buNone/>
-              <a:defRPr sz="2400" b="1">
-                <a:solidFill>
-                  <a:srgbClr val="D6E6F3"/>
+              <a:defRPr sz="2250" b="1">
+                <a:solidFill>
+                  <a:srgbClr val="A6C5D7"/>
                 </a:solidFill>
                 <a:latin typeface="Apple SD Gothic Neo"/>
                 <a:ea typeface="Apple SD Gothic Neo"/>
@@ -4140,15 +5337,15 @@
               </a:defRPr>
             </a:pPr>
             <a:r>
-              <a:rPr sz="2400" b="1">
-                <a:solidFill>
-                  <a:srgbClr val="D6E6F3"/>
+              <a:rPr sz="2250" b="1">
+                <a:solidFill>
+                  <a:srgbClr val="A6C5D7"/>
                 </a:solidFill>
                 <a:latin typeface="Apple SD Gothic Neo"/>
                 <a:ea typeface="Apple SD Gothic Neo"/>
                 <a:cs typeface="Apple SD Gothic Neo"/>
               </a:rPr>
-              <a:t>설정공방 LoreForge</a:t>
+              <a:t>문제 정의</a:t>
             </a:r>
           </a:p>
         </p:txBody>
@@ -4359,8 +5556,8 @@
         </p:nvSpPr>
         <p:spPr>
           <a:xfrm xmlns:a="http://schemas.openxmlformats.org/drawingml/2006/main">
-            <a:off x="609600" y="5953125"/>
-            <a:ext cx="10953750" cy="409575"/>
+            <a:off x="609600" y="6096000"/>
+            <a:ext cx="10972800" cy="361950"/>
           </a:xfrm>
           <a:prstGeom xmlns:a="http://schemas.openxmlformats.org/drawingml/2006/main" prst="rect">
             <a:avLst/>
@@ -4374,7 +5571,7 @@
           <a:bodyPr xmlns:a="http://schemas.openxmlformats.org/drawingml/2006/main" lIns="0" tIns="0" rIns="0" bIns="0"/>
           <a:lstStyle xmlns:a="http://schemas.openxmlformats.org/drawingml/2006/main">
             <a:defPPr>
-              <a:defRPr sz="2250" b="1">
+              <a:defRPr sz="2100" b="1">
                 <a:solidFill>
                   <a:srgbClr val="D6E6F3"/>
                 </a:solidFill>
@@ -4486,7 +5683,7 @@
           <a:p xmlns:a="http://schemas.openxmlformats.org/drawingml/2006/main">
             <a:pPr>
               <a:buNone/>
-              <a:defRPr sz="2250" b="1">
+              <a:defRPr sz="2100" b="1">
                 <a:solidFill>
                   <a:srgbClr val="D6E6F3"/>
                 </a:solidFill>
@@ -4496,7 +5693,7 @@
               </a:defRPr>
             </a:pPr>
             <a:r>
-              <a:rPr sz="2250" b="1">
+              <a:rPr sz="2100" b="1">
                 <a:solidFill>
                   <a:srgbClr val="D6E6F3"/>
                 </a:solidFill>
@@ -4691,8 +5888,8 @@
         </p:nvSpPr>
         <p:spPr>
           <a:xfrm xmlns:a="http://schemas.openxmlformats.org/drawingml/2006/main">
-            <a:off x="609600" y="6486525"/>
-            <a:ext cx="10972800" cy="238125"/>
+            <a:off x="609600" y="6543675"/>
+            <a:ext cx="9906000" cy="219075"/>
           </a:xfrm>
           <a:prstGeom xmlns:a="http://schemas.openxmlformats.org/drawingml/2006/main" prst="rect">
             <a:avLst/>
@@ -4706,7 +5903,7 @@
           <a:bodyPr xmlns:a="http://schemas.openxmlformats.org/drawingml/2006/main" lIns="0" tIns="0" rIns="0" bIns="0"/>
           <a:lstStyle xmlns:a="http://schemas.openxmlformats.org/drawingml/2006/main">
             <a:defPPr>
-              <a:defRPr sz="1275" b="0">
+              <a:defRPr sz="1200" b="0">
                 <a:solidFill>
                   <a:srgbClr val="A6C5D7"/>
                 </a:solidFill>
@@ -4818,7 +6015,7 @@
           <a:p xmlns:a="http://schemas.openxmlformats.org/drawingml/2006/main">
             <a:pPr>
               <a:buNone/>
-              <a:defRPr sz="1275" b="0">
+              <a:defRPr sz="1200" b="0">
                 <a:solidFill>
                   <a:srgbClr val="A6C5D7"/>
                 </a:solidFill>
@@ -4828,7 +6025,7 @@
               </a:defRPr>
             </a:pPr>
             <a:r>
-              <a:rPr sz="1275" b="0">
+              <a:rPr sz="1200" b="0">
                 <a:solidFill>
                   <a:srgbClr val="A6C5D7"/>
                 </a:solidFill>
@@ -4837,172 +6034,6 @@
                 <a:cs typeface="Apple SD Gothic Neo"/>
               </a:rPr>
               <a:t>이미지: 발표자 제공 · 작품별 설정 오류 판정이나 서비스 검증 결과가 아님</a:t>
-            </a:r>
-          </a:p>
-        </p:txBody>
-      </p:sp>
-      <p:sp>
-        <p:nvSpPr>
-          <p:cNvPr id="6" name="">
-            <a:extLst xmlns:a="http://schemas.openxmlformats.org/drawingml/2006/main">
-              <a:ext uri="{FF2B5EF4-FFF2-40B4-BE49-F238E27FC236}">
-                <a16:creationId xmlns:a16="http://schemas.microsoft.com/office/drawing/2014/main" id="{DD282D26-BD95-4D83-AE75-20AAF7549545}"/>
-              </a:ext>
-            </a:extLst>
-          </p:cNvPr>
-          <p:cNvSpPr>
-            <a:spLocks xmlns:a="http://schemas.openxmlformats.org/drawingml/2006/main" noGrp="1"/>
-          </p:cNvSpPr>
-          <p:nvPr/>
-        </p:nvSpPr>
-        <p:spPr>
-          <a:xfrm xmlns:a="http://schemas.openxmlformats.org/drawingml/2006/main">
-            <a:off x="609600" y="2133600"/>
-            <a:ext cx="8572500" cy="266700"/>
-          </a:xfrm>
-          <a:prstGeom xmlns:a="http://schemas.openxmlformats.org/drawingml/2006/main" prst="rect">
-            <a:avLst/>
-          </a:prstGeom>
-          <a:noFill xmlns:a="http://schemas.openxmlformats.org/drawingml/2006/main"/>
-          <a:ln xmlns:a="http://schemas.openxmlformats.org/drawingml/2006/main" w="0">
-            <a:noFill/>
-          </a:ln>
-        </p:spPr>
-        <p:txBody>
-          <a:bodyPr xmlns:a="http://schemas.openxmlformats.org/drawingml/2006/main" lIns="0" tIns="0" rIns="0" bIns="0"/>
-          <a:lstStyle xmlns:a="http://schemas.openxmlformats.org/drawingml/2006/main">
-            <a:defPPr>
-              <a:defRPr sz="1500" b="0">
-                <a:solidFill>
-                  <a:srgbClr val="A6C5D7"/>
-                </a:solidFill>
-                <a:latin typeface="Apple SD Gothic Neo"/>
-                <a:ea typeface="Apple SD Gothic Neo"/>
-                <a:cs typeface="Apple SD Gothic Neo"/>
-              </a:defRPr>
-            </a:defPPr>
-            <a:lvl1pPr>
-              <a:buNone/>
-              <a:defRPr sz="1425" b="0">
-                <a:solidFill>
-                  <a:srgbClr val="A6C5D7"/>
-                </a:solidFill>
-                <a:latin typeface="Apple SD Gothic Neo"/>
-                <a:ea typeface="Apple SD Gothic Neo"/>
-                <a:cs typeface="Apple SD Gothic Neo"/>
-              </a:defRPr>
-            </a:lvl1pPr>
-            <a:lvl2pPr>
-              <a:buNone/>
-              <a:defRPr sz="1425" b="0">
-                <a:solidFill>
-                  <a:srgbClr val="A6C5D7"/>
-                </a:solidFill>
-                <a:latin typeface="Apple SD Gothic Neo"/>
-                <a:ea typeface="Apple SD Gothic Neo"/>
-                <a:cs typeface="Apple SD Gothic Neo"/>
-              </a:defRPr>
-            </a:lvl2pPr>
-            <a:lvl3pPr>
-              <a:buNone/>
-              <a:defRPr sz="1425" b="0">
-                <a:solidFill>
-                  <a:srgbClr val="A6C5D7"/>
-                </a:solidFill>
-                <a:latin typeface="Apple SD Gothic Neo"/>
-                <a:ea typeface="Apple SD Gothic Neo"/>
-                <a:cs typeface="Apple SD Gothic Neo"/>
-              </a:defRPr>
-            </a:lvl3pPr>
-            <a:lvl4pPr>
-              <a:buNone/>
-              <a:defRPr sz="1425" b="0">
-                <a:solidFill>
-                  <a:srgbClr val="A6C5D7"/>
-                </a:solidFill>
-                <a:latin typeface="Apple SD Gothic Neo"/>
-                <a:ea typeface="Apple SD Gothic Neo"/>
-                <a:cs typeface="Apple SD Gothic Neo"/>
-              </a:defRPr>
-            </a:lvl4pPr>
-            <a:lvl5pPr>
-              <a:buNone/>
-              <a:defRPr sz="1425" b="0">
-                <a:solidFill>
-                  <a:srgbClr val="A6C5D7"/>
-                </a:solidFill>
-                <a:latin typeface="Apple SD Gothic Neo"/>
-                <a:ea typeface="Apple SD Gothic Neo"/>
-                <a:cs typeface="Apple SD Gothic Neo"/>
-              </a:defRPr>
-            </a:lvl5pPr>
-            <a:lvl6pPr>
-              <a:buNone/>
-              <a:defRPr sz="1425" b="0">
-                <a:solidFill>
-                  <a:srgbClr val="A6C5D7"/>
-                </a:solidFill>
-                <a:latin typeface="Apple SD Gothic Neo"/>
-                <a:ea typeface="Apple SD Gothic Neo"/>
-                <a:cs typeface="Apple SD Gothic Neo"/>
-              </a:defRPr>
-            </a:lvl6pPr>
-            <a:lvl7pPr>
-              <a:buNone/>
-              <a:defRPr sz="1425" b="0">
-                <a:solidFill>
-                  <a:srgbClr val="A6C5D7"/>
-                </a:solidFill>
-                <a:latin typeface="Apple SD Gothic Neo"/>
-                <a:ea typeface="Apple SD Gothic Neo"/>
-                <a:cs typeface="Apple SD Gothic Neo"/>
-              </a:defRPr>
-            </a:lvl7pPr>
-            <a:lvl8pPr>
-              <a:buNone/>
-              <a:defRPr sz="1425" b="0">
-                <a:solidFill>
-                  <a:srgbClr val="A6C5D7"/>
-                </a:solidFill>
-                <a:latin typeface="Apple SD Gothic Neo"/>
-                <a:ea typeface="Apple SD Gothic Neo"/>
-                <a:cs typeface="Apple SD Gothic Neo"/>
-              </a:defRPr>
-            </a:lvl8pPr>
-            <a:lvl9pPr>
-              <a:buNone/>
-              <a:defRPr sz="1425" b="0">
-                <a:solidFill>
-                  <a:srgbClr val="A6C5D7"/>
-                </a:solidFill>
-                <a:latin typeface="Apple SD Gothic Neo"/>
-                <a:ea typeface="Apple SD Gothic Neo"/>
-                <a:cs typeface="Apple SD Gothic Neo"/>
-              </a:defRPr>
-            </a:lvl9pPr>
-          </a:lstStyle>
-          <a:p xmlns:a="http://schemas.openxmlformats.org/drawingml/2006/main">
-            <a:pPr>
-              <a:buNone/>
-              <a:defRPr sz="1500" b="0">
-                <a:solidFill>
-                  <a:srgbClr val="A6C5D7"/>
-                </a:solidFill>
-                <a:latin typeface="Apple SD Gothic Neo"/>
-                <a:ea typeface="Apple SD Gothic Neo"/>
-                <a:cs typeface="Apple SD Gothic Neo"/>
-              </a:defRPr>
-            </a:pPr>
-            <a:r>
-              <a:rPr sz="1500" b="0">
-                <a:solidFill>
-                  <a:srgbClr val="A6C5D7"/>
-                </a:solidFill>
-                <a:latin typeface="Apple SD Gothic Neo"/>
-                <a:ea typeface="Apple SD Gothic Neo"/>
-                <a:cs typeface="Apple SD Gothic Neo"/>
-              </a:rPr>
-              <a:t>과제 2 · 세계관 창작과 설정 검토</a:t>
             </a:r>
           </a:p>
         </p:txBody>
@@ -5012,7 +6043,7 @@
           <p:cNvPr id="8" name="">
             <a:extLst xmlns:a="http://schemas.openxmlformats.org/drawingml/2006/main">
               <a:ext uri="{FF2B5EF4-FFF2-40B4-BE49-F238E27FC236}">
-                <a16:creationId xmlns:a16="http://schemas.microsoft.com/office/drawing/2014/main" id="{FC56AD85-8D52-4D00-AA7D-4ADC53BA4842}"/>
+                <a16:creationId xmlns:a16="http://schemas.microsoft.com/office/drawing/2014/main" id="{3E5BEBED-3868-4B7B-871B-C38A5153EEB6}"/>
               </a:ext>
             </a:extLst>
           </p:cNvPr>
@@ -5022,13 +6053,13 @@
           <p:nvPr/>
         </p:nvPicPr>
         <p:blipFill>
-          <a:blip xmlns:r="http://schemas.openxmlformats.org/officeDocument/2006/relationships" xmlns:a="http://schemas.openxmlformats.org/drawingml/2006/main" r:embed="R5c26e606e8ff463e"/>
+          <a:blip xmlns:r="http://schemas.openxmlformats.org/officeDocument/2006/relationships" xmlns:a="http://schemas.openxmlformats.org/drawingml/2006/main" r:embed="Rd9dfa1f3ca5149a0"/>
           <a:stretch xmlns:a="http://schemas.openxmlformats.org/drawingml/2006/main"/>
         </p:blipFill>
         <p:spPr>
           <a:xfrm xmlns:a="http://schemas.openxmlformats.org/drawingml/2006/main">
-            <a:off x="685720" y="2505075"/>
-            <a:ext cx="3467259" cy="2762250"/>
+            <a:off x="609600" y="2457450"/>
+            <a:ext cx="3586820" cy="2857500"/>
           </a:xfrm>
           <a:prstGeom xmlns:a="http://schemas.openxmlformats.org/drawingml/2006/main" prst="rect">
             <a:avLst/>
@@ -5051,8 +6082,8 @@
         </p:nvSpPr>
         <p:spPr>
           <a:xfrm xmlns:a="http://schemas.openxmlformats.org/drawingml/2006/main">
-            <a:off x="609600" y="5381625"/>
-            <a:ext cx="3619500" cy="352425"/>
+            <a:off x="609600" y="5467350"/>
+            <a:ext cx="3586820" cy="619125"/>
           </a:xfrm>
           <a:prstGeom xmlns:a="http://schemas.openxmlformats.org/drawingml/2006/main" prst="rect">
             <a:avLst/>
@@ -5066,7 +6097,7 @@
           <a:bodyPr xmlns:a="http://schemas.openxmlformats.org/drawingml/2006/main" lIns="0" tIns="0" rIns="0" bIns="0"/>
           <a:lstStyle xmlns:a="http://schemas.openxmlformats.org/drawingml/2006/main">
             <a:defPPr>
-              <a:defRPr sz="1950" b="1">
+              <a:defRPr sz="1875" b="1">
                 <a:solidFill>
                   <a:srgbClr val="FFFFFF"/>
                 </a:solidFill>
@@ -5076,6 +6107,7 @@
               </a:defRPr>
             </a:defPPr>
             <a:lvl1pPr>
+              <a:buNone/>
               <a:defRPr sz="1950" b="1">
                 <a:solidFill>
                   <a:srgbClr val="FFFFFF"/>
@@ -5086,6 +6118,7 @@
               </a:defRPr>
             </a:lvl1pPr>
             <a:lvl2pPr>
+              <a:buNone/>
               <a:defRPr sz="1950" b="1">
                 <a:solidFill>
                   <a:srgbClr val="FFFFFF"/>
@@ -5096,6 +6129,7 @@
               </a:defRPr>
             </a:lvl2pPr>
             <a:lvl3pPr>
+              <a:buNone/>
               <a:defRPr sz="1950" b="1">
                 <a:solidFill>
                   <a:srgbClr val="FFFFFF"/>
@@ -5106,6 +6140,7 @@
               </a:defRPr>
             </a:lvl3pPr>
             <a:lvl4pPr>
+              <a:buNone/>
               <a:defRPr sz="1950" b="1">
                 <a:solidFill>
                   <a:srgbClr val="FFFFFF"/>
@@ -5116,6 +6151,7 @@
               </a:defRPr>
             </a:lvl4pPr>
             <a:lvl5pPr>
+              <a:buNone/>
               <a:defRPr sz="1950" b="1">
                 <a:solidFill>
                   <a:srgbClr val="FFFFFF"/>
@@ -5126,6 +6162,7 @@
               </a:defRPr>
             </a:lvl5pPr>
             <a:lvl6pPr>
+              <a:buNone/>
               <a:defRPr sz="1950" b="1">
                 <a:solidFill>
                   <a:srgbClr val="FFFFFF"/>
@@ -5136,6 +6173,7 @@
               </a:defRPr>
             </a:lvl6pPr>
             <a:lvl7pPr>
+              <a:buNone/>
               <a:defRPr sz="1950" b="1">
                 <a:solidFill>
                   <a:srgbClr val="FFFFFF"/>
@@ -5146,6 +6184,7 @@
               </a:defRPr>
             </a:lvl7pPr>
             <a:lvl8pPr>
+              <a:buNone/>
               <a:defRPr sz="1950" b="1">
                 <a:solidFill>
                   <a:srgbClr val="FFFFFF"/>
@@ -5156,6 +6195,7 @@
               </a:defRPr>
             </a:lvl8pPr>
             <a:lvl9pPr>
+              <a:buNone/>
               <a:defRPr sz="1950" b="1">
                 <a:solidFill>
                   <a:srgbClr val="FFFFFF"/>
@@ -5168,7 +6208,8 @@
           </a:lstStyle>
           <a:p xmlns:a="http://schemas.openxmlformats.org/drawingml/2006/main">
             <a:pPr>
-              <a:defRPr sz="1950" b="1">
+              <a:buNone/>
+              <a:defRPr sz="1875" b="1">
                 <a:solidFill>
                   <a:srgbClr val="FFFFFF"/>
                 </a:solidFill>
@@ -5178,7 +6219,7 @@
               </a:defRPr>
             </a:pPr>
             <a:r>
-              <a:rPr sz="1950" b="1">
+              <a:rPr sz="1875" b="1">
                 <a:solidFill>
                   <a:srgbClr val="FFFFFF"/>
                 </a:solidFill>
@@ -5196,7 +6237,7 @@
           <p:cNvPr id="10" name="">
             <a:extLst xmlns:a="http://schemas.openxmlformats.org/drawingml/2006/main">
               <a:ext uri="{FF2B5EF4-FFF2-40B4-BE49-F238E27FC236}">
-                <a16:creationId xmlns:a16="http://schemas.microsoft.com/office/drawing/2014/main" id="{AE430326-4553-4D4D-A1CE-24D813C294E1}"/>
+                <a16:creationId xmlns:a16="http://schemas.microsoft.com/office/drawing/2014/main" id="{434F9B92-7AB7-4C56-BAF2-933F78BDD6B1}"/>
               </a:ext>
             </a:extLst>
           </p:cNvPr>
@@ -5206,13 +6247,13 @@
           <p:nvPr/>
         </p:nvPicPr>
         <p:blipFill>
-          <a:blip xmlns:r="http://schemas.openxmlformats.org/officeDocument/2006/relationships" xmlns:a="http://schemas.openxmlformats.org/drawingml/2006/main" r:embed="R6669dc521aa74a49"/>
+          <a:blip xmlns:r="http://schemas.openxmlformats.org/officeDocument/2006/relationships" xmlns:a="http://schemas.openxmlformats.org/drawingml/2006/main" r:embed="R91f2a275e4ec4454"/>
           <a:stretch xmlns:a="http://schemas.openxmlformats.org/drawingml/2006/main"/>
         </p:blipFill>
         <p:spPr>
           <a:xfrm xmlns:a="http://schemas.openxmlformats.org/drawingml/2006/main">
-            <a:off x="4457700" y="2684499"/>
-            <a:ext cx="2381250" cy="2403401"/>
+            <a:off x="4443910" y="2457450"/>
+            <a:ext cx="2831164" cy="2857500"/>
           </a:xfrm>
           <a:prstGeom xmlns:a="http://schemas.openxmlformats.org/drawingml/2006/main" prst="rect">
             <a:avLst/>
@@ -5235,8 +6276,8 @@
         </p:nvSpPr>
         <p:spPr>
           <a:xfrm xmlns:a="http://schemas.openxmlformats.org/drawingml/2006/main">
-            <a:off x="4457700" y="5381625"/>
-            <a:ext cx="2381250" cy="352425"/>
+            <a:off x="4443910" y="5467350"/>
+            <a:ext cx="2831164" cy="619125"/>
           </a:xfrm>
           <a:prstGeom xmlns:a="http://schemas.openxmlformats.org/drawingml/2006/main" prst="rect">
             <a:avLst/>
@@ -5250,7 +6291,7 @@
           <a:bodyPr xmlns:a="http://schemas.openxmlformats.org/drawingml/2006/main" lIns="0" tIns="0" rIns="0" bIns="0"/>
           <a:lstStyle xmlns:a="http://schemas.openxmlformats.org/drawingml/2006/main">
             <a:defPPr>
-              <a:defRPr sz="1950" b="1">
+              <a:defRPr sz="1875" b="1">
                 <a:solidFill>
                   <a:srgbClr val="FFFFFF"/>
                 </a:solidFill>
@@ -5260,6 +6301,7 @@
               </a:defRPr>
             </a:defPPr>
             <a:lvl1pPr>
+              <a:buNone/>
               <a:defRPr sz="1950" b="1">
                 <a:solidFill>
                   <a:srgbClr val="FFFFFF"/>
@@ -5270,6 +6312,7 @@
               </a:defRPr>
             </a:lvl1pPr>
             <a:lvl2pPr>
+              <a:buNone/>
               <a:defRPr sz="1950" b="1">
                 <a:solidFill>
                   <a:srgbClr val="FFFFFF"/>
@@ -5280,6 +6323,7 @@
               </a:defRPr>
             </a:lvl2pPr>
             <a:lvl3pPr>
+              <a:buNone/>
               <a:defRPr sz="1950" b="1">
                 <a:solidFill>
                   <a:srgbClr val="FFFFFF"/>
@@ -5290,6 +6334,7 @@
               </a:defRPr>
             </a:lvl3pPr>
             <a:lvl4pPr>
+              <a:buNone/>
               <a:defRPr sz="1950" b="1">
                 <a:solidFill>
                   <a:srgbClr val="FFFFFF"/>
@@ -5300,6 +6345,7 @@
               </a:defRPr>
             </a:lvl4pPr>
             <a:lvl5pPr>
+              <a:buNone/>
               <a:defRPr sz="1950" b="1">
                 <a:solidFill>
                   <a:srgbClr val="FFFFFF"/>
@@ -5310,6 +6356,7 @@
               </a:defRPr>
             </a:lvl5pPr>
             <a:lvl6pPr>
+              <a:buNone/>
               <a:defRPr sz="1950" b="1">
                 <a:solidFill>
                   <a:srgbClr val="FFFFFF"/>
@@ -5320,6 +6367,7 @@
               </a:defRPr>
             </a:lvl6pPr>
             <a:lvl7pPr>
+              <a:buNone/>
               <a:defRPr sz="1950" b="1">
                 <a:solidFill>
                   <a:srgbClr val="FFFFFF"/>
@@ -5330,6 +6378,7 @@
               </a:defRPr>
             </a:lvl7pPr>
             <a:lvl8pPr>
+              <a:buNone/>
               <a:defRPr sz="1950" b="1">
                 <a:solidFill>
                   <a:srgbClr val="FFFFFF"/>
@@ -5340,6 +6389,7 @@
               </a:defRPr>
             </a:lvl8pPr>
             <a:lvl9pPr>
+              <a:buNone/>
               <a:defRPr sz="1950" b="1">
                 <a:solidFill>
                   <a:srgbClr val="FFFFFF"/>
@@ -5352,7 +6402,8 @@
           </a:lstStyle>
           <a:p xmlns:a="http://schemas.openxmlformats.org/drawingml/2006/main">
             <a:pPr>
-              <a:defRPr sz="1950" b="1">
+              <a:buNone/>
+              <a:defRPr sz="1875" b="1">
                 <a:solidFill>
                   <a:srgbClr val="FFFFFF"/>
                 </a:solidFill>
@@ -5362,7 +6413,7 @@
               </a:defRPr>
             </a:pPr>
             <a:r>
-              <a:rPr sz="1950" b="1">
+              <a:rPr sz="1875" b="1">
                 <a:solidFill>
                   <a:srgbClr val="FFFFFF"/>
                 </a:solidFill>
@@ -5380,7 +6431,7 @@
           <p:cNvPr id="12" name="">
             <a:extLst xmlns:a="http://schemas.openxmlformats.org/drawingml/2006/main">
               <a:ext uri="{FF2B5EF4-FFF2-40B4-BE49-F238E27FC236}">
-                <a16:creationId xmlns:a16="http://schemas.microsoft.com/office/drawing/2014/main" id="{9C0846F1-F142-4E91-ADDF-4FF3EA6BD482}"/>
+                <a16:creationId xmlns:a16="http://schemas.microsoft.com/office/drawing/2014/main" id="{52FC0812-0855-4A89-A511-2E52B5FFC3D4}"/>
               </a:ext>
             </a:extLst>
           </p:cNvPr>
@@ -5390,13 +6441,13 @@
           <p:nvPr/>
         </p:nvPicPr>
         <p:blipFill>
-          <a:blip xmlns:r="http://schemas.openxmlformats.org/officeDocument/2006/relationships" xmlns:a="http://schemas.openxmlformats.org/drawingml/2006/main" r:embed="R80cdf11481a44241"/>
+          <a:blip xmlns:r="http://schemas.openxmlformats.org/officeDocument/2006/relationships" xmlns:a="http://schemas.openxmlformats.org/drawingml/2006/main" r:embed="Red3d988a9fcc45c2"/>
           <a:stretch xmlns:a="http://schemas.openxmlformats.org/drawingml/2006/main"/>
         </p:blipFill>
         <p:spPr>
           <a:xfrm xmlns:a="http://schemas.openxmlformats.org/drawingml/2006/main">
-            <a:off x="7071481" y="2505075"/>
-            <a:ext cx="2135263" cy="2762250"/>
+            <a:off x="7522563" y="2457450"/>
+            <a:ext cx="2208893" cy="2857500"/>
           </a:xfrm>
           <a:prstGeom xmlns:a="http://schemas.openxmlformats.org/drawingml/2006/main" prst="rect">
             <a:avLst/>
@@ -5419,8 +6470,8 @@
         </p:nvSpPr>
         <p:spPr>
           <a:xfrm xmlns:a="http://schemas.openxmlformats.org/drawingml/2006/main">
-            <a:off x="7067550" y="5381625"/>
-            <a:ext cx="2143125" cy="352425"/>
+            <a:off x="7522563" y="5467350"/>
+            <a:ext cx="2208893" cy="619125"/>
           </a:xfrm>
           <a:prstGeom xmlns:a="http://schemas.openxmlformats.org/drawingml/2006/main" prst="rect">
             <a:avLst/>
@@ -5434,7 +6485,7 @@
           <a:bodyPr xmlns:a="http://schemas.openxmlformats.org/drawingml/2006/main" lIns="0" tIns="0" rIns="0" bIns="0"/>
           <a:lstStyle xmlns:a="http://schemas.openxmlformats.org/drawingml/2006/main">
             <a:defPPr>
-              <a:defRPr sz="1950" b="1">
+              <a:defRPr sz="1875" b="1">
                 <a:solidFill>
                   <a:srgbClr val="FFFFFF"/>
                 </a:solidFill>
@@ -5444,6 +6495,7 @@
               </a:defRPr>
             </a:defPPr>
             <a:lvl1pPr>
+              <a:buNone/>
               <a:defRPr sz="1950" b="1">
                 <a:solidFill>
                   <a:srgbClr val="FFFFFF"/>
@@ -5454,6 +6506,7 @@
               </a:defRPr>
             </a:lvl1pPr>
             <a:lvl2pPr>
+              <a:buNone/>
               <a:defRPr sz="1950" b="1">
                 <a:solidFill>
                   <a:srgbClr val="FFFFFF"/>
@@ -5464,6 +6517,7 @@
               </a:defRPr>
             </a:lvl2pPr>
             <a:lvl3pPr>
+              <a:buNone/>
               <a:defRPr sz="1950" b="1">
                 <a:solidFill>
                   <a:srgbClr val="FFFFFF"/>
@@ -5474,6 +6528,7 @@
               </a:defRPr>
             </a:lvl3pPr>
             <a:lvl4pPr>
+              <a:buNone/>
               <a:defRPr sz="1950" b="1">
                 <a:solidFill>
                   <a:srgbClr val="FFFFFF"/>
@@ -5484,6 +6539,7 @@
               </a:defRPr>
             </a:lvl4pPr>
             <a:lvl5pPr>
+              <a:buNone/>
               <a:defRPr sz="1950" b="1">
                 <a:solidFill>
                   <a:srgbClr val="FFFFFF"/>
@@ -5494,6 +6550,7 @@
               </a:defRPr>
             </a:lvl5pPr>
             <a:lvl6pPr>
+              <a:buNone/>
               <a:defRPr sz="1950" b="1">
                 <a:solidFill>
                   <a:srgbClr val="FFFFFF"/>
@@ -5504,6 +6561,7 @@
               </a:defRPr>
             </a:lvl6pPr>
             <a:lvl7pPr>
+              <a:buNone/>
               <a:defRPr sz="1950" b="1">
                 <a:solidFill>
                   <a:srgbClr val="FFFFFF"/>
@@ -5514,6 +6572,7 @@
               </a:defRPr>
             </a:lvl7pPr>
             <a:lvl8pPr>
+              <a:buNone/>
               <a:defRPr sz="1950" b="1">
                 <a:solidFill>
                   <a:srgbClr val="FFFFFF"/>
@@ -5524,6 +6583,7 @@
               </a:defRPr>
             </a:lvl8pPr>
             <a:lvl9pPr>
+              <a:buNone/>
               <a:defRPr sz="1950" b="1">
                 <a:solidFill>
                   <a:srgbClr val="FFFFFF"/>
@@ -5536,7 +6596,8 @@
           </a:lstStyle>
           <a:p xmlns:a="http://schemas.openxmlformats.org/drawingml/2006/main">
             <a:pPr>
-              <a:defRPr sz="1950" b="1">
+              <a:buNone/>
+              <a:defRPr sz="1875" b="1">
                 <a:solidFill>
                   <a:srgbClr val="FFFFFF"/>
                 </a:solidFill>
@@ -5546,7 +6607,7 @@
               </a:defRPr>
             </a:pPr>
             <a:r>
-              <a:rPr sz="1950" b="1">
+              <a:rPr sz="1875" b="1">
                 <a:solidFill>
                   <a:srgbClr val="FFFFFF"/>
                 </a:solidFill>
@@ -5564,7 +6625,7 @@
           <p:cNvPr id="14" name="">
             <a:extLst xmlns:a="http://schemas.openxmlformats.org/drawingml/2006/main">
               <a:ext uri="{FF2B5EF4-FFF2-40B4-BE49-F238E27FC236}">
-                <a16:creationId xmlns:a16="http://schemas.microsoft.com/office/drawing/2014/main" id="{96F60B14-CFF5-45AD-9964-1643FE74AFC0}"/>
+                <a16:creationId xmlns:a16="http://schemas.microsoft.com/office/drawing/2014/main" id="{40692056-5631-4ECF-9486-356FFF72E16E}"/>
               </a:ext>
             </a:extLst>
           </p:cNvPr>
@@ -5574,13 +6635,13 @@
           <p:nvPr/>
         </p:nvPicPr>
         <p:blipFill>
-          <a:blip xmlns:r="http://schemas.openxmlformats.org/officeDocument/2006/relationships" xmlns:a="http://schemas.openxmlformats.org/drawingml/2006/main" r:embed="R1ae4126f3de54a06"/>
+          <a:blip xmlns:r="http://schemas.openxmlformats.org/officeDocument/2006/relationships" xmlns:a="http://schemas.openxmlformats.org/drawingml/2006/main" r:embed="R79a52c2a136c44be"/>
           <a:stretch xmlns:a="http://schemas.openxmlformats.org/drawingml/2006/main"/>
         </p:blipFill>
         <p:spPr>
           <a:xfrm xmlns:a="http://schemas.openxmlformats.org/drawingml/2006/main">
-            <a:off x="9664397" y="2505075"/>
-            <a:ext cx="1550006" cy="2762250"/>
+            <a:off x="9978945" y="2457450"/>
+            <a:ext cx="1603455" cy="2857500"/>
           </a:xfrm>
           <a:prstGeom xmlns:a="http://schemas.openxmlformats.org/drawingml/2006/main" prst="rect">
             <a:avLst/>
@@ -5603,8 +6664,8 @@
         </p:nvSpPr>
         <p:spPr>
           <a:xfrm xmlns:a="http://schemas.openxmlformats.org/drawingml/2006/main">
-            <a:off x="9439275" y="5381625"/>
-            <a:ext cx="2000250" cy="352425"/>
+            <a:off x="9978945" y="5467350"/>
+            <a:ext cx="1603455" cy="619125"/>
           </a:xfrm>
           <a:prstGeom xmlns:a="http://schemas.openxmlformats.org/drawingml/2006/main" prst="rect">
             <a:avLst/>
@@ -5618,7 +6679,7 @@
           <a:bodyPr xmlns:a="http://schemas.openxmlformats.org/drawingml/2006/main" lIns="0" tIns="0" rIns="0" bIns="0"/>
           <a:lstStyle xmlns:a="http://schemas.openxmlformats.org/drawingml/2006/main">
             <a:defPPr>
-              <a:defRPr sz="1950" b="1">
+              <a:defRPr sz="1875" b="1">
                 <a:solidFill>
                   <a:srgbClr val="FFFFFF"/>
                 </a:solidFill>
@@ -5628,6 +6689,7 @@
               </a:defRPr>
             </a:defPPr>
             <a:lvl1pPr>
+              <a:buNone/>
               <a:defRPr sz="1950" b="1">
                 <a:solidFill>
                   <a:srgbClr val="FFFFFF"/>
@@ -5638,6 +6700,7 @@
               </a:defRPr>
             </a:lvl1pPr>
             <a:lvl2pPr>
+              <a:buNone/>
               <a:defRPr sz="1950" b="1">
                 <a:solidFill>
                   <a:srgbClr val="FFFFFF"/>
@@ -5648,6 +6711,7 @@
               </a:defRPr>
             </a:lvl2pPr>
             <a:lvl3pPr>
+              <a:buNone/>
               <a:defRPr sz="1950" b="1">
                 <a:solidFill>
                   <a:srgbClr val="FFFFFF"/>
@@ -5658,6 +6722,7 @@
               </a:defRPr>
             </a:lvl3pPr>
             <a:lvl4pPr>
+              <a:buNone/>
               <a:defRPr sz="1950" b="1">
                 <a:solidFill>
                   <a:srgbClr val="FFFFFF"/>
@@ -5668,6 +6733,7 @@
               </a:defRPr>
             </a:lvl4pPr>
             <a:lvl5pPr>
+              <a:buNone/>
               <a:defRPr sz="1950" b="1">
                 <a:solidFill>
                   <a:srgbClr val="FFFFFF"/>
@@ -5678,6 +6744,7 @@
               </a:defRPr>
             </a:lvl5pPr>
             <a:lvl6pPr>
+              <a:buNone/>
               <a:defRPr sz="1950" b="1">
                 <a:solidFill>
                   <a:srgbClr val="FFFFFF"/>
@@ -5688,6 +6755,7 @@
               </a:defRPr>
             </a:lvl6pPr>
             <a:lvl7pPr>
+              <a:buNone/>
               <a:defRPr sz="1950" b="1">
                 <a:solidFill>
                   <a:srgbClr val="FFFFFF"/>
@@ -5698,6 +6766,7 @@
               </a:defRPr>
             </a:lvl7pPr>
             <a:lvl8pPr>
+              <a:buNone/>
               <a:defRPr sz="1950" b="1">
                 <a:solidFill>
                   <a:srgbClr val="FFFFFF"/>
@@ -5708,6 +6777,7 @@
               </a:defRPr>
             </a:lvl8pPr>
             <a:lvl9pPr>
+              <a:buNone/>
               <a:defRPr sz="1950" b="1">
                 <a:solidFill>
                   <a:srgbClr val="FFFFFF"/>
@@ -5720,7 +6790,8 @@
           </a:lstStyle>
           <a:p xmlns:a="http://schemas.openxmlformats.org/drawingml/2006/main">
             <a:pPr>
-              <a:defRPr sz="1950" b="1">
+              <a:buNone/>
+              <a:defRPr sz="1875" b="1">
                 <a:solidFill>
                   <a:srgbClr val="FFFFFF"/>
                 </a:solidFill>
@@ -5730,7 +6801,7 @@
               </a:defRPr>
             </a:pPr>
             <a:r>
-              <a:rPr sz="1950" b="1">
+              <a:rPr sz="1875" b="1">
                 <a:solidFill>
                   <a:srgbClr val="FFFFFF"/>
                 </a:solidFill>
@@ -5738,7 +6809,31 @@
                 <a:ea typeface="Apple SD Gothic Neo"/>
                 <a:cs typeface="Apple SD Gothic Neo"/>
               </a:rPr>
-              <a:t>갓 오브 하이스쿨</a:t>
+              <a:t>갓 오브</a:t>
+            </a:r>
+          </a:p>
+          <a:p xmlns:a="http://schemas.openxmlformats.org/drawingml/2006/main">
+            <a:pPr>
+              <a:buNone/>
+              <a:defRPr sz="1875" b="1">
+                <a:solidFill>
+                  <a:srgbClr val="FFFFFF"/>
+                </a:solidFill>
+                <a:latin typeface="Apple SD Gothic Neo"/>
+                <a:ea typeface="Apple SD Gothic Neo"/>
+                <a:cs typeface="Apple SD Gothic Neo"/>
+              </a:defRPr>
+            </a:pPr>
+            <a:r>
+              <a:rPr sz="1875" b="1">
+                <a:solidFill>
+                  <a:srgbClr val="FFFFFF"/>
+                </a:solidFill>
+                <a:latin typeface="Apple SD Gothic Neo"/>
+                <a:ea typeface="Apple SD Gothic Neo"/>
+                <a:cs typeface="Apple SD Gothic Neo"/>
+              </a:rPr>
+              <a:t>하이스쿨</a:t>
             </a:r>
           </a:p>
         </p:txBody>
@@ -5748,7 +6843,7 @@
           <p:cNvPr id="16" name="">
             <a:extLst xmlns:a="http://schemas.openxmlformats.org/drawingml/2006/main">
               <a:ext uri="{FF2B5EF4-FFF2-40B4-BE49-F238E27FC236}">
-                <a16:creationId xmlns:a16="http://schemas.microsoft.com/office/drawing/2014/main" id="{22AE983F-7B29-4860-B09C-1EDBB0FAA8DF}"/>
+                <a16:creationId xmlns:a16="http://schemas.microsoft.com/office/drawing/2014/main" id="{421B91D9-1134-4EFB-BA0A-5B11F41E4F26}"/>
               </a:ext>
             </a:extLst>
           </p:cNvPr>
@@ -5759,8 +6854,8 @@
         </p:nvSpPr>
         <p:spPr>
           <a:xfrm xmlns:a="http://schemas.openxmlformats.org/drawingml/2006/main">
-            <a:off x="9439275" y="5724525"/>
-            <a:ext cx="2000250" cy="238125"/>
+            <a:off x="10953750" y="6486525"/>
+            <a:ext cx="619125" cy="257175"/>
           </a:xfrm>
           <a:prstGeom xmlns:a="http://schemas.openxmlformats.org/drawingml/2006/main" prst="rect">
             <a:avLst/>
@@ -5894,7 +6989,7 @@
                 <a:ea typeface="Apple SD Gothic Neo"/>
                 <a:cs typeface="Apple SD Gothic Neo"/>
               </a:rPr>
-              <a:t>제아봉침 25만 배</a:t>
+              <a:t>2/8</a:t>
             </a:r>
           </a:p>
         </p:txBody>
@@ -5909,7 +7004,7 @@
 </p:sld>
 </file>
 
-<file path=ppt/slides/slide2.xml><?xml version="1.0" encoding="utf-8"?>
+<file path=ppt/slides/slide3.xml><?xml version="1.0" encoding="utf-8"?>
 <p:sld xmlns:p="http://schemas.openxmlformats.org/presentationml/2006/main">
   <p:cSld>
     <p:bg>
@@ -6255,7 +7350,7 @@
                 <a:ea typeface="Apple SD Gothic Neo"/>
                 <a:cs typeface="Apple SD Gothic Neo"/>
               </a:rPr>
-              <a:t>G074 김지민   ·   2/7</a:t>
+              <a:t>G074 김지민   ·   3/8</a:t>
             </a:r>
           </a:p>
         </p:txBody>
@@ -8262,7 +9357,7 @@
 </p:sld>
 </file>
 
-<file path=ppt/slides/slide3.xml><?xml version="1.0" encoding="utf-8"?>
+<file path=ppt/slides/slide4.xml><?xml version="1.0" encoding="utf-8"?>
 <p:sld xmlns:p="http://schemas.openxmlformats.org/presentationml/2006/main">
   <p:cSld>
     <p:bg>
@@ -8608,7 +9703,7 @@
                 <a:ea typeface="Apple SD Gothic Neo"/>
                 <a:cs typeface="Apple SD Gothic Neo"/>
               </a:rPr>
-              <a:t>G074 김지민   ·   3/7</a:t>
+              <a:t>G074 김지민   ·   4/8</a:t>
             </a:r>
           </a:p>
         </p:txBody>
@@ -9638,7 +10733,7 @@
           <p:cNvPr id="9" name="">
             <a:extLst xmlns:a="http://schemas.openxmlformats.org/drawingml/2006/main">
               <a:ext uri="{FF2B5EF4-FFF2-40B4-BE49-F238E27FC236}">
-                <a16:creationId xmlns:a16="http://schemas.microsoft.com/office/drawing/2014/main" id="{1C6CF6E0-7E2C-4D31-80D5-721C37BEF46F}"/>
+                <a16:creationId xmlns:a16="http://schemas.microsoft.com/office/drawing/2014/main" id="{639D84FB-78E1-4186-8F8E-05A3F27AE157}"/>
               </a:ext>
             </a:extLst>
           </p:cNvPr>
@@ -9648,7 +10743,7 @@
           <p:nvPr/>
         </p:nvPicPr>
         <p:blipFill>
-          <a:blip xmlns:r="http://schemas.openxmlformats.org/officeDocument/2006/relationships" xmlns:a="http://schemas.openxmlformats.org/drawingml/2006/main" r:embed="Rd02ed7daaa3b4187"/>
+          <a:blip xmlns:r="http://schemas.openxmlformats.org/officeDocument/2006/relationships" xmlns:a="http://schemas.openxmlformats.org/drawingml/2006/main" r:embed="R1e0d6d0cc311447c"/>
           <a:srcRect xmlns:a="http://schemas.openxmlformats.org/drawingml/2006/main" l="24500" t="32000" r="25000" b="22000"/>
           <a:stretch xmlns:a="http://schemas.openxmlformats.org/drawingml/2006/main"/>
         </p:blipFill>
@@ -9833,7 +10928,7 @@
           <p:cNvPr id="12" name="">
             <a:extLst xmlns:a="http://schemas.openxmlformats.org/drawingml/2006/main">
               <a:ext uri="{FF2B5EF4-FFF2-40B4-BE49-F238E27FC236}">
-                <a16:creationId xmlns:a16="http://schemas.microsoft.com/office/drawing/2014/main" id="{7327C31E-7690-4351-A486-F5D30B7E03C0}"/>
+                <a16:creationId xmlns:a16="http://schemas.microsoft.com/office/drawing/2014/main" id="{330E0B00-5997-4334-8B06-A4820B8631CC}"/>
               </a:ext>
             </a:extLst>
           </p:cNvPr>
@@ -9843,7 +10938,7 @@
           <p:nvPr/>
         </p:nvPicPr>
         <p:blipFill>
-          <a:blip xmlns:r="http://schemas.openxmlformats.org/officeDocument/2006/relationships" xmlns:a="http://schemas.openxmlformats.org/drawingml/2006/main" r:embed="R2c831c56f7d14837"/>
+          <a:blip xmlns:r="http://schemas.openxmlformats.org/officeDocument/2006/relationships" xmlns:a="http://schemas.openxmlformats.org/drawingml/2006/main" r:embed="Rccd5025e697347c4"/>
           <a:srcRect xmlns:a="http://schemas.openxmlformats.org/drawingml/2006/main" l="2700" t="39500" r="3200" b="20500"/>
           <a:stretch xmlns:a="http://schemas.openxmlformats.org/drawingml/2006/main"/>
         </p:blipFill>
@@ -9867,7 +10962,7 @@
 </p:sld>
 </file>
 
-<file path=ppt/slides/slide4.xml><?xml version="1.0" encoding="utf-8"?>
+<file path=ppt/slides/slide5.xml><?xml version="1.0" encoding="utf-8"?>
 <p:sld xmlns:p="http://schemas.openxmlformats.org/presentationml/2006/main">
   <p:cSld>
     <p:bg>
@@ -9891,7 +10986,7 @@
           <p:cNvPr id="12" name="">
             <a:extLst xmlns:a="http://schemas.openxmlformats.org/drawingml/2006/main">
               <a:ext uri="{FF2B5EF4-FFF2-40B4-BE49-F238E27FC236}">
-                <a16:creationId xmlns:a16="http://schemas.microsoft.com/office/drawing/2014/main" id="{C7EDEDBE-A00F-435B-95DD-48AC8508442C}"/>
+                <a16:creationId xmlns:a16="http://schemas.microsoft.com/office/drawing/2014/main" id="{12EDD95E-BB2A-453E-AFAA-A742C4A1463F}"/>
               </a:ext>
             </a:extLst>
           </p:cNvPr>
@@ -9922,7 +11017,7 @@
           <p:cNvPr id="11" name="">
             <a:extLst xmlns:a="http://schemas.openxmlformats.org/drawingml/2006/main">
               <a:ext uri="{FF2B5EF4-FFF2-40B4-BE49-F238E27FC236}">
-                <a16:creationId xmlns:a16="http://schemas.microsoft.com/office/drawing/2014/main" id="{214A8C57-3CAB-400B-872D-3980AB55CC25}"/>
+                <a16:creationId xmlns:a16="http://schemas.microsoft.com/office/drawing/2014/main" id="{DCF7306E-8BF3-4D9A-8547-1EB82299CF8A}"/>
               </a:ext>
             </a:extLst>
           </p:cNvPr>
@@ -9953,7 +11048,7 @@
           <p:cNvPr id="10" name="">
             <a:extLst xmlns:a="http://schemas.openxmlformats.org/drawingml/2006/main">
               <a:ext uri="{FF2B5EF4-FFF2-40B4-BE49-F238E27FC236}">
-                <a16:creationId xmlns:a16="http://schemas.microsoft.com/office/drawing/2014/main" id="{2A684972-CFF4-436F-A961-A509E8F9BFC0}"/>
+                <a16:creationId xmlns:a16="http://schemas.microsoft.com/office/drawing/2014/main" id="{CF485B55-9512-4DF7-9BB6-E38357CD9673}"/>
               </a:ext>
             </a:extLst>
           </p:cNvPr>
@@ -9984,7 +11079,7 @@
           <p:cNvPr id="9" name="">
             <a:extLst xmlns:a="http://schemas.openxmlformats.org/drawingml/2006/main">
               <a:ext uri="{FF2B5EF4-FFF2-40B4-BE49-F238E27FC236}">
-                <a16:creationId xmlns:a16="http://schemas.microsoft.com/office/drawing/2014/main" id="{616F4DB4-FD43-4C82-88F9-877A61552A96}"/>
+                <a16:creationId xmlns:a16="http://schemas.microsoft.com/office/drawing/2014/main" id="{9E9BA08C-14A9-46E1-8FCF-4669B4574DAA}"/>
               </a:ext>
             </a:extLst>
           </p:cNvPr>
@@ -10337,7 +11432,7 @@
                 <a:ea typeface="Apple SD Gothic Neo"/>
                 <a:cs typeface="Apple SD Gothic Neo"/>
               </a:rPr>
-              <a:t>G074 김지민   ·   4/7</a:t>
+              <a:t>G074 김지민   ·   5/8</a:t>
             </a:r>
           </a:p>
         </p:txBody>
@@ -12790,7 +13885,7 @@
 </p:sld>
 </file>
 
-<file path=ppt/slides/slide5.xml><?xml version="1.0" encoding="utf-8"?>
+<file path=ppt/slides/slide6.xml><?xml version="1.0" encoding="utf-8"?>
 <p:sld xmlns:p="http://schemas.openxmlformats.org/presentationml/2006/main">
   <p:cSld>
     <p:bg>
@@ -13136,7 +14231,7 @@
                 <a:ea typeface="Apple SD Gothic Neo"/>
                 <a:cs typeface="Apple SD Gothic Neo"/>
               </a:rPr>
-              <a:t>G074 김지민   ·   5/7</a:t>
+              <a:t>G074 김지민   ·   6/8</a:t>
             </a:r>
           </a:p>
         </p:txBody>
@@ -14743,7 +15838,7 @@
 </p:sld>
 </file>
 
-<file path=ppt/slides/slide6.xml><?xml version="1.0" encoding="utf-8"?>
+<file path=ppt/slides/slide7.xml><?xml version="1.0" encoding="utf-8"?>
 <p:sld xmlns:p="http://schemas.openxmlformats.org/presentationml/2006/main">
   <p:cSld>
     <p:bg>
@@ -15089,7 +16184,7 @@
                 <a:ea typeface="Apple SD Gothic Neo"/>
                 <a:cs typeface="Apple SD Gothic Neo"/>
               </a:rPr>
-              <a:t>G074 김지민   ·   6/7</a:t>
+              <a:t>G074 김지민   ·   7/8</a:t>
             </a:r>
           </a:p>
         </p:txBody>
@@ -16482,7 +17577,7 @@
 </p:sld>
 </file>
 
-<file path=ppt/slides/slide7.xml><?xml version="1.0" encoding="utf-8"?>
+<file path=ppt/slides/slide8.xml><?xml version="1.0" encoding="utf-8"?>
 <p:sld xmlns:p="http://schemas.openxmlformats.org/presentationml/2006/main">
   <p:cSld>
     <p:bg>
@@ -16828,7 +17923,7 @@
                 <a:ea typeface="Apple SD Gothic Neo"/>
                 <a:cs typeface="Apple SD Gothic Neo"/>
               </a:rPr>
-              <a:t>G074 김지민   ·   7/7</a:t>
+              <a:t>G074 김지민   ·   8/8</a:t>
             </a:r>
           </a:p>
         </p:txBody>

</xml_diff>

<commit_message>
docs(presentation): remove two annotated footer labels
변경 내용
- 표지의 과제 소개 하단 문구를 삭제했다.
- 문제 정의 장의 이미지 제공 및 사례 판정 안내 하단 문구를 삭제했다.

변경 이유
- 사용자가 지정한 두 요소만 제거하고 나머지 배치와 발표자 노트를 보존했다.

검증
- finalize-footers.mjs: 8장 PPTX 무결성·레이아웃·폰트·재가져오기 검사 통과.
- check-footers.py: 두 문구만 삭제되었으며 모든 노트와 나머지 본문이 유지됨을 확인했다.
- 변경된 두 장을 렌더로 확인했고 다른 6장은 기존과 픽셀이 동일함을 확인했다.
- git diff --check 통과.
</commit_message>
<xml_diff>
--- a/docs/presentation/LoreForge-G074-KimJimin.pptx
+++ b/docs/presentation/LoreForge-G074-KimJimin.pptx
@@ -2,20 +2,20 @@
 <file path=ppt/presentation.xml><?xml version="1.0" encoding="utf-8"?>
 <p:presentation xmlns:p="http://schemas.openxmlformats.org/presentationml/2006/main">
   <p:sldMasterIdLst>
-    <p:sldMasterId xmlns:r="http://schemas.openxmlformats.org/officeDocument/2006/relationships" id="2147483648" r:id="Racc8c6d32ac041c3"/>
+    <p:sldMasterId xmlns:r="http://schemas.openxmlformats.org/officeDocument/2006/relationships" id="2147483648" r:id="Rdff187d7a2f74154"/>
   </p:sldMasterIdLst>
   <p:notesMasterIdLst>
-    <p:notesMasterId xmlns:r="http://schemas.openxmlformats.org/officeDocument/2006/relationships" r:id="R9e9927a003fe46a4"/>
+    <p:notesMasterId xmlns:r="http://schemas.openxmlformats.org/officeDocument/2006/relationships" r:id="Rb7b19ee4a6af47c7"/>
   </p:notesMasterIdLst>
   <p:sldIdLst>
-    <p:sldId xmlns:r="http://schemas.openxmlformats.org/officeDocument/2006/relationships" id="256" r:id="Rf9e2382e861c4e6b"/>
-    <p:sldId xmlns:r="http://schemas.openxmlformats.org/officeDocument/2006/relationships" id="257" r:id="R907e80bd8ffe4345"/>
-    <p:sldId xmlns:r="http://schemas.openxmlformats.org/officeDocument/2006/relationships" id="258" r:id="R96c21c7530164453"/>
-    <p:sldId xmlns:r="http://schemas.openxmlformats.org/officeDocument/2006/relationships" id="259" r:id="Rc8a5a864f7e84109"/>
-    <p:sldId xmlns:r="http://schemas.openxmlformats.org/officeDocument/2006/relationships" id="260" r:id="R0090ee0dc30345c0"/>
-    <p:sldId xmlns:r="http://schemas.openxmlformats.org/officeDocument/2006/relationships" id="261" r:id="Re8be4268710f4614"/>
-    <p:sldId xmlns:r="http://schemas.openxmlformats.org/officeDocument/2006/relationships" id="262" r:id="Raf8278feab1e4d32"/>
-    <p:sldId xmlns:r="http://schemas.openxmlformats.org/officeDocument/2006/relationships" id="263" r:id="R4f1ac3a8a2db4f38"/>
+    <p:sldId xmlns:r="http://schemas.openxmlformats.org/officeDocument/2006/relationships" id="256" r:id="R37ba50c58c3a4b75"/>
+    <p:sldId xmlns:r="http://schemas.openxmlformats.org/officeDocument/2006/relationships" id="257" r:id="R24fa2645cbbe4607"/>
+    <p:sldId xmlns:r="http://schemas.openxmlformats.org/officeDocument/2006/relationships" id="258" r:id="R12491c180bef4fd6"/>
+    <p:sldId xmlns:r="http://schemas.openxmlformats.org/officeDocument/2006/relationships" id="259" r:id="Rb8d5e08040bb4277"/>
+    <p:sldId xmlns:r="http://schemas.openxmlformats.org/officeDocument/2006/relationships" id="260" r:id="R2be3c1a303fe4da9"/>
+    <p:sldId xmlns:r="http://schemas.openxmlformats.org/officeDocument/2006/relationships" id="261" r:id="Re7a55d0bcdac4109"/>
+    <p:sldId xmlns:r="http://schemas.openxmlformats.org/officeDocument/2006/relationships" id="262" r:id="R7a9090ac7e3841cd"/>
+    <p:sldId xmlns:r="http://schemas.openxmlformats.org/officeDocument/2006/relationships" id="263" r:id="Ra0c9f1cd265f467b"/>
   </p:sldIdLst>
   <p:sldSz cx="12192000" cy="6858000"/>
   <p:notesSz cx="6858000" cy="9144000"/>
@@ -3512,12 +3512,12 @@
   </p:cSld>
   <p:clrMap bg1="lt1" tx1="dk1" bg2="lt2" tx2="dk2" accent1="accent1" accent2="accent2" accent3="accent3" accent4="accent4" accent5="accent5" accent6="accent6" hlink="hlink" folHlink="folHlink"/>
   <p:sldLayoutIdLst>
-    <p:sldLayoutId xmlns:r="http://schemas.openxmlformats.org/officeDocument/2006/relationships" id="2147483649" r:id="Recd62abd2c2a421b"/>
-    <p:sldLayoutId xmlns:r="http://schemas.openxmlformats.org/officeDocument/2006/relationships" id="2147483650" r:id="R06f897c37c004173"/>
-    <p:sldLayoutId xmlns:r="http://schemas.openxmlformats.org/officeDocument/2006/relationships" id="2147483651" r:id="R3355fe4964894074"/>
-    <p:sldLayoutId xmlns:r="http://schemas.openxmlformats.org/officeDocument/2006/relationships" id="2147483652" r:id="R5851319acdfa431f"/>
-    <p:sldLayoutId xmlns:r="http://schemas.openxmlformats.org/officeDocument/2006/relationships" id="2147483653" r:id="Radeae5b4ab064945"/>
-    <p:sldLayoutId xmlns:r="http://schemas.openxmlformats.org/officeDocument/2006/relationships" id="2147483654" r:id="R8866585884b74860"/>
+    <p:sldLayoutId xmlns:r="http://schemas.openxmlformats.org/officeDocument/2006/relationships" id="2147483649" r:id="R1174749b9b714698"/>
+    <p:sldLayoutId xmlns:r="http://schemas.openxmlformats.org/officeDocument/2006/relationships" id="2147483650" r:id="R11633c85b1ea435b"/>
+    <p:sldLayoutId xmlns:r="http://schemas.openxmlformats.org/officeDocument/2006/relationships" id="2147483651" r:id="Ra24e6376433a4125"/>
+    <p:sldLayoutId xmlns:r="http://schemas.openxmlformats.org/officeDocument/2006/relationships" id="2147483652" r:id="Rb69fb47a902149ce"/>
+    <p:sldLayoutId xmlns:r="http://schemas.openxmlformats.org/officeDocument/2006/relationships" id="2147483653" r:id="R6ccb8e5855d34024"/>
+    <p:sldLayoutId xmlns:r="http://schemas.openxmlformats.org/officeDocument/2006/relationships" id="2147483654" r:id="Rc7e9ca62c08e4109"/>
   </p:sldLayoutIdLst>
   <p:txStyles>
     <p:titleStyle>
@@ -4104,6 +4104,7 @@
               </a:defRPr>
             </a:defPPr>
             <a:lvl1pPr>
+              <a:buNone/>
               <a:defRPr sz="3600" b="0">
                 <a:solidFill>
                   <a:srgbClr val="D6E6F3"/>
@@ -4114,6 +4115,7 @@
               </a:defRPr>
             </a:lvl1pPr>
             <a:lvl2pPr>
+              <a:buNone/>
               <a:defRPr sz="3600" b="0">
                 <a:solidFill>
                   <a:srgbClr val="D6E6F3"/>
@@ -4124,6 +4126,7 @@
               </a:defRPr>
             </a:lvl2pPr>
             <a:lvl3pPr>
+              <a:buNone/>
               <a:defRPr sz="3600" b="0">
                 <a:solidFill>
                   <a:srgbClr val="D6E6F3"/>
@@ -4134,6 +4137,7 @@
               </a:defRPr>
             </a:lvl3pPr>
             <a:lvl4pPr>
+              <a:buNone/>
               <a:defRPr sz="3600" b="0">
                 <a:solidFill>
                   <a:srgbClr val="D6E6F3"/>
@@ -4144,6 +4148,7 @@
               </a:defRPr>
             </a:lvl4pPr>
             <a:lvl5pPr>
+              <a:buNone/>
               <a:defRPr sz="3600" b="0">
                 <a:solidFill>
                   <a:srgbClr val="D6E6F3"/>
@@ -4154,6 +4159,7 @@
               </a:defRPr>
             </a:lvl5pPr>
             <a:lvl6pPr>
+              <a:buNone/>
               <a:defRPr sz="3600" b="0">
                 <a:solidFill>
                   <a:srgbClr val="D6E6F3"/>
@@ -4164,6 +4170,7 @@
               </a:defRPr>
             </a:lvl6pPr>
             <a:lvl7pPr>
+              <a:buNone/>
               <a:defRPr sz="3600" b="0">
                 <a:solidFill>
                   <a:srgbClr val="D6E6F3"/>
@@ -4174,6 +4181,7 @@
               </a:defRPr>
             </a:lvl7pPr>
             <a:lvl8pPr>
+              <a:buNone/>
               <a:defRPr sz="3600" b="0">
                 <a:solidFill>
                   <a:srgbClr val="D6E6F3"/>
@@ -4184,6 +4192,7 @@
               </a:defRPr>
             </a:lvl8pPr>
             <a:lvl9pPr>
+              <a:buNone/>
               <a:defRPr sz="3600" b="0">
                 <a:solidFill>
                   <a:srgbClr val="D6E6F3"/>
@@ -4196,6 +4205,7 @@
           </a:lstStyle>
           <a:p xmlns:a="http://schemas.openxmlformats.org/drawingml/2006/main">
             <a:pPr>
+              <a:buNone/>
               <a:defRPr sz="3600" b="0">
                 <a:solidFill>
                   <a:srgbClr val="D6E6F3"/>
@@ -4260,6 +4270,7 @@
               </a:defRPr>
             </a:defPPr>
             <a:lvl1pPr>
+              <a:buNone/>
               <a:defRPr sz="6600" b="1">
                 <a:solidFill>
                   <a:srgbClr val="FFFFFF"/>
@@ -4270,6 +4281,7 @@
               </a:defRPr>
             </a:lvl1pPr>
             <a:lvl2pPr>
+              <a:buNone/>
               <a:defRPr sz="6600" b="1">
                 <a:solidFill>
                   <a:srgbClr val="FFFFFF"/>
@@ -4280,6 +4292,7 @@
               </a:defRPr>
             </a:lvl2pPr>
             <a:lvl3pPr>
+              <a:buNone/>
               <a:defRPr sz="6600" b="1">
                 <a:solidFill>
                   <a:srgbClr val="FFFFFF"/>
@@ -4290,6 +4303,7 @@
               </a:defRPr>
             </a:lvl3pPr>
             <a:lvl4pPr>
+              <a:buNone/>
               <a:defRPr sz="6600" b="1">
                 <a:solidFill>
                   <a:srgbClr val="FFFFFF"/>
@@ -4300,6 +4314,7 @@
               </a:defRPr>
             </a:lvl4pPr>
             <a:lvl5pPr>
+              <a:buNone/>
               <a:defRPr sz="6600" b="1">
                 <a:solidFill>
                   <a:srgbClr val="FFFFFF"/>
@@ -4310,6 +4325,7 @@
               </a:defRPr>
             </a:lvl5pPr>
             <a:lvl6pPr>
+              <a:buNone/>
               <a:defRPr sz="6600" b="1">
                 <a:solidFill>
                   <a:srgbClr val="FFFFFF"/>
@@ -4320,6 +4336,7 @@
               </a:defRPr>
             </a:lvl6pPr>
             <a:lvl7pPr>
+              <a:buNone/>
               <a:defRPr sz="6600" b="1">
                 <a:solidFill>
                   <a:srgbClr val="FFFFFF"/>
@@ -4330,6 +4347,7 @@
               </a:defRPr>
             </a:lvl7pPr>
             <a:lvl8pPr>
+              <a:buNone/>
               <a:defRPr sz="6600" b="1">
                 <a:solidFill>
                   <a:srgbClr val="FFFFFF"/>
@@ -4340,6 +4358,7 @@
               </a:defRPr>
             </a:lvl8pPr>
             <a:lvl9pPr>
+              <a:buNone/>
               <a:defRPr sz="6600" b="1">
                 <a:solidFill>
                   <a:srgbClr val="FFFFFF"/>
@@ -4352,6 +4371,7 @@
           </a:lstStyle>
           <a:p xmlns:a="http://schemas.openxmlformats.org/drawingml/2006/main">
             <a:pPr>
+              <a:buNone/>
               <a:defRPr sz="6600" b="1">
                 <a:solidFill>
                   <a:srgbClr val="FFFFFF"/>
@@ -4416,6 +4436,7 @@
               </a:defRPr>
             </a:defPPr>
             <a:lvl1pPr>
+              <a:buNone/>
               <a:defRPr sz="2400" b="0">
                 <a:solidFill>
                   <a:srgbClr val="A6C5D7"/>
@@ -4426,6 +4447,7 @@
               </a:defRPr>
             </a:lvl1pPr>
             <a:lvl2pPr>
+              <a:buNone/>
               <a:defRPr sz="2400" b="0">
                 <a:solidFill>
                   <a:srgbClr val="A6C5D7"/>
@@ -4436,6 +4458,7 @@
               </a:defRPr>
             </a:lvl2pPr>
             <a:lvl3pPr>
+              <a:buNone/>
               <a:defRPr sz="2400" b="0">
                 <a:solidFill>
                   <a:srgbClr val="A6C5D7"/>
@@ -4446,6 +4469,7 @@
               </a:defRPr>
             </a:lvl3pPr>
             <a:lvl4pPr>
+              <a:buNone/>
               <a:defRPr sz="2400" b="0">
                 <a:solidFill>
                   <a:srgbClr val="A6C5D7"/>
@@ -4456,6 +4480,7 @@
               </a:defRPr>
             </a:lvl4pPr>
             <a:lvl5pPr>
+              <a:buNone/>
               <a:defRPr sz="2400" b="0">
                 <a:solidFill>
                   <a:srgbClr val="A6C5D7"/>
@@ -4466,6 +4491,7 @@
               </a:defRPr>
             </a:lvl5pPr>
             <a:lvl6pPr>
+              <a:buNone/>
               <a:defRPr sz="2400" b="0">
                 <a:solidFill>
                   <a:srgbClr val="A6C5D7"/>
@@ -4476,6 +4502,7 @@
               </a:defRPr>
             </a:lvl6pPr>
             <a:lvl7pPr>
+              <a:buNone/>
               <a:defRPr sz="2400" b="0">
                 <a:solidFill>
                   <a:srgbClr val="A6C5D7"/>
@@ -4486,6 +4513,7 @@
               </a:defRPr>
             </a:lvl7pPr>
             <a:lvl8pPr>
+              <a:buNone/>
               <a:defRPr sz="2400" b="0">
                 <a:solidFill>
                   <a:srgbClr val="A6C5D7"/>
@@ -4496,6 +4524,7 @@
               </a:defRPr>
             </a:lvl8pPr>
             <a:lvl9pPr>
+              <a:buNone/>
               <a:defRPr sz="2400" b="0">
                 <a:solidFill>
                   <a:srgbClr val="A6C5D7"/>
@@ -4508,6 +4537,7 @@
           </a:lstStyle>
           <a:p xmlns:a="http://schemas.openxmlformats.org/drawingml/2006/main">
             <a:pPr>
+              <a:buNone/>
               <a:defRPr sz="2400" b="0">
                 <a:solidFill>
                   <a:srgbClr val="A6C5D7"/>
@@ -4572,6 +4602,7 @@
               </a:defRPr>
             </a:defPPr>
             <a:lvl1pPr>
+              <a:buNone/>
               <a:defRPr sz="2700" b="1">
                 <a:solidFill>
                   <a:srgbClr val="FFFFFF"/>
@@ -4582,6 +4613,7 @@
               </a:defRPr>
             </a:lvl1pPr>
             <a:lvl2pPr>
+              <a:buNone/>
               <a:defRPr sz="2700" b="1">
                 <a:solidFill>
                   <a:srgbClr val="FFFFFF"/>
@@ -4592,6 +4624,7 @@
               </a:defRPr>
             </a:lvl2pPr>
             <a:lvl3pPr>
+              <a:buNone/>
               <a:defRPr sz="2700" b="1">
                 <a:solidFill>
                   <a:srgbClr val="FFFFFF"/>
@@ -4602,6 +4635,7 @@
               </a:defRPr>
             </a:lvl3pPr>
             <a:lvl4pPr>
+              <a:buNone/>
               <a:defRPr sz="2700" b="1">
                 <a:solidFill>
                   <a:srgbClr val="FFFFFF"/>
@@ -4612,6 +4646,7 @@
               </a:defRPr>
             </a:lvl4pPr>
             <a:lvl5pPr>
+              <a:buNone/>
               <a:defRPr sz="2700" b="1">
                 <a:solidFill>
                   <a:srgbClr val="FFFFFF"/>
@@ -4622,6 +4657,7 @@
               </a:defRPr>
             </a:lvl5pPr>
             <a:lvl6pPr>
+              <a:buNone/>
               <a:defRPr sz="2700" b="1">
                 <a:solidFill>
                   <a:srgbClr val="FFFFFF"/>
@@ -4632,6 +4668,7 @@
               </a:defRPr>
             </a:lvl6pPr>
             <a:lvl7pPr>
+              <a:buNone/>
               <a:defRPr sz="2700" b="1">
                 <a:solidFill>
                   <a:srgbClr val="FFFFFF"/>
@@ -4642,6 +4679,7 @@
               </a:defRPr>
             </a:lvl7pPr>
             <a:lvl8pPr>
+              <a:buNone/>
               <a:defRPr sz="2700" b="1">
                 <a:solidFill>
                   <a:srgbClr val="FFFFFF"/>
@@ -4652,6 +4690,7 @@
               </a:defRPr>
             </a:lvl8pPr>
             <a:lvl9pPr>
+              <a:buNone/>
               <a:defRPr sz="2700" b="1">
                 <a:solidFill>
                   <a:srgbClr val="FFFFFF"/>
@@ -4664,6 +4703,7 @@
           </a:lstStyle>
           <a:p xmlns:a="http://schemas.openxmlformats.org/drawingml/2006/main">
             <a:pPr>
+              <a:buNone/>
               <a:defRPr sz="2700" b="1">
                 <a:solidFill>
                   <a:srgbClr val="FFFFFF"/>
@@ -4728,6 +4768,7 @@
               </a:defRPr>
             </a:defPPr>
             <a:lvl1pPr>
+              <a:buNone/>
               <a:defRPr sz="1950" b="0">
                 <a:solidFill>
                   <a:srgbClr val="D6E6F3"/>
@@ -4738,6 +4779,7 @@
               </a:defRPr>
             </a:lvl1pPr>
             <a:lvl2pPr>
+              <a:buNone/>
               <a:defRPr sz="1950" b="0">
                 <a:solidFill>
                   <a:srgbClr val="D6E6F3"/>
@@ -4748,6 +4790,7 @@
               </a:defRPr>
             </a:lvl2pPr>
             <a:lvl3pPr>
+              <a:buNone/>
               <a:defRPr sz="1950" b="0">
                 <a:solidFill>
                   <a:srgbClr val="D6E6F3"/>
@@ -4758,6 +4801,7 @@
               </a:defRPr>
             </a:lvl3pPr>
             <a:lvl4pPr>
+              <a:buNone/>
               <a:defRPr sz="1950" b="0">
                 <a:solidFill>
                   <a:srgbClr val="D6E6F3"/>
@@ -4768,6 +4812,7 @@
               </a:defRPr>
             </a:lvl4pPr>
             <a:lvl5pPr>
+              <a:buNone/>
               <a:defRPr sz="1950" b="0">
                 <a:solidFill>
                   <a:srgbClr val="D6E6F3"/>
@@ -4778,6 +4823,7 @@
               </a:defRPr>
             </a:lvl5pPr>
             <a:lvl6pPr>
+              <a:buNone/>
               <a:defRPr sz="1950" b="0">
                 <a:solidFill>
                   <a:srgbClr val="D6E6F3"/>
@@ -4788,6 +4834,7 @@
               </a:defRPr>
             </a:lvl6pPr>
             <a:lvl7pPr>
+              <a:buNone/>
               <a:defRPr sz="1950" b="0">
                 <a:solidFill>
                   <a:srgbClr val="D6E6F3"/>
@@ -4798,6 +4845,7 @@
               </a:defRPr>
             </a:lvl7pPr>
             <a:lvl8pPr>
+              <a:buNone/>
               <a:defRPr sz="1950" b="0">
                 <a:solidFill>
                   <a:srgbClr val="D6E6F3"/>
@@ -4808,6 +4856,7 @@
               </a:defRPr>
             </a:lvl8pPr>
             <a:lvl9pPr>
+              <a:buNone/>
               <a:defRPr sz="1950" b="0">
                 <a:solidFill>
                   <a:srgbClr val="D6E6F3"/>
@@ -4820,6 +4869,7 @@
           </a:lstStyle>
           <a:p xmlns:a="http://schemas.openxmlformats.org/drawingml/2006/main">
             <a:pPr>
+              <a:buNone/>
               <a:defRPr sz="1950" b="0">
                 <a:solidFill>
                   <a:srgbClr val="D6E6F3"/>
@@ -4839,162 +4889,6 @@
                 <a:cs typeface="Apple SD Gothic Neo"/>
               </a:rPr>
               <a:t>SKALA 4기 광주캠퍼스</a:t>
-            </a:r>
-          </a:p>
-        </p:txBody>
-      </p:sp>
-      <p:sp>
-        <p:nvSpPr>
-          <p:cNvPr id="6" name="">
-            <a:extLst xmlns:a="http://schemas.openxmlformats.org/drawingml/2006/main">
-              <a:ext uri="{FF2B5EF4-FFF2-40B4-BE49-F238E27FC236}">
-                <a16:creationId xmlns:a16="http://schemas.microsoft.com/office/drawing/2014/main" id="{D29AF102-A090-43A0-A46C-DD86A69DDC9C}"/>
-              </a:ext>
-            </a:extLst>
-          </p:cNvPr>
-          <p:cNvSpPr>
-            <a:spLocks xmlns:a="http://schemas.openxmlformats.org/drawingml/2006/main" noGrp="1"/>
-          </p:cNvSpPr>
-          <p:nvPr/>
-        </p:nvSpPr>
-        <p:spPr>
-          <a:xfrm xmlns:a="http://schemas.openxmlformats.org/drawingml/2006/main">
-            <a:off x="742950" y="6334125"/>
-            <a:ext cx="9525000" cy="304800"/>
-          </a:xfrm>
-          <a:prstGeom xmlns:a="http://schemas.openxmlformats.org/drawingml/2006/main" prst="rect">
-            <a:avLst/>
-          </a:prstGeom>
-          <a:noFill xmlns:a="http://schemas.openxmlformats.org/drawingml/2006/main"/>
-          <a:ln xmlns:a="http://schemas.openxmlformats.org/drawingml/2006/main" w="0">
-            <a:noFill/>
-          </a:ln>
-        </p:spPr>
-        <p:txBody>
-          <a:bodyPr xmlns:a="http://schemas.openxmlformats.org/drawingml/2006/main" lIns="0" tIns="0" rIns="0" bIns="0"/>
-          <a:lstStyle xmlns:a="http://schemas.openxmlformats.org/drawingml/2006/main">
-            <a:defPPr>
-              <a:defRPr sz="1500" b="0">
-                <a:solidFill>
-                  <a:srgbClr val="A6C5D7"/>
-                </a:solidFill>
-                <a:latin typeface="Apple SD Gothic Neo"/>
-                <a:ea typeface="Apple SD Gothic Neo"/>
-                <a:cs typeface="Apple SD Gothic Neo"/>
-              </a:defRPr>
-            </a:defPPr>
-            <a:lvl1pPr>
-              <a:defRPr sz="1500" b="0">
-                <a:solidFill>
-                  <a:srgbClr val="A6C5D7"/>
-                </a:solidFill>
-                <a:latin typeface="Apple SD Gothic Neo"/>
-                <a:ea typeface="Apple SD Gothic Neo"/>
-                <a:cs typeface="Apple SD Gothic Neo"/>
-              </a:defRPr>
-            </a:lvl1pPr>
-            <a:lvl2pPr>
-              <a:defRPr sz="1500" b="0">
-                <a:solidFill>
-                  <a:srgbClr val="A6C5D7"/>
-                </a:solidFill>
-                <a:latin typeface="Apple SD Gothic Neo"/>
-                <a:ea typeface="Apple SD Gothic Neo"/>
-                <a:cs typeface="Apple SD Gothic Neo"/>
-              </a:defRPr>
-            </a:lvl2pPr>
-            <a:lvl3pPr>
-              <a:defRPr sz="1500" b="0">
-                <a:solidFill>
-                  <a:srgbClr val="A6C5D7"/>
-                </a:solidFill>
-                <a:latin typeface="Apple SD Gothic Neo"/>
-                <a:ea typeface="Apple SD Gothic Neo"/>
-                <a:cs typeface="Apple SD Gothic Neo"/>
-              </a:defRPr>
-            </a:lvl3pPr>
-            <a:lvl4pPr>
-              <a:defRPr sz="1500" b="0">
-                <a:solidFill>
-                  <a:srgbClr val="A6C5D7"/>
-                </a:solidFill>
-                <a:latin typeface="Apple SD Gothic Neo"/>
-                <a:ea typeface="Apple SD Gothic Neo"/>
-                <a:cs typeface="Apple SD Gothic Neo"/>
-              </a:defRPr>
-            </a:lvl4pPr>
-            <a:lvl5pPr>
-              <a:defRPr sz="1500" b="0">
-                <a:solidFill>
-                  <a:srgbClr val="A6C5D7"/>
-                </a:solidFill>
-                <a:latin typeface="Apple SD Gothic Neo"/>
-                <a:ea typeface="Apple SD Gothic Neo"/>
-                <a:cs typeface="Apple SD Gothic Neo"/>
-              </a:defRPr>
-            </a:lvl5pPr>
-            <a:lvl6pPr>
-              <a:defRPr sz="1500" b="0">
-                <a:solidFill>
-                  <a:srgbClr val="A6C5D7"/>
-                </a:solidFill>
-                <a:latin typeface="Apple SD Gothic Neo"/>
-                <a:ea typeface="Apple SD Gothic Neo"/>
-                <a:cs typeface="Apple SD Gothic Neo"/>
-              </a:defRPr>
-            </a:lvl6pPr>
-            <a:lvl7pPr>
-              <a:defRPr sz="1500" b="0">
-                <a:solidFill>
-                  <a:srgbClr val="A6C5D7"/>
-                </a:solidFill>
-                <a:latin typeface="Apple SD Gothic Neo"/>
-                <a:ea typeface="Apple SD Gothic Neo"/>
-                <a:cs typeface="Apple SD Gothic Neo"/>
-              </a:defRPr>
-            </a:lvl7pPr>
-            <a:lvl8pPr>
-              <a:defRPr sz="1500" b="0">
-                <a:solidFill>
-                  <a:srgbClr val="A6C5D7"/>
-                </a:solidFill>
-                <a:latin typeface="Apple SD Gothic Neo"/>
-                <a:ea typeface="Apple SD Gothic Neo"/>
-                <a:cs typeface="Apple SD Gothic Neo"/>
-              </a:defRPr>
-            </a:lvl8pPr>
-            <a:lvl9pPr>
-              <a:defRPr sz="1500" b="0">
-                <a:solidFill>
-                  <a:srgbClr val="A6C5D7"/>
-                </a:solidFill>
-                <a:latin typeface="Apple SD Gothic Neo"/>
-                <a:ea typeface="Apple SD Gothic Neo"/>
-                <a:cs typeface="Apple SD Gothic Neo"/>
-              </a:defRPr>
-            </a:lvl9pPr>
-          </a:lstStyle>
-          <a:p xmlns:a="http://schemas.openxmlformats.org/drawingml/2006/main">
-            <a:pPr>
-              <a:defRPr sz="1500" b="0">
-                <a:solidFill>
-                  <a:srgbClr val="A6C5D7"/>
-                </a:solidFill>
-                <a:latin typeface="Apple SD Gothic Neo"/>
-                <a:ea typeface="Apple SD Gothic Neo"/>
-                <a:cs typeface="Apple SD Gothic Neo"/>
-              </a:defRPr>
-            </a:pPr>
-            <a:r>
-              <a:rPr sz="1500" b="0">
-                <a:solidFill>
-                  <a:srgbClr val="A6C5D7"/>
-                </a:solidFill>
-                <a:latin typeface="Apple SD Gothic Neo"/>
-                <a:ea typeface="Apple SD Gothic Neo"/>
-                <a:cs typeface="Apple SD Gothic Neo"/>
-              </a:rPr>
-              <a:t>과제 2 · 자유 주제 AI 서비스 개발</a:t>
             </a:r>
           </a:p>
         </p:txBody>
@@ -5040,6 +4934,7 @@
               </a:defRPr>
             </a:defPPr>
             <a:lvl1pPr>
+              <a:buNone/>
               <a:defRPr sz="1350" b="0">
                 <a:solidFill>
                   <a:srgbClr val="A6C5D7"/>
@@ -5050,6 +4945,7 @@
               </a:defRPr>
             </a:lvl1pPr>
             <a:lvl2pPr>
+              <a:buNone/>
               <a:defRPr sz="1350" b="0">
                 <a:solidFill>
                   <a:srgbClr val="A6C5D7"/>
@@ -5060,6 +4956,7 @@
               </a:defRPr>
             </a:lvl2pPr>
             <a:lvl3pPr>
+              <a:buNone/>
               <a:defRPr sz="1350" b="0">
                 <a:solidFill>
                   <a:srgbClr val="A6C5D7"/>
@@ -5070,6 +4967,7 @@
               </a:defRPr>
             </a:lvl3pPr>
             <a:lvl4pPr>
+              <a:buNone/>
               <a:defRPr sz="1350" b="0">
                 <a:solidFill>
                   <a:srgbClr val="A6C5D7"/>
@@ -5080,6 +4978,7 @@
               </a:defRPr>
             </a:lvl4pPr>
             <a:lvl5pPr>
+              <a:buNone/>
               <a:defRPr sz="1350" b="0">
                 <a:solidFill>
                   <a:srgbClr val="A6C5D7"/>
@@ -5090,6 +4989,7 @@
               </a:defRPr>
             </a:lvl5pPr>
             <a:lvl6pPr>
+              <a:buNone/>
               <a:defRPr sz="1350" b="0">
                 <a:solidFill>
                   <a:srgbClr val="A6C5D7"/>
@@ -5100,6 +5000,7 @@
               </a:defRPr>
             </a:lvl6pPr>
             <a:lvl7pPr>
+              <a:buNone/>
               <a:defRPr sz="1350" b="0">
                 <a:solidFill>
                   <a:srgbClr val="A6C5D7"/>
@@ -5110,6 +5011,7 @@
               </a:defRPr>
             </a:lvl7pPr>
             <a:lvl8pPr>
+              <a:buNone/>
               <a:defRPr sz="1350" b="0">
                 <a:solidFill>
                   <a:srgbClr val="A6C5D7"/>
@@ -5120,6 +5022,7 @@
               </a:defRPr>
             </a:lvl8pPr>
             <a:lvl9pPr>
+              <a:buNone/>
               <a:defRPr sz="1350" b="0">
                 <a:solidFill>
                   <a:srgbClr val="A6C5D7"/>
@@ -5132,6 +5035,7 @@
           </a:lstStyle>
           <a:p xmlns:a="http://schemas.openxmlformats.org/drawingml/2006/main">
             <a:pPr>
+              <a:buNone/>
               <a:defRPr sz="1350" b="0">
                 <a:solidFill>
                   <a:srgbClr val="A6C5D7"/>
@@ -5872,178 +5776,12 @@
           </a:p>
         </p:txBody>
       </p:sp>
-      <p:sp>
-        <p:nvSpPr>
-          <p:cNvPr id="5" name="">
-            <a:extLst xmlns:a="http://schemas.openxmlformats.org/drawingml/2006/main">
-              <a:ext uri="{FF2B5EF4-FFF2-40B4-BE49-F238E27FC236}">
-                <a16:creationId xmlns:a16="http://schemas.microsoft.com/office/drawing/2014/main" id="{758A83AE-0342-41AF-8426-AAA3D74F7C51}"/>
-              </a:ext>
-            </a:extLst>
-          </p:cNvPr>
-          <p:cNvSpPr>
-            <a:spLocks xmlns:a="http://schemas.openxmlformats.org/drawingml/2006/main" noGrp="1"/>
-          </p:cNvSpPr>
-          <p:nvPr/>
-        </p:nvSpPr>
-        <p:spPr>
-          <a:xfrm xmlns:a="http://schemas.openxmlformats.org/drawingml/2006/main">
-            <a:off x="609600" y="6543675"/>
-            <a:ext cx="9906000" cy="219075"/>
-          </a:xfrm>
-          <a:prstGeom xmlns:a="http://schemas.openxmlformats.org/drawingml/2006/main" prst="rect">
-            <a:avLst/>
-          </a:prstGeom>
-          <a:noFill xmlns:a="http://schemas.openxmlformats.org/drawingml/2006/main"/>
-          <a:ln xmlns:a="http://schemas.openxmlformats.org/drawingml/2006/main" w="0">
-            <a:noFill/>
-          </a:ln>
-        </p:spPr>
-        <p:txBody>
-          <a:bodyPr xmlns:a="http://schemas.openxmlformats.org/drawingml/2006/main" lIns="0" tIns="0" rIns="0" bIns="0"/>
-          <a:lstStyle xmlns:a="http://schemas.openxmlformats.org/drawingml/2006/main">
-            <a:defPPr>
-              <a:defRPr sz="1200" b="0">
-                <a:solidFill>
-                  <a:srgbClr val="A6C5D7"/>
-                </a:solidFill>
-                <a:latin typeface="Apple SD Gothic Neo"/>
-                <a:ea typeface="Apple SD Gothic Neo"/>
-                <a:cs typeface="Apple SD Gothic Neo"/>
-              </a:defRPr>
-            </a:defPPr>
-            <a:lvl1pPr>
-              <a:buNone/>
-              <a:defRPr sz="1950" b="0">
-                <a:solidFill>
-                  <a:srgbClr val="D6E6F3"/>
-                </a:solidFill>
-                <a:latin typeface="Apple SD Gothic Neo"/>
-                <a:ea typeface="Apple SD Gothic Neo"/>
-                <a:cs typeface="Apple SD Gothic Neo"/>
-              </a:defRPr>
-            </a:lvl1pPr>
-            <a:lvl2pPr>
-              <a:buNone/>
-              <a:defRPr sz="1950" b="0">
-                <a:solidFill>
-                  <a:srgbClr val="D6E6F3"/>
-                </a:solidFill>
-                <a:latin typeface="Apple SD Gothic Neo"/>
-                <a:ea typeface="Apple SD Gothic Neo"/>
-                <a:cs typeface="Apple SD Gothic Neo"/>
-              </a:defRPr>
-            </a:lvl2pPr>
-            <a:lvl3pPr>
-              <a:buNone/>
-              <a:defRPr sz="1950" b="0">
-                <a:solidFill>
-                  <a:srgbClr val="D6E6F3"/>
-                </a:solidFill>
-                <a:latin typeface="Apple SD Gothic Neo"/>
-                <a:ea typeface="Apple SD Gothic Neo"/>
-                <a:cs typeface="Apple SD Gothic Neo"/>
-              </a:defRPr>
-            </a:lvl3pPr>
-            <a:lvl4pPr>
-              <a:buNone/>
-              <a:defRPr sz="1950" b="0">
-                <a:solidFill>
-                  <a:srgbClr val="D6E6F3"/>
-                </a:solidFill>
-                <a:latin typeface="Apple SD Gothic Neo"/>
-                <a:ea typeface="Apple SD Gothic Neo"/>
-                <a:cs typeface="Apple SD Gothic Neo"/>
-              </a:defRPr>
-            </a:lvl4pPr>
-            <a:lvl5pPr>
-              <a:buNone/>
-              <a:defRPr sz="1950" b="0">
-                <a:solidFill>
-                  <a:srgbClr val="D6E6F3"/>
-                </a:solidFill>
-                <a:latin typeface="Apple SD Gothic Neo"/>
-                <a:ea typeface="Apple SD Gothic Neo"/>
-                <a:cs typeface="Apple SD Gothic Neo"/>
-              </a:defRPr>
-            </a:lvl5pPr>
-            <a:lvl6pPr>
-              <a:buNone/>
-              <a:defRPr sz="1950" b="0">
-                <a:solidFill>
-                  <a:srgbClr val="D6E6F3"/>
-                </a:solidFill>
-                <a:latin typeface="Apple SD Gothic Neo"/>
-                <a:ea typeface="Apple SD Gothic Neo"/>
-                <a:cs typeface="Apple SD Gothic Neo"/>
-              </a:defRPr>
-            </a:lvl6pPr>
-            <a:lvl7pPr>
-              <a:buNone/>
-              <a:defRPr sz="1950" b="0">
-                <a:solidFill>
-                  <a:srgbClr val="D6E6F3"/>
-                </a:solidFill>
-                <a:latin typeface="Apple SD Gothic Neo"/>
-                <a:ea typeface="Apple SD Gothic Neo"/>
-                <a:cs typeface="Apple SD Gothic Neo"/>
-              </a:defRPr>
-            </a:lvl7pPr>
-            <a:lvl8pPr>
-              <a:buNone/>
-              <a:defRPr sz="1950" b="0">
-                <a:solidFill>
-                  <a:srgbClr val="D6E6F3"/>
-                </a:solidFill>
-                <a:latin typeface="Apple SD Gothic Neo"/>
-                <a:ea typeface="Apple SD Gothic Neo"/>
-                <a:cs typeface="Apple SD Gothic Neo"/>
-              </a:defRPr>
-            </a:lvl8pPr>
-            <a:lvl9pPr>
-              <a:buNone/>
-              <a:defRPr sz="1950" b="0">
-                <a:solidFill>
-                  <a:srgbClr val="D6E6F3"/>
-                </a:solidFill>
-                <a:latin typeface="Apple SD Gothic Neo"/>
-                <a:ea typeface="Apple SD Gothic Neo"/>
-                <a:cs typeface="Apple SD Gothic Neo"/>
-              </a:defRPr>
-            </a:lvl9pPr>
-          </a:lstStyle>
-          <a:p xmlns:a="http://schemas.openxmlformats.org/drawingml/2006/main">
-            <a:pPr>
-              <a:buNone/>
-              <a:defRPr sz="1200" b="0">
-                <a:solidFill>
-                  <a:srgbClr val="A6C5D7"/>
-                </a:solidFill>
-                <a:latin typeface="Apple SD Gothic Neo"/>
-                <a:ea typeface="Apple SD Gothic Neo"/>
-                <a:cs typeface="Apple SD Gothic Neo"/>
-              </a:defRPr>
-            </a:pPr>
-            <a:r>
-              <a:rPr sz="1200" b="0">
-                <a:solidFill>
-                  <a:srgbClr val="A6C5D7"/>
-                </a:solidFill>
-                <a:latin typeface="Apple SD Gothic Neo"/>
-                <a:ea typeface="Apple SD Gothic Neo"/>
-                <a:cs typeface="Apple SD Gothic Neo"/>
-              </a:rPr>
-              <a:t>이미지: 발표자 제공 · 작품별 설정 오류 판정이나 서비스 검증 결과가 아님</a:t>
-            </a:r>
-          </a:p>
-        </p:txBody>
-      </p:sp>
       <p:pic>
         <p:nvPicPr>
           <p:cNvPr id="8" name="">
             <a:extLst xmlns:a="http://schemas.openxmlformats.org/drawingml/2006/main">
               <a:ext uri="{FF2B5EF4-FFF2-40B4-BE49-F238E27FC236}">
-                <a16:creationId xmlns:a16="http://schemas.microsoft.com/office/drawing/2014/main" id="{3E5BEBED-3868-4B7B-871B-C38A5153EEB6}"/>
+                <a16:creationId xmlns:a16="http://schemas.microsoft.com/office/drawing/2014/main" id="{12825FDF-EA3D-47AC-8C9F-70704C26C131}"/>
               </a:ext>
             </a:extLst>
           </p:cNvPr>
@@ -6053,7 +5791,7 @@
           <p:nvPr/>
         </p:nvPicPr>
         <p:blipFill>
-          <a:blip xmlns:r="http://schemas.openxmlformats.org/officeDocument/2006/relationships" xmlns:a="http://schemas.openxmlformats.org/drawingml/2006/main" r:embed="Rd9dfa1f3ca5149a0"/>
+          <a:blip xmlns:r="http://schemas.openxmlformats.org/officeDocument/2006/relationships" xmlns:a="http://schemas.openxmlformats.org/drawingml/2006/main" r:embed="R2ac5e7fd7f0e4c6d"/>
           <a:stretch xmlns:a="http://schemas.openxmlformats.org/drawingml/2006/main"/>
         </p:blipFill>
         <p:spPr>
@@ -6237,7 +5975,7 @@
           <p:cNvPr id="10" name="">
             <a:extLst xmlns:a="http://schemas.openxmlformats.org/drawingml/2006/main">
               <a:ext uri="{FF2B5EF4-FFF2-40B4-BE49-F238E27FC236}">
-                <a16:creationId xmlns:a16="http://schemas.microsoft.com/office/drawing/2014/main" id="{434F9B92-7AB7-4C56-BAF2-933F78BDD6B1}"/>
+                <a16:creationId xmlns:a16="http://schemas.microsoft.com/office/drawing/2014/main" id="{61BECC3E-5CB7-429B-8966-DB6F1AC723FE}"/>
               </a:ext>
             </a:extLst>
           </p:cNvPr>
@@ -6247,7 +5985,7 @@
           <p:nvPr/>
         </p:nvPicPr>
         <p:blipFill>
-          <a:blip xmlns:r="http://schemas.openxmlformats.org/officeDocument/2006/relationships" xmlns:a="http://schemas.openxmlformats.org/drawingml/2006/main" r:embed="R91f2a275e4ec4454"/>
+          <a:blip xmlns:r="http://schemas.openxmlformats.org/officeDocument/2006/relationships" xmlns:a="http://schemas.openxmlformats.org/drawingml/2006/main" r:embed="R3678e235c3114f17"/>
           <a:stretch xmlns:a="http://schemas.openxmlformats.org/drawingml/2006/main"/>
         </p:blipFill>
         <p:spPr>
@@ -6431,7 +6169,7 @@
           <p:cNvPr id="12" name="">
             <a:extLst xmlns:a="http://schemas.openxmlformats.org/drawingml/2006/main">
               <a:ext uri="{FF2B5EF4-FFF2-40B4-BE49-F238E27FC236}">
-                <a16:creationId xmlns:a16="http://schemas.microsoft.com/office/drawing/2014/main" id="{52FC0812-0855-4A89-A511-2E52B5FFC3D4}"/>
+                <a16:creationId xmlns:a16="http://schemas.microsoft.com/office/drawing/2014/main" id="{BFB9214B-59B3-4D65-BF11-63B2198078AC}"/>
               </a:ext>
             </a:extLst>
           </p:cNvPr>
@@ -6441,7 +6179,7 @@
           <p:nvPr/>
         </p:nvPicPr>
         <p:blipFill>
-          <a:blip xmlns:r="http://schemas.openxmlformats.org/officeDocument/2006/relationships" xmlns:a="http://schemas.openxmlformats.org/drawingml/2006/main" r:embed="Red3d988a9fcc45c2"/>
+          <a:blip xmlns:r="http://schemas.openxmlformats.org/officeDocument/2006/relationships" xmlns:a="http://schemas.openxmlformats.org/drawingml/2006/main" r:embed="R6d5ca3072dcc4cf0"/>
           <a:stretch xmlns:a="http://schemas.openxmlformats.org/drawingml/2006/main"/>
         </p:blipFill>
         <p:spPr>
@@ -6625,7 +6363,7 @@
           <p:cNvPr id="14" name="">
             <a:extLst xmlns:a="http://schemas.openxmlformats.org/drawingml/2006/main">
               <a:ext uri="{FF2B5EF4-FFF2-40B4-BE49-F238E27FC236}">
-                <a16:creationId xmlns:a16="http://schemas.microsoft.com/office/drawing/2014/main" id="{40692056-5631-4ECF-9486-356FFF72E16E}"/>
+                <a16:creationId xmlns:a16="http://schemas.microsoft.com/office/drawing/2014/main" id="{BC921674-26FF-4283-B87A-B198D6CBE23D}"/>
               </a:ext>
             </a:extLst>
           </p:cNvPr>
@@ -6635,7 +6373,7 @@
           <p:nvPr/>
         </p:nvPicPr>
         <p:blipFill>
-          <a:blip xmlns:r="http://schemas.openxmlformats.org/officeDocument/2006/relationships" xmlns:a="http://schemas.openxmlformats.org/drawingml/2006/main" r:embed="R79a52c2a136c44be"/>
+          <a:blip xmlns:r="http://schemas.openxmlformats.org/officeDocument/2006/relationships" xmlns:a="http://schemas.openxmlformats.org/drawingml/2006/main" r:embed="R06a1314135b14bd7"/>
           <a:stretch xmlns:a="http://schemas.openxmlformats.org/drawingml/2006/main"/>
         </p:blipFill>
         <p:spPr>
@@ -6879,6 +6617,7 @@
               </a:defRPr>
             </a:defPPr>
             <a:lvl1pPr>
+              <a:buNone/>
               <a:defRPr sz="1350" b="0">
                 <a:solidFill>
                   <a:srgbClr val="A6C5D7"/>
@@ -6889,6 +6628,7 @@
               </a:defRPr>
             </a:lvl1pPr>
             <a:lvl2pPr>
+              <a:buNone/>
               <a:defRPr sz="1350" b="0">
                 <a:solidFill>
                   <a:srgbClr val="A6C5D7"/>
@@ -6899,6 +6639,7 @@
               </a:defRPr>
             </a:lvl2pPr>
             <a:lvl3pPr>
+              <a:buNone/>
               <a:defRPr sz="1350" b="0">
                 <a:solidFill>
                   <a:srgbClr val="A6C5D7"/>
@@ -6909,6 +6650,7 @@
               </a:defRPr>
             </a:lvl3pPr>
             <a:lvl4pPr>
+              <a:buNone/>
               <a:defRPr sz="1350" b="0">
                 <a:solidFill>
                   <a:srgbClr val="A6C5D7"/>
@@ -6919,6 +6661,7 @@
               </a:defRPr>
             </a:lvl4pPr>
             <a:lvl5pPr>
+              <a:buNone/>
               <a:defRPr sz="1350" b="0">
                 <a:solidFill>
                   <a:srgbClr val="A6C5D7"/>
@@ -6929,6 +6672,7 @@
               </a:defRPr>
             </a:lvl5pPr>
             <a:lvl6pPr>
+              <a:buNone/>
               <a:defRPr sz="1350" b="0">
                 <a:solidFill>
                   <a:srgbClr val="A6C5D7"/>
@@ -6939,6 +6683,7 @@
               </a:defRPr>
             </a:lvl6pPr>
             <a:lvl7pPr>
+              <a:buNone/>
               <a:defRPr sz="1350" b="0">
                 <a:solidFill>
                   <a:srgbClr val="A6C5D7"/>
@@ -6949,6 +6694,7 @@
               </a:defRPr>
             </a:lvl7pPr>
             <a:lvl8pPr>
+              <a:buNone/>
               <a:defRPr sz="1350" b="0">
                 <a:solidFill>
                   <a:srgbClr val="A6C5D7"/>
@@ -6959,6 +6705,7 @@
               </a:defRPr>
             </a:lvl8pPr>
             <a:lvl9pPr>
+              <a:buNone/>
               <a:defRPr sz="1350" b="0">
                 <a:solidFill>
                   <a:srgbClr val="A6C5D7"/>
@@ -6971,6 +6718,7 @@
           </a:lstStyle>
           <a:p xmlns:a="http://schemas.openxmlformats.org/drawingml/2006/main">
             <a:pPr>
+              <a:buNone/>
               <a:defRPr sz="1350" b="0">
                 <a:solidFill>
                   <a:srgbClr val="A6C5D7"/>
@@ -10733,7 +10481,7 @@
           <p:cNvPr id="9" name="">
             <a:extLst xmlns:a="http://schemas.openxmlformats.org/drawingml/2006/main">
               <a:ext uri="{FF2B5EF4-FFF2-40B4-BE49-F238E27FC236}">
-                <a16:creationId xmlns:a16="http://schemas.microsoft.com/office/drawing/2014/main" id="{639D84FB-78E1-4186-8F8E-05A3F27AE157}"/>
+                <a16:creationId xmlns:a16="http://schemas.microsoft.com/office/drawing/2014/main" id="{CA43A5E9-17DC-47A0-B7AE-AC8FBFA4E885}"/>
               </a:ext>
             </a:extLst>
           </p:cNvPr>
@@ -10743,7 +10491,7 @@
           <p:nvPr/>
         </p:nvPicPr>
         <p:blipFill>
-          <a:blip xmlns:r="http://schemas.openxmlformats.org/officeDocument/2006/relationships" xmlns:a="http://schemas.openxmlformats.org/drawingml/2006/main" r:embed="R1e0d6d0cc311447c"/>
+          <a:blip xmlns:r="http://schemas.openxmlformats.org/officeDocument/2006/relationships" xmlns:a="http://schemas.openxmlformats.org/drawingml/2006/main" r:embed="R655dc2b894da4b9f"/>
           <a:srcRect xmlns:a="http://schemas.openxmlformats.org/drawingml/2006/main" l="24500" t="32000" r="25000" b="22000"/>
           <a:stretch xmlns:a="http://schemas.openxmlformats.org/drawingml/2006/main"/>
         </p:blipFill>
@@ -10928,7 +10676,7 @@
           <p:cNvPr id="12" name="">
             <a:extLst xmlns:a="http://schemas.openxmlformats.org/drawingml/2006/main">
               <a:ext uri="{FF2B5EF4-FFF2-40B4-BE49-F238E27FC236}">
-                <a16:creationId xmlns:a16="http://schemas.microsoft.com/office/drawing/2014/main" id="{330E0B00-5997-4334-8B06-A4820B8631CC}"/>
+                <a16:creationId xmlns:a16="http://schemas.microsoft.com/office/drawing/2014/main" id="{80A46A9A-84AA-4AA3-AB48-65FA3676A1CB}"/>
               </a:ext>
             </a:extLst>
           </p:cNvPr>
@@ -10938,7 +10686,7 @@
           <p:nvPr/>
         </p:nvPicPr>
         <p:blipFill>
-          <a:blip xmlns:r="http://schemas.openxmlformats.org/officeDocument/2006/relationships" xmlns:a="http://schemas.openxmlformats.org/drawingml/2006/main" r:embed="Rccd5025e697347c4"/>
+          <a:blip xmlns:r="http://schemas.openxmlformats.org/officeDocument/2006/relationships" xmlns:a="http://schemas.openxmlformats.org/drawingml/2006/main" r:embed="R5d361649eede4494"/>
           <a:srcRect xmlns:a="http://schemas.openxmlformats.org/drawingml/2006/main" l="2700" t="39500" r="3200" b="20500"/>
           <a:stretch xmlns:a="http://schemas.openxmlformats.org/drawingml/2006/main"/>
         </p:blipFill>
@@ -10986,7 +10734,7 @@
           <p:cNvPr id="12" name="">
             <a:extLst xmlns:a="http://schemas.openxmlformats.org/drawingml/2006/main">
               <a:ext uri="{FF2B5EF4-FFF2-40B4-BE49-F238E27FC236}">
-                <a16:creationId xmlns:a16="http://schemas.microsoft.com/office/drawing/2014/main" id="{12EDD95E-BB2A-453E-AFAA-A742C4A1463F}"/>
+                <a16:creationId xmlns:a16="http://schemas.microsoft.com/office/drawing/2014/main" id="{1E31B0C4-FAD0-4F8E-83B8-4875C6C63E72}"/>
               </a:ext>
             </a:extLst>
           </p:cNvPr>
@@ -11017,7 +10765,7 @@
           <p:cNvPr id="11" name="">
             <a:extLst xmlns:a="http://schemas.openxmlformats.org/drawingml/2006/main">
               <a:ext uri="{FF2B5EF4-FFF2-40B4-BE49-F238E27FC236}">
-                <a16:creationId xmlns:a16="http://schemas.microsoft.com/office/drawing/2014/main" id="{DCF7306E-8BF3-4D9A-8547-1EB82299CF8A}"/>
+                <a16:creationId xmlns:a16="http://schemas.microsoft.com/office/drawing/2014/main" id="{76041443-DD64-4B3E-B586-937CAFD93ECA}"/>
               </a:ext>
             </a:extLst>
           </p:cNvPr>
@@ -11048,7 +10796,7 @@
           <p:cNvPr id="10" name="">
             <a:extLst xmlns:a="http://schemas.openxmlformats.org/drawingml/2006/main">
               <a:ext uri="{FF2B5EF4-FFF2-40B4-BE49-F238E27FC236}">
-                <a16:creationId xmlns:a16="http://schemas.microsoft.com/office/drawing/2014/main" id="{CF485B55-9512-4DF7-9BB6-E38357CD9673}"/>
+                <a16:creationId xmlns:a16="http://schemas.microsoft.com/office/drawing/2014/main" id="{88C7C5B5-E584-4F2C-BB5C-8D7F1D72DA7A}"/>
               </a:ext>
             </a:extLst>
           </p:cNvPr>
@@ -11079,7 +10827,7 @@
           <p:cNvPr id="9" name="">
             <a:extLst xmlns:a="http://schemas.openxmlformats.org/drawingml/2006/main">
               <a:ext uri="{FF2B5EF4-FFF2-40B4-BE49-F238E27FC236}">
-                <a16:creationId xmlns:a16="http://schemas.microsoft.com/office/drawing/2014/main" id="{9E9BA08C-14A9-46E1-8FCF-4669B4574DAA}"/>
+                <a16:creationId xmlns:a16="http://schemas.microsoft.com/office/drawing/2014/main" id="{9DDCE1DA-7FC3-4A50-BF41-9EF9125CEBC0}"/>
               </a:ext>
             </a:extLst>
           </p:cNvPr>

</xml_diff>

<commit_message>
docs(presentation): add expansion plans and closing thanks
변경 내용
- 기존 README의 개선 방향을 바탕으로 긴 원고 RAG, 검토 품질 평가, 읽기·탐색 개선을 설명하는 확장 계획 장을 추가했다.
- 들어주셔서 감사합니다 문구와 발표자 정보를 담은 마지막 장을 추가했다.
- 10장 구성의 페이지 번호·대본·발표자 노트를 맞추고 후반 설명을 줄여 4분 45초 목표를 유지했다.

변경 이유
- 발표를 현재 구현의 한계에서 끝내지 않고 이후 계획과 감사 인사로 마무리하기 위한 사용자 요청을 반영했다.
- 확장 계획은 완료 기능과 구분하고 기존 2분 주제·결과 및 3분 이내 기술 설명 구성을 보존했다.

검증
- finalize-closing.mjs: 10장 PPTX 무결성·레이아웃·폰트·재가져오기 검사 통과, 발견 사항 0건.
- check-closing.py: 전체 대본과 노트 일치, 기존 8장 본문 렌더 동일성, 삭제 요청 문구 부재, 문서 링크 확인.
- 추가 2장을 렌더로 확인하고 git diff --check를 통과했다.
- 목표 시간은 285초이며 실제 낭독 시간은 측정하지 않았다.
</commit_message>
<xml_diff>
--- a/docs/presentation/LoreForge-G074-KimJimin.pptx
+++ b/docs/presentation/LoreForge-G074-KimJimin.pptx
@@ -2,20 +2,22 @@
 <file path=ppt/presentation.xml><?xml version="1.0" encoding="utf-8"?>
 <p:presentation xmlns:p="http://schemas.openxmlformats.org/presentationml/2006/main">
   <p:sldMasterIdLst>
-    <p:sldMasterId xmlns:r="http://schemas.openxmlformats.org/officeDocument/2006/relationships" id="2147483648" r:id="Rdff187d7a2f74154"/>
+    <p:sldMasterId xmlns:r="http://schemas.openxmlformats.org/officeDocument/2006/relationships" id="2147483648" r:id="R1bc1d50c0a1b447d"/>
   </p:sldMasterIdLst>
   <p:notesMasterIdLst>
-    <p:notesMasterId xmlns:r="http://schemas.openxmlformats.org/officeDocument/2006/relationships" r:id="Rb7b19ee4a6af47c7"/>
+    <p:notesMasterId xmlns:r="http://schemas.openxmlformats.org/officeDocument/2006/relationships" r:id="R07976d093ab149bc"/>
   </p:notesMasterIdLst>
   <p:sldIdLst>
-    <p:sldId xmlns:r="http://schemas.openxmlformats.org/officeDocument/2006/relationships" id="256" r:id="R37ba50c58c3a4b75"/>
-    <p:sldId xmlns:r="http://schemas.openxmlformats.org/officeDocument/2006/relationships" id="257" r:id="R24fa2645cbbe4607"/>
-    <p:sldId xmlns:r="http://schemas.openxmlformats.org/officeDocument/2006/relationships" id="258" r:id="R12491c180bef4fd6"/>
-    <p:sldId xmlns:r="http://schemas.openxmlformats.org/officeDocument/2006/relationships" id="259" r:id="Rb8d5e08040bb4277"/>
-    <p:sldId xmlns:r="http://schemas.openxmlformats.org/officeDocument/2006/relationships" id="260" r:id="R2be3c1a303fe4da9"/>
-    <p:sldId xmlns:r="http://schemas.openxmlformats.org/officeDocument/2006/relationships" id="261" r:id="Re7a55d0bcdac4109"/>
-    <p:sldId xmlns:r="http://schemas.openxmlformats.org/officeDocument/2006/relationships" id="262" r:id="R7a9090ac7e3841cd"/>
-    <p:sldId xmlns:r="http://schemas.openxmlformats.org/officeDocument/2006/relationships" id="263" r:id="Ra0c9f1cd265f467b"/>
+    <p:sldId xmlns:r="http://schemas.openxmlformats.org/officeDocument/2006/relationships" id="256" r:id="Rf27d82f583284b25"/>
+    <p:sldId xmlns:r="http://schemas.openxmlformats.org/officeDocument/2006/relationships" id="257" r:id="Rbe576d99436d4f16"/>
+    <p:sldId xmlns:r="http://schemas.openxmlformats.org/officeDocument/2006/relationships" id="258" r:id="Rc23a14dfb20c4ce5"/>
+    <p:sldId xmlns:r="http://schemas.openxmlformats.org/officeDocument/2006/relationships" id="259" r:id="R9ea5a87ef8f44037"/>
+    <p:sldId xmlns:r="http://schemas.openxmlformats.org/officeDocument/2006/relationships" id="260" r:id="R9496342332054dc4"/>
+    <p:sldId xmlns:r="http://schemas.openxmlformats.org/officeDocument/2006/relationships" id="261" r:id="R04804b7d346d43da"/>
+    <p:sldId xmlns:r="http://schemas.openxmlformats.org/officeDocument/2006/relationships" id="262" r:id="R6e54a75a6633459d"/>
+    <p:sldId xmlns:r="http://schemas.openxmlformats.org/officeDocument/2006/relationships" id="263" r:id="R124523a083774d46"/>
+    <p:sldId xmlns:r="http://schemas.openxmlformats.org/officeDocument/2006/relationships" id="264" r:id="Rd88c8c5fa11649b3"/>
+    <p:sldId xmlns:r="http://schemas.openxmlformats.org/officeDocument/2006/relationships" id="265" r:id="R008ee752f10b43af"/>
   </p:sldIdLst>
   <p:sldSz cx="12192000" cy="6858000"/>
   <p:notesSz cx="6858000" cy="9144000"/>
@@ -455,6 +457,81 @@
           <a:p xmlns:a="http://schemas.openxmlformats.org/drawingml/2006/main">
             <a:r>
               <a:t>안녕하세요. SKALA 4기 광주캠퍼스 G074 김지민입니다. 과제 2로 세계관 창작과 검토를 돕는 설정공방 LoreForge를 만들었습니다.</a:t>
+            </a:r>
+          </a:p>
+        </p:txBody>
+      </p:sp>
+      <p:sp>
+        <p:nvSpPr>
+          <p:cNvPr id="4" name="Slide Number Placeholder 3"/>
+          <p:cNvSpPr>
+            <a:spLocks xmlns:a="http://schemas.openxmlformats.org/drawingml/2006/main" noGrp="1"/>
+          </p:cNvSpPr>
+          <p:nvPr>
+            <p:ph type="sldNum" idx="5"/>
+          </p:nvPr>
+        </p:nvSpPr>
+        <p:spPr/>
+        <p:txBody>
+          <a:bodyPr xmlns:a="http://schemas.openxmlformats.org/drawingml/2006/main"/>
+          <a:lstStyle xmlns:a="http://schemas.openxmlformats.org/drawingml/2006/main"/>
+          <a:p xmlns:a="http://schemas.openxmlformats.org/drawingml/2006/main"/>
+        </p:txBody>
+      </p:sp>
+    </p:spTree>
+  </p:cSld>
+  <p:clrMapOvr>
+    <a:masterClrMapping xmlns:a="http://schemas.openxmlformats.org/drawingml/2006/main"/>
+  </p:clrMapOvr>
+</p:notes>
+</file>
+
+<file path=ppt/notesSlides/notesSlide10.xml><?xml version="1.0" encoding="utf-8"?>
+<p:notes xmlns:p="http://schemas.openxmlformats.org/presentationml/2006/main">
+  <p:cSld>
+    <p:spTree>
+      <p:nvGrpSpPr>
+        <p:cNvPr id="1" name=""/>
+        <p:cNvGrpSpPr/>
+        <p:nvPr/>
+      </p:nvGrpSpPr>
+      <p:grpSpPr>
+        <a:xfrm xmlns:a="http://schemas.openxmlformats.org/drawingml/2006/main"/>
+      </p:grpSpPr>
+      <p:sp>
+        <p:nvSpPr>
+          <p:cNvPr id="2" name="Slide Image Placeholder 1"/>
+          <p:cNvSpPr>
+            <a:spLocks xmlns:a="http://schemas.openxmlformats.org/drawingml/2006/main" noGrp="1"/>
+          </p:cNvSpPr>
+          <p:nvPr>
+            <p:ph type="sldImg" idx="0"/>
+          </p:nvPr>
+        </p:nvSpPr>
+        <p:spPr/>
+      </p:sp>
+      <p:sp>
+        <p:nvSpPr>
+          <p:cNvPr id="3" name="Notes Placeholder 2"/>
+          <p:cNvSpPr>
+            <a:spLocks xmlns:a="http://schemas.openxmlformats.org/drawingml/2006/main" noGrp="1"/>
+          </p:cNvSpPr>
+          <p:nvPr>
+            <p:ph type="body" idx="1"/>
+          </p:nvPr>
+        </p:nvSpPr>
+        <p:spPr/>
+        <p:txBody>
+          <a:bodyPr xmlns:a="http://schemas.openxmlformats.org/drawingml/2006/main"/>
+          <a:lstStyle xmlns:a="http://schemas.openxmlformats.org/drawingml/2006/main"/>
+          <a:p xmlns:a="http://schemas.openxmlformats.org/drawingml/2006/main">
+            <a:r>
+              <a:t>[감사 인사 — 04:40–04:45 / 5초]</a:t>
+            </a:r>
+          </a:p>
+          <a:p xmlns:a="http://schemas.openxmlformats.org/drawingml/2006/main">
+            <a:r>
+              <a:t>이상으로 설정공방 LoreForge 소개를 마치겠습니다. 들어주셔서 감사합니다.</a:t>
             </a:r>
           </a:p>
         </p:txBody>
@@ -969,12 +1046,12 @@
           <a:lstStyle xmlns:a="http://schemas.openxmlformats.org/drawingml/2006/main"/>
           <a:p xmlns:a="http://schemas.openxmlformats.org/drawingml/2006/main">
             <a:r>
-              <a:t>[RAG 적용 범위와 현재 기준 전달 방식 — 03:45–04:20 / 35초]</a:t>
+              <a:t>[RAG 적용 범위와 현재 기준 전달 방식 — 03:45–04:10 / 25초]</a:t>
             </a:r>
           </a:p>
           <a:p xmlns:a="http://schemas.openxmlformats.org/drawingml/2006/main">
             <a:r>
-              <a:t>RAG는 이번 MVP에 구현하지 않았습니다. 입력과 조건, 채택 설정 등의 기준을 이만 자 이내로 제한해 전체를 제공합니다. 일부만 검색하다 예외를 빠뜨리는 위험을 줄이기 위한 선택입니다. 대신 기준이 길어지면 입력 비용과 지연이 늘고, 긴 원고는 범위를 줄여야 합니다. 이후 검색을 추가할 때는 관련 문장뿐 아니라 예외까지 찾는지 함께 평가하겠습니다.</a:t>
+              <a:t>이번 MVP에는 RAG를 적용하지 않았습니다. 입력과 조건, 채택 설정을 합쳐 이만 자 이내의 기준 전체를 제공합니다. 다른 문단의 예외도 함께 보여주기 위한 선택입니다. 대신 원고가 길어질수록 입력 비용과 지연이 늘고, 긴 원고는 범위를 줄여야 합니다.</a:t>
             </a:r>
           </a:p>
           <a:p xmlns:a="http://schemas.openxmlformats.org/drawingml/2006/main">
@@ -1054,12 +1131,12 @@
           <a:lstStyle xmlns:a="http://schemas.openxmlformats.org/drawingml/2006/main"/>
           <a:p xmlns:a="http://schemas.openxmlformats.org/drawingml/2006/main">
             <a:r>
-              <a:t>[검토 오탐 보완과 남은 한계 — 04:20–04:45 / 25초]</a:t>
+              <a:t>[검토 오탐 보완과 남은 한계 — 04:10–04:25 / 15초]</a:t>
             </a:r>
           </a:p>
           <a:p xmlns:a="http://schemas.openxmlformats.org/drawingml/2006/main">
             <a:r>
-              <a:t>회차와 조건을 먼저 비교해 정상 예외와 실제 위반을 구분하도록 보완했습니다. 수정 한 번으로 반복과 비용은 제한했지만, 더 수정하면 해결될 문제도 남을 수 있어 작성자에게 넘깁니다. 지적이 없다는 결과도 정확성 보장은 아닙니다. 구현에는 AI 도구를 활용했고, 요구사항과 결과를 직접 판단했습니다. 감사합니다.</a:t>
+              <a:t>회차와 조건을 비교해 오탐을 줄이도록 보완했습니다. 수정은 한 번으로 제한하고, 남은 문제는 작성자에게 넘깁니다. 지적이 없다는 결과도 정확성을 보장하지는 않습니다.</a:t>
             </a:r>
           </a:p>
           <a:p xmlns:a="http://schemas.openxmlformats.org/drawingml/2006/main">
@@ -1070,6 +1147,91 @@
           <a:p xmlns:a="http://schemas.openxmlformats.org/drawingml/2006/main">
             <a:r>
               <a:t>자료: docs/PRESENTATION.md, docs/RESULTS.md. 코드 기준 a3086ff. 공개 v4 생성·v5 검토 저장 결과를 2026-10-22 최신 화면에서 조회만 허용한 서버로 재캡처. v8 회귀 10건과는 별도 실행. 화면 시간 표시는 없음.</a:t>
+            </a:r>
+          </a:p>
+        </p:txBody>
+      </p:sp>
+      <p:sp>
+        <p:nvSpPr>
+          <p:cNvPr id="4" name="Slide Number Placeholder 3"/>
+          <p:cNvSpPr>
+            <a:spLocks xmlns:a="http://schemas.openxmlformats.org/drawingml/2006/main" noGrp="1"/>
+          </p:cNvSpPr>
+          <p:nvPr>
+            <p:ph type="sldNum" idx="5"/>
+          </p:nvPr>
+        </p:nvSpPr>
+        <p:spPr/>
+        <p:txBody>
+          <a:bodyPr xmlns:a="http://schemas.openxmlformats.org/drawingml/2006/main"/>
+          <a:lstStyle xmlns:a="http://schemas.openxmlformats.org/drawingml/2006/main"/>
+          <a:p xmlns:a="http://schemas.openxmlformats.org/drawingml/2006/main"/>
+        </p:txBody>
+      </p:sp>
+    </p:spTree>
+  </p:cSld>
+  <p:clrMapOvr>
+    <a:masterClrMapping xmlns:a="http://schemas.openxmlformats.org/drawingml/2006/main"/>
+  </p:clrMapOvr>
+</p:notes>
+</file>
+
+<file path=ppt/notesSlides/notesSlide9.xml><?xml version="1.0" encoding="utf-8"?>
+<p:notes xmlns:p="http://schemas.openxmlformats.org/presentationml/2006/main">
+  <p:cSld>
+    <p:spTree>
+      <p:nvGrpSpPr>
+        <p:cNvPr id="1" name=""/>
+        <p:cNvGrpSpPr/>
+        <p:nvPr/>
+      </p:nvGrpSpPr>
+      <p:grpSpPr>
+        <a:xfrm xmlns:a="http://schemas.openxmlformats.org/drawingml/2006/main"/>
+      </p:grpSpPr>
+      <p:sp>
+        <p:nvSpPr>
+          <p:cNvPr id="2" name="Slide Image Placeholder 1"/>
+          <p:cNvSpPr>
+            <a:spLocks xmlns:a="http://schemas.openxmlformats.org/drawingml/2006/main" noGrp="1"/>
+          </p:cNvSpPr>
+          <p:nvPr>
+            <p:ph type="sldImg" idx="0"/>
+          </p:nvPr>
+        </p:nvSpPr>
+        <p:spPr/>
+      </p:sp>
+      <p:sp>
+        <p:nvSpPr>
+          <p:cNvPr id="3" name="Notes Placeholder 2"/>
+          <p:cNvSpPr>
+            <a:spLocks xmlns:a="http://schemas.openxmlformats.org/drawingml/2006/main" noGrp="1"/>
+          </p:cNvSpPr>
+          <p:nvPr>
+            <p:ph type="body" idx="1"/>
+          </p:nvPr>
+        </p:nvSpPr>
+        <p:spPr/>
+        <p:txBody>
+          <a:bodyPr xmlns:a="http://schemas.openxmlformats.org/drawingml/2006/main"/>
+          <a:lstStyle xmlns:a="http://schemas.openxmlformats.org/drawingml/2006/main"/>
+          <a:p xmlns:a="http://schemas.openxmlformats.org/drawingml/2006/main">
+            <a:r>
+              <a:t>[추후 확장 계획 — 04:25–04:40 / 15초]</a:t>
+            </a:r>
+          </a:p>
+          <a:p xmlns:a="http://schemas.openxmlformats.org/drawingml/2006/main">
+            <a:r>
+              <a:t>앞으로는 긴 원고를 위한 RAG를 도입하되 예외 누락도 평가하겠습니다. 다양한 원고와 작성자 평가로 오탐을 확인하고, 처음 쓰는 사람과 모바일 환경의 사용성도 개선하겠습니다.</a:t>
+            </a:r>
+          </a:p>
+          <a:p xmlns:a="http://schemas.openxmlformats.org/drawingml/2006/main">
+            <a:r>
+              <a:t/>
+            </a:r>
+          </a:p>
+          <a:p xmlns:a="http://schemas.openxmlformats.org/drawingml/2006/main">
+            <a:r>
+              <a:t>확장 계획 근거: README.md의 개발 과정에서 얻은 점과 개선 방향. RAG·추가 품질 평가·모바일 실기기 사용성 확인은 향후 계획이며 완료 기능으로 설명하지 않는다.</a:t>
             </a:r>
           </a:p>
         </p:txBody>
@@ -3512,12 +3674,12 @@
   </p:cSld>
   <p:clrMap bg1="lt1" tx1="dk1" bg2="lt2" tx2="dk2" accent1="accent1" accent2="accent2" accent3="accent3" accent4="accent4" accent5="accent5" accent6="accent6" hlink="hlink" folHlink="folHlink"/>
   <p:sldLayoutIdLst>
-    <p:sldLayoutId xmlns:r="http://schemas.openxmlformats.org/officeDocument/2006/relationships" id="2147483649" r:id="R1174749b9b714698"/>
-    <p:sldLayoutId xmlns:r="http://schemas.openxmlformats.org/officeDocument/2006/relationships" id="2147483650" r:id="R11633c85b1ea435b"/>
-    <p:sldLayoutId xmlns:r="http://schemas.openxmlformats.org/officeDocument/2006/relationships" id="2147483651" r:id="Ra24e6376433a4125"/>
-    <p:sldLayoutId xmlns:r="http://schemas.openxmlformats.org/officeDocument/2006/relationships" id="2147483652" r:id="Rb69fb47a902149ce"/>
-    <p:sldLayoutId xmlns:r="http://schemas.openxmlformats.org/officeDocument/2006/relationships" id="2147483653" r:id="R6ccb8e5855d34024"/>
-    <p:sldLayoutId xmlns:r="http://schemas.openxmlformats.org/officeDocument/2006/relationships" id="2147483654" r:id="Rc7e9ca62c08e4109"/>
+    <p:sldLayoutId xmlns:r="http://schemas.openxmlformats.org/officeDocument/2006/relationships" id="2147483649" r:id="R53376466eb2b4580"/>
+    <p:sldLayoutId xmlns:r="http://schemas.openxmlformats.org/officeDocument/2006/relationships" id="2147483650" r:id="R8ec0eb200323454e"/>
+    <p:sldLayoutId xmlns:r="http://schemas.openxmlformats.org/officeDocument/2006/relationships" id="2147483651" r:id="Rd76fe575cbf44b02"/>
+    <p:sldLayoutId xmlns:r="http://schemas.openxmlformats.org/officeDocument/2006/relationships" id="2147483652" r:id="Rfc4b255b2ce24f93"/>
+    <p:sldLayoutId xmlns:r="http://schemas.openxmlformats.org/officeDocument/2006/relationships" id="2147483653" r:id="R6fb6e2ed6b9342ae"/>
+    <p:sldLayoutId xmlns:r="http://schemas.openxmlformats.org/officeDocument/2006/relationships" id="2147483654" r:id="Rfd1becd7005142d6"/>
   </p:sldLayoutIdLst>
   <p:txStyles>
     <p:titleStyle>
@@ -5054,7 +5216,7 @@
                 <a:ea typeface="Apple SD Gothic Neo"/>
                 <a:cs typeface="Apple SD Gothic Neo"/>
               </a:rPr>
-              <a:t>1/8</a:t>
+              <a:t>1/10</a:t>
             </a:r>
           </a:p>
         </p:txBody>
@@ -5063,6 +5225,815 @@
     <p:extLst>
       <p:ext uri="{BB962C8B-B14F-4D97-AF65-F5344CB8AC3E}">
         <p14:creationId xmlns:p14="http://schemas.microsoft.com/office/powerpoint/2010/main" val="472476322"/>
+      </p:ext>
+    </p:extLst>
+  </p:cSld>
+</p:sld>
+</file>
+
+<file path=ppt/slides/slide10.xml><?xml version="1.0" encoding="utf-8"?>
+<p:sld xmlns:p="http://schemas.openxmlformats.org/presentationml/2006/main">
+  <p:cSld>
+    <p:bg>
+      <p:bgPr>
+        <a:solidFill xmlns:a="http://schemas.openxmlformats.org/drawingml/2006/main">
+          <a:srgbClr val="000926"/>
+        </a:solidFill>
+      </p:bgPr>
+    </p:bg>
+    <p:spTree>
+      <p:nvGrpSpPr>
+        <p:cNvPr id="1" name=""/>
+        <p:cNvGrpSpPr/>
+        <p:nvPr/>
+      </p:nvGrpSpPr>
+      <p:grpSpPr>
+        <a:xfrm xmlns:a="http://schemas.openxmlformats.org/drawingml/2006/main"/>
+      </p:grpSpPr>
+      <p:sp>
+        <p:nvSpPr>
+          <p:cNvPr id="6" name="">
+            <a:extLst xmlns:a="http://schemas.openxmlformats.org/drawingml/2006/main">
+              <a:ext uri="{FF2B5EF4-FFF2-40B4-BE49-F238E27FC236}">
+                <a16:creationId xmlns:a16="http://schemas.microsoft.com/office/drawing/2014/main" id="{CAC0F2BD-58E6-41CC-AB31-DDF3CAAAAB10}"/>
+              </a:ext>
+            </a:extLst>
+          </p:cNvPr>
+          <p:cNvSpPr>
+            <a:spLocks xmlns:a="http://schemas.openxmlformats.org/drawingml/2006/main" noGrp="1"/>
+          </p:cNvSpPr>
+          <p:nvPr/>
+        </p:nvSpPr>
+        <p:spPr>
+          <a:xfrm xmlns:a="http://schemas.openxmlformats.org/drawingml/2006/main">
+            <a:off x="742950" y="1152525"/>
+            <a:ext cx="10668000" cy="523875"/>
+          </a:xfrm>
+          <a:prstGeom xmlns:a="http://schemas.openxmlformats.org/drawingml/2006/main" prst="rect">
+            <a:avLst/>
+          </a:prstGeom>
+          <a:noFill xmlns:a="http://schemas.openxmlformats.org/drawingml/2006/main"/>
+          <a:ln xmlns:a="http://schemas.openxmlformats.org/drawingml/2006/main" w="0">
+            <a:noFill/>
+          </a:ln>
+        </p:spPr>
+        <p:txBody>
+          <a:bodyPr xmlns:a="http://schemas.openxmlformats.org/drawingml/2006/main" lIns="0" tIns="0" rIns="0" bIns="0"/>
+          <a:lstStyle xmlns:a="http://schemas.openxmlformats.org/drawingml/2006/main">
+            <a:defPPr>
+              <a:defRPr sz="2550" b="0">
+                <a:solidFill>
+                  <a:srgbClr val="A6C5D7"/>
+                </a:solidFill>
+                <a:latin typeface="Apple SD Gothic Neo"/>
+                <a:ea typeface="Apple SD Gothic Neo"/>
+                <a:cs typeface="Apple SD Gothic Neo"/>
+              </a:defRPr>
+            </a:defPPr>
+            <a:lvl1pPr>
+              <a:defRPr sz="2550" b="0">
+                <a:solidFill>
+                  <a:srgbClr val="A6C5D7"/>
+                </a:solidFill>
+                <a:latin typeface="Apple SD Gothic Neo"/>
+                <a:ea typeface="Apple SD Gothic Neo"/>
+                <a:cs typeface="Apple SD Gothic Neo"/>
+              </a:defRPr>
+            </a:lvl1pPr>
+            <a:lvl2pPr>
+              <a:defRPr sz="2550" b="0">
+                <a:solidFill>
+                  <a:srgbClr val="A6C5D7"/>
+                </a:solidFill>
+                <a:latin typeface="Apple SD Gothic Neo"/>
+                <a:ea typeface="Apple SD Gothic Neo"/>
+                <a:cs typeface="Apple SD Gothic Neo"/>
+              </a:defRPr>
+            </a:lvl2pPr>
+            <a:lvl3pPr>
+              <a:defRPr sz="2550" b="0">
+                <a:solidFill>
+                  <a:srgbClr val="A6C5D7"/>
+                </a:solidFill>
+                <a:latin typeface="Apple SD Gothic Neo"/>
+                <a:ea typeface="Apple SD Gothic Neo"/>
+                <a:cs typeface="Apple SD Gothic Neo"/>
+              </a:defRPr>
+            </a:lvl3pPr>
+            <a:lvl4pPr>
+              <a:defRPr sz="2550" b="0">
+                <a:solidFill>
+                  <a:srgbClr val="A6C5D7"/>
+                </a:solidFill>
+                <a:latin typeface="Apple SD Gothic Neo"/>
+                <a:ea typeface="Apple SD Gothic Neo"/>
+                <a:cs typeface="Apple SD Gothic Neo"/>
+              </a:defRPr>
+            </a:lvl4pPr>
+            <a:lvl5pPr>
+              <a:defRPr sz="2550" b="0">
+                <a:solidFill>
+                  <a:srgbClr val="A6C5D7"/>
+                </a:solidFill>
+                <a:latin typeface="Apple SD Gothic Neo"/>
+                <a:ea typeface="Apple SD Gothic Neo"/>
+                <a:cs typeface="Apple SD Gothic Neo"/>
+              </a:defRPr>
+            </a:lvl5pPr>
+            <a:lvl6pPr>
+              <a:defRPr sz="2550" b="0">
+                <a:solidFill>
+                  <a:srgbClr val="A6C5D7"/>
+                </a:solidFill>
+                <a:latin typeface="Apple SD Gothic Neo"/>
+                <a:ea typeface="Apple SD Gothic Neo"/>
+                <a:cs typeface="Apple SD Gothic Neo"/>
+              </a:defRPr>
+            </a:lvl6pPr>
+            <a:lvl7pPr>
+              <a:defRPr sz="2550" b="0">
+                <a:solidFill>
+                  <a:srgbClr val="A6C5D7"/>
+                </a:solidFill>
+                <a:latin typeface="Apple SD Gothic Neo"/>
+                <a:ea typeface="Apple SD Gothic Neo"/>
+                <a:cs typeface="Apple SD Gothic Neo"/>
+              </a:defRPr>
+            </a:lvl7pPr>
+            <a:lvl8pPr>
+              <a:defRPr sz="2550" b="0">
+                <a:solidFill>
+                  <a:srgbClr val="A6C5D7"/>
+                </a:solidFill>
+                <a:latin typeface="Apple SD Gothic Neo"/>
+                <a:ea typeface="Apple SD Gothic Neo"/>
+                <a:cs typeface="Apple SD Gothic Neo"/>
+              </a:defRPr>
+            </a:lvl8pPr>
+            <a:lvl9pPr>
+              <a:defRPr sz="2550" b="0">
+                <a:solidFill>
+                  <a:srgbClr val="A6C5D7"/>
+                </a:solidFill>
+                <a:latin typeface="Apple SD Gothic Neo"/>
+                <a:ea typeface="Apple SD Gothic Neo"/>
+                <a:cs typeface="Apple SD Gothic Neo"/>
+              </a:defRPr>
+            </a:lvl9pPr>
+          </a:lstStyle>
+          <a:p xmlns:a="http://schemas.openxmlformats.org/drawingml/2006/main">
+            <a:pPr>
+              <a:defRPr sz="2550" b="0">
+                <a:solidFill>
+                  <a:srgbClr val="A6C5D7"/>
+                </a:solidFill>
+                <a:latin typeface="Apple SD Gothic Neo"/>
+                <a:ea typeface="Apple SD Gothic Neo"/>
+                <a:cs typeface="Apple SD Gothic Neo"/>
+              </a:defRPr>
+            </a:pPr>
+            <a:r>
+              <a:rPr sz="2550" b="0">
+                <a:solidFill>
+                  <a:srgbClr val="A6C5D7"/>
+                </a:solidFill>
+                <a:latin typeface="Apple SD Gothic Neo"/>
+                <a:ea typeface="Apple SD Gothic Neo"/>
+                <a:cs typeface="Apple SD Gothic Neo"/>
+              </a:rPr>
+              <a:t>설정공방 LoreForge</a:t>
+            </a:r>
+          </a:p>
+        </p:txBody>
+      </p:sp>
+      <p:sp>
+        <p:nvSpPr>
+          <p:cNvPr id="2" name="">
+            <a:extLst xmlns:a="http://schemas.openxmlformats.org/drawingml/2006/main">
+              <a:ext uri="{FF2B5EF4-FFF2-40B4-BE49-F238E27FC236}">
+                <a16:creationId xmlns:a16="http://schemas.microsoft.com/office/drawing/2014/main" id="{F5680C13-CA21-42DD-A0A2-3A346A96FBB9}"/>
+              </a:ext>
+            </a:extLst>
+          </p:cNvPr>
+          <p:cNvSpPr>
+            <a:spLocks xmlns:a="http://schemas.openxmlformats.org/drawingml/2006/main" noGrp="1"/>
+          </p:cNvSpPr>
+          <p:nvPr/>
+        </p:nvSpPr>
+        <p:spPr>
+          <a:xfrm xmlns:a="http://schemas.openxmlformats.org/drawingml/2006/main">
+            <a:off x="742950" y="2581275"/>
+            <a:ext cx="10668000" cy="1047750"/>
+          </a:xfrm>
+          <a:prstGeom xmlns:a="http://schemas.openxmlformats.org/drawingml/2006/main" prst="rect">
+            <a:avLst/>
+          </a:prstGeom>
+          <a:noFill xmlns:a="http://schemas.openxmlformats.org/drawingml/2006/main"/>
+          <a:ln xmlns:a="http://schemas.openxmlformats.org/drawingml/2006/main" w="0">
+            <a:noFill/>
+          </a:ln>
+        </p:spPr>
+        <p:txBody>
+          <a:bodyPr xmlns:a="http://schemas.openxmlformats.org/drawingml/2006/main" lIns="0" tIns="0" rIns="0" bIns="0"/>
+          <a:lstStyle xmlns:a="http://schemas.openxmlformats.org/drawingml/2006/main">
+            <a:defPPr>
+              <a:defRPr sz="5400" b="1">
+                <a:solidFill>
+                  <a:srgbClr val="FFFFFF"/>
+                </a:solidFill>
+                <a:latin typeface="Apple SD Gothic Neo"/>
+                <a:ea typeface="Apple SD Gothic Neo"/>
+                <a:cs typeface="Apple SD Gothic Neo"/>
+              </a:defRPr>
+            </a:defPPr>
+            <a:lvl1pPr>
+              <a:defRPr sz="5400" b="1">
+                <a:solidFill>
+                  <a:srgbClr val="FFFFFF"/>
+                </a:solidFill>
+                <a:latin typeface="Apple SD Gothic Neo"/>
+                <a:ea typeface="Apple SD Gothic Neo"/>
+                <a:cs typeface="Apple SD Gothic Neo"/>
+              </a:defRPr>
+            </a:lvl1pPr>
+            <a:lvl2pPr>
+              <a:defRPr sz="5400" b="1">
+                <a:solidFill>
+                  <a:srgbClr val="FFFFFF"/>
+                </a:solidFill>
+                <a:latin typeface="Apple SD Gothic Neo"/>
+                <a:ea typeface="Apple SD Gothic Neo"/>
+                <a:cs typeface="Apple SD Gothic Neo"/>
+              </a:defRPr>
+            </a:lvl2pPr>
+            <a:lvl3pPr>
+              <a:defRPr sz="5400" b="1">
+                <a:solidFill>
+                  <a:srgbClr val="FFFFFF"/>
+                </a:solidFill>
+                <a:latin typeface="Apple SD Gothic Neo"/>
+                <a:ea typeface="Apple SD Gothic Neo"/>
+                <a:cs typeface="Apple SD Gothic Neo"/>
+              </a:defRPr>
+            </a:lvl3pPr>
+            <a:lvl4pPr>
+              <a:defRPr sz="5400" b="1">
+                <a:solidFill>
+                  <a:srgbClr val="FFFFFF"/>
+                </a:solidFill>
+                <a:latin typeface="Apple SD Gothic Neo"/>
+                <a:ea typeface="Apple SD Gothic Neo"/>
+                <a:cs typeface="Apple SD Gothic Neo"/>
+              </a:defRPr>
+            </a:lvl4pPr>
+            <a:lvl5pPr>
+              <a:defRPr sz="5400" b="1">
+                <a:solidFill>
+                  <a:srgbClr val="FFFFFF"/>
+                </a:solidFill>
+                <a:latin typeface="Apple SD Gothic Neo"/>
+                <a:ea typeface="Apple SD Gothic Neo"/>
+                <a:cs typeface="Apple SD Gothic Neo"/>
+              </a:defRPr>
+            </a:lvl5pPr>
+            <a:lvl6pPr>
+              <a:defRPr sz="5400" b="1">
+                <a:solidFill>
+                  <a:srgbClr val="FFFFFF"/>
+                </a:solidFill>
+                <a:latin typeface="Apple SD Gothic Neo"/>
+                <a:ea typeface="Apple SD Gothic Neo"/>
+                <a:cs typeface="Apple SD Gothic Neo"/>
+              </a:defRPr>
+            </a:lvl6pPr>
+            <a:lvl7pPr>
+              <a:defRPr sz="5400" b="1">
+                <a:solidFill>
+                  <a:srgbClr val="FFFFFF"/>
+                </a:solidFill>
+                <a:latin typeface="Apple SD Gothic Neo"/>
+                <a:ea typeface="Apple SD Gothic Neo"/>
+                <a:cs typeface="Apple SD Gothic Neo"/>
+              </a:defRPr>
+            </a:lvl7pPr>
+            <a:lvl8pPr>
+              <a:defRPr sz="5400" b="1">
+                <a:solidFill>
+                  <a:srgbClr val="FFFFFF"/>
+                </a:solidFill>
+                <a:latin typeface="Apple SD Gothic Neo"/>
+                <a:ea typeface="Apple SD Gothic Neo"/>
+                <a:cs typeface="Apple SD Gothic Neo"/>
+              </a:defRPr>
+            </a:lvl8pPr>
+            <a:lvl9pPr>
+              <a:defRPr sz="5400" b="1">
+                <a:solidFill>
+                  <a:srgbClr val="FFFFFF"/>
+                </a:solidFill>
+                <a:latin typeface="Apple SD Gothic Neo"/>
+                <a:ea typeface="Apple SD Gothic Neo"/>
+                <a:cs typeface="Apple SD Gothic Neo"/>
+              </a:defRPr>
+            </a:lvl9pPr>
+          </a:lstStyle>
+          <a:p xmlns:a="http://schemas.openxmlformats.org/drawingml/2006/main">
+            <a:pPr>
+              <a:defRPr sz="5400" b="1">
+                <a:solidFill>
+                  <a:srgbClr val="FFFFFF"/>
+                </a:solidFill>
+                <a:latin typeface="Apple SD Gothic Neo"/>
+                <a:ea typeface="Apple SD Gothic Neo"/>
+                <a:cs typeface="Apple SD Gothic Neo"/>
+              </a:defRPr>
+            </a:pPr>
+            <a:r>
+              <a:rPr sz="5400" b="1">
+                <a:solidFill>
+                  <a:srgbClr val="FFFFFF"/>
+                </a:solidFill>
+                <a:latin typeface="Apple SD Gothic Neo"/>
+                <a:ea typeface="Apple SD Gothic Neo"/>
+                <a:cs typeface="Apple SD Gothic Neo"/>
+              </a:rPr>
+              <a:t>들어주셔서 감사합니다</a:t>
+            </a:r>
+          </a:p>
+        </p:txBody>
+      </p:sp>
+      <p:sp>
+        <p:nvSpPr>
+          <p:cNvPr id="3" name="">
+            <a:extLst xmlns:a="http://schemas.openxmlformats.org/drawingml/2006/main">
+              <a:ext uri="{FF2B5EF4-FFF2-40B4-BE49-F238E27FC236}">
+                <a16:creationId xmlns:a16="http://schemas.microsoft.com/office/drawing/2014/main" id="{A09CBC2B-D9CC-486A-9FD3-409797338228}"/>
+              </a:ext>
+            </a:extLst>
+          </p:cNvPr>
+          <p:cNvSpPr>
+            <a:spLocks xmlns:a="http://schemas.openxmlformats.org/drawingml/2006/main" noGrp="1"/>
+          </p:cNvSpPr>
+          <p:nvPr/>
+        </p:nvSpPr>
+        <p:spPr>
+          <a:xfrm xmlns:a="http://schemas.openxmlformats.org/drawingml/2006/main">
+            <a:off x="742950" y="5029200"/>
+            <a:ext cx="10477500" cy="476250"/>
+          </a:xfrm>
+          <a:prstGeom xmlns:a="http://schemas.openxmlformats.org/drawingml/2006/main" prst="rect">
+            <a:avLst/>
+          </a:prstGeom>
+          <a:noFill xmlns:a="http://schemas.openxmlformats.org/drawingml/2006/main"/>
+          <a:ln xmlns:a="http://schemas.openxmlformats.org/drawingml/2006/main" w="0">
+            <a:noFill/>
+          </a:ln>
+        </p:spPr>
+        <p:txBody>
+          <a:bodyPr xmlns:a="http://schemas.openxmlformats.org/drawingml/2006/main" lIns="0" tIns="0" rIns="0" bIns="0"/>
+          <a:lstStyle xmlns:a="http://schemas.openxmlformats.org/drawingml/2006/main">
+            <a:defPPr>
+              <a:defRPr sz="2550" b="1">
+                <a:solidFill>
+                  <a:srgbClr val="FFFFFF"/>
+                </a:solidFill>
+                <a:latin typeface="Apple SD Gothic Neo"/>
+                <a:ea typeface="Apple SD Gothic Neo"/>
+                <a:cs typeface="Apple SD Gothic Neo"/>
+              </a:defRPr>
+            </a:defPPr>
+            <a:lvl1pPr>
+              <a:defRPr sz="2550" b="1">
+                <a:solidFill>
+                  <a:srgbClr val="FFFFFF"/>
+                </a:solidFill>
+                <a:latin typeface="Apple SD Gothic Neo"/>
+                <a:ea typeface="Apple SD Gothic Neo"/>
+                <a:cs typeface="Apple SD Gothic Neo"/>
+              </a:defRPr>
+            </a:lvl1pPr>
+            <a:lvl2pPr>
+              <a:defRPr sz="2550" b="1">
+                <a:solidFill>
+                  <a:srgbClr val="FFFFFF"/>
+                </a:solidFill>
+                <a:latin typeface="Apple SD Gothic Neo"/>
+                <a:ea typeface="Apple SD Gothic Neo"/>
+                <a:cs typeface="Apple SD Gothic Neo"/>
+              </a:defRPr>
+            </a:lvl2pPr>
+            <a:lvl3pPr>
+              <a:defRPr sz="2550" b="1">
+                <a:solidFill>
+                  <a:srgbClr val="FFFFFF"/>
+                </a:solidFill>
+                <a:latin typeface="Apple SD Gothic Neo"/>
+                <a:ea typeface="Apple SD Gothic Neo"/>
+                <a:cs typeface="Apple SD Gothic Neo"/>
+              </a:defRPr>
+            </a:lvl3pPr>
+            <a:lvl4pPr>
+              <a:defRPr sz="2550" b="1">
+                <a:solidFill>
+                  <a:srgbClr val="FFFFFF"/>
+                </a:solidFill>
+                <a:latin typeface="Apple SD Gothic Neo"/>
+                <a:ea typeface="Apple SD Gothic Neo"/>
+                <a:cs typeface="Apple SD Gothic Neo"/>
+              </a:defRPr>
+            </a:lvl4pPr>
+            <a:lvl5pPr>
+              <a:defRPr sz="2550" b="1">
+                <a:solidFill>
+                  <a:srgbClr val="FFFFFF"/>
+                </a:solidFill>
+                <a:latin typeface="Apple SD Gothic Neo"/>
+                <a:ea typeface="Apple SD Gothic Neo"/>
+                <a:cs typeface="Apple SD Gothic Neo"/>
+              </a:defRPr>
+            </a:lvl5pPr>
+            <a:lvl6pPr>
+              <a:defRPr sz="2550" b="1">
+                <a:solidFill>
+                  <a:srgbClr val="FFFFFF"/>
+                </a:solidFill>
+                <a:latin typeface="Apple SD Gothic Neo"/>
+                <a:ea typeface="Apple SD Gothic Neo"/>
+                <a:cs typeface="Apple SD Gothic Neo"/>
+              </a:defRPr>
+            </a:lvl6pPr>
+            <a:lvl7pPr>
+              <a:defRPr sz="2550" b="1">
+                <a:solidFill>
+                  <a:srgbClr val="FFFFFF"/>
+                </a:solidFill>
+                <a:latin typeface="Apple SD Gothic Neo"/>
+                <a:ea typeface="Apple SD Gothic Neo"/>
+                <a:cs typeface="Apple SD Gothic Neo"/>
+              </a:defRPr>
+            </a:lvl7pPr>
+            <a:lvl8pPr>
+              <a:defRPr sz="2550" b="1">
+                <a:solidFill>
+                  <a:srgbClr val="FFFFFF"/>
+                </a:solidFill>
+                <a:latin typeface="Apple SD Gothic Neo"/>
+                <a:ea typeface="Apple SD Gothic Neo"/>
+                <a:cs typeface="Apple SD Gothic Neo"/>
+              </a:defRPr>
+            </a:lvl8pPr>
+            <a:lvl9pPr>
+              <a:defRPr sz="2550" b="1">
+                <a:solidFill>
+                  <a:srgbClr val="FFFFFF"/>
+                </a:solidFill>
+                <a:latin typeface="Apple SD Gothic Neo"/>
+                <a:ea typeface="Apple SD Gothic Neo"/>
+                <a:cs typeface="Apple SD Gothic Neo"/>
+              </a:defRPr>
+            </a:lvl9pPr>
+          </a:lstStyle>
+          <a:p xmlns:a="http://schemas.openxmlformats.org/drawingml/2006/main">
+            <a:pPr>
+              <a:defRPr sz="2550" b="1">
+                <a:solidFill>
+                  <a:srgbClr val="FFFFFF"/>
+                </a:solidFill>
+                <a:latin typeface="Apple SD Gothic Neo"/>
+                <a:ea typeface="Apple SD Gothic Neo"/>
+                <a:cs typeface="Apple SD Gothic Neo"/>
+              </a:defRPr>
+            </a:pPr>
+            <a:r>
+              <a:rPr sz="2550" b="1">
+                <a:solidFill>
+                  <a:srgbClr val="FFFFFF"/>
+                </a:solidFill>
+                <a:latin typeface="Apple SD Gothic Neo"/>
+                <a:ea typeface="Apple SD Gothic Neo"/>
+                <a:cs typeface="Apple SD Gothic Neo"/>
+              </a:rPr>
+              <a:t>G074 김지민</a:t>
+            </a:r>
+          </a:p>
+        </p:txBody>
+      </p:sp>
+      <p:sp>
+        <p:nvSpPr>
+          <p:cNvPr id="4" name="">
+            <a:extLst xmlns:a="http://schemas.openxmlformats.org/drawingml/2006/main">
+              <a:ext uri="{FF2B5EF4-FFF2-40B4-BE49-F238E27FC236}">
+                <a16:creationId xmlns:a16="http://schemas.microsoft.com/office/drawing/2014/main" id="{8207F513-981B-4FD9-9314-A145CE1342D8}"/>
+              </a:ext>
+            </a:extLst>
+          </p:cNvPr>
+          <p:cNvSpPr>
+            <a:spLocks xmlns:a="http://schemas.openxmlformats.org/drawingml/2006/main" noGrp="1"/>
+          </p:cNvSpPr>
+          <p:nvPr/>
+        </p:nvSpPr>
+        <p:spPr>
+          <a:xfrm xmlns:a="http://schemas.openxmlformats.org/drawingml/2006/main">
+            <a:off x="742950" y="5600700"/>
+            <a:ext cx="10477500" cy="381000"/>
+          </a:xfrm>
+          <a:prstGeom xmlns:a="http://schemas.openxmlformats.org/drawingml/2006/main" prst="rect">
+            <a:avLst/>
+          </a:prstGeom>
+          <a:noFill xmlns:a="http://schemas.openxmlformats.org/drawingml/2006/main"/>
+          <a:ln xmlns:a="http://schemas.openxmlformats.org/drawingml/2006/main" w="0">
+            <a:noFill/>
+          </a:ln>
+        </p:spPr>
+        <p:txBody>
+          <a:bodyPr xmlns:a="http://schemas.openxmlformats.org/drawingml/2006/main" lIns="0" tIns="0" rIns="0" bIns="0"/>
+          <a:lstStyle xmlns:a="http://schemas.openxmlformats.org/drawingml/2006/main">
+            <a:defPPr>
+              <a:defRPr sz="1950" b="0">
+                <a:solidFill>
+                  <a:srgbClr val="D6E6F3"/>
+                </a:solidFill>
+                <a:latin typeface="Apple SD Gothic Neo"/>
+                <a:ea typeface="Apple SD Gothic Neo"/>
+                <a:cs typeface="Apple SD Gothic Neo"/>
+              </a:defRPr>
+            </a:defPPr>
+            <a:lvl1pPr>
+              <a:defRPr sz="1950" b="0">
+                <a:solidFill>
+                  <a:srgbClr val="D6E6F3"/>
+                </a:solidFill>
+                <a:latin typeface="Apple SD Gothic Neo"/>
+                <a:ea typeface="Apple SD Gothic Neo"/>
+                <a:cs typeface="Apple SD Gothic Neo"/>
+              </a:defRPr>
+            </a:lvl1pPr>
+            <a:lvl2pPr>
+              <a:defRPr sz="1950" b="0">
+                <a:solidFill>
+                  <a:srgbClr val="D6E6F3"/>
+                </a:solidFill>
+                <a:latin typeface="Apple SD Gothic Neo"/>
+                <a:ea typeface="Apple SD Gothic Neo"/>
+                <a:cs typeface="Apple SD Gothic Neo"/>
+              </a:defRPr>
+            </a:lvl2pPr>
+            <a:lvl3pPr>
+              <a:defRPr sz="1950" b="0">
+                <a:solidFill>
+                  <a:srgbClr val="D6E6F3"/>
+                </a:solidFill>
+                <a:latin typeface="Apple SD Gothic Neo"/>
+                <a:ea typeface="Apple SD Gothic Neo"/>
+                <a:cs typeface="Apple SD Gothic Neo"/>
+              </a:defRPr>
+            </a:lvl3pPr>
+            <a:lvl4pPr>
+              <a:defRPr sz="1950" b="0">
+                <a:solidFill>
+                  <a:srgbClr val="D6E6F3"/>
+                </a:solidFill>
+                <a:latin typeface="Apple SD Gothic Neo"/>
+                <a:ea typeface="Apple SD Gothic Neo"/>
+                <a:cs typeface="Apple SD Gothic Neo"/>
+              </a:defRPr>
+            </a:lvl4pPr>
+            <a:lvl5pPr>
+              <a:defRPr sz="1950" b="0">
+                <a:solidFill>
+                  <a:srgbClr val="D6E6F3"/>
+                </a:solidFill>
+                <a:latin typeface="Apple SD Gothic Neo"/>
+                <a:ea typeface="Apple SD Gothic Neo"/>
+                <a:cs typeface="Apple SD Gothic Neo"/>
+              </a:defRPr>
+            </a:lvl5pPr>
+            <a:lvl6pPr>
+              <a:defRPr sz="1950" b="0">
+                <a:solidFill>
+                  <a:srgbClr val="D6E6F3"/>
+                </a:solidFill>
+                <a:latin typeface="Apple SD Gothic Neo"/>
+                <a:ea typeface="Apple SD Gothic Neo"/>
+                <a:cs typeface="Apple SD Gothic Neo"/>
+              </a:defRPr>
+            </a:lvl6pPr>
+            <a:lvl7pPr>
+              <a:defRPr sz="1950" b="0">
+                <a:solidFill>
+                  <a:srgbClr val="D6E6F3"/>
+                </a:solidFill>
+                <a:latin typeface="Apple SD Gothic Neo"/>
+                <a:ea typeface="Apple SD Gothic Neo"/>
+                <a:cs typeface="Apple SD Gothic Neo"/>
+              </a:defRPr>
+            </a:lvl7pPr>
+            <a:lvl8pPr>
+              <a:defRPr sz="1950" b="0">
+                <a:solidFill>
+                  <a:srgbClr val="D6E6F3"/>
+                </a:solidFill>
+                <a:latin typeface="Apple SD Gothic Neo"/>
+                <a:ea typeface="Apple SD Gothic Neo"/>
+                <a:cs typeface="Apple SD Gothic Neo"/>
+              </a:defRPr>
+            </a:lvl8pPr>
+            <a:lvl9pPr>
+              <a:defRPr sz="1950" b="0">
+                <a:solidFill>
+                  <a:srgbClr val="D6E6F3"/>
+                </a:solidFill>
+                <a:latin typeface="Apple SD Gothic Neo"/>
+                <a:ea typeface="Apple SD Gothic Neo"/>
+                <a:cs typeface="Apple SD Gothic Neo"/>
+              </a:defRPr>
+            </a:lvl9pPr>
+          </a:lstStyle>
+          <a:p xmlns:a="http://schemas.openxmlformats.org/drawingml/2006/main">
+            <a:pPr>
+              <a:defRPr sz="1950" b="0">
+                <a:solidFill>
+                  <a:srgbClr val="D6E6F3"/>
+                </a:solidFill>
+                <a:latin typeface="Apple SD Gothic Neo"/>
+                <a:ea typeface="Apple SD Gothic Neo"/>
+                <a:cs typeface="Apple SD Gothic Neo"/>
+              </a:defRPr>
+            </a:pPr>
+            <a:r>
+              <a:rPr sz="1950" b="0">
+                <a:solidFill>
+                  <a:srgbClr val="D6E6F3"/>
+                </a:solidFill>
+                <a:latin typeface="Apple SD Gothic Neo"/>
+                <a:ea typeface="Apple SD Gothic Neo"/>
+                <a:cs typeface="Apple SD Gothic Neo"/>
+              </a:rPr>
+              <a:t>SKALA 4기 광주캠퍼스</a:t>
+            </a:r>
+          </a:p>
+        </p:txBody>
+      </p:sp>
+      <p:sp>
+        <p:nvSpPr>
+          <p:cNvPr id="5" name="">
+            <a:extLst xmlns:a="http://schemas.openxmlformats.org/drawingml/2006/main">
+              <a:ext uri="{FF2B5EF4-FFF2-40B4-BE49-F238E27FC236}">
+                <a16:creationId xmlns:a16="http://schemas.microsoft.com/office/drawing/2014/main" id="{6EFE641A-374B-4EE5-BEE4-142BF93C50A7}"/>
+              </a:ext>
+            </a:extLst>
+          </p:cNvPr>
+          <p:cNvSpPr>
+            <a:spLocks xmlns:a="http://schemas.openxmlformats.org/drawingml/2006/main" noGrp="1"/>
+          </p:cNvSpPr>
+          <p:nvPr/>
+        </p:nvSpPr>
+        <p:spPr>
+          <a:xfrm xmlns:a="http://schemas.openxmlformats.org/drawingml/2006/main">
+            <a:off x="10763250" y="6486525"/>
+            <a:ext cx="809625" cy="257175"/>
+          </a:xfrm>
+          <a:prstGeom xmlns:a="http://schemas.openxmlformats.org/drawingml/2006/main" prst="rect">
+            <a:avLst/>
+          </a:prstGeom>
+          <a:noFill xmlns:a="http://schemas.openxmlformats.org/drawingml/2006/main"/>
+          <a:ln xmlns:a="http://schemas.openxmlformats.org/drawingml/2006/main" w="0">
+            <a:noFill/>
+          </a:ln>
+        </p:spPr>
+        <p:txBody>
+          <a:bodyPr xmlns:a="http://schemas.openxmlformats.org/drawingml/2006/main" lIns="0" tIns="0" rIns="0" bIns="0"/>
+          <a:lstStyle xmlns:a="http://schemas.openxmlformats.org/drawingml/2006/main">
+            <a:defPPr>
+              <a:defRPr sz="1350" b="0">
+                <a:solidFill>
+                  <a:srgbClr val="A6C5D7"/>
+                </a:solidFill>
+                <a:latin typeface="Apple SD Gothic Neo"/>
+                <a:ea typeface="Apple SD Gothic Neo"/>
+                <a:cs typeface="Apple SD Gothic Neo"/>
+              </a:defRPr>
+            </a:defPPr>
+            <a:lvl1pPr>
+              <a:defRPr sz="1350" b="0">
+                <a:solidFill>
+                  <a:srgbClr val="A6C5D7"/>
+                </a:solidFill>
+                <a:latin typeface="Apple SD Gothic Neo"/>
+                <a:ea typeface="Apple SD Gothic Neo"/>
+                <a:cs typeface="Apple SD Gothic Neo"/>
+              </a:defRPr>
+            </a:lvl1pPr>
+            <a:lvl2pPr>
+              <a:defRPr sz="1350" b="0">
+                <a:solidFill>
+                  <a:srgbClr val="A6C5D7"/>
+                </a:solidFill>
+                <a:latin typeface="Apple SD Gothic Neo"/>
+                <a:ea typeface="Apple SD Gothic Neo"/>
+                <a:cs typeface="Apple SD Gothic Neo"/>
+              </a:defRPr>
+            </a:lvl2pPr>
+            <a:lvl3pPr>
+              <a:defRPr sz="1350" b="0">
+                <a:solidFill>
+                  <a:srgbClr val="A6C5D7"/>
+                </a:solidFill>
+                <a:latin typeface="Apple SD Gothic Neo"/>
+                <a:ea typeface="Apple SD Gothic Neo"/>
+                <a:cs typeface="Apple SD Gothic Neo"/>
+              </a:defRPr>
+            </a:lvl3pPr>
+            <a:lvl4pPr>
+              <a:defRPr sz="1350" b="0">
+                <a:solidFill>
+                  <a:srgbClr val="A6C5D7"/>
+                </a:solidFill>
+                <a:latin typeface="Apple SD Gothic Neo"/>
+                <a:ea typeface="Apple SD Gothic Neo"/>
+                <a:cs typeface="Apple SD Gothic Neo"/>
+              </a:defRPr>
+            </a:lvl4pPr>
+            <a:lvl5pPr>
+              <a:defRPr sz="1350" b="0">
+                <a:solidFill>
+                  <a:srgbClr val="A6C5D7"/>
+                </a:solidFill>
+                <a:latin typeface="Apple SD Gothic Neo"/>
+                <a:ea typeface="Apple SD Gothic Neo"/>
+                <a:cs typeface="Apple SD Gothic Neo"/>
+              </a:defRPr>
+            </a:lvl5pPr>
+            <a:lvl6pPr>
+              <a:defRPr sz="1350" b="0">
+                <a:solidFill>
+                  <a:srgbClr val="A6C5D7"/>
+                </a:solidFill>
+                <a:latin typeface="Apple SD Gothic Neo"/>
+                <a:ea typeface="Apple SD Gothic Neo"/>
+                <a:cs typeface="Apple SD Gothic Neo"/>
+              </a:defRPr>
+            </a:lvl6pPr>
+            <a:lvl7pPr>
+              <a:defRPr sz="1350" b="0">
+                <a:solidFill>
+                  <a:srgbClr val="A6C5D7"/>
+                </a:solidFill>
+                <a:latin typeface="Apple SD Gothic Neo"/>
+                <a:ea typeface="Apple SD Gothic Neo"/>
+                <a:cs typeface="Apple SD Gothic Neo"/>
+              </a:defRPr>
+            </a:lvl7pPr>
+            <a:lvl8pPr>
+              <a:defRPr sz="1350" b="0">
+                <a:solidFill>
+                  <a:srgbClr val="A6C5D7"/>
+                </a:solidFill>
+                <a:latin typeface="Apple SD Gothic Neo"/>
+                <a:ea typeface="Apple SD Gothic Neo"/>
+                <a:cs typeface="Apple SD Gothic Neo"/>
+              </a:defRPr>
+            </a:lvl8pPr>
+            <a:lvl9pPr>
+              <a:defRPr sz="1350" b="0">
+                <a:solidFill>
+                  <a:srgbClr val="A6C5D7"/>
+                </a:solidFill>
+                <a:latin typeface="Apple SD Gothic Neo"/>
+                <a:ea typeface="Apple SD Gothic Neo"/>
+                <a:cs typeface="Apple SD Gothic Neo"/>
+              </a:defRPr>
+            </a:lvl9pPr>
+          </a:lstStyle>
+          <a:p xmlns:a="http://schemas.openxmlformats.org/drawingml/2006/main">
+            <a:pPr>
+              <a:defRPr sz="1350" b="0">
+                <a:solidFill>
+                  <a:srgbClr val="A6C5D7"/>
+                </a:solidFill>
+                <a:latin typeface="Apple SD Gothic Neo"/>
+                <a:ea typeface="Apple SD Gothic Neo"/>
+                <a:cs typeface="Apple SD Gothic Neo"/>
+              </a:defRPr>
+            </a:pPr>
+            <a:r>
+              <a:rPr sz="1350" b="0">
+                <a:solidFill>
+                  <a:srgbClr val="A6C5D7"/>
+                </a:solidFill>
+                <a:latin typeface="Apple SD Gothic Neo"/>
+                <a:ea typeface="Apple SD Gothic Neo"/>
+                <a:cs typeface="Apple SD Gothic Neo"/>
+              </a:rPr>
+              <a:t>10/10</a:t>
+            </a:r>
+          </a:p>
+        </p:txBody>
+      </p:sp>
+    </p:spTree>
+    <p:extLst>
+      <p:ext uri="{BB962C8B-B14F-4D97-AF65-F5344CB8AC3E}">
+        <p14:creationId xmlns:p14="http://schemas.microsoft.com/office/powerpoint/2010/main" val="1055387861"/>
       </p:ext>
     </p:extLst>
   </p:cSld>
@@ -5781,7 +6752,7 @@
           <p:cNvPr id="8" name="">
             <a:extLst xmlns:a="http://schemas.openxmlformats.org/drawingml/2006/main">
               <a:ext uri="{FF2B5EF4-FFF2-40B4-BE49-F238E27FC236}">
-                <a16:creationId xmlns:a16="http://schemas.microsoft.com/office/drawing/2014/main" id="{12825FDF-EA3D-47AC-8C9F-70704C26C131}"/>
+                <a16:creationId xmlns:a16="http://schemas.microsoft.com/office/drawing/2014/main" id="{3F1A74BC-FDB9-4A0F-A8D9-9DCCA8E46793}"/>
               </a:ext>
             </a:extLst>
           </p:cNvPr>
@@ -5791,7 +6762,7 @@
           <p:nvPr/>
         </p:nvPicPr>
         <p:blipFill>
-          <a:blip xmlns:r="http://schemas.openxmlformats.org/officeDocument/2006/relationships" xmlns:a="http://schemas.openxmlformats.org/drawingml/2006/main" r:embed="R2ac5e7fd7f0e4c6d"/>
+          <a:blip xmlns:r="http://schemas.openxmlformats.org/officeDocument/2006/relationships" xmlns:a="http://schemas.openxmlformats.org/drawingml/2006/main" r:embed="R0591b18cd50340b1"/>
           <a:stretch xmlns:a="http://schemas.openxmlformats.org/drawingml/2006/main"/>
         </p:blipFill>
         <p:spPr>
@@ -5975,7 +6946,7 @@
           <p:cNvPr id="10" name="">
             <a:extLst xmlns:a="http://schemas.openxmlformats.org/drawingml/2006/main">
               <a:ext uri="{FF2B5EF4-FFF2-40B4-BE49-F238E27FC236}">
-                <a16:creationId xmlns:a16="http://schemas.microsoft.com/office/drawing/2014/main" id="{61BECC3E-5CB7-429B-8966-DB6F1AC723FE}"/>
+                <a16:creationId xmlns:a16="http://schemas.microsoft.com/office/drawing/2014/main" id="{FBF6645F-1A6F-4B4A-97CA-63B8F2AE477D}"/>
               </a:ext>
             </a:extLst>
           </p:cNvPr>
@@ -5985,7 +6956,7 @@
           <p:nvPr/>
         </p:nvPicPr>
         <p:blipFill>
-          <a:blip xmlns:r="http://schemas.openxmlformats.org/officeDocument/2006/relationships" xmlns:a="http://schemas.openxmlformats.org/drawingml/2006/main" r:embed="R3678e235c3114f17"/>
+          <a:blip xmlns:r="http://schemas.openxmlformats.org/officeDocument/2006/relationships" xmlns:a="http://schemas.openxmlformats.org/drawingml/2006/main" r:embed="R28615accd0d74420"/>
           <a:stretch xmlns:a="http://schemas.openxmlformats.org/drawingml/2006/main"/>
         </p:blipFill>
         <p:spPr>
@@ -6169,7 +7140,7 @@
           <p:cNvPr id="12" name="">
             <a:extLst xmlns:a="http://schemas.openxmlformats.org/drawingml/2006/main">
               <a:ext uri="{FF2B5EF4-FFF2-40B4-BE49-F238E27FC236}">
-                <a16:creationId xmlns:a16="http://schemas.microsoft.com/office/drawing/2014/main" id="{BFB9214B-59B3-4D65-BF11-63B2198078AC}"/>
+                <a16:creationId xmlns:a16="http://schemas.microsoft.com/office/drawing/2014/main" id="{055F8670-A8DA-47F3-A54F-FC4FF82E4D23}"/>
               </a:ext>
             </a:extLst>
           </p:cNvPr>
@@ -6179,7 +7150,7 @@
           <p:nvPr/>
         </p:nvPicPr>
         <p:blipFill>
-          <a:blip xmlns:r="http://schemas.openxmlformats.org/officeDocument/2006/relationships" xmlns:a="http://schemas.openxmlformats.org/drawingml/2006/main" r:embed="R6d5ca3072dcc4cf0"/>
+          <a:blip xmlns:r="http://schemas.openxmlformats.org/officeDocument/2006/relationships" xmlns:a="http://schemas.openxmlformats.org/drawingml/2006/main" r:embed="R0578071f61d84e3a"/>
           <a:stretch xmlns:a="http://schemas.openxmlformats.org/drawingml/2006/main"/>
         </p:blipFill>
         <p:spPr>
@@ -6363,7 +7334,7 @@
           <p:cNvPr id="14" name="">
             <a:extLst xmlns:a="http://schemas.openxmlformats.org/drawingml/2006/main">
               <a:ext uri="{FF2B5EF4-FFF2-40B4-BE49-F238E27FC236}">
-                <a16:creationId xmlns:a16="http://schemas.microsoft.com/office/drawing/2014/main" id="{BC921674-26FF-4283-B87A-B198D6CBE23D}"/>
+                <a16:creationId xmlns:a16="http://schemas.microsoft.com/office/drawing/2014/main" id="{4CD28B57-4A86-40DC-89BA-7302876BB3A0}"/>
               </a:ext>
             </a:extLst>
           </p:cNvPr>
@@ -6373,7 +7344,7 @@
           <p:nvPr/>
         </p:nvPicPr>
         <p:blipFill>
-          <a:blip xmlns:r="http://schemas.openxmlformats.org/officeDocument/2006/relationships" xmlns:a="http://schemas.openxmlformats.org/drawingml/2006/main" r:embed="R06a1314135b14bd7"/>
+          <a:blip xmlns:r="http://schemas.openxmlformats.org/officeDocument/2006/relationships" xmlns:a="http://schemas.openxmlformats.org/drawingml/2006/main" r:embed="R2681068941ec4e4d"/>
           <a:stretch xmlns:a="http://schemas.openxmlformats.org/drawingml/2006/main"/>
         </p:blipFill>
         <p:spPr>
@@ -6737,7 +7708,7 @@
                 <a:ea typeface="Apple SD Gothic Neo"/>
                 <a:cs typeface="Apple SD Gothic Neo"/>
               </a:rPr>
-              <a:t>2/8</a:t>
+              <a:t>2/10</a:t>
             </a:r>
           </a:p>
         </p:txBody>
@@ -7098,7 +8069,7 @@
                 <a:ea typeface="Apple SD Gothic Neo"/>
                 <a:cs typeface="Apple SD Gothic Neo"/>
               </a:rPr>
-              <a:t>G074 김지민   ·   3/8</a:t>
+              <a:t>G074 김지민   ·   3/10</a:t>
             </a:r>
           </a:p>
         </p:txBody>
@@ -9451,7 +10422,7 @@
                 <a:ea typeface="Apple SD Gothic Neo"/>
                 <a:cs typeface="Apple SD Gothic Neo"/>
               </a:rPr>
-              <a:t>G074 김지민   ·   4/8</a:t>
+              <a:t>G074 김지민   ·   4/10</a:t>
             </a:r>
           </a:p>
         </p:txBody>
@@ -10481,7 +11452,7 @@
           <p:cNvPr id="9" name="">
             <a:extLst xmlns:a="http://schemas.openxmlformats.org/drawingml/2006/main">
               <a:ext uri="{FF2B5EF4-FFF2-40B4-BE49-F238E27FC236}">
-                <a16:creationId xmlns:a16="http://schemas.microsoft.com/office/drawing/2014/main" id="{CA43A5E9-17DC-47A0-B7AE-AC8FBFA4E885}"/>
+                <a16:creationId xmlns:a16="http://schemas.microsoft.com/office/drawing/2014/main" id="{213F729B-F36E-41C9-97E0-5A549074E56F}"/>
               </a:ext>
             </a:extLst>
           </p:cNvPr>
@@ -10491,7 +11462,7 @@
           <p:nvPr/>
         </p:nvPicPr>
         <p:blipFill>
-          <a:blip xmlns:r="http://schemas.openxmlformats.org/officeDocument/2006/relationships" xmlns:a="http://schemas.openxmlformats.org/drawingml/2006/main" r:embed="R655dc2b894da4b9f"/>
+          <a:blip xmlns:r="http://schemas.openxmlformats.org/officeDocument/2006/relationships" xmlns:a="http://schemas.openxmlformats.org/drawingml/2006/main" r:embed="R33b77e9017de4bed"/>
           <a:srcRect xmlns:a="http://schemas.openxmlformats.org/drawingml/2006/main" l="24500" t="32000" r="25000" b="22000"/>
           <a:stretch xmlns:a="http://schemas.openxmlformats.org/drawingml/2006/main"/>
         </p:blipFill>
@@ -10676,7 +11647,7 @@
           <p:cNvPr id="12" name="">
             <a:extLst xmlns:a="http://schemas.openxmlformats.org/drawingml/2006/main">
               <a:ext uri="{FF2B5EF4-FFF2-40B4-BE49-F238E27FC236}">
-                <a16:creationId xmlns:a16="http://schemas.microsoft.com/office/drawing/2014/main" id="{80A46A9A-84AA-4AA3-AB48-65FA3676A1CB}"/>
+                <a16:creationId xmlns:a16="http://schemas.microsoft.com/office/drawing/2014/main" id="{395D25EF-D435-4026-94F5-41670DCAD6BD}"/>
               </a:ext>
             </a:extLst>
           </p:cNvPr>
@@ -10686,7 +11657,7 @@
           <p:nvPr/>
         </p:nvPicPr>
         <p:blipFill>
-          <a:blip xmlns:r="http://schemas.openxmlformats.org/officeDocument/2006/relationships" xmlns:a="http://schemas.openxmlformats.org/drawingml/2006/main" r:embed="R5d361649eede4494"/>
+          <a:blip xmlns:r="http://schemas.openxmlformats.org/officeDocument/2006/relationships" xmlns:a="http://schemas.openxmlformats.org/drawingml/2006/main" r:embed="Rf93793ba7b174d32"/>
           <a:srcRect xmlns:a="http://schemas.openxmlformats.org/drawingml/2006/main" l="2700" t="39500" r="3200" b="20500"/>
           <a:stretch xmlns:a="http://schemas.openxmlformats.org/drawingml/2006/main"/>
         </p:blipFill>
@@ -10734,7 +11705,7 @@
           <p:cNvPr id="12" name="">
             <a:extLst xmlns:a="http://schemas.openxmlformats.org/drawingml/2006/main">
               <a:ext uri="{FF2B5EF4-FFF2-40B4-BE49-F238E27FC236}">
-                <a16:creationId xmlns:a16="http://schemas.microsoft.com/office/drawing/2014/main" id="{1E31B0C4-FAD0-4F8E-83B8-4875C6C63E72}"/>
+                <a16:creationId xmlns:a16="http://schemas.microsoft.com/office/drawing/2014/main" id="{F8EC2D5B-F4E5-4D9F-AA01-0043CE379C9C}"/>
               </a:ext>
             </a:extLst>
           </p:cNvPr>
@@ -10765,7 +11736,7 @@
           <p:cNvPr id="11" name="">
             <a:extLst xmlns:a="http://schemas.openxmlformats.org/drawingml/2006/main">
               <a:ext uri="{FF2B5EF4-FFF2-40B4-BE49-F238E27FC236}">
-                <a16:creationId xmlns:a16="http://schemas.microsoft.com/office/drawing/2014/main" id="{76041443-DD64-4B3E-B586-937CAFD93ECA}"/>
+                <a16:creationId xmlns:a16="http://schemas.microsoft.com/office/drawing/2014/main" id="{2CB53B22-5AD8-41F1-B416-C934B0201617}"/>
               </a:ext>
             </a:extLst>
           </p:cNvPr>
@@ -10796,7 +11767,7 @@
           <p:cNvPr id="10" name="">
             <a:extLst xmlns:a="http://schemas.openxmlformats.org/drawingml/2006/main">
               <a:ext uri="{FF2B5EF4-FFF2-40B4-BE49-F238E27FC236}">
-                <a16:creationId xmlns:a16="http://schemas.microsoft.com/office/drawing/2014/main" id="{88C7C5B5-E584-4F2C-BB5C-8D7F1D72DA7A}"/>
+                <a16:creationId xmlns:a16="http://schemas.microsoft.com/office/drawing/2014/main" id="{5DEC7AAE-392D-4661-A148-A09112B439F0}"/>
               </a:ext>
             </a:extLst>
           </p:cNvPr>
@@ -10827,7 +11798,7 @@
           <p:cNvPr id="9" name="">
             <a:extLst xmlns:a="http://schemas.openxmlformats.org/drawingml/2006/main">
               <a:ext uri="{FF2B5EF4-FFF2-40B4-BE49-F238E27FC236}">
-                <a16:creationId xmlns:a16="http://schemas.microsoft.com/office/drawing/2014/main" id="{9DDCE1DA-7FC3-4A50-BF41-9EF9125CEBC0}"/>
+                <a16:creationId xmlns:a16="http://schemas.microsoft.com/office/drawing/2014/main" id="{86FC0B01-BFEC-4E24-8963-CCF7738C9F2B}"/>
               </a:ext>
             </a:extLst>
           </p:cNvPr>
@@ -11180,7 +12151,7 @@
                 <a:ea typeface="Apple SD Gothic Neo"/>
                 <a:cs typeface="Apple SD Gothic Neo"/>
               </a:rPr>
-              <a:t>G074 김지민   ·   5/8</a:t>
+              <a:t>G074 김지민   ·   5/10</a:t>
             </a:r>
           </a:p>
         </p:txBody>
@@ -13979,7 +14950,7 @@
                 <a:ea typeface="Apple SD Gothic Neo"/>
                 <a:cs typeface="Apple SD Gothic Neo"/>
               </a:rPr>
-              <a:t>G074 김지민   ·   6/8</a:t>
+              <a:t>G074 김지민   ·   6/10</a:t>
             </a:r>
           </a:p>
         </p:txBody>
@@ -15932,7 +16903,7 @@
                 <a:ea typeface="Apple SD Gothic Neo"/>
                 <a:cs typeface="Apple SD Gothic Neo"/>
               </a:rPr>
-              <a:t>G074 김지민   ·   7/8</a:t>
+              <a:t>G074 김지민   ·   7/10</a:t>
             </a:r>
           </a:p>
         </p:txBody>
@@ -17671,7 +18642,7 @@
                 <a:ea typeface="Apple SD Gothic Neo"/>
                 <a:cs typeface="Apple SD Gothic Neo"/>
               </a:rPr>
-              <a:t>G074 김지민   ·   8/8</a:t>
+              <a:t>G074 김지민   ·   8/10</a:t>
             </a:r>
           </a:p>
         </p:txBody>
@@ -18890,6 +19861,1976 @@
     <p:extLst>
       <p:ext uri="{BB962C8B-B14F-4D97-AF65-F5344CB8AC3E}">
         <p14:creationId xmlns:p14="http://schemas.microsoft.com/office/powerpoint/2010/main" val="1966249133"/>
+      </p:ext>
+    </p:extLst>
+  </p:cSld>
+</p:sld>
+</file>
+
+<file path=ppt/slides/slide9.xml><?xml version="1.0" encoding="utf-8"?>
+<p:sld xmlns:p="http://schemas.openxmlformats.org/presentationml/2006/main">
+  <p:cSld>
+    <p:bg>
+      <p:bgPr>
+        <a:solidFill xmlns:a="http://schemas.openxmlformats.org/drawingml/2006/main">
+          <a:srgbClr val="F7FAFD"/>
+        </a:solidFill>
+      </p:bgPr>
+    </p:bg>
+    <p:spTree>
+      <p:nvGrpSpPr>
+        <p:cNvPr id="1" name=""/>
+        <p:cNvGrpSpPr/>
+        <p:nvPr/>
+      </p:nvGrpSpPr>
+      <p:grpSpPr>
+        <a:xfrm xmlns:a="http://schemas.openxmlformats.org/drawingml/2006/main"/>
+      </p:grpSpPr>
+      <p:sp>
+        <p:nvSpPr>
+          <p:cNvPr id="13" name="">
+            <a:extLst xmlns:a="http://schemas.openxmlformats.org/drawingml/2006/main">
+              <a:ext uri="{FF2B5EF4-FFF2-40B4-BE49-F238E27FC236}">
+                <a16:creationId xmlns:a16="http://schemas.microsoft.com/office/drawing/2014/main" id="{97DEC7B8-10CF-402C-A574-37E74057CF8A}"/>
+              </a:ext>
+            </a:extLst>
+          </p:cNvPr>
+          <p:cNvSpPr>
+            <a:spLocks xmlns:a="http://schemas.openxmlformats.org/drawingml/2006/main" noGrp="1"/>
+          </p:cNvSpPr>
+          <p:nvPr/>
+        </p:nvSpPr>
+        <p:spPr>
+          <a:xfrm xmlns:a="http://schemas.openxmlformats.org/drawingml/2006/main">
+            <a:off x="609600" y="466725"/>
+            <a:ext cx="10972800" cy="619125"/>
+          </a:xfrm>
+          <a:prstGeom xmlns:a="http://schemas.openxmlformats.org/drawingml/2006/main" prst="rect">
+            <a:avLst/>
+          </a:prstGeom>
+          <a:noFill xmlns:a="http://schemas.openxmlformats.org/drawingml/2006/main"/>
+          <a:ln xmlns:a="http://schemas.openxmlformats.org/drawingml/2006/main" w="0">
+            <a:noFill/>
+          </a:ln>
+        </p:spPr>
+        <p:txBody>
+          <a:bodyPr xmlns:a="http://schemas.openxmlformats.org/drawingml/2006/main" lIns="0" tIns="0" rIns="0" bIns="0"/>
+          <a:lstStyle xmlns:a="http://schemas.openxmlformats.org/drawingml/2006/main">
+            <a:defPPr>
+              <a:defRPr sz="3300" b="1">
+                <a:solidFill>
+                  <a:srgbClr val="000926"/>
+                </a:solidFill>
+                <a:latin typeface="Apple SD Gothic Neo"/>
+                <a:ea typeface="Apple SD Gothic Neo"/>
+                <a:cs typeface="Apple SD Gothic Neo"/>
+              </a:defRPr>
+            </a:defPPr>
+            <a:lvl1pPr>
+              <a:defRPr sz="3300" b="1">
+                <a:solidFill>
+                  <a:srgbClr val="000926"/>
+                </a:solidFill>
+                <a:latin typeface="Apple SD Gothic Neo"/>
+                <a:ea typeface="Apple SD Gothic Neo"/>
+                <a:cs typeface="Apple SD Gothic Neo"/>
+              </a:defRPr>
+            </a:lvl1pPr>
+            <a:lvl2pPr>
+              <a:defRPr sz="3300" b="1">
+                <a:solidFill>
+                  <a:srgbClr val="000926"/>
+                </a:solidFill>
+                <a:latin typeface="Apple SD Gothic Neo"/>
+                <a:ea typeface="Apple SD Gothic Neo"/>
+                <a:cs typeface="Apple SD Gothic Neo"/>
+              </a:defRPr>
+            </a:lvl2pPr>
+            <a:lvl3pPr>
+              <a:defRPr sz="3300" b="1">
+                <a:solidFill>
+                  <a:srgbClr val="000926"/>
+                </a:solidFill>
+                <a:latin typeface="Apple SD Gothic Neo"/>
+                <a:ea typeface="Apple SD Gothic Neo"/>
+                <a:cs typeface="Apple SD Gothic Neo"/>
+              </a:defRPr>
+            </a:lvl3pPr>
+            <a:lvl4pPr>
+              <a:defRPr sz="3300" b="1">
+                <a:solidFill>
+                  <a:srgbClr val="000926"/>
+                </a:solidFill>
+                <a:latin typeface="Apple SD Gothic Neo"/>
+                <a:ea typeface="Apple SD Gothic Neo"/>
+                <a:cs typeface="Apple SD Gothic Neo"/>
+              </a:defRPr>
+            </a:lvl4pPr>
+            <a:lvl5pPr>
+              <a:defRPr sz="3300" b="1">
+                <a:solidFill>
+                  <a:srgbClr val="000926"/>
+                </a:solidFill>
+                <a:latin typeface="Apple SD Gothic Neo"/>
+                <a:ea typeface="Apple SD Gothic Neo"/>
+                <a:cs typeface="Apple SD Gothic Neo"/>
+              </a:defRPr>
+            </a:lvl5pPr>
+            <a:lvl6pPr>
+              <a:defRPr sz="3300" b="1">
+                <a:solidFill>
+                  <a:srgbClr val="000926"/>
+                </a:solidFill>
+                <a:latin typeface="Apple SD Gothic Neo"/>
+                <a:ea typeface="Apple SD Gothic Neo"/>
+                <a:cs typeface="Apple SD Gothic Neo"/>
+              </a:defRPr>
+            </a:lvl6pPr>
+            <a:lvl7pPr>
+              <a:defRPr sz="3300" b="1">
+                <a:solidFill>
+                  <a:srgbClr val="000926"/>
+                </a:solidFill>
+                <a:latin typeface="Apple SD Gothic Neo"/>
+                <a:ea typeface="Apple SD Gothic Neo"/>
+                <a:cs typeface="Apple SD Gothic Neo"/>
+              </a:defRPr>
+            </a:lvl7pPr>
+            <a:lvl8pPr>
+              <a:defRPr sz="3300" b="1">
+                <a:solidFill>
+                  <a:srgbClr val="000926"/>
+                </a:solidFill>
+                <a:latin typeface="Apple SD Gothic Neo"/>
+                <a:ea typeface="Apple SD Gothic Neo"/>
+                <a:cs typeface="Apple SD Gothic Neo"/>
+              </a:defRPr>
+            </a:lvl8pPr>
+            <a:lvl9pPr>
+              <a:defRPr sz="3300" b="1">
+                <a:solidFill>
+                  <a:srgbClr val="000926"/>
+                </a:solidFill>
+                <a:latin typeface="Apple SD Gothic Neo"/>
+                <a:ea typeface="Apple SD Gothic Neo"/>
+                <a:cs typeface="Apple SD Gothic Neo"/>
+              </a:defRPr>
+            </a:lvl9pPr>
+          </a:lstStyle>
+          <a:p xmlns:a="http://schemas.openxmlformats.org/drawingml/2006/main">
+            <a:pPr>
+              <a:defRPr sz="3300" b="1">
+                <a:solidFill>
+                  <a:srgbClr val="000926"/>
+                </a:solidFill>
+                <a:latin typeface="Apple SD Gothic Neo"/>
+                <a:ea typeface="Apple SD Gothic Neo"/>
+                <a:cs typeface="Apple SD Gothic Neo"/>
+              </a:defRPr>
+            </a:pPr>
+            <a:r>
+              <a:rPr sz="3300" b="1">
+                <a:solidFill>
+                  <a:srgbClr val="000926"/>
+                </a:solidFill>
+                <a:latin typeface="Apple SD Gothic Neo"/>
+                <a:ea typeface="Apple SD Gothic Neo"/>
+                <a:cs typeface="Apple SD Gothic Neo"/>
+              </a:rPr>
+              <a:t>추후 확장 계획</a:t>
+            </a:r>
+          </a:p>
+        </p:txBody>
+      </p:sp>
+      <p:sp>
+        <p:nvSpPr>
+          <p:cNvPr id="2" name="">
+            <a:extLst xmlns:a="http://schemas.openxmlformats.org/drawingml/2006/main">
+              <a:ext uri="{FF2B5EF4-FFF2-40B4-BE49-F238E27FC236}">
+                <a16:creationId xmlns:a16="http://schemas.microsoft.com/office/drawing/2014/main" id="{16C7FEA2-C02F-4E5B-A2CA-68F57ECE07FE}"/>
+              </a:ext>
+            </a:extLst>
+          </p:cNvPr>
+          <p:cNvSpPr>
+            <a:spLocks xmlns:a="http://schemas.openxmlformats.org/drawingml/2006/main" noGrp="1"/>
+          </p:cNvSpPr>
+          <p:nvPr/>
+        </p:nvSpPr>
+        <p:spPr>
+          <a:xfrm xmlns:a="http://schemas.openxmlformats.org/drawingml/2006/main">
+            <a:off x="609600" y="1362075"/>
+            <a:ext cx="10972800" cy="428625"/>
+          </a:xfrm>
+          <a:prstGeom xmlns:a="http://schemas.openxmlformats.org/drawingml/2006/main" prst="rect">
+            <a:avLst/>
+          </a:prstGeom>
+          <a:noFill xmlns:a="http://schemas.openxmlformats.org/drawingml/2006/main"/>
+          <a:ln xmlns:a="http://schemas.openxmlformats.org/drawingml/2006/main" w="0">
+            <a:noFill/>
+          </a:ln>
+        </p:spPr>
+        <p:txBody>
+          <a:bodyPr xmlns:a="http://schemas.openxmlformats.org/drawingml/2006/main" lIns="0" tIns="0" rIns="0" bIns="0"/>
+          <a:lstStyle xmlns:a="http://schemas.openxmlformats.org/drawingml/2006/main">
+            <a:defPPr>
+              <a:defRPr sz="2250" b="1">
+                <a:solidFill>
+                  <a:srgbClr val="0F52BA"/>
+                </a:solidFill>
+                <a:latin typeface="Apple SD Gothic Neo"/>
+                <a:ea typeface="Apple SD Gothic Neo"/>
+                <a:cs typeface="Apple SD Gothic Neo"/>
+              </a:defRPr>
+            </a:defPPr>
+            <a:lvl1pPr>
+              <a:defRPr sz="2250" b="1">
+                <a:solidFill>
+                  <a:srgbClr val="0F52BA"/>
+                </a:solidFill>
+                <a:latin typeface="Apple SD Gothic Neo"/>
+                <a:ea typeface="Apple SD Gothic Neo"/>
+                <a:cs typeface="Apple SD Gothic Neo"/>
+              </a:defRPr>
+            </a:lvl1pPr>
+            <a:lvl2pPr>
+              <a:defRPr sz="2250" b="1">
+                <a:solidFill>
+                  <a:srgbClr val="0F52BA"/>
+                </a:solidFill>
+                <a:latin typeface="Apple SD Gothic Neo"/>
+                <a:ea typeface="Apple SD Gothic Neo"/>
+                <a:cs typeface="Apple SD Gothic Neo"/>
+              </a:defRPr>
+            </a:lvl2pPr>
+            <a:lvl3pPr>
+              <a:defRPr sz="2250" b="1">
+                <a:solidFill>
+                  <a:srgbClr val="0F52BA"/>
+                </a:solidFill>
+                <a:latin typeface="Apple SD Gothic Neo"/>
+                <a:ea typeface="Apple SD Gothic Neo"/>
+                <a:cs typeface="Apple SD Gothic Neo"/>
+              </a:defRPr>
+            </a:lvl3pPr>
+            <a:lvl4pPr>
+              <a:defRPr sz="2250" b="1">
+                <a:solidFill>
+                  <a:srgbClr val="0F52BA"/>
+                </a:solidFill>
+                <a:latin typeface="Apple SD Gothic Neo"/>
+                <a:ea typeface="Apple SD Gothic Neo"/>
+                <a:cs typeface="Apple SD Gothic Neo"/>
+              </a:defRPr>
+            </a:lvl4pPr>
+            <a:lvl5pPr>
+              <a:defRPr sz="2250" b="1">
+                <a:solidFill>
+                  <a:srgbClr val="0F52BA"/>
+                </a:solidFill>
+                <a:latin typeface="Apple SD Gothic Neo"/>
+                <a:ea typeface="Apple SD Gothic Neo"/>
+                <a:cs typeface="Apple SD Gothic Neo"/>
+              </a:defRPr>
+            </a:lvl5pPr>
+            <a:lvl6pPr>
+              <a:defRPr sz="2250" b="1">
+                <a:solidFill>
+                  <a:srgbClr val="0F52BA"/>
+                </a:solidFill>
+                <a:latin typeface="Apple SD Gothic Neo"/>
+                <a:ea typeface="Apple SD Gothic Neo"/>
+                <a:cs typeface="Apple SD Gothic Neo"/>
+              </a:defRPr>
+            </a:lvl6pPr>
+            <a:lvl7pPr>
+              <a:defRPr sz="2250" b="1">
+                <a:solidFill>
+                  <a:srgbClr val="0F52BA"/>
+                </a:solidFill>
+                <a:latin typeface="Apple SD Gothic Neo"/>
+                <a:ea typeface="Apple SD Gothic Neo"/>
+                <a:cs typeface="Apple SD Gothic Neo"/>
+              </a:defRPr>
+            </a:lvl7pPr>
+            <a:lvl8pPr>
+              <a:defRPr sz="2250" b="1">
+                <a:solidFill>
+                  <a:srgbClr val="0F52BA"/>
+                </a:solidFill>
+                <a:latin typeface="Apple SD Gothic Neo"/>
+                <a:ea typeface="Apple SD Gothic Neo"/>
+                <a:cs typeface="Apple SD Gothic Neo"/>
+              </a:defRPr>
+            </a:lvl8pPr>
+            <a:lvl9pPr>
+              <a:defRPr sz="2250" b="1">
+                <a:solidFill>
+                  <a:srgbClr val="0F52BA"/>
+                </a:solidFill>
+                <a:latin typeface="Apple SD Gothic Neo"/>
+                <a:ea typeface="Apple SD Gothic Neo"/>
+                <a:cs typeface="Apple SD Gothic Neo"/>
+              </a:defRPr>
+            </a:lvl9pPr>
+          </a:lstStyle>
+          <a:p xmlns:a="http://schemas.openxmlformats.org/drawingml/2006/main">
+            <a:pPr>
+              <a:defRPr sz="2250" b="1">
+                <a:solidFill>
+                  <a:srgbClr val="0F52BA"/>
+                </a:solidFill>
+                <a:latin typeface="Apple SD Gothic Neo"/>
+                <a:ea typeface="Apple SD Gothic Neo"/>
+                <a:cs typeface="Apple SD Gothic Neo"/>
+              </a:defRPr>
+            </a:pPr>
+            <a:r>
+              <a:rPr sz="2250" b="1">
+                <a:solidFill>
+                  <a:srgbClr val="0F52BA"/>
+                </a:solidFill>
+                <a:latin typeface="Apple SD Gothic Neo"/>
+                <a:ea typeface="Apple SD Gothic Neo"/>
+                <a:cs typeface="Apple SD Gothic Neo"/>
+              </a:rPr>
+              <a:t>긴 원고와 다양한 창작 환경으로 확장</a:t>
+            </a:r>
+          </a:p>
+        </p:txBody>
+      </p:sp>
+      <p:sp>
+        <p:nvSpPr>
+          <p:cNvPr id="3" name="">
+            <a:extLst xmlns:a="http://schemas.openxmlformats.org/drawingml/2006/main">
+              <a:ext uri="{FF2B5EF4-FFF2-40B4-BE49-F238E27FC236}">
+                <a16:creationId xmlns:a16="http://schemas.microsoft.com/office/drawing/2014/main" id="{83F65968-A260-4CC2-98A4-DB895D21A9D6}"/>
+              </a:ext>
+            </a:extLst>
+          </p:cNvPr>
+          <p:cNvSpPr>
+            <a:spLocks xmlns:a="http://schemas.openxmlformats.org/drawingml/2006/main" noGrp="1"/>
+          </p:cNvSpPr>
+          <p:nvPr/>
+        </p:nvSpPr>
+        <p:spPr>
+          <a:xfrm xmlns:a="http://schemas.openxmlformats.org/drawingml/2006/main">
+            <a:off x="609600" y="2333625"/>
+            <a:ext cx="762000" cy="523875"/>
+          </a:xfrm>
+          <a:prstGeom xmlns:a="http://schemas.openxmlformats.org/drawingml/2006/main" prst="rect">
+            <a:avLst/>
+          </a:prstGeom>
+          <a:noFill xmlns:a="http://schemas.openxmlformats.org/drawingml/2006/main"/>
+          <a:ln xmlns:a="http://schemas.openxmlformats.org/drawingml/2006/main" w="0">
+            <a:noFill/>
+          </a:ln>
+        </p:spPr>
+        <p:txBody>
+          <a:bodyPr xmlns:a="http://schemas.openxmlformats.org/drawingml/2006/main" lIns="0" tIns="0" rIns="0" bIns="0"/>
+          <a:lstStyle xmlns:a="http://schemas.openxmlformats.org/drawingml/2006/main">
+            <a:defPPr>
+              <a:defRPr sz="3000" b="1">
+                <a:solidFill>
+                  <a:srgbClr val="0F52BA"/>
+                </a:solidFill>
+                <a:latin typeface="Apple SD Gothic Neo"/>
+                <a:ea typeface="Apple SD Gothic Neo"/>
+                <a:cs typeface="Apple SD Gothic Neo"/>
+              </a:defRPr>
+            </a:defPPr>
+            <a:lvl1pPr>
+              <a:defRPr sz="3000" b="1">
+                <a:solidFill>
+                  <a:srgbClr val="0F52BA"/>
+                </a:solidFill>
+                <a:latin typeface="Apple SD Gothic Neo"/>
+                <a:ea typeface="Apple SD Gothic Neo"/>
+                <a:cs typeface="Apple SD Gothic Neo"/>
+              </a:defRPr>
+            </a:lvl1pPr>
+            <a:lvl2pPr>
+              <a:defRPr sz="3000" b="1">
+                <a:solidFill>
+                  <a:srgbClr val="0F52BA"/>
+                </a:solidFill>
+                <a:latin typeface="Apple SD Gothic Neo"/>
+                <a:ea typeface="Apple SD Gothic Neo"/>
+                <a:cs typeface="Apple SD Gothic Neo"/>
+              </a:defRPr>
+            </a:lvl2pPr>
+            <a:lvl3pPr>
+              <a:defRPr sz="3000" b="1">
+                <a:solidFill>
+                  <a:srgbClr val="0F52BA"/>
+                </a:solidFill>
+                <a:latin typeface="Apple SD Gothic Neo"/>
+                <a:ea typeface="Apple SD Gothic Neo"/>
+                <a:cs typeface="Apple SD Gothic Neo"/>
+              </a:defRPr>
+            </a:lvl3pPr>
+            <a:lvl4pPr>
+              <a:defRPr sz="3000" b="1">
+                <a:solidFill>
+                  <a:srgbClr val="0F52BA"/>
+                </a:solidFill>
+                <a:latin typeface="Apple SD Gothic Neo"/>
+                <a:ea typeface="Apple SD Gothic Neo"/>
+                <a:cs typeface="Apple SD Gothic Neo"/>
+              </a:defRPr>
+            </a:lvl4pPr>
+            <a:lvl5pPr>
+              <a:defRPr sz="3000" b="1">
+                <a:solidFill>
+                  <a:srgbClr val="0F52BA"/>
+                </a:solidFill>
+                <a:latin typeface="Apple SD Gothic Neo"/>
+                <a:ea typeface="Apple SD Gothic Neo"/>
+                <a:cs typeface="Apple SD Gothic Neo"/>
+              </a:defRPr>
+            </a:lvl5pPr>
+            <a:lvl6pPr>
+              <a:defRPr sz="3000" b="1">
+                <a:solidFill>
+                  <a:srgbClr val="0F52BA"/>
+                </a:solidFill>
+                <a:latin typeface="Apple SD Gothic Neo"/>
+                <a:ea typeface="Apple SD Gothic Neo"/>
+                <a:cs typeface="Apple SD Gothic Neo"/>
+              </a:defRPr>
+            </a:lvl6pPr>
+            <a:lvl7pPr>
+              <a:defRPr sz="3000" b="1">
+                <a:solidFill>
+                  <a:srgbClr val="0F52BA"/>
+                </a:solidFill>
+                <a:latin typeface="Apple SD Gothic Neo"/>
+                <a:ea typeface="Apple SD Gothic Neo"/>
+                <a:cs typeface="Apple SD Gothic Neo"/>
+              </a:defRPr>
+            </a:lvl7pPr>
+            <a:lvl8pPr>
+              <a:defRPr sz="3000" b="1">
+                <a:solidFill>
+                  <a:srgbClr val="0F52BA"/>
+                </a:solidFill>
+                <a:latin typeface="Apple SD Gothic Neo"/>
+                <a:ea typeface="Apple SD Gothic Neo"/>
+                <a:cs typeface="Apple SD Gothic Neo"/>
+              </a:defRPr>
+            </a:lvl8pPr>
+            <a:lvl9pPr>
+              <a:defRPr sz="3000" b="1">
+                <a:solidFill>
+                  <a:srgbClr val="0F52BA"/>
+                </a:solidFill>
+                <a:latin typeface="Apple SD Gothic Neo"/>
+                <a:ea typeface="Apple SD Gothic Neo"/>
+                <a:cs typeface="Apple SD Gothic Neo"/>
+              </a:defRPr>
+            </a:lvl9pPr>
+          </a:lstStyle>
+          <a:p xmlns:a="http://schemas.openxmlformats.org/drawingml/2006/main">
+            <a:pPr>
+              <a:defRPr sz="3000" b="1">
+                <a:solidFill>
+                  <a:srgbClr val="0F52BA"/>
+                </a:solidFill>
+                <a:latin typeface="Apple SD Gothic Neo"/>
+                <a:ea typeface="Apple SD Gothic Neo"/>
+                <a:cs typeface="Apple SD Gothic Neo"/>
+              </a:defRPr>
+            </a:pPr>
+            <a:r>
+              <a:rPr sz="3000" b="1">
+                <a:solidFill>
+                  <a:srgbClr val="0F52BA"/>
+                </a:solidFill>
+                <a:latin typeface="Apple SD Gothic Neo"/>
+                <a:ea typeface="Apple SD Gothic Neo"/>
+                <a:cs typeface="Apple SD Gothic Neo"/>
+              </a:rPr>
+              <a:t>01</a:t>
+            </a:r>
+          </a:p>
+        </p:txBody>
+      </p:sp>
+      <p:sp>
+        <p:nvSpPr>
+          <p:cNvPr id="4" name="">
+            <a:extLst xmlns:a="http://schemas.openxmlformats.org/drawingml/2006/main">
+              <a:ext uri="{FF2B5EF4-FFF2-40B4-BE49-F238E27FC236}">
+                <a16:creationId xmlns:a16="http://schemas.microsoft.com/office/drawing/2014/main" id="{C421903C-E42D-4D11-9025-66C18F20E1AE}"/>
+              </a:ext>
+            </a:extLst>
+          </p:cNvPr>
+          <p:cNvSpPr>
+            <a:spLocks xmlns:a="http://schemas.openxmlformats.org/drawingml/2006/main" noGrp="1"/>
+          </p:cNvSpPr>
+          <p:nvPr/>
+        </p:nvSpPr>
+        <p:spPr>
+          <a:xfrm xmlns:a="http://schemas.openxmlformats.org/drawingml/2006/main">
+            <a:off x="1562100" y="2333625"/>
+            <a:ext cx="2857500" cy="523875"/>
+          </a:xfrm>
+          <a:prstGeom xmlns:a="http://schemas.openxmlformats.org/drawingml/2006/main" prst="rect">
+            <a:avLst/>
+          </a:prstGeom>
+          <a:noFill xmlns:a="http://schemas.openxmlformats.org/drawingml/2006/main"/>
+          <a:ln xmlns:a="http://schemas.openxmlformats.org/drawingml/2006/main" w="0">
+            <a:noFill/>
+          </a:ln>
+        </p:spPr>
+        <p:txBody>
+          <a:bodyPr xmlns:a="http://schemas.openxmlformats.org/drawingml/2006/main" lIns="0" tIns="0" rIns="0" bIns="0"/>
+          <a:lstStyle xmlns:a="http://schemas.openxmlformats.org/drawingml/2006/main">
+            <a:defPPr>
+              <a:defRPr sz="2400" b="1">
+                <a:solidFill>
+                  <a:srgbClr val="000926"/>
+                </a:solidFill>
+                <a:latin typeface="Apple SD Gothic Neo"/>
+                <a:ea typeface="Apple SD Gothic Neo"/>
+                <a:cs typeface="Apple SD Gothic Neo"/>
+              </a:defRPr>
+            </a:defPPr>
+            <a:lvl1pPr>
+              <a:defRPr sz="2400" b="1">
+                <a:solidFill>
+                  <a:srgbClr val="000926"/>
+                </a:solidFill>
+                <a:latin typeface="Apple SD Gothic Neo"/>
+                <a:ea typeface="Apple SD Gothic Neo"/>
+                <a:cs typeface="Apple SD Gothic Neo"/>
+              </a:defRPr>
+            </a:lvl1pPr>
+            <a:lvl2pPr>
+              <a:defRPr sz="2400" b="1">
+                <a:solidFill>
+                  <a:srgbClr val="000926"/>
+                </a:solidFill>
+                <a:latin typeface="Apple SD Gothic Neo"/>
+                <a:ea typeface="Apple SD Gothic Neo"/>
+                <a:cs typeface="Apple SD Gothic Neo"/>
+              </a:defRPr>
+            </a:lvl2pPr>
+            <a:lvl3pPr>
+              <a:defRPr sz="2400" b="1">
+                <a:solidFill>
+                  <a:srgbClr val="000926"/>
+                </a:solidFill>
+                <a:latin typeface="Apple SD Gothic Neo"/>
+                <a:ea typeface="Apple SD Gothic Neo"/>
+                <a:cs typeface="Apple SD Gothic Neo"/>
+              </a:defRPr>
+            </a:lvl3pPr>
+            <a:lvl4pPr>
+              <a:defRPr sz="2400" b="1">
+                <a:solidFill>
+                  <a:srgbClr val="000926"/>
+                </a:solidFill>
+                <a:latin typeface="Apple SD Gothic Neo"/>
+                <a:ea typeface="Apple SD Gothic Neo"/>
+                <a:cs typeface="Apple SD Gothic Neo"/>
+              </a:defRPr>
+            </a:lvl4pPr>
+            <a:lvl5pPr>
+              <a:defRPr sz="2400" b="1">
+                <a:solidFill>
+                  <a:srgbClr val="000926"/>
+                </a:solidFill>
+                <a:latin typeface="Apple SD Gothic Neo"/>
+                <a:ea typeface="Apple SD Gothic Neo"/>
+                <a:cs typeface="Apple SD Gothic Neo"/>
+              </a:defRPr>
+            </a:lvl5pPr>
+            <a:lvl6pPr>
+              <a:defRPr sz="2400" b="1">
+                <a:solidFill>
+                  <a:srgbClr val="000926"/>
+                </a:solidFill>
+                <a:latin typeface="Apple SD Gothic Neo"/>
+                <a:ea typeface="Apple SD Gothic Neo"/>
+                <a:cs typeface="Apple SD Gothic Neo"/>
+              </a:defRPr>
+            </a:lvl6pPr>
+            <a:lvl7pPr>
+              <a:defRPr sz="2400" b="1">
+                <a:solidFill>
+                  <a:srgbClr val="000926"/>
+                </a:solidFill>
+                <a:latin typeface="Apple SD Gothic Neo"/>
+                <a:ea typeface="Apple SD Gothic Neo"/>
+                <a:cs typeface="Apple SD Gothic Neo"/>
+              </a:defRPr>
+            </a:lvl7pPr>
+            <a:lvl8pPr>
+              <a:defRPr sz="2400" b="1">
+                <a:solidFill>
+                  <a:srgbClr val="000926"/>
+                </a:solidFill>
+                <a:latin typeface="Apple SD Gothic Neo"/>
+                <a:ea typeface="Apple SD Gothic Neo"/>
+                <a:cs typeface="Apple SD Gothic Neo"/>
+              </a:defRPr>
+            </a:lvl8pPr>
+            <a:lvl9pPr>
+              <a:defRPr sz="2400" b="1">
+                <a:solidFill>
+                  <a:srgbClr val="000926"/>
+                </a:solidFill>
+                <a:latin typeface="Apple SD Gothic Neo"/>
+                <a:ea typeface="Apple SD Gothic Neo"/>
+                <a:cs typeface="Apple SD Gothic Neo"/>
+              </a:defRPr>
+            </a:lvl9pPr>
+          </a:lstStyle>
+          <a:p xmlns:a="http://schemas.openxmlformats.org/drawingml/2006/main">
+            <a:pPr>
+              <a:defRPr sz="2400" b="1">
+                <a:solidFill>
+                  <a:srgbClr val="000926"/>
+                </a:solidFill>
+                <a:latin typeface="Apple SD Gothic Neo"/>
+                <a:ea typeface="Apple SD Gothic Neo"/>
+                <a:cs typeface="Apple SD Gothic Neo"/>
+              </a:defRPr>
+            </a:pPr>
+            <a:r>
+              <a:rPr sz="2400" b="1">
+                <a:solidFill>
+                  <a:srgbClr val="000926"/>
+                </a:solidFill>
+                <a:latin typeface="Apple SD Gothic Neo"/>
+                <a:ea typeface="Apple SD Gothic Neo"/>
+                <a:cs typeface="Apple SD Gothic Neo"/>
+              </a:rPr>
+              <a:t>긴 원고 지원</a:t>
+            </a:r>
+          </a:p>
+        </p:txBody>
+      </p:sp>
+      <p:sp>
+        <p:nvSpPr>
+          <p:cNvPr id="5" name="">
+            <a:extLst xmlns:a="http://schemas.openxmlformats.org/drawingml/2006/main">
+              <a:ext uri="{FF2B5EF4-FFF2-40B4-BE49-F238E27FC236}">
+                <a16:creationId xmlns:a16="http://schemas.microsoft.com/office/drawing/2014/main" id="{B276DB02-3310-44DF-B6A5-94AF59632E23}"/>
+              </a:ext>
+            </a:extLst>
+          </p:cNvPr>
+          <p:cNvSpPr>
+            <a:spLocks xmlns:a="http://schemas.openxmlformats.org/drawingml/2006/main" noGrp="1"/>
+          </p:cNvSpPr>
+          <p:nvPr/>
+        </p:nvSpPr>
+        <p:spPr>
+          <a:xfrm xmlns:a="http://schemas.openxmlformats.org/drawingml/2006/main">
+            <a:off x="4610100" y="2333625"/>
+            <a:ext cx="6953250" cy="809625"/>
+          </a:xfrm>
+          <a:prstGeom xmlns:a="http://schemas.openxmlformats.org/drawingml/2006/main" prst="rect">
+            <a:avLst/>
+          </a:prstGeom>
+          <a:noFill xmlns:a="http://schemas.openxmlformats.org/drawingml/2006/main"/>
+          <a:ln xmlns:a="http://schemas.openxmlformats.org/drawingml/2006/main" w="0">
+            <a:noFill/>
+          </a:ln>
+        </p:spPr>
+        <p:txBody>
+          <a:bodyPr xmlns:a="http://schemas.openxmlformats.org/drawingml/2006/main" lIns="0" tIns="0" rIns="0" bIns="0"/>
+          <a:lstStyle xmlns:a="http://schemas.openxmlformats.org/drawingml/2006/main">
+            <a:defPPr>
+              <a:defRPr sz="2100" b="0">
+                <a:solidFill>
+                  <a:srgbClr val="172B45"/>
+                </a:solidFill>
+                <a:latin typeface="Apple SD Gothic Neo"/>
+                <a:ea typeface="Apple SD Gothic Neo"/>
+                <a:cs typeface="Apple SD Gothic Neo"/>
+              </a:defRPr>
+            </a:defPPr>
+            <a:lvl1pPr>
+              <a:defRPr sz="2100" b="0">
+                <a:solidFill>
+                  <a:srgbClr val="172B45"/>
+                </a:solidFill>
+                <a:latin typeface="Apple SD Gothic Neo"/>
+                <a:ea typeface="Apple SD Gothic Neo"/>
+                <a:cs typeface="Apple SD Gothic Neo"/>
+              </a:defRPr>
+            </a:lvl1pPr>
+            <a:lvl2pPr>
+              <a:defRPr sz="2100" b="0">
+                <a:solidFill>
+                  <a:srgbClr val="172B45"/>
+                </a:solidFill>
+                <a:latin typeface="Apple SD Gothic Neo"/>
+                <a:ea typeface="Apple SD Gothic Neo"/>
+                <a:cs typeface="Apple SD Gothic Neo"/>
+              </a:defRPr>
+            </a:lvl2pPr>
+            <a:lvl3pPr>
+              <a:defRPr sz="2100" b="0">
+                <a:solidFill>
+                  <a:srgbClr val="172B45"/>
+                </a:solidFill>
+                <a:latin typeface="Apple SD Gothic Neo"/>
+                <a:ea typeface="Apple SD Gothic Neo"/>
+                <a:cs typeface="Apple SD Gothic Neo"/>
+              </a:defRPr>
+            </a:lvl3pPr>
+            <a:lvl4pPr>
+              <a:defRPr sz="2100" b="0">
+                <a:solidFill>
+                  <a:srgbClr val="172B45"/>
+                </a:solidFill>
+                <a:latin typeface="Apple SD Gothic Neo"/>
+                <a:ea typeface="Apple SD Gothic Neo"/>
+                <a:cs typeface="Apple SD Gothic Neo"/>
+              </a:defRPr>
+            </a:lvl4pPr>
+            <a:lvl5pPr>
+              <a:defRPr sz="2100" b="0">
+                <a:solidFill>
+                  <a:srgbClr val="172B45"/>
+                </a:solidFill>
+                <a:latin typeface="Apple SD Gothic Neo"/>
+                <a:ea typeface="Apple SD Gothic Neo"/>
+                <a:cs typeface="Apple SD Gothic Neo"/>
+              </a:defRPr>
+            </a:lvl5pPr>
+            <a:lvl6pPr>
+              <a:defRPr sz="2100" b="0">
+                <a:solidFill>
+                  <a:srgbClr val="172B45"/>
+                </a:solidFill>
+                <a:latin typeface="Apple SD Gothic Neo"/>
+                <a:ea typeface="Apple SD Gothic Neo"/>
+                <a:cs typeface="Apple SD Gothic Neo"/>
+              </a:defRPr>
+            </a:lvl6pPr>
+            <a:lvl7pPr>
+              <a:defRPr sz="2100" b="0">
+                <a:solidFill>
+                  <a:srgbClr val="172B45"/>
+                </a:solidFill>
+                <a:latin typeface="Apple SD Gothic Neo"/>
+                <a:ea typeface="Apple SD Gothic Neo"/>
+                <a:cs typeface="Apple SD Gothic Neo"/>
+              </a:defRPr>
+            </a:lvl7pPr>
+            <a:lvl8pPr>
+              <a:defRPr sz="2100" b="0">
+                <a:solidFill>
+                  <a:srgbClr val="172B45"/>
+                </a:solidFill>
+                <a:latin typeface="Apple SD Gothic Neo"/>
+                <a:ea typeface="Apple SD Gothic Neo"/>
+                <a:cs typeface="Apple SD Gothic Neo"/>
+              </a:defRPr>
+            </a:lvl8pPr>
+            <a:lvl9pPr>
+              <a:defRPr sz="2100" b="0">
+                <a:solidFill>
+                  <a:srgbClr val="172B45"/>
+                </a:solidFill>
+                <a:latin typeface="Apple SD Gothic Neo"/>
+                <a:ea typeface="Apple SD Gothic Neo"/>
+                <a:cs typeface="Apple SD Gothic Neo"/>
+              </a:defRPr>
+            </a:lvl9pPr>
+          </a:lstStyle>
+          <a:p xmlns:a="http://schemas.openxmlformats.org/drawingml/2006/main">
+            <a:pPr>
+              <a:defRPr sz="2100" b="0">
+                <a:solidFill>
+                  <a:srgbClr val="172B45"/>
+                </a:solidFill>
+                <a:latin typeface="Apple SD Gothic Neo"/>
+                <a:ea typeface="Apple SD Gothic Neo"/>
+                <a:cs typeface="Apple SD Gothic Neo"/>
+              </a:defRPr>
+            </a:pPr>
+            <a:r>
+              <a:rPr sz="2100" b="0">
+                <a:solidFill>
+                  <a:srgbClr val="172B45"/>
+                </a:solidFill>
+                <a:latin typeface="Apple SD Gothic Neo"/>
+                <a:ea typeface="Apple SD Gothic Neo"/>
+                <a:cs typeface="Apple SD Gothic Neo"/>
+              </a:rPr>
+              <a:t>장면·설정 단위 RAG 검색</a:t>
+            </a:r>
+          </a:p>
+          <a:p xmlns:a="http://schemas.openxmlformats.org/drawingml/2006/main">
+            <a:pPr>
+              <a:defRPr sz="2100" b="0">
+                <a:solidFill>
+                  <a:srgbClr val="172B45"/>
+                </a:solidFill>
+                <a:latin typeface="Apple SD Gothic Neo"/>
+                <a:ea typeface="Apple SD Gothic Neo"/>
+                <a:cs typeface="Apple SD Gothic Neo"/>
+              </a:defRPr>
+            </a:pPr>
+            <a:r>
+              <a:rPr sz="2100" b="0">
+                <a:solidFill>
+                  <a:srgbClr val="172B45"/>
+                </a:solidFill>
+                <a:latin typeface="Apple SD Gothic Neo"/>
+                <a:ea typeface="Apple SD Gothic Neo"/>
+                <a:cs typeface="Apple SD Gothic Neo"/>
+              </a:rPr>
+              <a:t>관련 예외까지 찾는지 함께 평가</a:t>
+            </a:r>
+          </a:p>
+        </p:txBody>
+      </p:sp>
+      <p:sp>
+        <p:nvSpPr>
+          <p:cNvPr id="6" name="">
+            <a:extLst xmlns:a="http://schemas.openxmlformats.org/drawingml/2006/main">
+              <a:ext uri="{FF2B5EF4-FFF2-40B4-BE49-F238E27FC236}">
+                <a16:creationId xmlns:a16="http://schemas.microsoft.com/office/drawing/2014/main" id="{54E15F1C-632E-4C46-B46E-726A77BEBC99}"/>
+              </a:ext>
+            </a:extLst>
+          </p:cNvPr>
+          <p:cNvSpPr>
+            <a:spLocks xmlns:a="http://schemas.openxmlformats.org/drawingml/2006/main" noGrp="1"/>
+          </p:cNvSpPr>
+          <p:nvPr/>
+        </p:nvSpPr>
+        <p:spPr>
+          <a:xfrm xmlns:a="http://schemas.openxmlformats.org/drawingml/2006/main">
+            <a:off x="609600" y="3505200"/>
+            <a:ext cx="762000" cy="523875"/>
+          </a:xfrm>
+          <a:prstGeom xmlns:a="http://schemas.openxmlformats.org/drawingml/2006/main" prst="rect">
+            <a:avLst/>
+          </a:prstGeom>
+          <a:noFill xmlns:a="http://schemas.openxmlformats.org/drawingml/2006/main"/>
+          <a:ln xmlns:a="http://schemas.openxmlformats.org/drawingml/2006/main" w="0">
+            <a:noFill/>
+          </a:ln>
+        </p:spPr>
+        <p:txBody>
+          <a:bodyPr xmlns:a="http://schemas.openxmlformats.org/drawingml/2006/main" lIns="0" tIns="0" rIns="0" bIns="0"/>
+          <a:lstStyle xmlns:a="http://schemas.openxmlformats.org/drawingml/2006/main">
+            <a:defPPr>
+              <a:defRPr sz="3000" b="1">
+                <a:solidFill>
+                  <a:srgbClr val="0F52BA"/>
+                </a:solidFill>
+                <a:latin typeface="Apple SD Gothic Neo"/>
+                <a:ea typeface="Apple SD Gothic Neo"/>
+                <a:cs typeface="Apple SD Gothic Neo"/>
+              </a:defRPr>
+            </a:defPPr>
+            <a:lvl1pPr>
+              <a:defRPr sz="3000" b="1">
+                <a:solidFill>
+                  <a:srgbClr val="0F52BA"/>
+                </a:solidFill>
+                <a:latin typeface="Apple SD Gothic Neo"/>
+                <a:ea typeface="Apple SD Gothic Neo"/>
+                <a:cs typeface="Apple SD Gothic Neo"/>
+              </a:defRPr>
+            </a:lvl1pPr>
+            <a:lvl2pPr>
+              <a:defRPr sz="3000" b="1">
+                <a:solidFill>
+                  <a:srgbClr val="0F52BA"/>
+                </a:solidFill>
+                <a:latin typeface="Apple SD Gothic Neo"/>
+                <a:ea typeface="Apple SD Gothic Neo"/>
+                <a:cs typeface="Apple SD Gothic Neo"/>
+              </a:defRPr>
+            </a:lvl2pPr>
+            <a:lvl3pPr>
+              <a:defRPr sz="3000" b="1">
+                <a:solidFill>
+                  <a:srgbClr val="0F52BA"/>
+                </a:solidFill>
+                <a:latin typeface="Apple SD Gothic Neo"/>
+                <a:ea typeface="Apple SD Gothic Neo"/>
+                <a:cs typeface="Apple SD Gothic Neo"/>
+              </a:defRPr>
+            </a:lvl3pPr>
+            <a:lvl4pPr>
+              <a:defRPr sz="3000" b="1">
+                <a:solidFill>
+                  <a:srgbClr val="0F52BA"/>
+                </a:solidFill>
+                <a:latin typeface="Apple SD Gothic Neo"/>
+                <a:ea typeface="Apple SD Gothic Neo"/>
+                <a:cs typeface="Apple SD Gothic Neo"/>
+              </a:defRPr>
+            </a:lvl4pPr>
+            <a:lvl5pPr>
+              <a:defRPr sz="3000" b="1">
+                <a:solidFill>
+                  <a:srgbClr val="0F52BA"/>
+                </a:solidFill>
+                <a:latin typeface="Apple SD Gothic Neo"/>
+                <a:ea typeface="Apple SD Gothic Neo"/>
+                <a:cs typeface="Apple SD Gothic Neo"/>
+              </a:defRPr>
+            </a:lvl5pPr>
+            <a:lvl6pPr>
+              <a:defRPr sz="3000" b="1">
+                <a:solidFill>
+                  <a:srgbClr val="0F52BA"/>
+                </a:solidFill>
+                <a:latin typeface="Apple SD Gothic Neo"/>
+                <a:ea typeface="Apple SD Gothic Neo"/>
+                <a:cs typeface="Apple SD Gothic Neo"/>
+              </a:defRPr>
+            </a:lvl6pPr>
+            <a:lvl7pPr>
+              <a:defRPr sz="3000" b="1">
+                <a:solidFill>
+                  <a:srgbClr val="0F52BA"/>
+                </a:solidFill>
+                <a:latin typeface="Apple SD Gothic Neo"/>
+                <a:ea typeface="Apple SD Gothic Neo"/>
+                <a:cs typeface="Apple SD Gothic Neo"/>
+              </a:defRPr>
+            </a:lvl7pPr>
+            <a:lvl8pPr>
+              <a:defRPr sz="3000" b="1">
+                <a:solidFill>
+                  <a:srgbClr val="0F52BA"/>
+                </a:solidFill>
+                <a:latin typeface="Apple SD Gothic Neo"/>
+                <a:ea typeface="Apple SD Gothic Neo"/>
+                <a:cs typeface="Apple SD Gothic Neo"/>
+              </a:defRPr>
+            </a:lvl8pPr>
+            <a:lvl9pPr>
+              <a:defRPr sz="3000" b="1">
+                <a:solidFill>
+                  <a:srgbClr val="0F52BA"/>
+                </a:solidFill>
+                <a:latin typeface="Apple SD Gothic Neo"/>
+                <a:ea typeface="Apple SD Gothic Neo"/>
+                <a:cs typeface="Apple SD Gothic Neo"/>
+              </a:defRPr>
+            </a:lvl9pPr>
+          </a:lstStyle>
+          <a:p xmlns:a="http://schemas.openxmlformats.org/drawingml/2006/main">
+            <a:pPr>
+              <a:defRPr sz="3000" b="1">
+                <a:solidFill>
+                  <a:srgbClr val="0F52BA"/>
+                </a:solidFill>
+                <a:latin typeface="Apple SD Gothic Neo"/>
+                <a:ea typeface="Apple SD Gothic Neo"/>
+                <a:cs typeface="Apple SD Gothic Neo"/>
+              </a:defRPr>
+            </a:pPr>
+            <a:r>
+              <a:rPr sz="3000" b="1">
+                <a:solidFill>
+                  <a:srgbClr val="0F52BA"/>
+                </a:solidFill>
+                <a:latin typeface="Apple SD Gothic Neo"/>
+                <a:ea typeface="Apple SD Gothic Neo"/>
+                <a:cs typeface="Apple SD Gothic Neo"/>
+              </a:rPr>
+              <a:t>02</a:t>
+            </a:r>
+          </a:p>
+        </p:txBody>
+      </p:sp>
+      <p:sp>
+        <p:nvSpPr>
+          <p:cNvPr id="7" name="">
+            <a:extLst xmlns:a="http://schemas.openxmlformats.org/drawingml/2006/main">
+              <a:ext uri="{FF2B5EF4-FFF2-40B4-BE49-F238E27FC236}">
+                <a16:creationId xmlns:a16="http://schemas.microsoft.com/office/drawing/2014/main" id="{C087B55D-F035-4EA5-B0B5-65AF9DD91738}"/>
+              </a:ext>
+            </a:extLst>
+          </p:cNvPr>
+          <p:cNvSpPr>
+            <a:spLocks xmlns:a="http://schemas.openxmlformats.org/drawingml/2006/main" noGrp="1"/>
+          </p:cNvSpPr>
+          <p:nvPr/>
+        </p:nvSpPr>
+        <p:spPr>
+          <a:xfrm xmlns:a="http://schemas.openxmlformats.org/drawingml/2006/main">
+            <a:off x="1562100" y="3505200"/>
+            <a:ext cx="2857500" cy="523875"/>
+          </a:xfrm>
+          <a:prstGeom xmlns:a="http://schemas.openxmlformats.org/drawingml/2006/main" prst="rect">
+            <a:avLst/>
+          </a:prstGeom>
+          <a:noFill xmlns:a="http://schemas.openxmlformats.org/drawingml/2006/main"/>
+          <a:ln xmlns:a="http://schemas.openxmlformats.org/drawingml/2006/main" w="0">
+            <a:noFill/>
+          </a:ln>
+        </p:spPr>
+        <p:txBody>
+          <a:bodyPr xmlns:a="http://schemas.openxmlformats.org/drawingml/2006/main" lIns="0" tIns="0" rIns="0" bIns="0"/>
+          <a:lstStyle xmlns:a="http://schemas.openxmlformats.org/drawingml/2006/main">
+            <a:defPPr>
+              <a:defRPr sz="2400" b="1">
+                <a:solidFill>
+                  <a:srgbClr val="000926"/>
+                </a:solidFill>
+                <a:latin typeface="Apple SD Gothic Neo"/>
+                <a:ea typeface="Apple SD Gothic Neo"/>
+                <a:cs typeface="Apple SD Gothic Neo"/>
+              </a:defRPr>
+            </a:defPPr>
+            <a:lvl1pPr>
+              <a:defRPr sz="2400" b="1">
+                <a:solidFill>
+                  <a:srgbClr val="000926"/>
+                </a:solidFill>
+                <a:latin typeface="Apple SD Gothic Neo"/>
+                <a:ea typeface="Apple SD Gothic Neo"/>
+                <a:cs typeface="Apple SD Gothic Neo"/>
+              </a:defRPr>
+            </a:lvl1pPr>
+            <a:lvl2pPr>
+              <a:defRPr sz="2400" b="1">
+                <a:solidFill>
+                  <a:srgbClr val="000926"/>
+                </a:solidFill>
+                <a:latin typeface="Apple SD Gothic Neo"/>
+                <a:ea typeface="Apple SD Gothic Neo"/>
+                <a:cs typeface="Apple SD Gothic Neo"/>
+              </a:defRPr>
+            </a:lvl2pPr>
+            <a:lvl3pPr>
+              <a:defRPr sz="2400" b="1">
+                <a:solidFill>
+                  <a:srgbClr val="000926"/>
+                </a:solidFill>
+                <a:latin typeface="Apple SD Gothic Neo"/>
+                <a:ea typeface="Apple SD Gothic Neo"/>
+                <a:cs typeface="Apple SD Gothic Neo"/>
+              </a:defRPr>
+            </a:lvl3pPr>
+            <a:lvl4pPr>
+              <a:defRPr sz="2400" b="1">
+                <a:solidFill>
+                  <a:srgbClr val="000926"/>
+                </a:solidFill>
+                <a:latin typeface="Apple SD Gothic Neo"/>
+                <a:ea typeface="Apple SD Gothic Neo"/>
+                <a:cs typeface="Apple SD Gothic Neo"/>
+              </a:defRPr>
+            </a:lvl4pPr>
+            <a:lvl5pPr>
+              <a:defRPr sz="2400" b="1">
+                <a:solidFill>
+                  <a:srgbClr val="000926"/>
+                </a:solidFill>
+                <a:latin typeface="Apple SD Gothic Neo"/>
+                <a:ea typeface="Apple SD Gothic Neo"/>
+                <a:cs typeface="Apple SD Gothic Neo"/>
+              </a:defRPr>
+            </a:lvl5pPr>
+            <a:lvl6pPr>
+              <a:defRPr sz="2400" b="1">
+                <a:solidFill>
+                  <a:srgbClr val="000926"/>
+                </a:solidFill>
+                <a:latin typeface="Apple SD Gothic Neo"/>
+                <a:ea typeface="Apple SD Gothic Neo"/>
+                <a:cs typeface="Apple SD Gothic Neo"/>
+              </a:defRPr>
+            </a:lvl6pPr>
+            <a:lvl7pPr>
+              <a:defRPr sz="2400" b="1">
+                <a:solidFill>
+                  <a:srgbClr val="000926"/>
+                </a:solidFill>
+                <a:latin typeface="Apple SD Gothic Neo"/>
+                <a:ea typeface="Apple SD Gothic Neo"/>
+                <a:cs typeface="Apple SD Gothic Neo"/>
+              </a:defRPr>
+            </a:lvl7pPr>
+            <a:lvl8pPr>
+              <a:defRPr sz="2400" b="1">
+                <a:solidFill>
+                  <a:srgbClr val="000926"/>
+                </a:solidFill>
+                <a:latin typeface="Apple SD Gothic Neo"/>
+                <a:ea typeface="Apple SD Gothic Neo"/>
+                <a:cs typeface="Apple SD Gothic Neo"/>
+              </a:defRPr>
+            </a:lvl8pPr>
+            <a:lvl9pPr>
+              <a:defRPr sz="2400" b="1">
+                <a:solidFill>
+                  <a:srgbClr val="000926"/>
+                </a:solidFill>
+                <a:latin typeface="Apple SD Gothic Neo"/>
+                <a:ea typeface="Apple SD Gothic Neo"/>
+                <a:cs typeface="Apple SD Gothic Neo"/>
+              </a:defRPr>
+            </a:lvl9pPr>
+          </a:lstStyle>
+          <a:p xmlns:a="http://schemas.openxmlformats.org/drawingml/2006/main">
+            <a:pPr>
+              <a:defRPr sz="2400" b="1">
+                <a:solidFill>
+                  <a:srgbClr val="000926"/>
+                </a:solidFill>
+                <a:latin typeface="Apple SD Gothic Neo"/>
+                <a:ea typeface="Apple SD Gothic Neo"/>
+                <a:cs typeface="Apple SD Gothic Neo"/>
+              </a:defRPr>
+            </a:pPr>
+            <a:r>
+              <a:rPr sz="2400" b="1">
+                <a:solidFill>
+                  <a:srgbClr val="000926"/>
+                </a:solidFill>
+                <a:latin typeface="Apple SD Gothic Neo"/>
+                <a:ea typeface="Apple SD Gothic Neo"/>
+                <a:cs typeface="Apple SD Gothic Neo"/>
+              </a:rPr>
+              <a:t>검토 품질 평가</a:t>
+            </a:r>
+          </a:p>
+        </p:txBody>
+      </p:sp>
+      <p:sp>
+        <p:nvSpPr>
+          <p:cNvPr id="8" name="">
+            <a:extLst xmlns:a="http://schemas.openxmlformats.org/drawingml/2006/main">
+              <a:ext uri="{FF2B5EF4-FFF2-40B4-BE49-F238E27FC236}">
+                <a16:creationId xmlns:a16="http://schemas.microsoft.com/office/drawing/2014/main" id="{AB6046B2-56BC-40A7-98C6-E8360FAE5CA9}"/>
+              </a:ext>
+            </a:extLst>
+          </p:cNvPr>
+          <p:cNvSpPr>
+            <a:spLocks xmlns:a="http://schemas.openxmlformats.org/drawingml/2006/main" noGrp="1"/>
+          </p:cNvSpPr>
+          <p:nvPr/>
+        </p:nvSpPr>
+        <p:spPr>
+          <a:xfrm xmlns:a="http://schemas.openxmlformats.org/drawingml/2006/main">
+            <a:off x="4610100" y="3505200"/>
+            <a:ext cx="6953250" cy="809625"/>
+          </a:xfrm>
+          <a:prstGeom xmlns:a="http://schemas.openxmlformats.org/drawingml/2006/main" prst="rect">
+            <a:avLst/>
+          </a:prstGeom>
+          <a:noFill xmlns:a="http://schemas.openxmlformats.org/drawingml/2006/main"/>
+          <a:ln xmlns:a="http://schemas.openxmlformats.org/drawingml/2006/main" w="0">
+            <a:noFill/>
+          </a:ln>
+        </p:spPr>
+        <p:txBody>
+          <a:bodyPr xmlns:a="http://schemas.openxmlformats.org/drawingml/2006/main" lIns="0" tIns="0" rIns="0" bIns="0"/>
+          <a:lstStyle xmlns:a="http://schemas.openxmlformats.org/drawingml/2006/main">
+            <a:defPPr>
+              <a:defRPr sz="2100" b="0">
+                <a:solidFill>
+                  <a:srgbClr val="172B45"/>
+                </a:solidFill>
+                <a:latin typeface="Apple SD Gothic Neo"/>
+                <a:ea typeface="Apple SD Gothic Neo"/>
+                <a:cs typeface="Apple SD Gothic Neo"/>
+              </a:defRPr>
+            </a:defPPr>
+            <a:lvl1pPr>
+              <a:defRPr sz="2100" b="0">
+                <a:solidFill>
+                  <a:srgbClr val="172B45"/>
+                </a:solidFill>
+                <a:latin typeface="Apple SD Gothic Neo"/>
+                <a:ea typeface="Apple SD Gothic Neo"/>
+                <a:cs typeface="Apple SD Gothic Neo"/>
+              </a:defRPr>
+            </a:lvl1pPr>
+            <a:lvl2pPr>
+              <a:defRPr sz="2100" b="0">
+                <a:solidFill>
+                  <a:srgbClr val="172B45"/>
+                </a:solidFill>
+                <a:latin typeface="Apple SD Gothic Neo"/>
+                <a:ea typeface="Apple SD Gothic Neo"/>
+                <a:cs typeface="Apple SD Gothic Neo"/>
+              </a:defRPr>
+            </a:lvl2pPr>
+            <a:lvl3pPr>
+              <a:defRPr sz="2100" b="0">
+                <a:solidFill>
+                  <a:srgbClr val="172B45"/>
+                </a:solidFill>
+                <a:latin typeface="Apple SD Gothic Neo"/>
+                <a:ea typeface="Apple SD Gothic Neo"/>
+                <a:cs typeface="Apple SD Gothic Neo"/>
+              </a:defRPr>
+            </a:lvl3pPr>
+            <a:lvl4pPr>
+              <a:defRPr sz="2100" b="0">
+                <a:solidFill>
+                  <a:srgbClr val="172B45"/>
+                </a:solidFill>
+                <a:latin typeface="Apple SD Gothic Neo"/>
+                <a:ea typeface="Apple SD Gothic Neo"/>
+                <a:cs typeface="Apple SD Gothic Neo"/>
+              </a:defRPr>
+            </a:lvl4pPr>
+            <a:lvl5pPr>
+              <a:defRPr sz="2100" b="0">
+                <a:solidFill>
+                  <a:srgbClr val="172B45"/>
+                </a:solidFill>
+                <a:latin typeface="Apple SD Gothic Neo"/>
+                <a:ea typeface="Apple SD Gothic Neo"/>
+                <a:cs typeface="Apple SD Gothic Neo"/>
+              </a:defRPr>
+            </a:lvl5pPr>
+            <a:lvl6pPr>
+              <a:defRPr sz="2100" b="0">
+                <a:solidFill>
+                  <a:srgbClr val="172B45"/>
+                </a:solidFill>
+                <a:latin typeface="Apple SD Gothic Neo"/>
+                <a:ea typeface="Apple SD Gothic Neo"/>
+                <a:cs typeface="Apple SD Gothic Neo"/>
+              </a:defRPr>
+            </a:lvl6pPr>
+            <a:lvl7pPr>
+              <a:defRPr sz="2100" b="0">
+                <a:solidFill>
+                  <a:srgbClr val="172B45"/>
+                </a:solidFill>
+                <a:latin typeface="Apple SD Gothic Neo"/>
+                <a:ea typeface="Apple SD Gothic Neo"/>
+                <a:cs typeface="Apple SD Gothic Neo"/>
+              </a:defRPr>
+            </a:lvl7pPr>
+            <a:lvl8pPr>
+              <a:defRPr sz="2100" b="0">
+                <a:solidFill>
+                  <a:srgbClr val="172B45"/>
+                </a:solidFill>
+                <a:latin typeface="Apple SD Gothic Neo"/>
+                <a:ea typeface="Apple SD Gothic Neo"/>
+                <a:cs typeface="Apple SD Gothic Neo"/>
+              </a:defRPr>
+            </a:lvl8pPr>
+            <a:lvl9pPr>
+              <a:defRPr sz="2100" b="0">
+                <a:solidFill>
+                  <a:srgbClr val="172B45"/>
+                </a:solidFill>
+                <a:latin typeface="Apple SD Gothic Neo"/>
+                <a:ea typeface="Apple SD Gothic Neo"/>
+                <a:cs typeface="Apple SD Gothic Neo"/>
+              </a:defRPr>
+            </a:lvl9pPr>
+          </a:lstStyle>
+          <a:p xmlns:a="http://schemas.openxmlformats.org/drawingml/2006/main">
+            <a:pPr>
+              <a:defRPr sz="2100" b="0">
+                <a:solidFill>
+                  <a:srgbClr val="172B45"/>
+                </a:solidFill>
+                <a:latin typeface="Apple SD Gothic Neo"/>
+                <a:ea typeface="Apple SD Gothic Neo"/>
+                <a:cs typeface="Apple SD Gothic Neo"/>
+              </a:defRPr>
+            </a:pPr>
+            <a:r>
+              <a:rPr sz="2100" b="0">
+                <a:solidFill>
+                  <a:srgbClr val="172B45"/>
+                </a:solidFill>
+                <a:latin typeface="Apple SD Gothic Neo"/>
+                <a:ea typeface="Apple SD Gothic Neo"/>
+                <a:cs typeface="Apple SD Gothic Neo"/>
+              </a:rPr>
+              <a:t>다양한 원고와 작성자 판단으로</a:t>
+            </a:r>
+          </a:p>
+          <a:p xmlns:a="http://schemas.openxmlformats.org/drawingml/2006/main">
+            <a:pPr>
+              <a:defRPr sz="2100" b="0">
+                <a:solidFill>
+                  <a:srgbClr val="172B45"/>
+                </a:solidFill>
+                <a:latin typeface="Apple SD Gothic Neo"/>
+                <a:ea typeface="Apple SD Gothic Neo"/>
+                <a:cs typeface="Apple SD Gothic Neo"/>
+              </a:defRPr>
+            </a:pPr>
+            <a:r>
+              <a:rPr sz="2100" b="0">
+                <a:solidFill>
+                  <a:srgbClr val="172B45"/>
+                </a:solidFill>
+                <a:latin typeface="Apple SD Gothic Neo"/>
+                <a:ea typeface="Apple SD Gothic Neo"/>
+                <a:cs typeface="Apple SD Gothic Neo"/>
+              </a:rPr>
+              <a:t>오탐과 놓친 문제를 함께 확인</a:t>
+            </a:r>
+          </a:p>
+        </p:txBody>
+      </p:sp>
+      <p:sp>
+        <p:nvSpPr>
+          <p:cNvPr id="9" name="">
+            <a:extLst xmlns:a="http://schemas.openxmlformats.org/drawingml/2006/main">
+              <a:ext uri="{FF2B5EF4-FFF2-40B4-BE49-F238E27FC236}">
+                <a16:creationId xmlns:a16="http://schemas.microsoft.com/office/drawing/2014/main" id="{7AF797E1-0CE6-4216-9A68-FFAF0F42E742}"/>
+              </a:ext>
+            </a:extLst>
+          </p:cNvPr>
+          <p:cNvSpPr>
+            <a:spLocks xmlns:a="http://schemas.openxmlformats.org/drawingml/2006/main" noGrp="1"/>
+          </p:cNvSpPr>
+          <p:nvPr/>
+        </p:nvSpPr>
+        <p:spPr>
+          <a:xfrm xmlns:a="http://schemas.openxmlformats.org/drawingml/2006/main">
+            <a:off x="609600" y="4676775"/>
+            <a:ext cx="762000" cy="523875"/>
+          </a:xfrm>
+          <a:prstGeom xmlns:a="http://schemas.openxmlformats.org/drawingml/2006/main" prst="rect">
+            <a:avLst/>
+          </a:prstGeom>
+          <a:noFill xmlns:a="http://schemas.openxmlformats.org/drawingml/2006/main"/>
+          <a:ln xmlns:a="http://schemas.openxmlformats.org/drawingml/2006/main" w="0">
+            <a:noFill/>
+          </a:ln>
+        </p:spPr>
+        <p:txBody>
+          <a:bodyPr xmlns:a="http://schemas.openxmlformats.org/drawingml/2006/main" lIns="0" tIns="0" rIns="0" bIns="0"/>
+          <a:lstStyle xmlns:a="http://schemas.openxmlformats.org/drawingml/2006/main">
+            <a:defPPr>
+              <a:defRPr sz="3000" b="1">
+                <a:solidFill>
+                  <a:srgbClr val="0F52BA"/>
+                </a:solidFill>
+                <a:latin typeface="Apple SD Gothic Neo"/>
+                <a:ea typeface="Apple SD Gothic Neo"/>
+                <a:cs typeface="Apple SD Gothic Neo"/>
+              </a:defRPr>
+            </a:defPPr>
+            <a:lvl1pPr>
+              <a:defRPr sz="3000" b="1">
+                <a:solidFill>
+                  <a:srgbClr val="0F52BA"/>
+                </a:solidFill>
+                <a:latin typeface="Apple SD Gothic Neo"/>
+                <a:ea typeface="Apple SD Gothic Neo"/>
+                <a:cs typeface="Apple SD Gothic Neo"/>
+              </a:defRPr>
+            </a:lvl1pPr>
+            <a:lvl2pPr>
+              <a:defRPr sz="3000" b="1">
+                <a:solidFill>
+                  <a:srgbClr val="0F52BA"/>
+                </a:solidFill>
+                <a:latin typeface="Apple SD Gothic Neo"/>
+                <a:ea typeface="Apple SD Gothic Neo"/>
+                <a:cs typeface="Apple SD Gothic Neo"/>
+              </a:defRPr>
+            </a:lvl2pPr>
+            <a:lvl3pPr>
+              <a:defRPr sz="3000" b="1">
+                <a:solidFill>
+                  <a:srgbClr val="0F52BA"/>
+                </a:solidFill>
+                <a:latin typeface="Apple SD Gothic Neo"/>
+                <a:ea typeface="Apple SD Gothic Neo"/>
+                <a:cs typeface="Apple SD Gothic Neo"/>
+              </a:defRPr>
+            </a:lvl3pPr>
+            <a:lvl4pPr>
+              <a:defRPr sz="3000" b="1">
+                <a:solidFill>
+                  <a:srgbClr val="0F52BA"/>
+                </a:solidFill>
+                <a:latin typeface="Apple SD Gothic Neo"/>
+                <a:ea typeface="Apple SD Gothic Neo"/>
+                <a:cs typeface="Apple SD Gothic Neo"/>
+              </a:defRPr>
+            </a:lvl4pPr>
+            <a:lvl5pPr>
+              <a:defRPr sz="3000" b="1">
+                <a:solidFill>
+                  <a:srgbClr val="0F52BA"/>
+                </a:solidFill>
+                <a:latin typeface="Apple SD Gothic Neo"/>
+                <a:ea typeface="Apple SD Gothic Neo"/>
+                <a:cs typeface="Apple SD Gothic Neo"/>
+              </a:defRPr>
+            </a:lvl5pPr>
+            <a:lvl6pPr>
+              <a:defRPr sz="3000" b="1">
+                <a:solidFill>
+                  <a:srgbClr val="0F52BA"/>
+                </a:solidFill>
+                <a:latin typeface="Apple SD Gothic Neo"/>
+                <a:ea typeface="Apple SD Gothic Neo"/>
+                <a:cs typeface="Apple SD Gothic Neo"/>
+              </a:defRPr>
+            </a:lvl6pPr>
+            <a:lvl7pPr>
+              <a:defRPr sz="3000" b="1">
+                <a:solidFill>
+                  <a:srgbClr val="0F52BA"/>
+                </a:solidFill>
+                <a:latin typeface="Apple SD Gothic Neo"/>
+                <a:ea typeface="Apple SD Gothic Neo"/>
+                <a:cs typeface="Apple SD Gothic Neo"/>
+              </a:defRPr>
+            </a:lvl7pPr>
+            <a:lvl8pPr>
+              <a:defRPr sz="3000" b="1">
+                <a:solidFill>
+                  <a:srgbClr val="0F52BA"/>
+                </a:solidFill>
+                <a:latin typeface="Apple SD Gothic Neo"/>
+                <a:ea typeface="Apple SD Gothic Neo"/>
+                <a:cs typeface="Apple SD Gothic Neo"/>
+              </a:defRPr>
+            </a:lvl8pPr>
+            <a:lvl9pPr>
+              <a:defRPr sz="3000" b="1">
+                <a:solidFill>
+                  <a:srgbClr val="0F52BA"/>
+                </a:solidFill>
+                <a:latin typeface="Apple SD Gothic Neo"/>
+                <a:ea typeface="Apple SD Gothic Neo"/>
+                <a:cs typeface="Apple SD Gothic Neo"/>
+              </a:defRPr>
+            </a:lvl9pPr>
+          </a:lstStyle>
+          <a:p xmlns:a="http://schemas.openxmlformats.org/drawingml/2006/main">
+            <a:pPr>
+              <a:defRPr sz="3000" b="1">
+                <a:solidFill>
+                  <a:srgbClr val="0F52BA"/>
+                </a:solidFill>
+                <a:latin typeface="Apple SD Gothic Neo"/>
+                <a:ea typeface="Apple SD Gothic Neo"/>
+                <a:cs typeface="Apple SD Gothic Neo"/>
+              </a:defRPr>
+            </a:pPr>
+            <a:r>
+              <a:rPr sz="3000" b="1">
+                <a:solidFill>
+                  <a:srgbClr val="0F52BA"/>
+                </a:solidFill>
+                <a:latin typeface="Apple SD Gothic Neo"/>
+                <a:ea typeface="Apple SD Gothic Neo"/>
+                <a:cs typeface="Apple SD Gothic Neo"/>
+              </a:rPr>
+              <a:t>03</a:t>
+            </a:r>
+          </a:p>
+        </p:txBody>
+      </p:sp>
+      <p:sp>
+        <p:nvSpPr>
+          <p:cNvPr id="10" name="">
+            <a:extLst xmlns:a="http://schemas.openxmlformats.org/drawingml/2006/main">
+              <a:ext uri="{FF2B5EF4-FFF2-40B4-BE49-F238E27FC236}">
+                <a16:creationId xmlns:a16="http://schemas.microsoft.com/office/drawing/2014/main" id="{00B29A7F-8346-40AC-A258-5DD2FF8EFA22}"/>
+              </a:ext>
+            </a:extLst>
+          </p:cNvPr>
+          <p:cNvSpPr>
+            <a:spLocks xmlns:a="http://schemas.openxmlformats.org/drawingml/2006/main" noGrp="1"/>
+          </p:cNvSpPr>
+          <p:nvPr/>
+        </p:nvSpPr>
+        <p:spPr>
+          <a:xfrm xmlns:a="http://schemas.openxmlformats.org/drawingml/2006/main">
+            <a:off x="1562100" y="4676775"/>
+            <a:ext cx="2857500" cy="523875"/>
+          </a:xfrm>
+          <a:prstGeom xmlns:a="http://schemas.openxmlformats.org/drawingml/2006/main" prst="rect">
+            <a:avLst/>
+          </a:prstGeom>
+          <a:noFill xmlns:a="http://schemas.openxmlformats.org/drawingml/2006/main"/>
+          <a:ln xmlns:a="http://schemas.openxmlformats.org/drawingml/2006/main" w="0">
+            <a:noFill/>
+          </a:ln>
+        </p:spPr>
+        <p:txBody>
+          <a:bodyPr xmlns:a="http://schemas.openxmlformats.org/drawingml/2006/main" lIns="0" tIns="0" rIns="0" bIns="0"/>
+          <a:lstStyle xmlns:a="http://schemas.openxmlformats.org/drawingml/2006/main">
+            <a:defPPr>
+              <a:defRPr sz="2400" b="1">
+                <a:solidFill>
+                  <a:srgbClr val="000926"/>
+                </a:solidFill>
+                <a:latin typeface="Apple SD Gothic Neo"/>
+                <a:ea typeface="Apple SD Gothic Neo"/>
+                <a:cs typeface="Apple SD Gothic Neo"/>
+              </a:defRPr>
+            </a:defPPr>
+            <a:lvl1pPr>
+              <a:defRPr sz="2400" b="1">
+                <a:solidFill>
+                  <a:srgbClr val="000926"/>
+                </a:solidFill>
+                <a:latin typeface="Apple SD Gothic Neo"/>
+                <a:ea typeface="Apple SD Gothic Neo"/>
+                <a:cs typeface="Apple SD Gothic Neo"/>
+              </a:defRPr>
+            </a:lvl1pPr>
+            <a:lvl2pPr>
+              <a:defRPr sz="2400" b="1">
+                <a:solidFill>
+                  <a:srgbClr val="000926"/>
+                </a:solidFill>
+                <a:latin typeface="Apple SD Gothic Neo"/>
+                <a:ea typeface="Apple SD Gothic Neo"/>
+                <a:cs typeface="Apple SD Gothic Neo"/>
+              </a:defRPr>
+            </a:lvl2pPr>
+            <a:lvl3pPr>
+              <a:defRPr sz="2400" b="1">
+                <a:solidFill>
+                  <a:srgbClr val="000926"/>
+                </a:solidFill>
+                <a:latin typeface="Apple SD Gothic Neo"/>
+                <a:ea typeface="Apple SD Gothic Neo"/>
+                <a:cs typeface="Apple SD Gothic Neo"/>
+              </a:defRPr>
+            </a:lvl3pPr>
+            <a:lvl4pPr>
+              <a:defRPr sz="2400" b="1">
+                <a:solidFill>
+                  <a:srgbClr val="000926"/>
+                </a:solidFill>
+                <a:latin typeface="Apple SD Gothic Neo"/>
+                <a:ea typeface="Apple SD Gothic Neo"/>
+                <a:cs typeface="Apple SD Gothic Neo"/>
+              </a:defRPr>
+            </a:lvl4pPr>
+            <a:lvl5pPr>
+              <a:defRPr sz="2400" b="1">
+                <a:solidFill>
+                  <a:srgbClr val="000926"/>
+                </a:solidFill>
+                <a:latin typeface="Apple SD Gothic Neo"/>
+                <a:ea typeface="Apple SD Gothic Neo"/>
+                <a:cs typeface="Apple SD Gothic Neo"/>
+              </a:defRPr>
+            </a:lvl5pPr>
+            <a:lvl6pPr>
+              <a:defRPr sz="2400" b="1">
+                <a:solidFill>
+                  <a:srgbClr val="000926"/>
+                </a:solidFill>
+                <a:latin typeface="Apple SD Gothic Neo"/>
+                <a:ea typeface="Apple SD Gothic Neo"/>
+                <a:cs typeface="Apple SD Gothic Neo"/>
+              </a:defRPr>
+            </a:lvl6pPr>
+            <a:lvl7pPr>
+              <a:defRPr sz="2400" b="1">
+                <a:solidFill>
+                  <a:srgbClr val="000926"/>
+                </a:solidFill>
+                <a:latin typeface="Apple SD Gothic Neo"/>
+                <a:ea typeface="Apple SD Gothic Neo"/>
+                <a:cs typeface="Apple SD Gothic Neo"/>
+              </a:defRPr>
+            </a:lvl7pPr>
+            <a:lvl8pPr>
+              <a:defRPr sz="2400" b="1">
+                <a:solidFill>
+                  <a:srgbClr val="000926"/>
+                </a:solidFill>
+                <a:latin typeface="Apple SD Gothic Neo"/>
+                <a:ea typeface="Apple SD Gothic Neo"/>
+                <a:cs typeface="Apple SD Gothic Neo"/>
+              </a:defRPr>
+            </a:lvl8pPr>
+            <a:lvl9pPr>
+              <a:defRPr sz="2400" b="1">
+                <a:solidFill>
+                  <a:srgbClr val="000926"/>
+                </a:solidFill>
+                <a:latin typeface="Apple SD Gothic Neo"/>
+                <a:ea typeface="Apple SD Gothic Neo"/>
+                <a:cs typeface="Apple SD Gothic Neo"/>
+              </a:defRPr>
+            </a:lvl9pPr>
+          </a:lstStyle>
+          <a:p xmlns:a="http://schemas.openxmlformats.org/drawingml/2006/main">
+            <a:pPr>
+              <a:defRPr sz="2400" b="1">
+                <a:solidFill>
+                  <a:srgbClr val="000926"/>
+                </a:solidFill>
+                <a:latin typeface="Apple SD Gothic Neo"/>
+                <a:ea typeface="Apple SD Gothic Neo"/>
+                <a:cs typeface="Apple SD Gothic Neo"/>
+              </a:defRPr>
+            </a:pPr>
+            <a:r>
+              <a:rPr sz="2400" b="1">
+                <a:solidFill>
+                  <a:srgbClr val="000926"/>
+                </a:solidFill>
+                <a:latin typeface="Apple SD Gothic Neo"/>
+                <a:ea typeface="Apple SD Gothic Neo"/>
+                <a:cs typeface="Apple SD Gothic Neo"/>
+              </a:rPr>
+              <a:t>읽기와 탐색 개선</a:t>
+            </a:r>
+          </a:p>
+        </p:txBody>
+      </p:sp>
+      <p:sp>
+        <p:nvSpPr>
+          <p:cNvPr id="11" name="">
+            <a:extLst xmlns:a="http://schemas.openxmlformats.org/drawingml/2006/main">
+              <a:ext uri="{FF2B5EF4-FFF2-40B4-BE49-F238E27FC236}">
+                <a16:creationId xmlns:a16="http://schemas.microsoft.com/office/drawing/2014/main" id="{647E17C2-6795-4223-AB03-B3C0643BBEC2}"/>
+              </a:ext>
+            </a:extLst>
+          </p:cNvPr>
+          <p:cNvSpPr>
+            <a:spLocks xmlns:a="http://schemas.openxmlformats.org/drawingml/2006/main" noGrp="1"/>
+          </p:cNvSpPr>
+          <p:nvPr/>
+        </p:nvSpPr>
+        <p:spPr>
+          <a:xfrm xmlns:a="http://schemas.openxmlformats.org/drawingml/2006/main">
+            <a:off x="4610100" y="4676775"/>
+            <a:ext cx="6953250" cy="809625"/>
+          </a:xfrm>
+          <a:prstGeom xmlns:a="http://schemas.openxmlformats.org/drawingml/2006/main" prst="rect">
+            <a:avLst/>
+          </a:prstGeom>
+          <a:noFill xmlns:a="http://schemas.openxmlformats.org/drawingml/2006/main"/>
+          <a:ln xmlns:a="http://schemas.openxmlformats.org/drawingml/2006/main" w="0">
+            <a:noFill/>
+          </a:ln>
+        </p:spPr>
+        <p:txBody>
+          <a:bodyPr xmlns:a="http://schemas.openxmlformats.org/drawingml/2006/main" lIns="0" tIns="0" rIns="0" bIns="0"/>
+          <a:lstStyle xmlns:a="http://schemas.openxmlformats.org/drawingml/2006/main">
+            <a:defPPr>
+              <a:defRPr sz="2100" b="0">
+                <a:solidFill>
+                  <a:srgbClr val="172B45"/>
+                </a:solidFill>
+                <a:latin typeface="Apple SD Gothic Neo"/>
+                <a:ea typeface="Apple SD Gothic Neo"/>
+                <a:cs typeface="Apple SD Gothic Neo"/>
+              </a:defRPr>
+            </a:defPPr>
+            <a:lvl1pPr>
+              <a:defRPr sz="2100" b="0">
+                <a:solidFill>
+                  <a:srgbClr val="172B45"/>
+                </a:solidFill>
+                <a:latin typeface="Apple SD Gothic Neo"/>
+                <a:ea typeface="Apple SD Gothic Neo"/>
+                <a:cs typeface="Apple SD Gothic Neo"/>
+              </a:defRPr>
+            </a:lvl1pPr>
+            <a:lvl2pPr>
+              <a:defRPr sz="2100" b="0">
+                <a:solidFill>
+                  <a:srgbClr val="172B45"/>
+                </a:solidFill>
+                <a:latin typeface="Apple SD Gothic Neo"/>
+                <a:ea typeface="Apple SD Gothic Neo"/>
+                <a:cs typeface="Apple SD Gothic Neo"/>
+              </a:defRPr>
+            </a:lvl2pPr>
+            <a:lvl3pPr>
+              <a:defRPr sz="2100" b="0">
+                <a:solidFill>
+                  <a:srgbClr val="172B45"/>
+                </a:solidFill>
+                <a:latin typeface="Apple SD Gothic Neo"/>
+                <a:ea typeface="Apple SD Gothic Neo"/>
+                <a:cs typeface="Apple SD Gothic Neo"/>
+              </a:defRPr>
+            </a:lvl3pPr>
+            <a:lvl4pPr>
+              <a:defRPr sz="2100" b="0">
+                <a:solidFill>
+                  <a:srgbClr val="172B45"/>
+                </a:solidFill>
+                <a:latin typeface="Apple SD Gothic Neo"/>
+                <a:ea typeface="Apple SD Gothic Neo"/>
+                <a:cs typeface="Apple SD Gothic Neo"/>
+              </a:defRPr>
+            </a:lvl4pPr>
+            <a:lvl5pPr>
+              <a:defRPr sz="2100" b="0">
+                <a:solidFill>
+                  <a:srgbClr val="172B45"/>
+                </a:solidFill>
+                <a:latin typeface="Apple SD Gothic Neo"/>
+                <a:ea typeface="Apple SD Gothic Neo"/>
+                <a:cs typeface="Apple SD Gothic Neo"/>
+              </a:defRPr>
+            </a:lvl5pPr>
+            <a:lvl6pPr>
+              <a:defRPr sz="2100" b="0">
+                <a:solidFill>
+                  <a:srgbClr val="172B45"/>
+                </a:solidFill>
+                <a:latin typeface="Apple SD Gothic Neo"/>
+                <a:ea typeface="Apple SD Gothic Neo"/>
+                <a:cs typeface="Apple SD Gothic Neo"/>
+              </a:defRPr>
+            </a:lvl6pPr>
+            <a:lvl7pPr>
+              <a:defRPr sz="2100" b="0">
+                <a:solidFill>
+                  <a:srgbClr val="172B45"/>
+                </a:solidFill>
+                <a:latin typeface="Apple SD Gothic Neo"/>
+                <a:ea typeface="Apple SD Gothic Neo"/>
+                <a:cs typeface="Apple SD Gothic Neo"/>
+              </a:defRPr>
+            </a:lvl7pPr>
+            <a:lvl8pPr>
+              <a:defRPr sz="2100" b="0">
+                <a:solidFill>
+                  <a:srgbClr val="172B45"/>
+                </a:solidFill>
+                <a:latin typeface="Apple SD Gothic Neo"/>
+                <a:ea typeface="Apple SD Gothic Neo"/>
+                <a:cs typeface="Apple SD Gothic Neo"/>
+              </a:defRPr>
+            </a:lvl8pPr>
+            <a:lvl9pPr>
+              <a:defRPr sz="2100" b="0">
+                <a:solidFill>
+                  <a:srgbClr val="172B45"/>
+                </a:solidFill>
+                <a:latin typeface="Apple SD Gothic Neo"/>
+                <a:ea typeface="Apple SD Gothic Neo"/>
+                <a:cs typeface="Apple SD Gothic Neo"/>
+              </a:defRPr>
+            </a:lvl9pPr>
+          </a:lstStyle>
+          <a:p xmlns:a="http://schemas.openxmlformats.org/drawingml/2006/main">
+            <a:pPr>
+              <a:defRPr sz="2100" b="0">
+                <a:solidFill>
+                  <a:srgbClr val="172B45"/>
+                </a:solidFill>
+                <a:latin typeface="Apple SD Gothic Neo"/>
+                <a:ea typeface="Apple SD Gothic Neo"/>
+                <a:cs typeface="Apple SD Gothic Neo"/>
+              </a:defRPr>
+            </a:pPr>
+            <a:r>
+              <a:rPr sz="2100" b="0">
+                <a:solidFill>
+                  <a:srgbClr val="172B45"/>
+                </a:solidFill>
+                <a:latin typeface="Apple SD Gothic Neo"/>
+                <a:ea typeface="Apple SD Gothic Neo"/>
+                <a:cs typeface="Apple SD Gothic Neo"/>
+              </a:rPr>
+              <a:t>처음 쓰는 사람과 모바일 환경에서</a:t>
+            </a:r>
+          </a:p>
+          <a:p xmlns:a="http://schemas.openxmlformats.org/drawingml/2006/main">
+            <a:pPr>
+              <a:defRPr sz="2100" b="0">
+                <a:solidFill>
+                  <a:srgbClr val="172B45"/>
+                </a:solidFill>
+                <a:latin typeface="Apple SD Gothic Neo"/>
+                <a:ea typeface="Apple SD Gothic Neo"/>
+                <a:cs typeface="Apple SD Gothic Neo"/>
+              </a:defRPr>
+            </a:pPr>
+            <a:r>
+              <a:rPr sz="2100" b="0">
+                <a:solidFill>
+                  <a:srgbClr val="172B45"/>
+                </a:solidFill>
+                <a:latin typeface="Apple SD Gothic Neo"/>
+                <a:ea typeface="Apple SD Gothic Neo"/>
+                <a:cs typeface="Apple SD Gothic Neo"/>
+              </a:rPr>
+              <a:t>본문·관계도·근거 이동을 점검</a:t>
+            </a:r>
+          </a:p>
+        </p:txBody>
+      </p:sp>
+      <p:sp>
+        <p:nvSpPr>
+          <p:cNvPr id="12" name="">
+            <a:extLst xmlns:a="http://schemas.openxmlformats.org/drawingml/2006/main">
+              <a:ext uri="{FF2B5EF4-FFF2-40B4-BE49-F238E27FC236}">
+                <a16:creationId xmlns:a16="http://schemas.microsoft.com/office/drawing/2014/main" id="{B36E7974-852E-49B2-AE35-290F6C4C1D9F}"/>
+              </a:ext>
+            </a:extLst>
+          </p:cNvPr>
+          <p:cNvSpPr>
+            <a:spLocks xmlns:a="http://schemas.openxmlformats.org/drawingml/2006/main" noGrp="1"/>
+          </p:cNvSpPr>
+          <p:nvPr/>
+        </p:nvSpPr>
+        <p:spPr>
+          <a:xfrm xmlns:a="http://schemas.openxmlformats.org/drawingml/2006/main">
+            <a:off x="609600" y="6419850"/>
+            <a:ext cx="5238750" cy="285750"/>
+          </a:xfrm>
+          <a:prstGeom xmlns:a="http://schemas.openxmlformats.org/drawingml/2006/main" prst="rect">
+            <a:avLst/>
+          </a:prstGeom>
+          <a:noFill xmlns:a="http://schemas.openxmlformats.org/drawingml/2006/main"/>
+          <a:ln xmlns:a="http://schemas.openxmlformats.org/drawingml/2006/main" w="0">
+            <a:noFill/>
+          </a:ln>
+        </p:spPr>
+        <p:txBody>
+          <a:bodyPr xmlns:a="http://schemas.openxmlformats.org/drawingml/2006/main" lIns="0" tIns="0" rIns="0" bIns="0"/>
+          <a:lstStyle xmlns:a="http://schemas.openxmlformats.org/drawingml/2006/main">
+            <a:defPPr>
+              <a:defRPr sz="1350" b="0">
+                <a:solidFill>
+                  <a:srgbClr val="526A84"/>
+                </a:solidFill>
+                <a:latin typeface="Apple SD Gothic Neo"/>
+                <a:ea typeface="Apple SD Gothic Neo"/>
+                <a:cs typeface="Apple SD Gothic Neo"/>
+              </a:defRPr>
+            </a:defPPr>
+            <a:lvl1pPr>
+              <a:defRPr sz="1350" b="0">
+                <a:solidFill>
+                  <a:srgbClr val="526A84"/>
+                </a:solidFill>
+                <a:latin typeface="Apple SD Gothic Neo"/>
+                <a:ea typeface="Apple SD Gothic Neo"/>
+                <a:cs typeface="Apple SD Gothic Neo"/>
+              </a:defRPr>
+            </a:lvl1pPr>
+            <a:lvl2pPr>
+              <a:defRPr sz="1350" b="0">
+                <a:solidFill>
+                  <a:srgbClr val="526A84"/>
+                </a:solidFill>
+                <a:latin typeface="Apple SD Gothic Neo"/>
+                <a:ea typeface="Apple SD Gothic Neo"/>
+                <a:cs typeface="Apple SD Gothic Neo"/>
+              </a:defRPr>
+            </a:lvl2pPr>
+            <a:lvl3pPr>
+              <a:defRPr sz="1350" b="0">
+                <a:solidFill>
+                  <a:srgbClr val="526A84"/>
+                </a:solidFill>
+                <a:latin typeface="Apple SD Gothic Neo"/>
+                <a:ea typeface="Apple SD Gothic Neo"/>
+                <a:cs typeface="Apple SD Gothic Neo"/>
+              </a:defRPr>
+            </a:lvl3pPr>
+            <a:lvl4pPr>
+              <a:defRPr sz="1350" b="0">
+                <a:solidFill>
+                  <a:srgbClr val="526A84"/>
+                </a:solidFill>
+                <a:latin typeface="Apple SD Gothic Neo"/>
+                <a:ea typeface="Apple SD Gothic Neo"/>
+                <a:cs typeface="Apple SD Gothic Neo"/>
+              </a:defRPr>
+            </a:lvl4pPr>
+            <a:lvl5pPr>
+              <a:defRPr sz="1350" b="0">
+                <a:solidFill>
+                  <a:srgbClr val="526A84"/>
+                </a:solidFill>
+                <a:latin typeface="Apple SD Gothic Neo"/>
+                <a:ea typeface="Apple SD Gothic Neo"/>
+                <a:cs typeface="Apple SD Gothic Neo"/>
+              </a:defRPr>
+            </a:lvl5pPr>
+            <a:lvl6pPr>
+              <a:defRPr sz="1350" b="0">
+                <a:solidFill>
+                  <a:srgbClr val="526A84"/>
+                </a:solidFill>
+                <a:latin typeface="Apple SD Gothic Neo"/>
+                <a:ea typeface="Apple SD Gothic Neo"/>
+                <a:cs typeface="Apple SD Gothic Neo"/>
+              </a:defRPr>
+            </a:lvl6pPr>
+            <a:lvl7pPr>
+              <a:defRPr sz="1350" b="0">
+                <a:solidFill>
+                  <a:srgbClr val="526A84"/>
+                </a:solidFill>
+                <a:latin typeface="Apple SD Gothic Neo"/>
+                <a:ea typeface="Apple SD Gothic Neo"/>
+                <a:cs typeface="Apple SD Gothic Neo"/>
+              </a:defRPr>
+            </a:lvl7pPr>
+            <a:lvl8pPr>
+              <a:defRPr sz="1350" b="0">
+                <a:solidFill>
+                  <a:srgbClr val="526A84"/>
+                </a:solidFill>
+                <a:latin typeface="Apple SD Gothic Neo"/>
+                <a:ea typeface="Apple SD Gothic Neo"/>
+                <a:cs typeface="Apple SD Gothic Neo"/>
+              </a:defRPr>
+            </a:lvl8pPr>
+            <a:lvl9pPr>
+              <a:defRPr sz="1350" b="0">
+                <a:solidFill>
+                  <a:srgbClr val="526A84"/>
+                </a:solidFill>
+                <a:latin typeface="Apple SD Gothic Neo"/>
+                <a:ea typeface="Apple SD Gothic Neo"/>
+                <a:cs typeface="Apple SD Gothic Neo"/>
+              </a:defRPr>
+            </a:lvl9pPr>
+          </a:lstStyle>
+          <a:p xmlns:a="http://schemas.openxmlformats.org/drawingml/2006/main">
+            <a:pPr>
+              <a:defRPr sz="1350" b="0">
+                <a:solidFill>
+                  <a:srgbClr val="526A84"/>
+                </a:solidFill>
+                <a:latin typeface="Apple SD Gothic Neo"/>
+                <a:ea typeface="Apple SD Gothic Neo"/>
+                <a:cs typeface="Apple SD Gothic Neo"/>
+              </a:defRPr>
+            </a:pPr>
+            <a:r>
+              <a:rPr sz="1350" b="0">
+                <a:solidFill>
+                  <a:srgbClr val="526A84"/>
+                </a:solidFill>
+                <a:latin typeface="Apple SD Gothic Neo"/>
+                <a:ea typeface="Apple SD Gothic Neo"/>
+                <a:cs typeface="Apple SD Gothic Neo"/>
+              </a:rPr>
+              <a:t>G074 김지민   ·   9/10</a:t>
+            </a:r>
+          </a:p>
+        </p:txBody>
+      </p:sp>
+    </p:spTree>
+    <p:extLst>
+      <p:ext uri="{BB962C8B-B14F-4D97-AF65-F5344CB8AC3E}">
+        <p14:creationId xmlns:p14="http://schemas.microsoft.com/office/powerpoint/2010/main" val="719463996"/>
       </p:ext>
     </p:extLst>
   </p:cSld>

</xml_diff>

<commit_message>
docs(presentation): refine the closing appreciation phrase
변경 내용
- 마지막 장과 발표 대본·발표자 노트의 인사를 경청해 주셔서 감사합니다로 다듬었다.
- 길어진 문구가 한 줄에 들어가도록 마지막 장 글자 크기를 조정했다.

변경 이유
- 발표 상황에 어울리는 정중한 마무리 표현을 요청한 피드백을 반영했다.

검증
- finalize-thanks.mjs: PPTX 무결성·레이아웃·폰트·재가져오기 검사 통과.
- check-thanks.py: 대본·노트 일치와 기존 9장 렌더 동일성 확인.
- 마지막 장 렌더를 확인하고 git diff --check를 통과했다.
</commit_message>
<xml_diff>
--- a/docs/presentation/LoreForge-G074-KimJimin.pptx
+++ b/docs/presentation/LoreForge-G074-KimJimin.pptx
@@ -2,22 +2,22 @@
 <file path=ppt/presentation.xml><?xml version="1.0" encoding="utf-8"?>
 <p:presentation xmlns:p="http://schemas.openxmlformats.org/presentationml/2006/main">
   <p:sldMasterIdLst>
-    <p:sldMasterId xmlns:r="http://schemas.openxmlformats.org/officeDocument/2006/relationships" id="2147483648" r:id="R1bc1d50c0a1b447d"/>
+    <p:sldMasterId xmlns:r="http://schemas.openxmlformats.org/officeDocument/2006/relationships" id="2147483648" r:id="Reb0ee5c2cb3349a6"/>
   </p:sldMasterIdLst>
   <p:notesMasterIdLst>
-    <p:notesMasterId xmlns:r="http://schemas.openxmlformats.org/officeDocument/2006/relationships" r:id="R07976d093ab149bc"/>
+    <p:notesMasterId xmlns:r="http://schemas.openxmlformats.org/officeDocument/2006/relationships" r:id="R33cbd0e56d6c4f99"/>
   </p:notesMasterIdLst>
   <p:sldIdLst>
-    <p:sldId xmlns:r="http://schemas.openxmlformats.org/officeDocument/2006/relationships" id="256" r:id="Rf27d82f583284b25"/>
-    <p:sldId xmlns:r="http://schemas.openxmlformats.org/officeDocument/2006/relationships" id="257" r:id="Rbe576d99436d4f16"/>
-    <p:sldId xmlns:r="http://schemas.openxmlformats.org/officeDocument/2006/relationships" id="258" r:id="Rc23a14dfb20c4ce5"/>
-    <p:sldId xmlns:r="http://schemas.openxmlformats.org/officeDocument/2006/relationships" id="259" r:id="R9ea5a87ef8f44037"/>
-    <p:sldId xmlns:r="http://schemas.openxmlformats.org/officeDocument/2006/relationships" id="260" r:id="R9496342332054dc4"/>
-    <p:sldId xmlns:r="http://schemas.openxmlformats.org/officeDocument/2006/relationships" id="261" r:id="R04804b7d346d43da"/>
-    <p:sldId xmlns:r="http://schemas.openxmlformats.org/officeDocument/2006/relationships" id="262" r:id="R6e54a75a6633459d"/>
-    <p:sldId xmlns:r="http://schemas.openxmlformats.org/officeDocument/2006/relationships" id="263" r:id="R124523a083774d46"/>
-    <p:sldId xmlns:r="http://schemas.openxmlformats.org/officeDocument/2006/relationships" id="264" r:id="Rd88c8c5fa11649b3"/>
-    <p:sldId xmlns:r="http://schemas.openxmlformats.org/officeDocument/2006/relationships" id="265" r:id="R008ee752f10b43af"/>
+    <p:sldId xmlns:r="http://schemas.openxmlformats.org/officeDocument/2006/relationships" id="256" r:id="Rf3f17830da564b65"/>
+    <p:sldId xmlns:r="http://schemas.openxmlformats.org/officeDocument/2006/relationships" id="257" r:id="Rf7ef9285b9794354"/>
+    <p:sldId xmlns:r="http://schemas.openxmlformats.org/officeDocument/2006/relationships" id="258" r:id="R7ffa527c3fb04567"/>
+    <p:sldId xmlns:r="http://schemas.openxmlformats.org/officeDocument/2006/relationships" id="259" r:id="R707de29aaf6448fa"/>
+    <p:sldId xmlns:r="http://schemas.openxmlformats.org/officeDocument/2006/relationships" id="260" r:id="Ra0e0607f86674eed"/>
+    <p:sldId xmlns:r="http://schemas.openxmlformats.org/officeDocument/2006/relationships" id="261" r:id="R9836e62652a24736"/>
+    <p:sldId xmlns:r="http://schemas.openxmlformats.org/officeDocument/2006/relationships" id="262" r:id="Rc6fa95b12a4d4ad4"/>
+    <p:sldId xmlns:r="http://schemas.openxmlformats.org/officeDocument/2006/relationships" id="263" r:id="R0ec8f569025d4ac2"/>
+    <p:sldId xmlns:r="http://schemas.openxmlformats.org/officeDocument/2006/relationships" id="264" r:id="R2a60130aa18c4be6"/>
+    <p:sldId xmlns:r="http://schemas.openxmlformats.org/officeDocument/2006/relationships" id="265" r:id="R6fd68b01d6504e24"/>
   </p:sldIdLst>
   <p:sldSz cx="12192000" cy="6858000"/>
   <p:notesSz cx="6858000" cy="9144000"/>
@@ -531,7 +531,7 @@
           </a:p>
           <a:p xmlns:a="http://schemas.openxmlformats.org/drawingml/2006/main">
             <a:r>
-              <a:t>이상으로 설정공방 LoreForge 소개를 마치겠습니다. 들어주셔서 감사합니다.</a:t>
+              <a:t>이상으로 설정공방 LoreForge 소개를 마치겠습니다. 경청해 주셔서 감사합니다.</a:t>
             </a:r>
           </a:p>
         </p:txBody>
@@ -3674,12 +3674,12 @@
   </p:cSld>
   <p:clrMap bg1="lt1" tx1="dk1" bg2="lt2" tx2="dk2" accent1="accent1" accent2="accent2" accent3="accent3" accent4="accent4" accent5="accent5" accent6="accent6" hlink="hlink" folHlink="folHlink"/>
   <p:sldLayoutIdLst>
-    <p:sldLayoutId xmlns:r="http://schemas.openxmlformats.org/officeDocument/2006/relationships" id="2147483649" r:id="R53376466eb2b4580"/>
-    <p:sldLayoutId xmlns:r="http://schemas.openxmlformats.org/officeDocument/2006/relationships" id="2147483650" r:id="R8ec0eb200323454e"/>
-    <p:sldLayoutId xmlns:r="http://schemas.openxmlformats.org/officeDocument/2006/relationships" id="2147483651" r:id="Rd76fe575cbf44b02"/>
-    <p:sldLayoutId xmlns:r="http://schemas.openxmlformats.org/officeDocument/2006/relationships" id="2147483652" r:id="Rfc4b255b2ce24f93"/>
-    <p:sldLayoutId xmlns:r="http://schemas.openxmlformats.org/officeDocument/2006/relationships" id="2147483653" r:id="R6fb6e2ed6b9342ae"/>
-    <p:sldLayoutId xmlns:r="http://schemas.openxmlformats.org/officeDocument/2006/relationships" id="2147483654" r:id="Rfd1becd7005142d6"/>
+    <p:sldLayoutId xmlns:r="http://schemas.openxmlformats.org/officeDocument/2006/relationships" id="2147483649" r:id="Rd1322d48c3da43dd"/>
+    <p:sldLayoutId xmlns:r="http://schemas.openxmlformats.org/officeDocument/2006/relationships" id="2147483650" r:id="R2f80595ac28d4ba0"/>
+    <p:sldLayoutId xmlns:r="http://schemas.openxmlformats.org/officeDocument/2006/relationships" id="2147483651" r:id="R75954b3bb57f4f71"/>
+    <p:sldLayoutId xmlns:r="http://schemas.openxmlformats.org/officeDocument/2006/relationships" id="2147483652" r:id="Rb61c9e08154d48a1"/>
+    <p:sldLayoutId xmlns:r="http://schemas.openxmlformats.org/officeDocument/2006/relationships" id="2147483653" r:id="R9036203f7f584c66"/>
+    <p:sldLayoutId xmlns:r="http://schemas.openxmlformats.org/officeDocument/2006/relationships" id="2147483654" r:id="Rfc082add5c944f83"/>
   </p:sldLayoutIdLst>
   <p:txStyles>
     <p:titleStyle>
@@ -5291,6 +5291,7 @@
               </a:defRPr>
             </a:defPPr>
             <a:lvl1pPr>
+              <a:buNone/>
               <a:defRPr sz="2550" b="0">
                 <a:solidFill>
                   <a:srgbClr val="A6C5D7"/>
@@ -5301,6 +5302,7 @@
               </a:defRPr>
             </a:lvl1pPr>
             <a:lvl2pPr>
+              <a:buNone/>
               <a:defRPr sz="2550" b="0">
                 <a:solidFill>
                   <a:srgbClr val="A6C5D7"/>
@@ -5311,6 +5313,7 @@
               </a:defRPr>
             </a:lvl2pPr>
             <a:lvl3pPr>
+              <a:buNone/>
               <a:defRPr sz="2550" b="0">
                 <a:solidFill>
                   <a:srgbClr val="A6C5D7"/>
@@ -5321,6 +5324,7 @@
               </a:defRPr>
             </a:lvl3pPr>
             <a:lvl4pPr>
+              <a:buNone/>
               <a:defRPr sz="2550" b="0">
                 <a:solidFill>
                   <a:srgbClr val="A6C5D7"/>
@@ -5331,6 +5335,7 @@
               </a:defRPr>
             </a:lvl4pPr>
             <a:lvl5pPr>
+              <a:buNone/>
               <a:defRPr sz="2550" b="0">
                 <a:solidFill>
                   <a:srgbClr val="A6C5D7"/>
@@ -5341,6 +5346,7 @@
               </a:defRPr>
             </a:lvl5pPr>
             <a:lvl6pPr>
+              <a:buNone/>
               <a:defRPr sz="2550" b="0">
                 <a:solidFill>
                   <a:srgbClr val="A6C5D7"/>
@@ -5351,6 +5357,7 @@
               </a:defRPr>
             </a:lvl6pPr>
             <a:lvl7pPr>
+              <a:buNone/>
               <a:defRPr sz="2550" b="0">
                 <a:solidFill>
                   <a:srgbClr val="A6C5D7"/>
@@ -5361,6 +5368,7 @@
               </a:defRPr>
             </a:lvl7pPr>
             <a:lvl8pPr>
+              <a:buNone/>
               <a:defRPr sz="2550" b="0">
                 <a:solidFill>
                   <a:srgbClr val="A6C5D7"/>
@@ -5371,6 +5379,7 @@
               </a:defRPr>
             </a:lvl8pPr>
             <a:lvl9pPr>
+              <a:buNone/>
               <a:defRPr sz="2550" b="0">
                 <a:solidFill>
                   <a:srgbClr val="A6C5D7"/>
@@ -5383,6 +5392,7 @@
           </a:lstStyle>
           <a:p xmlns:a="http://schemas.openxmlformats.org/drawingml/2006/main">
             <a:pPr>
+              <a:buNone/>
               <a:defRPr sz="2550" b="0">
                 <a:solidFill>
                   <a:srgbClr val="A6C5D7"/>
@@ -5437,7 +5447,7 @@
           <a:bodyPr xmlns:a="http://schemas.openxmlformats.org/drawingml/2006/main" lIns="0" tIns="0" rIns="0" bIns="0"/>
           <a:lstStyle xmlns:a="http://schemas.openxmlformats.org/drawingml/2006/main">
             <a:defPPr>
-              <a:defRPr sz="5400" b="1">
+              <a:defRPr sz="4800" b="1">
                 <a:solidFill>
                   <a:srgbClr val="FFFFFF"/>
                 </a:solidFill>
@@ -5447,6 +5457,7 @@
               </a:defRPr>
             </a:defPPr>
             <a:lvl1pPr>
+              <a:buNone/>
               <a:defRPr sz="5400" b="1">
                 <a:solidFill>
                   <a:srgbClr val="FFFFFF"/>
@@ -5457,6 +5468,7 @@
               </a:defRPr>
             </a:lvl1pPr>
             <a:lvl2pPr>
+              <a:buNone/>
               <a:defRPr sz="5400" b="1">
                 <a:solidFill>
                   <a:srgbClr val="FFFFFF"/>
@@ -5467,6 +5479,7 @@
               </a:defRPr>
             </a:lvl2pPr>
             <a:lvl3pPr>
+              <a:buNone/>
               <a:defRPr sz="5400" b="1">
                 <a:solidFill>
                   <a:srgbClr val="FFFFFF"/>
@@ -5477,6 +5490,7 @@
               </a:defRPr>
             </a:lvl3pPr>
             <a:lvl4pPr>
+              <a:buNone/>
               <a:defRPr sz="5400" b="1">
                 <a:solidFill>
                   <a:srgbClr val="FFFFFF"/>
@@ -5487,6 +5501,7 @@
               </a:defRPr>
             </a:lvl4pPr>
             <a:lvl5pPr>
+              <a:buNone/>
               <a:defRPr sz="5400" b="1">
                 <a:solidFill>
                   <a:srgbClr val="FFFFFF"/>
@@ -5497,6 +5512,7 @@
               </a:defRPr>
             </a:lvl5pPr>
             <a:lvl6pPr>
+              <a:buNone/>
               <a:defRPr sz="5400" b="1">
                 <a:solidFill>
                   <a:srgbClr val="FFFFFF"/>
@@ -5507,6 +5523,7 @@
               </a:defRPr>
             </a:lvl6pPr>
             <a:lvl7pPr>
+              <a:buNone/>
               <a:defRPr sz="5400" b="1">
                 <a:solidFill>
                   <a:srgbClr val="FFFFFF"/>
@@ -5517,6 +5534,7 @@
               </a:defRPr>
             </a:lvl7pPr>
             <a:lvl8pPr>
+              <a:buNone/>
               <a:defRPr sz="5400" b="1">
                 <a:solidFill>
                   <a:srgbClr val="FFFFFF"/>
@@ -5527,6 +5545,7 @@
               </a:defRPr>
             </a:lvl8pPr>
             <a:lvl9pPr>
+              <a:buNone/>
               <a:defRPr sz="5400" b="1">
                 <a:solidFill>
                   <a:srgbClr val="FFFFFF"/>
@@ -5539,7 +5558,8 @@
           </a:lstStyle>
           <a:p xmlns:a="http://schemas.openxmlformats.org/drawingml/2006/main">
             <a:pPr>
-              <a:defRPr sz="5400" b="1">
+              <a:buNone/>
+              <a:defRPr sz="4800" b="1">
                 <a:solidFill>
                   <a:srgbClr val="FFFFFF"/>
                 </a:solidFill>
@@ -5549,7 +5569,7 @@
               </a:defRPr>
             </a:pPr>
             <a:r>
-              <a:rPr sz="5400" b="1">
+              <a:rPr sz="4800" b="1">
                 <a:solidFill>
                   <a:srgbClr val="FFFFFF"/>
                 </a:solidFill>
@@ -5557,7 +5577,7 @@
                 <a:ea typeface="Apple SD Gothic Neo"/>
                 <a:cs typeface="Apple SD Gothic Neo"/>
               </a:rPr>
-              <a:t>들어주셔서 감사합니다</a:t>
+              <a:t>경청해 주셔서 감사합니다.</a:t>
             </a:r>
           </a:p>
         </p:txBody>
@@ -5603,6 +5623,7 @@
               </a:defRPr>
             </a:defPPr>
             <a:lvl1pPr>
+              <a:buNone/>
               <a:defRPr sz="2550" b="1">
                 <a:solidFill>
                   <a:srgbClr val="FFFFFF"/>
@@ -5613,6 +5634,7 @@
               </a:defRPr>
             </a:lvl1pPr>
             <a:lvl2pPr>
+              <a:buNone/>
               <a:defRPr sz="2550" b="1">
                 <a:solidFill>
                   <a:srgbClr val="FFFFFF"/>
@@ -5623,6 +5645,7 @@
               </a:defRPr>
             </a:lvl2pPr>
             <a:lvl3pPr>
+              <a:buNone/>
               <a:defRPr sz="2550" b="1">
                 <a:solidFill>
                   <a:srgbClr val="FFFFFF"/>
@@ -5633,6 +5656,7 @@
               </a:defRPr>
             </a:lvl3pPr>
             <a:lvl4pPr>
+              <a:buNone/>
               <a:defRPr sz="2550" b="1">
                 <a:solidFill>
                   <a:srgbClr val="FFFFFF"/>
@@ -5643,6 +5667,7 @@
               </a:defRPr>
             </a:lvl4pPr>
             <a:lvl5pPr>
+              <a:buNone/>
               <a:defRPr sz="2550" b="1">
                 <a:solidFill>
                   <a:srgbClr val="FFFFFF"/>
@@ -5653,6 +5678,7 @@
               </a:defRPr>
             </a:lvl5pPr>
             <a:lvl6pPr>
+              <a:buNone/>
               <a:defRPr sz="2550" b="1">
                 <a:solidFill>
                   <a:srgbClr val="FFFFFF"/>
@@ -5663,6 +5689,7 @@
               </a:defRPr>
             </a:lvl6pPr>
             <a:lvl7pPr>
+              <a:buNone/>
               <a:defRPr sz="2550" b="1">
                 <a:solidFill>
                   <a:srgbClr val="FFFFFF"/>
@@ -5673,6 +5700,7 @@
               </a:defRPr>
             </a:lvl7pPr>
             <a:lvl8pPr>
+              <a:buNone/>
               <a:defRPr sz="2550" b="1">
                 <a:solidFill>
                   <a:srgbClr val="FFFFFF"/>
@@ -5683,6 +5711,7 @@
               </a:defRPr>
             </a:lvl8pPr>
             <a:lvl9pPr>
+              <a:buNone/>
               <a:defRPr sz="2550" b="1">
                 <a:solidFill>
                   <a:srgbClr val="FFFFFF"/>
@@ -5695,6 +5724,7 @@
           </a:lstStyle>
           <a:p xmlns:a="http://schemas.openxmlformats.org/drawingml/2006/main">
             <a:pPr>
+              <a:buNone/>
               <a:defRPr sz="2550" b="1">
                 <a:solidFill>
                   <a:srgbClr val="FFFFFF"/>
@@ -5759,6 +5789,7 @@
               </a:defRPr>
             </a:defPPr>
             <a:lvl1pPr>
+              <a:buNone/>
               <a:defRPr sz="1950" b="0">
                 <a:solidFill>
                   <a:srgbClr val="D6E6F3"/>
@@ -5769,6 +5800,7 @@
               </a:defRPr>
             </a:lvl1pPr>
             <a:lvl2pPr>
+              <a:buNone/>
               <a:defRPr sz="1950" b="0">
                 <a:solidFill>
                   <a:srgbClr val="D6E6F3"/>
@@ -5779,6 +5811,7 @@
               </a:defRPr>
             </a:lvl2pPr>
             <a:lvl3pPr>
+              <a:buNone/>
               <a:defRPr sz="1950" b="0">
                 <a:solidFill>
                   <a:srgbClr val="D6E6F3"/>
@@ -5789,6 +5822,7 @@
               </a:defRPr>
             </a:lvl3pPr>
             <a:lvl4pPr>
+              <a:buNone/>
               <a:defRPr sz="1950" b="0">
                 <a:solidFill>
                   <a:srgbClr val="D6E6F3"/>
@@ -5799,6 +5833,7 @@
               </a:defRPr>
             </a:lvl4pPr>
             <a:lvl5pPr>
+              <a:buNone/>
               <a:defRPr sz="1950" b="0">
                 <a:solidFill>
                   <a:srgbClr val="D6E6F3"/>
@@ -5809,6 +5844,7 @@
               </a:defRPr>
             </a:lvl5pPr>
             <a:lvl6pPr>
+              <a:buNone/>
               <a:defRPr sz="1950" b="0">
                 <a:solidFill>
                   <a:srgbClr val="D6E6F3"/>
@@ -5819,6 +5855,7 @@
               </a:defRPr>
             </a:lvl6pPr>
             <a:lvl7pPr>
+              <a:buNone/>
               <a:defRPr sz="1950" b="0">
                 <a:solidFill>
                   <a:srgbClr val="D6E6F3"/>
@@ -5829,6 +5866,7 @@
               </a:defRPr>
             </a:lvl7pPr>
             <a:lvl8pPr>
+              <a:buNone/>
               <a:defRPr sz="1950" b="0">
                 <a:solidFill>
                   <a:srgbClr val="D6E6F3"/>
@@ -5839,6 +5877,7 @@
               </a:defRPr>
             </a:lvl8pPr>
             <a:lvl9pPr>
+              <a:buNone/>
               <a:defRPr sz="1950" b="0">
                 <a:solidFill>
                   <a:srgbClr val="D6E6F3"/>
@@ -5851,6 +5890,7 @@
           </a:lstStyle>
           <a:p xmlns:a="http://schemas.openxmlformats.org/drawingml/2006/main">
             <a:pPr>
+              <a:buNone/>
               <a:defRPr sz="1950" b="0">
                 <a:solidFill>
                   <a:srgbClr val="D6E6F3"/>
@@ -5915,6 +5955,7 @@
               </a:defRPr>
             </a:defPPr>
             <a:lvl1pPr>
+              <a:buNone/>
               <a:defRPr sz="1350" b="0">
                 <a:solidFill>
                   <a:srgbClr val="A6C5D7"/>
@@ -5925,6 +5966,7 @@
               </a:defRPr>
             </a:lvl1pPr>
             <a:lvl2pPr>
+              <a:buNone/>
               <a:defRPr sz="1350" b="0">
                 <a:solidFill>
                   <a:srgbClr val="A6C5D7"/>
@@ -5935,6 +5977,7 @@
               </a:defRPr>
             </a:lvl2pPr>
             <a:lvl3pPr>
+              <a:buNone/>
               <a:defRPr sz="1350" b="0">
                 <a:solidFill>
                   <a:srgbClr val="A6C5D7"/>
@@ -5945,6 +5988,7 @@
               </a:defRPr>
             </a:lvl3pPr>
             <a:lvl4pPr>
+              <a:buNone/>
               <a:defRPr sz="1350" b="0">
                 <a:solidFill>
                   <a:srgbClr val="A6C5D7"/>
@@ -5955,6 +5999,7 @@
               </a:defRPr>
             </a:lvl4pPr>
             <a:lvl5pPr>
+              <a:buNone/>
               <a:defRPr sz="1350" b="0">
                 <a:solidFill>
                   <a:srgbClr val="A6C5D7"/>
@@ -5965,6 +6010,7 @@
               </a:defRPr>
             </a:lvl5pPr>
             <a:lvl6pPr>
+              <a:buNone/>
               <a:defRPr sz="1350" b="0">
                 <a:solidFill>
                   <a:srgbClr val="A6C5D7"/>
@@ -5975,6 +6021,7 @@
               </a:defRPr>
             </a:lvl6pPr>
             <a:lvl7pPr>
+              <a:buNone/>
               <a:defRPr sz="1350" b="0">
                 <a:solidFill>
                   <a:srgbClr val="A6C5D7"/>
@@ -5985,6 +6032,7 @@
               </a:defRPr>
             </a:lvl7pPr>
             <a:lvl8pPr>
+              <a:buNone/>
               <a:defRPr sz="1350" b="0">
                 <a:solidFill>
                   <a:srgbClr val="A6C5D7"/>
@@ -5995,6 +6043,7 @@
               </a:defRPr>
             </a:lvl8pPr>
             <a:lvl9pPr>
+              <a:buNone/>
               <a:defRPr sz="1350" b="0">
                 <a:solidFill>
                   <a:srgbClr val="A6C5D7"/>
@@ -6007,6 +6056,7 @@
           </a:lstStyle>
           <a:p xmlns:a="http://schemas.openxmlformats.org/drawingml/2006/main">
             <a:pPr>
+              <a:buNone/>
               <a:defRPr sz="1350" b="0">
                 <a:solidFill>
                   <a:srgbClr val="A6C5D7"/>
@@ -6752,7 +6802,7 @@
           <p:cNvPr id="8" name="">
             <a:extLst xmlns:a="http://schemas.openxmlformats.org/drawingml/2006/main">
               <a:ext uri="{FF2B5EF4-FFF2-40B4-BE49-F238E27FC236}">
-                <a16:creationId xmlns:a16="http://schemas.microsoft.com/office/drawing/2014/main" id="{3F1A74BC-FDB9-4A0F-A8D9-9DCCA8E46793}"/>
+                <a16:creationId xmlns:a16="http://schemas.microsoft.com/office/drawing/2014/main" id="{7C40B8B7-F1AE-4B7C-83BE-10BDBB39FD25}"/>
               </a:ext>
             </a:extLst>
           </p:cNvPr>
@@ -6762,7 +6812,7 @@
           <p:nvPr/>
         </p:nvPicPr>
         <p:blipFill>
-          <a:blip xmlns:r="http://schemas.openxmlformats.org/officeDocument/2006/relationships" xmlns:a="http://schemas.openxmlformats.org/drawingml/2006/main" r:embed="R0591b18cd50340b1"/>
+          <a:blip xmlns:r="http://schemas.openxmlformats.org/officeDocument/2006/relationships" xmlns:a="http://schemas.openxmlformats.org/drawingml/2006/main" r:embed="Rd964353340be4a29"/>
           <a:stretch xmlns:a="http://schemas.openxmlformats.org/drawingml/2006/main"/>
         </p:blipFill>
         <p:spPr>
@@ -6946,7 +6996,7 @@
           <p:cNvPr id="10" name="">
             <a:extLst xmlns:a="http://schemas.openxmlformats.org/drawingml/2006/main">
               <a:ext uri="{FF2B5EF4-FFF2-40B4-BE49-F238E27FC236}">
-                <a16:creationId xmlns:a16="http://schemas.microsoft.com/office/drawing/2014/main" id="{FBF6645F-1A6F-4B4A-97CA-63B8F2AE477D}"/>
+                <a16:creationId xmlns:a16="http://schemas.microsoft.com/office/drawing/2014/main" id="{7CFADCE7-CDAD-420C-B748-94526954FFD5}"/>
               </a:ext>
             </a:extLst>
           </p:cNvPr>
@@ -6956,7 +7006,7 @@
           <p:nvPr/>
         </p:nvPicPr>
         <p:blipFill>
-          <a:blip xmlns:r="http://schemas.openxmlformats.org/officeDocument/2006/relationships" xmlns:a="http://schemas.openxmlformats.org/drawingml/2006/main" r:embed="R28615accd0d74420"/>
+          <a:blip xmlns:r="http://schemas.openxmlformats.org/officeDocument/2006/relationships" xmlns:a="http://schemas.openxmlformats.org/drawingml/2006/main" r:embed="Rc064798c58a04527"/>
           <a:stretch xmlns:a="http://schemas.openxmlformats.org/drawingml/2006/main"/>
         </p:blipFill>
         <p:spPr>
@@ -7140,7 +7190,7 @@
           <p:cNvPr id="12" name="">
             <a:extLst xmlns:a="http://schemas.openxmlformats.org/drawingml/2006/main">
               <a:ext uri="{FF2B5EF4-FFF2-40B4-BE49-F238E27FC236}">
-                <a16:creationId xmlns:a16="http://schemas.microsoft.com/office/drawing/2014/main" id="{055F8670-A8DA-47F3-A54F-FC4FF82E4D23}"/>
+                <a16:creationId xmlns:a16="http://schemas.microsoft.com/office/drawing/2014/main" id="{37633512-8A59-4F11-9695-59E1EFC3A15E}"/>
               </a:ext>
             </a:extLst>
           </p:cNvPr>
@@ -7150,7 +7200,7 @@
           <p:nvPr/>
         </p:nvPicPr>
         <p:blipFill>
-          <a:blip xmlns:r="http://schemas.openxmlformats.org/officeDocument/2006/relationships" xmlns:a="http://schemas.openxmlformats.org/drawingml/2006/main" r:embed="R0578071f61d84e3a"/>
+          <a:blip xmlns:r="http://schemas.openxmlformats.org/officeDocument/2006/relationships" xmlns:a="http://schemas.openxmlformats.org/drawingml/2006/main" r:embed="R6cdabb9541164a4d"/>
           <a:stretch xmlns:a="http://schemas.openxmlformats.org/drawingml/2006/main"/>
         </p:blipFill>
         <p:spPr>
@@ -7334,7 +7384,7 @@
           <p:cNvPr id="14" name="">
             <a:extLst xmlns:a="http://schemas.openxmlformats.org/drawingml/2006/main">
               <a:ext uri="{FF2B5EF4-FFF2-40B4-BE49-F238E27FC236}">
-                <a16:creationId xmlns:a16="http://schemas.microsoft.com/office/drawing/2014/main" id="{4CD28B57-4A86-40DC-89BA-7302876BB3A0}"/>
+                <a16:creationId xmlns:a16="http://schemas.microsoft.com/office/drawing/2014/main" id="{A04254A2-3800-40A8-9314-416CAD218435}"/>
               </a:ext>
             </a:extLst>
           </p:cNvPr>
@@ -7344,7 +7394,7 @@
           <p:nvPr/>
         </p:nvPicPr>
         <p:blipFill>
-          <a:blip xmlns:r="http://schemas.openxmlformats.org/officeDocument/2006/relationships" xmlns:a="http://schemas.openxmlformats.org/drawingml/2006/main" r:embed="R2681068941ec4e4d"/>
+          <a:blip xmlns:r="http://schemas.openxmlformats.org/officeDocument/2006/relationships" xmlns:a="http://schemas.openxmlformats.org/drawingml/2006/main" r:embed="R65431a85d87f46a1"/>
           <a:stretch xmlns:a="http://schemas.openxmlformats.org/drawingml/2006/main"/>
         </p:blipFill>
         <p:spPr>
@@ -11452,7 +11502,7 @@
           <p:cNvPr id="9" name="">
             <a:extLst xmlns:a="http://schemas.openxmlformats.org/drawingml/2006/main">
               <a:ext uri="{FF2B5EF4-FFF2-40B4-BE49-F238E27FC236}">
-                <a16:creationId xmlns:a16="http://schemas.microsoft.com/office/drawing/2014/main" id="{213F729B-F36E-41C9-97E0-5A549074E56F}"/>
+                <a16:creationId xmlns:a16="http://schemas.microsoft.com/office/drawing/2014/main" id="{CDFD9DA3-1BC6-42A8-A6F4-140313C22AA2}"/>
               </a:ext>
             </a:extLst>
           </p:cNvPr>
@@ -11462,7 +11512,7 @@
           <p:nvPr/>
         </p:nvPicPr>
         <p:blipFill>
-          <a:blip xmlns:r="http://schemas.openxmlformats.org/officeDocument/2006/relationships" xmlns:a="http://schemas.openxmlformats.org/drawingml/2006/main" r:embed="R33b77e9017de4bed"/>
+          <a:blip xmlns:r="http://schemas.openxmlformats.org/officeDocument/2006/relationships" xmlns:a="http://schemas.openxmlformats.org/drawingml/2006/main" r:embed="R5d933a63a6ae40ee"/>
           <a:srcRect xmlns:a="http://schemas.openxmlformats.org/drawingml/2006/main" l="24500" t="32000" r="25000" b="22000"/>
           <a:stretch xmlns:a="http://schemas.openxmlformats.org/drawingml/2006/main"/>
         </p:blipFill>
@@ -11647,7 +11697,7 @@
           <p:cNvPr id="12" name="">
             <a:extLst xmlns:a="http://schemas.openxmlformats.org/drawingml/2006/main">
               <a:ext uri="{FF2B5EF4-FFF2-40B4-BE49-F238E27FC236}">
-                <a16:creationId xmlns:a16="http://schemas.microsoft.com/office/drawing/2014/main" id="{395D25EF-D435-4026-94F5-41670DCAD6BD}"/>
+                <a16:creationId xmlns:a16="http://schemas.microsoft.com/office/drawing/2014/main" id="{488603A8-A6F3-4F70-ADD2-15F7663FA96D}"/>
               </a:ext>
             </a:extLst>
           </p:cNvPr>
@@ -11657,7 +11707,7 @@
           <p:nvPr/>
         </p:nvPicPr>
         <p:blipFill>
-          <a:blip xmlns:r="http://schemas.openxmlformats.org/officeDocument/2006/relationships" xmlns:a="http://schemas.openxmlformats.org/drawingml/2006/main" r:embed="Rf93793ba7b174d32"/>
+          <a:blip xmlns:r="http://schemas.openxmlformats.org/officeDocument/2006/relationships" xmlns:a="http://schemas.openxmlformats.org/drawingml/2006/main" r:embed="Rf317cc4be30f45ed"/>
           <a:srcRect xmlns:a="http://schemas.openxmlformats.org/drawingml/2006/main" l="2700" t="39500" r="3200" b="20500"/>
           <a:stretch xmlns:a="http://schemas.openxmlformats.org/drawingml/2006/main"/>
         </p:blipFill>
@@ -11705,7 +11755,7 @@
           <p:cNvPr id="12" name="">
             <a:extLst xmlns:a="http://schemas.openxmlformats.org/drawingml/2006/main">
               <a:ext uri="{FF2B5EF4-FFF2-40B4-BE49-F238E27FC236}">
-                <a16:creationId xmlns:a16="http://schemas.microsoft.com/office/drawing/2014/main" id="{F8EC2D5B-F4E5-4D9F-AA01-0043CE379C9C}"/>
+                <a16:creationId xmlns:a16="http://schemas.microsoft.com/office/drawing/2014/main" id="{666D6316-2129-4469-931A-AEC3738DF086}"/>
               </a:ext>
             </a:extLst>
           </p:cNvPr>
@@ -11736,7 +11786,7 @@
           <p:cNvPr id="11" name="">
             <a:extLst xmlns:a="http://schemas.openxmlformats.org/drawingml/2006/main">
               <a:ext uri="{FF2B5EF4-FFF2-40B4-BE49-F238E27FC236}">
-                <a16:creationId xmlns:a16="http://schemas.microsoft.com/office/drawing/2014/main" id="{2CB53B22-5AD8-41F1-B416-C934B0201617}"/>
+                <a16:creationId xmlns:a16="http://schemas.microsoft.com/office/drawing/2014/main" id="{F4A4AF6D-3A4B-4F95-AC68-4DE63287CDAE}"/>
               </a:ext>
             </a:extLst>
           </p:cNvPr>
@@ -11767,7 +11817,7 @@
           <p:cNvPr id="10" name="">
             <a:extLst xmlns:a="http://schemas.openxmlformats.org/drawingml/2006/main">
               <a:ext uri="{FF2B5EF4-FFF2-40B4-BE49-F238E27FC236}">
-                <a16:creationId xmlns:a16="http://schemas.microsoft.com/office/drawing/2014/main" id="{5DEC7AAE-392D-4661-A148-A09112B439F0}"/>
+                <a16:creationId xmlns:a16="http://schemas.microsoft.com/office/drawing/2014/main" id="{9DB4017A-BD11-4238-8854-A5E26162C92A}"/>
               </a:ext>
             </a:extLst>
           </p:cNvPr>
@@ -11798,7 +11848,7 @@
           <p:cNvPr id="9" name="">
             <a:extLst xmlns:a="http://schemas.openxmlformats.org/drawingml/2006/main">
               <a:ext uri="{FF2B5EF4-FFF2-40B4-BE49-F238E27FC236}">
-                <a16:creationId xmlns:a16="http://schemas.microsoft.com/office/drawing/2014/main" id="{86FC0B01-BFEC-4E24-8963-CCF7738C9F2B}"/>
+                <a16:creationId xmlns:a16="http://schemas.microsoft.com/office/drawing/2014/main" id="{F100251F-8ED3-4519-AABC-50EC0362D913}"/>
               </a:ext>
             </a:extLst>
           </p:cNvPr>
@@ -19927,6 +19977,7 @@
               </a:defRPr>
             </a:defPPr>
             <a:lvl1pPr>
+              <a:buNone/>
               <a:defRPr sz="3300" b="1">
                 <a:solidFill>
                   <a:srgbClr val="000926"/>
@@ -19937,6 +19988,7 @@
               </a:defRPr>
             </a:lvl1pPr>
             <a:lvl2pPr>
+              <a:buNone/>
               <a:defRPr sz="3300" b="1">
                 <a:solidFill>
                   <a:srgbClr val="000926"/>
@@ -19947,6 +19999,7 @@
               </a:defRPr>
             </a:lvl2pPr>
             <a:lvl3pPr>
+              <a:buNone/>
               <a:defRPr sz="3300" b="1">
                 <a:solidFill>
                   <a:srgbClr val="000926"/>
@@ -19957,6 +20010,7 @@
               </a:defRPr>
             </a:lvl3pPr>
             <a:lvl4pPr>
+              <a:buNone/>
               <a:defRPr sz="3300" b="1">
                 <a:solidFill>
                   <a:srgbClr val="000926"/>
@@ -19967,6 +20021,7 @@
               </a:defRPr>
             </a:lvl4pPr>
             <a:lvl5pPr>
+              <a:buNone/>
               <a:defRPr sz="3300" b="1">
                 <a:solidFill>
                   <a:srgbClr val="000926"/>
@@ -19977,6 +20032,7 @@
               </a:defRPr>
             </a:lvl5pPr>
             <a:lvl6pPr>
+              <a:buNone/>
               <a:defRPr sz="3300" b="1">
                 <a:solidFill>
                   <a:srgbClr val="000926"/>
@@ -19987,6 +20043,7 @@
               </a:defRPr>
             </a:lvl6pPr>
             <a:lvl7pPr>
+              <a:buNone/>
               <a:defRPr sz="3300" b="1">
                 <a:solidFill>
                   <a:srgbClr val="000926"/>
@@ -19997,6 +20054,7 @@
               </a:defRPr>
             </a:lvl7pPr>
             <a:lvl8pPr>
+              <a:buNone/>
               <a:defRPr sz="3300" b="1">
                 <a:solidFill>
                   <a:srgbClr val="000926"/>
@@ -20007,6 +20065,7 @@
               </a:defRPr>
             </a:lvl8pPr>
             <a:lvl9pPr>
+              <a:buNone/>
               <a:defRPr sz="3300" b="1">
                 <a:solidFill>
                   <a:srgbClr val="000926"/>
@@ -20019,6 +20078,7 @@
           </a:lstStyle>
           <a:p xmlns:a="http://schemas.openxmlformats.org/drawingml/2006/main">
             <a:pPr>
+              <a:buNone/>
               <a:defRPr sz="3300" b="1">
                 <a:solidFill>
                   <a:srgbClr val="000926"/>
@@ -20083,6 +20143,7 @@
               </a:defRPr>
             </a:defPPr>
             <a:lvl1pPr>
+              <a:buNone/>
               <a:defRPr sz="2250" b="1">
                 <a:solidFill>
                   <a:srgbClr val="0F52BA"/>
@@ -20093,6 +20154,7 @@
               </a:defRPr>
             </a:lvl1pPr>
             <a:lvl2pPr>
+              <a:buNone/>
               <a:defRPr sz="2250" b="1">
                 <a:solidFill>
                   <a:srgbClr val="0F52BA"/>
@@ -20103,6 +20165,7 @@
               </a:defRPr>
             </a:lvl2pPr>
             <a:lvl3pPr>
+              <a:buNone/>
               <a:defRPr sz="2250" b="1">
                 <a:solidFill>
                   <a:srgbClr val="0F52BA"/>
@@ -20113,6 +20176,7 @@
               </a:defRPr>
             </a:lvl3pPr>
             <a:lvl4pPr>
+              <a:buNone/>
               <a:defRPr sz="2250" b="1">
                 <a:solidFill>
                   <a:srgbClr val="0F52BA"/>
@@ -20123,6 +20187,7 @@
               </a:defRPr>
             </a:lvl4pPr>
             <a:lvl5pPr>
+              <a:buNone/>
               <a:defRPr sz="2250" b="1">
                 <a:solidFill>
                   <a:srgbClr val="0F52BA"/>
@@ -20133,6 +20198,7 @@
               </a:defRPr>
             </a:lvl5pPr>
             <a:lvl6pPr>
+              <a:buNone/>
               <a:defRPr sz="2250" b="1">
                 <a:solidFill>
                   <a:srgbClr val="0F52BA"/>
@@ -20143,6 +20209,7 @@
               </a:defRPr>
             </a:lvl6pPr>
             <a:lvl7pPr>
+              <a:buNone/>
               <a:defRPr sz="2250" b="1">
                 <a:solidFill>
                   <a:srgbClr val="0F52BA"/>
@@ -20153,6 +20220,7 @@
               </a:defRPr>
             </a:lvl7pPr>
             <a:lvl8pPr>
+              <a:buNone/>
               <a:defRPr sz="2250" b="1">
                 <a:solidFill>
                   <a:srgbClr val="0F52BA"/>
@@ -20163,6 +20231,7 @@
               </a:defRPr>
             </a:lvl8pPr>
             <a:lvl9pPr>
+              <a:buNone/>
               <a:defRPr sz="2250" b="1">
                 <a:solidFill>
                   <a:srgbClr val="0F52BA"/>
@@ -20175,6 +20244,7 @@
           </a:lstStyle>
           <a:p xmlns:a="http://schemas.openxmlformats.org/drawingml/2006/main">
             <a:pPr>
+              <a:buNone/>
               <a:defRPr sz="2250" b="1">
                 <a:solidFill>
                   <a:srgbClr val="0F52BA"/>
@@ -20239,6 +20309,7 @@
               </a:defRPr>
             </a:defPPr>
             <a:lvl1pPr>
+              <a:buNone/>
               <a:defRPr sz="3000" b="1">
                 <a:solidFill>
                   <a:srgbClr val="0F52BA"/>
@@ -20249,6 +20320,7 @@
               </a:defRPr>
             </a:lvl1pPr>
             <a:lvl2pPr>
+              <a:buNone/>
               <a:defRPr sz="3000" b="1">
                 <a:solidFill>
                   <a:srgbClr val="0F52BA"/>
@@ -20259,6 +20331,7 @@
               </a:defRPr>
             </a:lvl2pPr>
             <a:lvl3pPr>
+              <a:buNone/>
               <a:defRPr sz="3000" b="1">
                 <a:solidFill>
                   <a:srgbClr val="0F52BA"/>
@@ -20269,6 +20342,7 @@
               </a:defRPr>
             </a:lvl3pPr>
             <a:lvl4pPr>
+              <a:buNone/>
               <a:defRPr sz="3000" b="1">
                 <a:solidFill>
                   <a:srgbClr val="0F52BA"/>
@@ -20279,6 +20353,7 @@
               </a:defRPr>
             </a:lvl4pPr>
             <a:lvl5pPr>
+              <a:buNone/>
               <a:defRPr sz="3000" b="1">
                 <a:solidFill>
                   <a:srgbClr val="0F52BA"/>
@@ -20289,6 +20364,7 @@
               </a:defRPr>
             </a:lvl5pPr>
             <a:lvl6pPr>
+              <a:buNone/>
               <a:defRPr sz="3000" b="1">
                 <a:solidFill>
                   <a:srgbClr val="0F52BA"/>
@@ -20299,6 +20375,7 @@
               </a:defRPr>
             </a:lvl6pPr>
             <a:lvl7pPr>
+              <a:buNone/>
               <a:defRPr sz="3000" b="1">
                 <a:solidFill>
                   <a:srgbClr val="0F52BA"/>
@@ -20309,6 +20386,7 @@
               </a:defRPr>
             </a:lvl7pPr>
             <a:lvl8pPr>
+              <a:buNone/>
               <a:defRPr sz="3000" b="1">
                 <a:solidFill>
                   <a:srgbClr val="0F52BA"/>
@@ -20319,6 +20397,7 @@
               </a:defRPr>
             </a:lvl8pPr>
             <a:lvl9pPr>
+              <a:buNone/>
               <a:defRPr sz="3000" b="1">
                 <a:solidFill>
                   <a:srgbClr val="0F52BA"/>
@@ -20331,6 +20410,7 @@
           </a:lstStyle>
           <a:p xmlns:a="http://schemas.openxmlformats.org/drawingml/2006/main">
             <a:pPr>
+              <a:buNone/>
               <a:defRPr sz="3000" b="1">
                 <a:solidFill>
                   <a:srgbClr val="0F52BA"/>
@@ -20395,6 +20475,7 @@
               </a:defRPr>
             </a:defPPr>
             <a:lvl1pPr>
+              <a:buNone/>
               <a:defRPr sz="2400" b="1">
                 <a:solidFill>
                   <a:srgbClr val="000926"/>
@@ -20405,6 +20486,7 @@
               </a:defRPr>
             </a:lvl1pPr>
             <a:lvl2pPr>
+              <a:buNone/>
               <a:defRPr sz="2400" b="1">
                 <a:solidFill>
                   <a:srgbClr val="000926"/>
@@ -20415,6 +20497,7 @@
               </a:defRPr>
             </a:lvl2pPr>
             <a:lvl3pPr>
+              <a:buNone/>
               <a:defRPr sz="2400" b="1">
                 <a:solidFill>
                   <a:srgbClr val="000926"/>
@@ -20425,6 +20508,7 @@
               </a:defRPr>
             </a:lvl3pPr>
             <a:lvl4pPr>
+              <a:buNone/>
               <a:defRPr sz="2400" b="1">
                 <a:solidFill>
                   <a:srgbClr val="000926"/>
@@ -20435,6 +20519,7 @@
               </a:defRPr>
             </a:lvl4pPr>
             <a:lvl5pPr>
+              <a:buNone/>
               <a:defRPr sz="2400" b="1">
                 <a:solidFill>
                   <a:srgbClr val="000926"/>
@@ -20445,6 +20530,7 @@
               </a:defRPr>
             </a:lvl5pPr>
             <a:lvl6pPr>
+              <a:buNone/>
               <a:defRPr sz="2400" b="1">
                 <a:solidFill>
                   <a:srgbClr val="000926"/>
@@ -20455,6 +20541,7 @@
               </a:defRPr>
             </a:lvl6pPr>
             <a:lvl7pPr>
+              <a:buNone/>
               <a:defRPr sz="2400" b="1">
                 <a:solidFill>
                   <a:srgbClr val="000926"/>
@@ -20465,6 +20552,7 @@
               </a:defRPr>
             </a:lvl7pPr>
             <a:lvl8pPr>
+              <a:buNone/>
               <a:defRPr sz="2400" b="1">
                 <a:solidFill>
                   <a:srgbClr val="000926"/>
@@ -20475,6 +20563,7 @@
               </a:defRPr>
             </a:lvl8pPr>
             <a:lvl9pPr>
+              <a:buNone/>
               <a:defRPr sz="2400" b="1">
                 <a:solidFill>
                   <a:srgbClr val="000926"/>
@@ -20487,6 +20576,7 @@
           </a:lstStyle>
           <a:p xmlns:a="http://schemas.openxmlformats.org/drawingml/2006/main">
             <a:pPr>
+              <a:buNone/>
               <a:defRPr sz="2400" b="1">
                 <a:solidFill>
                   <a:srgbClr val="000926"/>
@@ -20551,6 +20641,7 @@
               </a:defRPr>
             </a:defPPr>
             <a:lvl1pPr>
+              <a:buNone/>
               <a:defRPr sz="2100" b="0">
                 <a:solidFill>
                   <a:srgbClr val="172B45"/>
@@ -20561,6 +20652,7 @@
               </a:defRPr>
             </a:lvl1pPr>
             <a:lvl2pPr>
+              <a:buNone/>
               <a:defRPr sz="2100" b="0">
                 <a:solidFill>
                   <a:srgbClr val="172B45"/>
@@ -20571,6 +20663,7 @@
               </a:defRPr>
             </a:lvl2pPr>
             <a:lvl3pPr>
+              <a:buNone/>
               <a:defRPr sz="2100" b="0">
                 <a:solidFill>
                   <a:srgbClr val="172B45"/>
@@ -20581,6 +20674,7 @@
               </a:defRPr>
             </a:lvl3pPr>
             <a:lvl4pPr>
+              <a:buNone/>
               <a:defRPr sz="2100" b="0">
                 <a:solidFill>
                   <a:srgbClr val="172B45"/>
@@ -20591,6 +20685,7 @@
               </a:defRPr>
             </a:lvl4pPr>
             <a:lvl5pPr>
+              <a:buNone/>
               <a:defRPr sz="2100" b="0">
                 <a:solidFill>
                   <a:srgbClr val="172B45"/>
@@ -20601,6 +20696,7 @@
               </a:defRPr>
             </a:lvl5pPr>
             <a:lvl6pPr>
+              <a:buNone/>
               <a:defRPr sz="2100" b="0">
                 <a:solidFill>
                   <a:srgbClr val="172B45"/>
@@ -20611,6 +20707,7 @@
               </a:defRPr>
             </a:lvl6pPr>
             <a:lvl7pPr>
+              <a:buNone/>
               <a:defRPr sz="2100" b="0">
                 <a:solidFill>
                   <a:srgbClr val="172B45"/>
@@ -20621,6 +20718,7 @@
               </a:defRPr>
             </a:lvl7pPr>
             <a:lvl8pPr>
+              <a:buNone/>
               <a:defRPr sz="2100" b="0">
                 <a:solidFill>
                   <a:srgbClr val="172B45"/>
@@ -20631,6 +20729,7 @@
               </a:defRPr>
             </a:lvl8pPr>
             <a:lvl9pPr>
+              <a:buNone/>
               <a:defRPr sz="2100" b="0">
                 <a:solidFill>
                   <a:srgbClr val="172B45"/>
@@ -20643,6 +20742,7 @@
           </a:lstStyle>
           <a:p xmlns:a="http://schemas.openxmlformats.org/drawingml/2006/main">
             <a:pPr>
+              <a:buNone/>
               <a:defRPr sz="2100" b="0">
                 <a:solidFill>
                   <a:srgbClr val="172B45"/>
@@ -20666,6 +20766,7 @@
           </a:p>
           <a:p xmlns:a="http://schemas.openxmlformats.org/drawingml/2006/main">
             <a:pPr>
+              <a:buNone/>
               <a:defRPr sz="2100" b="0">
                 <a:solidFill>
                   <a:srgbClr val="172B45"/>
@@ -20730,6 +20831,7 @@
               </a:defRPr>
             </a:defPPr>
             <a:lvl1pPr>
+              <a:buNone/>
               <a:defRPr sz="3000" b="1">
                 <a:solidFill>
                   <a:srgbClr val="0F52BA"/>
@@ -20740,6 +20842,7 @@
               </a:defRPr>
             </a:lvl1pPr>
             <a:lvl2pPr>
+              <a:buNone/>
               <a:defRPr sz="3000" b="1">
                 <a:solidFill>
                   <a:srgbClr val="0F52BA"/>
@@ -20750,6 +20853,7 @@
               </a:defRPr>
             </a:lvl2pPr>
             <a:lvl3pPr>
+              <a:buNone/>
               <a:defRPr sz="3000" b="1">
                 <a:solidFill>
                   <a:srgbClr val="0F52BA"/>
@@ -20760,6 +20864,7 @@
               </a:defRPr>
             </a:lvl3pPr>
             <a:lvl4pPr>
+              <a:buNone/>
               <a:defRPr sz="3000" b="1">
                 <a:solidFill>
                   <a:srgbClr val="0F52BA"/>
@@ -20770,6 +20875,7 @@
               </a:defRPr>
             </a:lvl4pPr>
             <a:lvl5pPr>
+              <a:buNone/>
               <a:defRPr sz="3000" b="1">
                 <a:solidFill>
                   <a:srgbClr val="0F52BA"/>
@@ -20780,6 +20886,7 @@
               </a:defRPr>
             </a:lvl5pPr>
             <a:lvl6pPr>
+              <a:buNone/>
               <a:defRPr sz="3000" b="1">
                 <a:solidFill>
                   <a:srgbClr val="0F52BA"/>
@@ -20790,6 +20897,7 @@
               </a:defRPr>
             </a:lvl6pPr>
             <a:lvl7pPr>
+              <a:buNone/>
               <a:defRPr sz="3000" b="1">
                 <a:solidFill>
                   <a:srgbClr val="0F52BA"/>
@@ -20800,6 +20908,7 @@
               </a:defRPr>
             </a:lvl7pPr>
             <a:lvl8pPr>
+              <a:buNone/>
               <a:defRPr sz="3000" b="1">
                 <a:solidFill>
                   <a:srgbClr val="0F52BA"/>
@@ -20810,6 +20919,7 @@
               </a:defRPr>
             </a:lvl8pPr>
             <a:lvl9pPr>
+              <a:buNone/>
               <a:defRPr sz="3000" b="1">
                 <a:solidFill>
                   <a:srgbClr val="0F52BA"/>
@@ -20822,6 +20932,7 @@
           </a:lstStyle>
           <a:p xmlns:a="http://schemas.openxmlformats.org/drawingml/2006/main">
             <a:pPr>
+              <a:buNone/>
               <a:defRPr sz="3000" b="1">
                 <a:solidFill>
                   <a:srgbClr val="0F52BA"/>
@@ -20886,6 +20997,7 @@
               </a:defRPr>
             </a:defPPr>
             <a:lvl1pPr>
+              <a:buNone/>
               <a:defRPr sz="2400" b="1">
                 <a:solidFill>
                   <a:srgbClr val="000926"/>
@@ -20896,6 +21008,7 @@
               </a:defRPr>
             </a:lvl1pPr>
             <a:lvl2pPr>
+              <a:buNone/>
               <a:defRPr sz="2400" b="1">
                 <a:solidFill>
                   <a:srgbClr val="000926"/>
@@ -20906,6 +21019,7 @@
               </a:defRPr>
             </a:lvl2pPr>
             <a:lvl3pPr>
+              <a:buNone/>
               <a:defRPr sz="2400" b="1">
                 <a:solidFill>
                   <a:srgbClr val="000926"/>
@@ -20916,6 +21030,7 @@
               </a:defRPr>
             </a:lvl3pPr>
             <a:lvl4pPr>
+              <a:buNone/>
               <a:defRPr sz="2400" b="1">
                 <a:solidFill>
                   <a:srgbClr val="000926"/>
@@ -20926,6 +21041,7 @@
               </a:defRPr>
             </a:lvl4pPr>
             <a:lvl5pPr>
+              <a:buNone/>
               <a:defRPr sz="2400" b="1">
                 <a:solidFill>
                   <a:srgbClr val="000926"/>
@@ -20936,6 +21052,7 @@
               </a:defRPr>
             </a:lvl5pPr>
             <a:lvl6pPr>
+              <a:buNone/>
               <a:defRPr sz="2400" b="1">
                 <a:solidFill>
                   <a:srgbClr val="000926"/>
@@ -20946,6 +21063,7 @@
               </a:defRPr>
             </a:lvl6pPr>
             <a:lvl7pPr>
+              <a:buNone/>
               <a:defRPr sz="2400" b="1">
                 <a:solidFill>
                   <a:srgbClr val="000926"/>
@@ -20956,6 +21074,7 @@
               </a:defRPr>
             </a:lvl7pPr>
             <a:lvl8pPr>
+              <a:buNone/>
               <a:defRPr sz="2400" b="1">
                 <a:solidFill>
                   <a:srgbClr val="000926"/>
@@ -20966,6 +21085,7 @@
               </a:defRPr>
             </a:lvl8pPr>
             <a:lvl9pPr>
+              <a:buNone/>
               <a:defRPr sz="2400" b="1">
                 <a:solidFill>
                   <a:srgbClr val="000926"/>
@@ -20978,6 +21098,7 @@
           </a:lstStyle>
           <a:p xmlns:a="http://schemas.openxmlformats.org/drawingml/2006/main">
             <a:pPr>
+              <a:buNone/>
               <a:defRPr sz="2400" b="1">
                 <a:solidFill>
                   <a:srgbClr val="000926"/>
@@ -21042,6 +21163,7 @@
               </a:defRPr>
             </a:defPPr>
             <a:lvl1pPr>
+              <a:buNone/>
               <a:defRPr sz="2100" b="0">
                 <a:solidFill>
                   <a:srgbClr val="172B45"/>
@@ -21052,6 +21174,7 @@
               </a:defRPr>
             </a:lvl1pPr>
             <a:lvl2pPr>
+              <a:buNone/>
               <a:defRPr sz="2100" b="0">
                 <a:solidFill>
                   <a:srgbClr val="172B45"/>
@@ -21062,6 +21185,7 @@
               </a:defRPr>
             </a:lvl2pPr>
             <a:lvl3pPr>
+              <a:buNone/>
               <a:defRPr sz="2100" b="0">
                 <a:solidFill>
                   <a:srgbClr val="172B45"/>
@@ -21072,6 +21196,7 @@
               </a:defRPr>
             </a:lvl3pPr>
             <a:lvl4pPr>
+              <a:buNone/>
               <a:defRPr sz="2100" b="0">
                 <a:solidFill>
                   <a:srgbClr val="172B45"/>
@@ -21082,6 +21207,7 @@
               </a:defRPr>
             </a:lvl4pPr>
             <a:lvl5pPr>
+              <a:buNone/>
               <a:defRPr sz="2100" b="0">
                 <a:solidFill>
                   <a:srgbClr val="172B45"/>
@@ -21092,6 +21218,7 @@
               </a:defRPr>
             </a:lvl5pPr>
             <a:lvl6pPr>
+              <a:buNone/>
               <a:defRPr sz="2100" b="0">
                 <a:solidFill>
                   <a:srgbClr val="172B45"/>
@@ -21102,6 +21229,7 @@
               </a:defRPr>
             </a:lvl6pPr>
             <a:lvl7pPr>
+              <a:buNone/>
               <a:defRPr sz="2100" b="0">
                 <a:solidFill>
                   <a:srgbClr val="172B45"/>
@@ -21112,6 +21240,7 @@
               </a:defRPr>
             </a:lvl7pPr>
             <a:lvl8pPr>
+              <a:buNone/>
               <a:defRPr sz="2100" b="0">
                 <a:solidFill>
                   <a:srgbClr val="172B45"/>
@@ -21122,6 +21251,7 @@
               </a:defRPr>
             </a:lvl8pPr>
             <a:lvl9pPr>
+              <a:buNone/>
               <a:defRPr sz="2100" b="0">
                 <a:solidFill>
                   <a:srgbClr val="172B45"/>
@@ -21134,6 +21264,7 @@
           </a:lstStyle>
           <a:p xmlns:a="http://schemas.openxmlformats.org/drawingml/2006/main">
             <a:pPr>
+              <a:buNone/>
               <a:defRPr sz="2100" b="0">
                 <a:solidFill>
                   <a:srgbClr val="172B45"/>
@@ -21157,6 +21288,7 @@
           </a:p>
           <a:p xmlns:a="http://schemas.openxmlformats.org/drawingml/2006/main">
             <a:pPr>
+              <a:buNone/>
               <a:defRPr sz="2100" b="0">
                 <a:solidFill>
                   <a:srgbClr val="172B45"/>
@@ -21221,6 +21353,7 @@
               </a:defRPr>
             </a:defPPr>
             <a:lvl1pPr>
+              <a:buNone/>
               <a:defRPr sz="3000" b="1">
                 <a:solidFill>
                   <a:srgbClr val="0F52BA"/>
@@ -21231,6 +21364,7 @@
               </a:defRPr>
             </a:lvl1pPr>
             <a:lvl2pPr>
+              <a:buNone/>
               <a:defRPr sz="3000" b="1">
                 <a:solidFill>
                   <a:srgbClr val="0F52BA"/>
@@ -21241,6 +21375,7 @@
               </a:defRPr>
             </a:lvl2pPr>
             <a:lvl3pPr>
+              <a:buNone/>
               <a:defRPr sz="3000" b="1">
                 <a:solidFill>
                   <a:srgbClr val="0F52BA"/>
@@ -21251,6 +21386,7 @@
               </a:defRPr>
             </a:lvl3pPr>
             <a:lvl4pPr>
+              <a:buNone/>
               <a:defRPr sz="3000" b="1">
                 <a:solidFill>
                   <a:srgbClr val="0F52BA"/>
@@ -21261,6 +21397,7 @@
               </a:defRPr>
             </a:lvl4pPr>
             <a:lvl5pPr>
+              <a:buNone/>
               <a:defRPr sz="3000" b="1">
                 <a:solidFill>
                   <a:srgbClr val="0F52BA"/>
@@ -21271,6 +21408,7 @@
               </a:defRPr>
             </a:lvl5pPr>
             <a:lvl6pPr>
+              <a:buNone/>
               <a:defRPr sz="3000" b="1">
                 <a:solidFill>
                   <a:srgbClr val="0F52BA"/>
@@ -21281,6 +21419,7 @@
               </a:defRPr>
             </a:lvl6pPr>
             <a:lvl7pPr>
+              <a:buNone/>
               <a:defRPr sz="3000" b="1">
                 <a:solidFill>
                   <a:srgbClr val="0F52BA"/>
@@ -21291,6 +21430,7 @@
               </a:defRPr>
             </a:lvl7pPr>
             <a:lvl8pPr>
+              <a:buNone/>
               <a:defRPr sz="3000" b="1">
                 <a:solidFill>
                   <a:srgbClr val="0F52BA"/>
@@ -21301,6 +21441,7 @@
               </a:defRPr>
             </a:lvl8pPr>
             <a:lvl9pPr>
+              <a:buNone/>
               <a:defRPr sz="3000" b="1">
                 <a:solidFill>
                   <a:srgbClr val="0F52BA"/>
@@ -21313,6 +21454,7 @@
           </a:lstStyle>
           <a:p xmlns:a="http://schemas.openxmlformats.org/drawingml/2006/main">
             <a:pPr>
+              <a:buNone/>
               <a:defRPr sz="3000" b="1">
                 <a:solidFill>
                   <a:srgbClr val="0F52BA"/>
@@ -21377,6 +21519,7 @@
               </a:defRPr>
             </a:defPPr>
             <a:lvl1pPr>
+              <a:buNone/>
               <a:defRPr sz="2400" b="1">
                 <a:solidFill>
                   <a:srgbClr val="000926"/>
@@ -21387,6 +21530,7 @@
               </a:defRPr>
             </a:lvl1pPr>
             <a:lvl2pPr>
+              <a:buNone/>
               <a:defRPr sz="2400" b="1">
                 <a:solidFill>
                   <a:srgbClr val="000926"/>
@@ -21397,6 +21541,7 @@
               </a:defRPr>
             </a:lvl2pPr>
             <a:lvl3pPr>
+              <a:buNone/>
               <a:defRPr sz="2400" b="1">
                 <a:solidFill>
                   <a:srgbClr val="000926"/>
@@ -21407,6 +21552,7 @@
               </a:defRPr>
             </a:lvl3pPr>
             <a:lvl4pPr>
+              <a:buNone/>
               <a:defRPr sz="2400" b="1">
                 <a:solidFill>
                   <a:srgbClr val="000926"/>
@@ -21417,6 +21563,7 @@
               </a:defRPr>
             </a:lvl4pPr>
             <a:lvl5pPr>
+              <a:buNone/>
               <a:defRPr sz="2400" b="1">
                 <a:solidFill>
                   <a:srgbClr val="000926"/>
@@ -21427,6 +21574,7 @@
               </a:defRPr>
             </a:lvl5pPr>
             <a:lvl6pPr>
+              <a:buNone/>
               <a:defRPr sz="2400" b="1">
                 <a:solidFill>
                   <a:srgbClr val="000926"/>
@@ -21437,6 +21585,7 @@
               </a:defRPr>
             </a:lvl6pPr>
             <a:lvl7pPr>
+              <a:buNone/>
               <a:defRPr sz="2400" b="1">
                 <a:solidFill>
                   <a:srgbClr val="000926"/>
@@ -21447,6 +21596,7 @@
               </a:defRPr>
             </a:lvl7pPr>
             <a:lvl8pPr>
+              <a:buNone/>
               <a:defRPr sz="2400" b="1">
                 <a:solidFill>
                   <a:srgbClr val="000926"/>
@@ -21457,6 +21607,7 @@
               </a:defRPr>
             </a:lvl8pPr>
             <a:lvl9pPr>
+              <a:buNone/>
               <a:defRPr sz="2400" b="1">
                 <a:solidFill>
                   <a:srgbClr val="000926"/>
@@ -21469,6 +21620,7 @@
           </a:lstStyle>
           <a:p xmlns:a="http://schemas.openxmlformats.org/drawingml/2006/main">
             <a:pPr>
+              <a:buNone/>
               <a:defRPr sz="2400" b="1">
                 <a:solidFill>
                   <a:srgbClr val="000926"/>
@@ -21533,6 +21685,7 @@
               </a:defRPr>
             </a:defPPr>
             <a:lvl1pPr>
+              <a:buNone/>
               <a:defRPr sz="2100" b="0">
                 <a:solidFill>
                   <a:srgbClr val="172B45"/>
@@ -21543,6 +21696,7 @@
               </a:defRPr>
             </a:lvl1pPr>
             <a:lvl2pPr>
+              <a:buNone/>
               <a:defRPr sz="2100" b="0">
                 <a:solidFill>
                   <a:srgbClr val="172B45"/>
@@ -21553,6 +21707,7 @@
               </a:defRPr>
             </a:lvl2pPr>
             <a:lvl3pPr>
+              <a:buNone/>
               <a:defRPr sz="2100" b="0">
                 <a:solidFill>
                   <a:srgbClr val="172B45"/>
@@ -21563,6 +21718,7 @@
               </a:defRPr>
             </a:lvl3pPr>
             <a:lvl4pPr>
+              <a:buNone/>
               <a:defRPr sz="2100" b="0">
                 <a:solidFill>
                   <a:srgbClr val="172B45"/>
@@ -21573,6 +21729,7 @@
               </a:defRPr>
             </a:lvl4pPr>
             <a:lvl5pPr>
+              <a:buNone/>
               <a:defRPr sz="2100" b="0">
                 <a:solidFill>
                   <a:srgbClr val="172B45"/>
@@ -21583,6 +21740,7 @@
               </a:defRPr>
             </a:lvl5pPr>
             <a:lvl6pPr>
+              <a:buNone/>
               <a:defRPr sz="2100" b="0">
                 <a:solidFill>
                   <a:srgbClr val="172B45"/>
@@ -21593,6 +21751,7 @@
               </a:defRPr>
             </a:lvl6pPr>
             <a:lvl7pPr>
+              <a:buNone/>
               <a:defRPr sz="2100" b="0">
                 <a:solidFill>
                   <a:srgbClr val="172B45"/>
@@ -21603,6 +21762,7 @@
               </a:defRPr>
             </a:lvl7pPr>
             <a:lvl8pPr>
+              <a:buNone/>
               <a:defRPr sz="2100" b="0">
                 <a:solidFill>
                   <a:srgbClr val="172B45"/>
@@ -21613,6 +21773,7 @@
               </a:defRPr>
             </a:lvl8pPr>
             <a:lvl9pPr>
+              <a:buNone/>
               <a:defRPr sz="2100" b="0">
                 <a:solidFill>
                   <a:srgbClr val="172B45"/>
@@ -21625,6 +21786,7 @@
           </a:lstStyle>
           <a:p xmlns:a="http://schemas.openxmlformats.org/drawingml/2006/main">
             <a:pPr>
+              <a:buNone/>
               <a:defRPr sz="2100" b="0">
                 <a:solidFill>
                   <a:srgbClr val="172B45"/>
@@ -21648,6 +21810,7 @@
           </a:p>
           <a:p xmlns:a="http://schemas.openxmlformats.org/drawingml/2006/main">
             <a:pPr>
+              <a:buNone/>
               <a:defRPr sz="2100" b="0">
                 <a:solidFill>
                   <a:srgbClr val="172B45"/>
@@ -21712,6 +21875,7 @@
               </a:defRPr>
             </a:defPPr>
             <a:lvl1pPr>
+              <a:buNone/>
               <a:defRPr sz="1350" b="0">
                 <a:solidFill>
                   <a:srgbClr val="526A84"/>
@@ -21722,6 +21886,7 @@
               </a:defRPr>
             </a:lvl1pPr>
             <a:lvl2pPr>
+              <a:buNone/>
               <a:defRPr sz="1350" b="0">
                 <a:solidFill>
                   <a:srgbClr val="526A84"/>
@@ -21732,6 +21897,7 @@
               </a:defRPr>
             </a:lvl2pPr>
             <a:lvl3pPr>
+              <a:buNone/>
               <a:defRPr sz="1350" b="0">
                 <a:solidFill>
                   <a:srgbClr val="526A84"/>
@@ -21742,6 +21908,7 @@
               </a:defRPr>
             </a:lvl3pPr>
             <a:lvl4pPr>
+              <a:buNone/>
               <a:defRPr sz="1350" b="0">
                 <a:solidFill>
                   <a:srgbClr val="526A84"/>
@@ -21752,6 +21919,7 @@
               </a:defRPr>
             </a:lvl4pPr>
             <a:lvl5pPr>
+              <a:buNone/>
               <a:defRPr sz="1350" b="0">
                 <a:solidFill>
                   <a:srgbClr val="526A84"/>
@@ -21762,6 +21930,7 @@
               </a:defRPr>
             </a:lvl5pPr>
             <a:lvl6pPr>
+              <a:buNone/>
               <a:defRPr sz="1350" b="0">
                 <a:solidFill>
                   <a:srgbClr val="526A84"/>
@@ -21772,6 +21941,7 @@
               </a:defRPr>
             </a:lvl6pPr>
             <a:lvl7pPr>
+              <a:buNone/>
               <a:defRPr sz="1350" b="0">
                 <a:solidFill>
                   <a:srgbClr val="526A84"/>
@@ -21782,6 +21952,7 @@
               </a:defRPr>
             </a:lvl7pPr>
             <a:lvl8pPr>
+              <a:buNone/>
               <a:defRPr sz="1350" b="0">
                 <a:solidFill>
                   <a:srgbClr val="526A84"/>
@@ -21792,6 +21963,7 @@
               </a:defRPr>
             </a:lvl8pPr>
             <a:lvl9pPr>
+              <a:buNone/>
               <a:defRPr sz="1350" b="0">
                 <a:solidFill>
                   <a:srgbClr val="526A84"/>
@@ -21804,6 +21976,7 @@
           </a:lstStyle>
           <a:p xmlns:a="http://schemas.openxmlformats.org/drawingml/2006/main">
             <a:pPr>
+              <a:buNone/>
               <a:defRPr sz="1350" b="0">
                 <a:solidFill>
                   <a:srgbClr val="526A84"/>

</xml_diff>